<commit_message>
Rewrite presentation slides as academic prose with subheadings
Co-Authored-By: Claude Fable 5.1 <noreply@anthropic.com>
Claude-Session: https://claude.ai/code/session_01KHo5ZcKCUwhCAvyoKeeMWs
</commit_message>
<xml_diff>
--- a/seminar/רפרט_רווחה_נפשית_ולגיטימיות.pptx
+++ b/seminar/רפרט_רווחה_נפשית_ולגיטימיות.pptx
@@ -117,7 +117,36 @@
   <c:date1904 val="0"/>
   <c:roundedCorners val="1"/>
   <c:chart>
-    <c:autoTitleDeleted val="1"/>
+    <c:title>
+      <c:tx>
+        <c:rich>
+          <a:bodyPr/>
+          <a:lstStyle/>
+          <a:p>
+            <a:pPr>
+              <a:defRPr sz="1100" b="0" i="0" u="none" strike="noStrike">
+                <a:solidFill>
+                  <a:srgbClr val="1F3A5F"/>
+                </a:solidFill>
+                <a:latin typeface="Arial"/>
+              </a:defRPr>
+            </a:pPr>
+            <a:r>
+              <a:rPr sz="1100" b="0" i="0" u="none" strike="noStrike">
+                <a:solidFill>
+                  <a:srgbClr val="1F3A5F"/>
+                </a:solidFill>
+                <a:latin typeface="Arial"/>
+              </a:rPr>
+              <a:t>מאפייני הרקע של השפוטים באחוזים (N = 2,379)</a:t>
+            </a:r>
+          </a:p>
+        </c:rich>
+      </c:tx>
+      <c:layout/>
+      <c:overlay val="0"/>
+    </c:title>
+    <c:autoTitleDeleted val="0"/>
     <c:plotArea>
       <c:layout/>
       <c:barChart>
@@ -292,7 +321,7 @@
           <a:lstStyle/>
           <a:p>
             <a:pPr>
-              <a:defRPr sz="1100" b="0" i="0" u="none" strike="noStrike">
+              <a:defRPr sz="1000" b="0" i="0" u="none" strike="noStrike">
                 <a:solidFill>
                   <a:srgbClr val="22303F"/>
                 </a:solidFill>
@@ -312,7 +341,7 @@
         <c:axId val="2094734552"/>
         <c:scaling>
           <c:orientation val="minMax"/>
-          <c:max val="110"/>
+          <c:max val="115"/>
         </c:scaling>
         <c:delete val="1"/>
         <c:axPos val="b"/>
@@ -384,7 +413,7 @@
           <a:lstStyle/>
           <a:p>
             <a:pPr>
-              <a:defRPr sz="1200" b="0" i="0" u="none" strike="noStrike">
+              <a:defRPr sz="1100" b="0" i="0" u="none" strike="noStrike">
                 <a:solidFill>
                   <a:srgbClr val="1F3A5F"/>
                 </a:solidFill>
@@ -392,7 +421,7 @@
               </a:defRPr>
             </a:pPr>
             <a:r>
-              <a:rPr sz="1200" b="0" i="0" u="none" strike="noStrike">
+              <a:rPr sz="1100" b="0" i="0" u="none" strike="noStrike">
                 <a:solidFill>
                   <a:srgbClr val="1F3A5F"/>
                 </a:solidFill>
@@ -441,7 +470,7 @@
               <a:lstStyle/>
               <a:p>
                 <a:pPr>
-                  <a:defRPr b="0" i="0" strike="noStrike" sz="1200" u="none">
+                  <a:defRPr b="0" i="0" strike="noStrike" sz="1100" u="none">
                     <a:solidFill>
                       <a:srgbClr val="22303F"/>
                     </a:solidFill>
@@ -503,7 +532,7 @@
             <a:lstStyle/>
             <a:p>
               <a:pPr>
-                <a:defRPr b="0" i="0" strike="noStrike" sz="1200" u="none">
+                <a:defRPr b="0" i="0" strike="noStrike" sz="1100" u="none">
                   <a:solidFill>
                     <a:srgbClr val="22303F"/>
                   </a:solidFill>
@@ -551,7 +580,7 @@
           <a:lstStyle/>
           <a:p>
             <a:pPr>
-              <a:defRPr sz="1000" b="0" i="0" u="none" strike="noStrike">
+              <a:defRPr sz="900" b="0" i="0" u="none" strike="noStrike">
                 <a:solidFill>
                   <a:srgbClr val="22303F"/>
                 </a:solidFill>
@@ -605,7 +634,7 @@
           <a:lstStyle/>
           <a:p>
             <a:pPr>
-              <a:defRPr sz="1000" b="0" i="0" u="none" strike="noStrike">
+              <a:defRPr sz="900" b="0" i="0" u="none" strike="noStrike">
                 <a:solidFill>
                   <a:srgbClr val="5B6B7C"/>
                 </a:solidFill>
@@ -1038,7 +1067,7 @@
           <a:p>
             <a:r>
               <a:rPr lang="en-US" dirty="0"/>
-              <a:t>שקף פתיחה: להציג את שאלת המחקר ואת המגישות.</a:t>
+              <a:t/>
             </a:r>
             <a:endParaRPr lang="en-US" dirty="0"/>
           </a:p>
@@ -1478,7 +1507,7 @@
           <a:p>
             <a:r>
               <a:rPr lang="en-US" dirty="0"/>
-              <a:t>פער של כ-0.7 נקודות ברווחה בין הקבוצה הנמוכה לגבוהה, כ-80% מסטיית תקן. n: 427 / 809 / 1,108.</a:t>
+              <a:t/>
             </a:r>
             <a:endParaRPr lang="en-US" dirty="0"/>
           </a:p>
@@ -1928,7 +1957,7 @@
                 <a:ea typeface="Arial" pitchFamily="34" charset="-122"/>
                 <a:cs typeface="Arial" pitchFamily="34" charset="-120"/>
               </a:rPr>
-              <a:t>המכללה האקדמית אשקלון | החוג לקרימינולוגיה</a:t>
+              <a:t>המכללה האקדמית אשקלון, החוג לקרימינולוגיה</a:t>
             </a:r>
             <a:endParaRPr lang="he-IL" sz="1400" dirty="0"/>
           </a:p>
@@ -2020,8 +2049,8 @@
         </p:nvSpPr>
         <p:spPr>
           <a:xfrm>
-            <a:off x="548640" y="1508760"/>
-            <a:ext cx="8046720" cy="1005840"/>
+            <a:off x="548640" y="1463040"/>
+            <a:ext cx="8046720" cy="960120"/>
           </a:xfrm>
           <a:prstGeom prst="rect">
             <a:avLst/>
@@ -2037,7 +2066,7 @@
               <a:buNone/>
             </a:pPr>
             <a:r>
-              <a:rPr lang="he-IL" altLang="en-US" sz="2800" b="1" dirty="0">
+              <a:rPr lang="he-IL" altLang="en-US" sz="2600" b="1" dirty="0">
                 <a:solidFill>
                   <a:srgbClr val="FFFFFF"/>
                 </a:solidFill>
@@ -2047,7 +2076,7 @@
               </a:rPr>
               <a:t>רווחה נפשית ותפיסת הלגיטימיות של סגל הכליאה בקרב אסירים שפוטים בישראל</a:t>
             </a:r>
-            <a:endParaRPr lang="he-IL" sz="2800" dirty="0"/>
+            <a:endParaRPr lang="he-IL" sz="2600" dirty="0"/>
           </a:p>
         </p:txBody>
       </p:sp>
@@ -2059,7 +2088,7 @@
         </p:nvSpPr>
         <p:spPr>
           <a:xfrm>
-            <a:off x="548640" y="2606040"/>
+            <a:off x="548640" y="2514600"/>
             <a:ext cx="8046720" cy="822960"/>
           </a:xfrm>
           <a:prstGeom prst="rect">
@@ -2076,7 +2105,7 @@
               <a:buNone/>
             </a:pPr>
             <a:r>
-              <a:rPr lang="he-IL" altLang="en-US" sz="1600" dirty="0">
+              <a:rPr lang="he-IL" altLang="en-US" sz="1500" dirty="0">
                 <a:solidFill>
                   <a:srgbClr val="CFDBEA"/>
                 </a:solidFill>
@@ -2086,7 +2115,7 @@
               </a:rPr>
               <a:t>שאלת המחקר: באיזו מידה קיים קשר בין רווחה נפשית לבין תפיסת הלגיטימיות של סגל הכליאה בקרב אסירים שפוטים בלבד?</a:t>
             </a:r>
-            <a:endParaRPr lang="he-IL" sz="1600" dirty="0"/>
+            <a:endParaRPr lang="he-IL" sz="1500" dirty="0"/>
           </a:p>
         </p:txBody>
       </p:sp>
@@ -2098,7 +2127,7 @@
         </p:nvSpPr>
         <p:spPr>
           <a:xfrm>
-            <a:off x="548640" y="3611880"/>
+            <a:off x="548640" y="3520440"/>
             <a:ext cx="8046720" cy="1097280"/>
           </a:xfrm>
           <a:prstGeom prst="roundRect">
@@ -2125,7 +2154,7 @@
         </p:nvSpPr>
         <p:spPr>
           <a:xfrm>
-            <a:off x="777240" y="3703320"/>
+            <a:off x="777240" y="3611880"/>
             <a:ext cx="7589520" cy="274320"/>
           </a:xfrm>
           <a:prstGeom prst="rect">
@@ -2164,7 +2193,7 @@
         </p:nvSpPr>
         <p:spPr>
           <a:xfrm>
-            <a:off x="777240" y="4005072"/>
+            <a:off x="777240" y="3913632"/>
             <a:ext cx="7589520" cy="292608"/>
           </a:xfrm>
           <a:prstGeom prst="rect">
@@ -2203,7 +2232,7 @@
         </p:nvSpPr>
         <p:spPr>
           <a:xfrm>
-            <a:off x="777240" y="4315968"/>
+            <a:off x="777240" y="4224528"/>
             <a:ext cx="7589520" cy="292608"/>
           </a:xfrm>
           <a:prstGeom prst="rect">
@@ -2274,8 +2303,8 @@
         </p:nvSpPr>
         <p:spPr>
           <a:xfrm>
-            <a:off x="457200" y="320040"/>
-            <a:ext cx="8229600" cy="731520"/>
+            <a:off x="457200" y="274320"/>
+            <a:ext cx="8229600" cy="640080"/>
           </a:xfrm>
           <a:prstGeom prst="rect">
             <a:avLst/>
@@ -2291,7 +2320,7 @@
               <a:buNone/>
             </a:pPr>
             <a:r>
-              <a:rPr lang="he-IL" altLang="en-US" sz="3200" b="1" dirty="0">
+              <a:rPr lang="he-IL" altLang="en-US" sz="3000" b="1" dirty="0">
                 <a:solidFill>
                   <a:srgbClr val="1F3A5F"/>
                 </a:solidFill>
@@ -2301,7 +2330,7 @@
               </a:rPr>
               <a:t>רקע</a:t>
             </a:r>
-            <a:endParaRPr lang="he-IL" sz="3200" dirty="0"/>
+            <a:endParaRPr lang="he-IL" sz="3000" dirty="0"/>
           </a:p>
         </p:txBody>
       </p:sp>
@@ -2313,12 +2342,12 @@
         </p:nvSpPr>
         <p:spPr>
           <a:xfrm>
-            <a:off x="457200" y="1188720"/>
-            <a:ext cx="5394960" cy="3383280"/>
+            <a:off x="457200" y="1051560"/>
+            <a:ext cx="5486400" cy="3520440"/>
           </a:xfrm>
           <a:prstGeom prst="roundRect">
             <a:avLst>
-              <a:gd name="adj" fmla="val 2703"/>
+              <a:gd name="adj" fmla="val 2597"/>
             </a:avLst>
           </a:prstGeom>
           <a:solidFill>
@@ -2340,8 +2369,8 @@
         </p:nvSpPr>
         <p:spPr>
           <a:xfrm>
-            <a:off x="685800" y="1371600"/>
-            <a:ext cx="4983480" cy="3063240"/>
+            <a:off x="685800" y="1188720"/>
+            <a:ext cx="5029200" cy="320040"/>
           </a:xfrm>
           <a:prstGeom prst="rect">
             <a:avLst/>
@@ -2353,12 +2382,50 @@
           <a:bodyPr wrap="square" lIns="0" tIns="0" rIns="0" bIns="0" rtlCol="0" anchor="t"/>
           <a:lstStyle/>
           <a:p>
-            <a:pPr algn="r" marL="342900" indent="-342900">
-              <a:spcAft>
-                <a:spcPts val="800"/>
-              </a:spcAft>
-              <a:buSzPct val="100000"/>
-              <a:buChar char="•"/>
+            <a:pPr rtl="1" algn="r" indent="0" marL="0">
+              <a:buNone/>
+            </a:pPr>
+            <a:r>
+              <a:rPr lang="he-IL" altLang="en-US" sz="1400" b="1" dirty="0">
+                <a:solidFill>
+                  <a:srgbClr val="E8892B"/>
+                </a:solidFill>
+                <a:latin typeface="Arial" pitchFamily="34" charset="0"/>
+                <a:ea typeface="Arial" pitchFamily="34" charset="-122"/>
+                <a:cs typeface="Arial" pitchFamily="34" charset="-120"/>
+              </a:rPr>
+              <a:t>לגיטימיות כתנאי לסדר בבית הסוהר</a:t>
+            </a:r>
+            <a:endParaRPr lang="he-IL" sz="1400" dirty="0"/>
+          </a:p>
+        </p:txBody>
+      </p:sp>
+      <p:sp>
+        <p:nvSpPr>
+          <p:cNvPr id="5" name="Text 3"/>
+          <p:cNvSpPr txBox="1"/>
+          <p:nvPr/>
+        </p:nvSpPr>
+        <p:spPr>
+          <a:xfrm>
+            <a:off x="685800" y="1554480"/>
+            <a:ext cx="5029200" cy="1417320"/>
+          </a:xfrm>
+          <a:prstGeom prst="rect">
+            <a:avLst/>
+          </a:prstGeom>
+          <a:noFill/>
+          <a:ln/>
+        </p:spPr>
+        <p:txBody>
+          <a:bodyPr wrap="square" lIns="0" tIns="0" rIns="0" bIns="0" rtlCol="0" anchor="t"/>
+          <a:lstStyle/>
+          <a:p>
+            <a:pPr rtl="1" algn="just" indent="0" marL="0">
+              <a:lnSpc>
+                <a:spcPct val="115000"/>
+              </a:lnSpc>
+              <a:buNone/>
             </a:pPr>
             <a:r>
               <a:rPr lang="he-IL" altLang="en-US" sz="1200" dirty="0">
@@ -2369,17 +2436,77 @@
                 <a:ea typeface="Arial" pitchFamily="34" charset="-122"/>
                 <a:cs typeface="Arial" pitchFamily="34" charset="-120"/>
               </a:rPr>
-              <a:t>הסדר באגף אינו מתקיים בכוח בלבד אלא נשען על תחושת האסירים שהמשטר הוגן ושהסגל ראוי לציות (Sparks &amp; Bottoms, 1995).</a:t>
+              <a:t>בית הסוהר הוא מוסד שבו סמכות הסגל כמעט מוחלטת, ובכל זאת הסדר היומיומי באגף תלוי בשיתוף פעולה של האסירים. ספרקס ובוטומס (1995) טענו שסדר בבתי סוהר אינו מתקיים בכוח בלבד אלא נשען על תחושת האסירים שהמשטר הוגן ושמי שמפעיל אותו ראוי לציות. תחושה זו היא הלגיטימיות: המידה שבה האסיר תופס את הסגל כמכבד, כנגיש וכהוגן בטיפול בבקשותיו.</a:t>
             </a:r>
             <a:endParaRPr lang="he-IL" sz="1200" dirty="0"/>
           </a:p>
-          <a:p>
-            <a:pPr algn="r" marL="342900" indent="-342900">
-              <a:spcAft>
-                <a:spcPts val="800"/>
-              </a:spcAft>
-              <a:buSzPct val="100000"/>
-              <a:buChar char="•"/>
+        </p:txBody>
+      </p:sp>
+      <p:sp>
+        <p:nvSpPr>
+          <p:cNvPr id="6" name="Text 4"/>
+          <p:cNvSpPr txBox="1"/>
+          <p:nvPr/>
+        </p:nvSpPr>
+        <p:spPr>
+          <a:xfrm>
+            <a:off x="685800" y="3017520"/>
+            <a:ext cx="5029200" cy="320040"/>
+          </a:xfrm>
+          <a:prstGeom prst="rect">
+            <a:avLst/>
+          </a:prstGeom>
+          <a:noFill/>
+          <a:ln/>
+        </p:spPr>
+        <p:txBody>
+          <a:bodyPr wrap="square" lIns="0" tIns="0" rIns="0" bIns="0" rtlCol="0" anchor="t"/>
+          <a:lstStyle/>
+          <a:p>
+            <a:pPr rtl="1" algn="r" indent="0" marL="0">
+              <a:buNone/>
+            </a:pPr>
+            <a:r>
+              <a:rPr lang="he-IL" altLang="en-US" sz="1400" b="1" dirty="0">
+                <a:solidFill>
+                  <a:srgbClr val="E8892B"/>
+                </a:solidFill>
+                <a:latin typeface="Arial" pitchFamily="34" charset="0"/>
+                <a:ea typeface="Arial" pitchFamily="34" charset="-122"/>
+                <a:cs typeface="Arial" pitchFamily="34" charset="-120"/>
+              </a:rPr>
+              <a:t>ההקשר הישראלי</a:t>
+            </a:r>
+            <a:endParaRPr lang="he-IL" sz="1400" dirty="0"/>
+          </a:p>
+        </p:txBody>
+      </p:sp>
+      <p:sp>
+        <p:nvSpPr>
+          <p:cNvPr id="7" name="Text 5"/>
+          <p:cNvSpPr txBox="1"/>
+          <p:nvPr/>
+        </p:nvSpPr>
+        <p:spPr>
+          <a:xfrm>
+            <a:off x="685800" y="3383280"/>
+            <a:ext cx="5029200" cy="1188720"/>
+          </a:xfrm>
+          <a:prstGeom prst="rect">
+            <a:avLst/>
+          </a:prstGeom>
+          <a:noFill/>
+          <a:ln/>
+        </p:spPr>
+        <p:txBody>
+          <a:bodyPr wrap="square" lIns="0" tIns="0" rIns="0" bIns="0" rtlCol="0" anchor="t"/>
+          <a:lstStyle/>
+          <a:p>
+            <a:pPr rtl="1" algn="just" indent="0" marL="0">
+              <a:lnSpc>
+                <a:spcPct val="115000"/>
+              </a:lnSpc>
+              <a:buNone/>
             </a:pPr>
             <a:r>
               <a:rPr lang="he-IL" altLang="en-US" sz="1200" dirty="0">
@@ -2390,110 +2517,26 @@
                 <a:ea typeface="Arial" pitchFamily="34" charset="-122"/>
                 <a:cs typeface="Arial" pitchFamily="34" charset="-120"/>
               </a:rPr>
-              <a:t>לגיטימיות: המידה שבה האסיר תופס את הסגל כמכבד, נגיש והוגן בטיפול בבקשותיו.</a:t>
+              <a:t>במאי 2019 כ-80 אחוזים ממקומות הכליאה בישראל היו קטנים מתקן 4.5 מטרים רבועים לאסיר (יכימוביץ-כהן, 2020). על רקע זה נערך בסתיו 2021 סקר תנאי המחיה הראשון בהיקפו בשירות בתי הסוהר, ובו נמצא שהלגיטימיות ממתנת את הקשר בין תנאי המחיה לשביעות הרצון מפעילויות השיקום (ועקנין, 2024). המחקר הנוכחי בוחן מאותו מערך את הקשר הישיר בין רווחה נפשית ללגיטימיות בקרב שפוטים.</a:t>
             </a:r>
             <a:endParaRPr lang="he-IL" sz="1200" dirty="0"/>
           </a:p>
-          <a:p>
-            <a:pPr algn="r" marL="342900" indent="-342900">
-              <a:spcAft>
-                <a:spcPts val="800"/>
-              </a:spcAft>
-              <a:buSzPct val="100000"/>
-              <a:buChar char="•"/>
-            </a:pPr>
-            <a:r>
-              <a:rPr lang="he-IL" altLang="en-US" sz="1200" dirty="0">
-                <a:solidFill>
-                  <a:srgbClr val="22303F"/>
-                </a:solidFill>
-                <a:latin typeface="Arial" pitchFamily="34" charset="0"/>
-                <a:ea typeface="Arial" pitchFamily="34" charset="-122"/>
-                <a:cs typeface="Arial" pitchFamily="34" charset="-120"/>
-              </a:rPr>
-              <a:t>בישראל כ-80% ממקומות הכליאה היו קטנים מתקן 4.5 מ"ר לאסיר במאי 2019 (יכימוביץ-כהן, 2020).</a:t>
-            </a:r>
-            <a:endParaRPr lang="he-IL" sz="1200" dirty="0"/>
-          </a:p>
-          <a:p>
-            <a:pPr algn="r" marL="342900" indent="-342900">
-              <a:spcAft>
-                <a:spcPts val="800"/>
-              </a:spcAft>
-              <a:buSzPct val="100000"/>
-              <a:buChar char="•"/>
-            </a:pPr>
-            <a:r>
-              <a:rPr lang="he-IL" altLang="en-US" sz="1200" dirty="0">
-                <a:solidFill>
-                  <a:srgbClr val="22303F"/>
-                </a:solidFill>
-                <a:latin typeface="Arial" pitchFamily="34" charset="0"/>
-                <a:ea typeface="Arial" pitchFamily="34" charset="-122"/>
-                <a:cs typeface="Arial" pitchFamily="34" charset="-120"/>
-              </a:rPr>
-              <a:t>בסתיו 2021 נערך סקר תנאי המחיה הראשון בהיקפו בשב"ס: 2,363 שפוטים ו-1,427 עצורים (ועקנין, 2024).</a:t>
-            </a:r>
-            <a:endParaRPr lang="he-IL" sz="1200" dirty="0"/>
-          </a:p>
-          <a:p>
-            <a:pPr algn="r" marL="342900" indent="-342900">
-              <a:spcAft>
-                <a:spcPts val="800"/>
-              </a:spcAft>
-              <a:buSzPct val="100000"/>
-              <a:buChar char="•"/>
-            </a:pPr>
-            <a:r>
-              <a:rPr lang="he-IL" altLang="en-US" sz="1200" dirty="0">
-                <a:solidFill>
-                  <a:srgbClr val="22303F"/>
-                </a:solidFill>
-                <a:latin typeface="Arial" pitchFamily="34" charset="0"/>
-                <a:ea typeface="Arial" pitchFamily="34" charset="-122"/>
-                <a:cs typeface="Arial" pitchFamily="34" charset="-120"/>
-              </a:rPr>
-              <a:t>הסקר מצא שהלגיטימיות ממתנת את הקשר בין תנאי המחיה לשביעות הרצון מפעילויות השיקום.</a:t>
-            </a:r>
-            <a:endParaRPr lang="he-IL" sz="1200" dirty="0"/>
-          </a:p>
-          <a:p>
-            <a:pPr algn="r" marL="342900" indent="-342900">
-              <a:spcAft>
-                <a:spcPts val="800"/>
-              </a:spcAft>
-              <a:buSzPct val="100000"/>
-              <a:buChar char="•"/>
-            </a:pPr>
-            <a:r>
-              <a:rPr lang="he-IL" altLang="en-US" sz="1200" dirty="0">
-                <a:solidFill>
-                  <a:srgbClr val="22303F"/>
-                </a:solidFill>
-                <a:latin typeface="Arial" pitchFamily="34" charset="0"/>
-                <a:ea typeface="Arial" pitchFamily="34" charset="-122"/>
-                <a:cs typeface="Arial" pitchFamily="34" charset="-120"/>
-              </a:rPr>
-              <a:t>המחקר הנוכחי בוחן חוט אחד מאותו מערך: הקשר בין רווחה נפשית ללגיטימיות בקרב שפוטים.</a:t>
-            </a:r>
-            <a:endParaRPr lang="he-IL" sz="1200" dirty="0"/>
-          </a:p>
-        </p:txBody>
-      </p:sp>
-      <p:sp>
-        <p:nvSpPr>
-          <p:cNvPr id="5" name="Shape 3"/>
+        </p:txBody>
+      </p:sp>
+      <p:sp>
+        <p:nvSpPr>
+          <p:cNvPr id="8" name="Shape 6"/>
           <p:cNvSpPr/>
           <p:nvPr/>
         </p:nvSpPr>
         <p:spPr>
           <a:xfrm>
-            <a:off x="6126480" y="1188720"/>
-            <a:ext cx="2560320" cy="1005840"/>
+            <a:off x="6217920" y="1051560"/>
+            <a:ext cx="2468880" cy="1024128"/>
           </a:xfrm>
           <a:prstGeom prst="roundRect">
             <a:avLst>
-              <a:gd name="adj" fmla="val 9091"/>
+              <a:gd name="adj" fmla="val 8929"/>
             </a:avLst>
           </a:prstGeom>
           <a:solidFill>
@@ -2509,14 +2552,14 @@
       </p:sp>
       <p:sp>
         <p:nvSpPr>
-          <p:cNvPr id="6" name="Text 4"/>
-          <p:cNvSpPr txBox="1"/>
-          <p:nvPr/>
-        </p:nvSpPr>
-        <p:spPr>
-          <a:xfrm>
-            <a:off x="6217920" y="1261872"/>
-            <a:ext cx="2377440" cy="548640"/>
+          <p:cNvPr id="9" name="Text 7"/>
+          <p:cNvSpPr txBox="1"/>
+          <p:nvPr/>
+        </p:nvSpPr>
+        <p:spPr>
+          <a:xfrm>
+            <a:off x="6309360" y="1124712"/>
+            <a:ext cx="2286000" cy="548640"/>
           </a:xfrm>
           <a:prstGeom prst="rect">
             <a:avLst/>
@@ -2548,14 +2591,14 @@
       </p:sp>
       <p:sp>
         <p:nvSpPr>
-          <p:cNvPr id="7" name="Text 5"/>
-          <p:cNvSpPr txBox="1"/>
-          <p:nvPr/>
-        </p:nvSpPr>
-        <p:spPr>
-          <a:xfrm>
-            <a:off x="6217920" y="1810512"/>
-            <a:ext cx="2377440" cy="320040"/>
+          <p:cNvPr id="10" name="Text 8"/>
+          <p:cNvSpPr txBox="1"/>
+          <p:nvPr/>
+        </p:nvSpPr>
+        <p:spPr>
+          <a:xfrm>
+            <a:off x="6309360" y="1691640"/>
+            <a:ext cx="2286000" cy="320040"/>
           </a:xfrm>
           <a:prstGeom prst="rect">
             <a:avLst/>
@@ -2579,7 +2622,7 @@
                 <a:ea typeface="Arial" pitchFamily="34" charset="-122"/>
                 <a:cs typeface="Arial" pitchFamily="34" charset="-120"/>
               </a:rPr>
-              <a:t>משתתפים בסקר המקורי</a:t>
+              <a:t>משתתפים בסקר שב"ס 2021</a:t>
             </a:r>
             <a:endParaRPr lang="he-IL" sz="1100" dirty="0"/>
           </a:p>
@@ -2587,18 +2630,18 @@
       </p:sp>
       <p:sp>
         <p:nvSpPr>
-          <p:cNvPr id="8" name="Shape 6"/>
+          <p:cNvPr id="11" name="Shape 9"/>
           <p:cNvSpPr/>
           <p:nvPr/>
         </p:nvSpPr>
         <p:spPr>
           <a:xfrm>
-            <a:off x="6126480" y="2377440"/>
-            <a:ext cx="2560320" cy="1005840"/>
+            <a:off x="6217920" y="2304288"/>
+            <a:ext cx="2468880" cy="1024128"/>
           </a:xfrm>
           <a:prstGeom prst="roundRect">
             <a:avLst>
-              <a:gd name="adj" fmla="val 9091"/>
+              <a:gd name="adj" fmla="val 8929"/>
             </a:avLst>
           </a:prstGeom>
           <a:solidFill>
@@ -2614,14 +2657,14 @@
       </p:sp>
       <p:sp>
         <p:nvSpPr>
-          <p:cNvPr id="9" name="Text 7"/>
-          <p:cNvSpPr txBox="1"/>
-          <p:nvPr/>
-        </p:nvSpPr>
-        <p:spPr>
-          <a:xfrm>
-            <a:off x="6217920" y="2450592"/>
-            <a:ext cx="2377440" cy="548640"/>
+          <p:cNvPr id="12" name="Text 10"/>
+          <p:cNvSpPr txBox="1"/>
+          <p:nvPr/>
+        </p:nvSpPr>
+        <p:spPr>
+          <a:xfrm>
+            <a:off x="6309360" y="2377440"/>
+            <a:ext cx="2286000" cy="548640"/>
           </a:xfrm>
           <a:prstGeom prst="rect">
             <a:avLst/>
@@ -2653,14 +2696,14 @@
       </p:sp>
       <p:sp>
         <p:nvSpPr>
-          <p:cNvPr id="10" name="Text 8"/>
-          <p:cNvSpPr txBox="1"/>
-          <p:nvPr/>
-        </p:nvSpPr>
-        <p:spPr>
-          <a:xfrm>
-            <a:off x="6217920" y="2999232"/>
-            <a:ext cx="2377440" cy="320040"/>
+          <p:cNvPr id="13" name="Text 11"/>
+          <p:cNvSpPr txBox="1"/>
+          <p:nvPr/>
+        </p:nvSpPr>
+        <p:spPr>
+          <a:xfrm>
+            <a:off x="6309360" y="2944368"/>
+            <a:ext cx="2286000" cy="320040"/>
           </a:xfrm>
           <a:prstGeom prst="rect">
             <a:avLst/>
@@ -2692,18 +2735,18 @@
       </p:sp>
       <p:sp>
         <p:nvSpPr>
-          <p:cNvPr id="11" name="Shape 9"/>
+          <p:cNvPr id="14" name="Shape 12"/>
           <p:cNvSpPr/>
           <p:nvPr/>
         </p:nvSpPr>
         <p:spPr>
           <a:xfrm>
-            <a:off x="6126480" y="3566160"/>
-            <a:ext cx="2560320" cy="1005840"/>
+            <a:off x="6217920" y="3547872"/>
+            <a:ext cx="2468880" cy="1024128"/>
           </a:xfrm>
           <a:prstGeom prst="roundRect">
             <a:avLst>
-              <a:gd name="adj" fmla="val 9091"/>
+              <a:gd name="adj" fmla="val 8929"/>
             </a:avLst>
           </a:prstGeom>
           <a:solidFill>
@@ -2719,14 +2762,14 @@
       </p:sp>
       <p:sp>
         <p:nvSpPr>
-          <p:cNvPr id="12" name="Text 10"/>
-          <p:cNvSpPr txBox="1"/>
-          <p:nvPr/>
-        </p:nvSpPr>
-        <p:spPr>
-          <a:xfrm>
-            <a:off x="6217920" y="3639312"/>
-            <a:ext cx="2377440" cy="548640"/>
+          <p:cNvPr id="15" name="Text 13"/>
+          <p:cNvSpPr txBox="1"/>
+          <p:nvPr/>
+        </p:nvSpPr>
+        <p:spPr>
+          <a:xfrm>
+            <a:off x="6309360" y="3621024"/>
+            <a:ext cx="2286000" cy="548640"/>
           </a:xfrm>
           <a:prstGeom prst="rect">
             <a:avLst/>
@@ -2758,14 +2801,14 @@
       </p:sp>
       <p:sp>
         <p:nvSpPr>
-          <p:cNvPr id="13" name="Text 11"/>
-          <p:cNvSpPr txBox="1"/>
-          <p:nvPr/>
-        </p:nvSpPr>
-        <p:spPr>
-          <a:xfrm>
-            <a:off x="6217920" y="4187952"/>
-            <a:ext cx="2377440" cy="320040"/>
+          <p:cNvPr id="16" name="Text 14"/>
+          <p:cNvSpPr txBox="1"/>
+          <p:nvPr/>
+        </p:nvSpPr>
+        <p:spPr>
+          <a:xfrm>
+            <a:off x="6309360" y="4187952"/>
+            <a:ext cx="2286000" cy="320040"/>
           </a:xfrm>
           <a:prstGeom prst="rect">
             <a:avLst/>
@@ -2797,14 +2840,14 @@
       </p:sp>
       <p:sp>
         <p:nvSpPr>
-          <p:cNvPr id="14" name="Text 12"/>
+          <p:cNvPr id="17" name="Text 15"/>
           <p:cNvSpPr txBox="1"/>
           <p:nvPr/>
         </p:nvSpPr>
         <p:spPr>
           <a:xfrm>
             <a:off x="457200" y="4754880"/>
-            <a:ext cx="6400800" cy="274320"/>
+            <a:ext cx="6858000" cy="274320"/>
           </a:xfrm>
           <a:prstGeom prst="rect">
             <a:avLst/>
@@ -2828,7 +2871,7 @@
                 <a:ea typeface="Arial" pitchFamily="34" charset="-122"/>
                 <a:cs typeface="Arial" pitchFamily="34" charset="-120"/>
               </a:rPr>
-              <a:t>רווחה נפשית ולגיטימיות הסגל בקרב אסירים שפוטים</a:t>
+              <a:t>רווחה נפשית ותפיסת הלגיטימיות של סגל הכליאה בקרב אסירים שפוטים בישראל</a:t>
             </a:r>
             <a:endParaRPr lang="he-IL" sz="1000" dirty="0"/>
           </a:p>
@@ -2836,7 +2879,7 @@
       </p:sp>
       <p:sp>
         <p:nvSpPr>
-          <p:cNvPr id="15" name="Text 13"/>
+          <p:cNvPr id="18" name="Text 16"/>
           <p:cNvSpPr txBox="1"/>
           <p:nvPr/>
         </p:nvSpPr>
@@ -2913,8 +2956,8 @@
         </p:nvSpPr>
         <p:spPr>
           <a:xfrm>
-            <a:off x="457200" y="320040"/>
-            <a:ext cx="8229600" cy="731520"/>
+            <a:off x="457200" y="274320"/>
+            <a:ext cx="8229600" cy="640080"/>
           </a:xfrm>
           <a:prstGeom prst="rect">
             <a:avLst/>
@@ -2930,7 +2973,7 @@
               <a:buNone/>
             </a:pPr>
             <a:r>
-              <a:rPr lang="he-IL" altLang="en-US" sz="3200" b="1" dirty="0">
+              <a:rPr lang="he-IL" altLang="en-US" sz="3000" b="1" dirty="0">
                 <a:solidFill>
                   <a:srgbClr val="1F3A5F"/>
                 </a:solidFill>
@@ -2940,7 +2983,7 @@
               </a:rPr>
               <a:t>סקירת ספרות</a:t>
             </a:r>
-            <a:endParaRPr lang="he-IL" sz="3200" dirty="0"/>
+            <a:endParaRPr lang="he-IL" sz="3000" dirty="0"/>
           </a:p>
         </p:txBody>
       </p:sp>
@@ -2952,12 +2995,12 @@
         </p:nvSpPr>
         <p:spPr>
           <a:xfrm>
-            <a:off x="457200" y="1188720"/>
-            <a:ext cx="8229600" cy="603504"/>
+            <a:off x="457200" y="1051560"/>
+            <a:ext cx="8229600" cy="1691640"/>
           </a:xfrm>
           <a:prstGeom prst="roundRect">
             <a:avLst>
-              <a:gd name="adj" fmla="val 12121"/>
+              <a:gd name="adj" fmla="val 5405"/>
             </a:avLst>
           </a:prstGeom>
           <a:solidFill>
@@ -2973,160 +3016,99 @@
       </p:sp>
       <p:sp>
         <p:nvSpPr>
-          <p:cNvPr id="4" name="Shape 2"/>
+          <p:cNvPr id="4" name="Text 2"/>
+          <p:cNvSpPr txBox="1"/>
+          <p:nvPr/>
+        </p:nvSpPr>
+        <p:spPr>
+          <a:xfrm>
+            <a:off x="685800" y="1161288"/>
+            <a:ext cx="7772400" cy="320040"/>
+          </a:xfrm>
+          <a:prstGeom prst="rect">
+            <a:avLst/>
+          </a:prstGeom>
+          <a:noFill/>
+          <a:ln/>
+        </p:spPr>
+        <p:txBody>
+          <a:bodyPr wrap="square" lIns="0" tIns="0" rIns="0" bIns="0" rtlCol="0" anchor="t"/>
+          <a:lstStyle/>
+          <a:p>
+            <a:pPr rtl="1" algn="r" indent="0" marL="0">
+              <a:buNone/>
+            </a:pPr>
+            <a:r>
+              <a:rPr lang="he-IL" altLang="en-US" sz="1400" b="1" dirty="0">
+                <a:solidFill>
+                  <a:srgbClr val="E8892B"/>
+                </a:solidFill>
+                <a:latin typeface="Arial" pitchFamily="34" charset="0"/>
+                <a:ea typeface="Arial" pitchFamily="34" charset="-122"/>
+                <a:cs typeface="Arial" pitchFamily="34" charset="-120"/>
+              </a:rPr>
+              <a:t>הסתגלות למאסר ורווחה נפשית</a:t>
+            </a:r>
+            <a:endParaRPr lang="he-IL" sz="1400" dirty="0"/>
+          </a:p>
+        </p:txBody>
+      </p:sp>
+      <p:sp>
+        <p:nvSpPr>
+          <p:cNvPr id="5" name="Text 3"/>
+          <p:cNvSpPr txBox="1"/>
+          <p:nvPr/>
+        </p:nvSpPr>
+        <p:spPr>
+          <a:xfrm>
+            <a:off x="685800" y="1508760"/>
+            <a:ext cx="7772400" cy="1188720"/>
+          </a:xfrm>
+          <a:prstGeom prst="rect">
+            <a:avLst/>
+          </a:prstGeom>
+          <a:noFill/>
+          <a:ln/>
+        </p:spPr>
+        <p:txBody>
+          <a:bodyPr wrap="square" lIns="0" tIns="0" rIns="0" bIns="0" rtlCol="0" anchor="t"/>
+          <a:lstStyle/>
+          <a:p>
+            <a:pPr rtl="1" algn="just" indent="0" marL="0">
+              <a:lnSpc>
+                <a:spcPct val="115000"/>
+              </a:lnSpc>
+              <a:buNone/>
+            </a:pPr>
+            <a:r>
+              <a:rPr lang="he-IL" altLang="en-US" sz="1150" dirty="0">
+                <a:solidFill>
+                  <a:srgbClr val="22303F"/>
+                </a:solidFill>
+                <a:latin typeface="Arial" pitchFamily="34" charset="0"/>
+                <a:ea typeface="Arial" pitchFamily="34" charset="-122"/>
+                <a:cs typeface="Arial" pitchFamily="34" charset="-120"/>
+              </a:rPr>
+              <a:t>הספרות עברה מתיאור כללי של כאבי המאסר לבחינה של ההבדלים בין בתי סוהר. אוטי וליבלינג (2024) זיהו על בסיס 518 סקרי איכות חיים באנגליה שמתחת לסף של 3.05 ביחסי סגל ואסירים עולים בחדות שיעורי האלימות והפגיעה העצמית, וון גינקן ואחרים (2019) מצאו בקרב 4,538 אסירים בהולנד שתפיסות אישיות של אוטונומיה וביטחון קשורות לרווחה. במערך אורך באוסטרליה הראו סרג'נט ואחרים (2026) שצדק פרוצדורלי מעלה את הרווחה הנפשית, ושהיחסים עם הסגל הם המנגנון המתווך.</a:t>
+            </a:r>
+            <a:endParaRPr lang="he-IL" sz="1150" dirty="0"/>
+          </a:p>
+        </p:txBody>
+      </p:sp>
+      <p:sp>
+        <p:nvSpPr>
+          <p:cNvPr id="6" name="Shape 4"/>
           <p:cNvSpPr/>
           <p:nvPr/>
         </p:nvSpPr>
         <p:spPr>
           <a:xfrm>
-            <a:off x="8183880" y="1325880"/>
-            <a:ext cx="329184" cy="329184"/>
-          </a:xfrm>
-          <a:prstGeom prst="ellipse">
-            <a:avLst/>
-          </a:prstGeom>
-          <a:solidFill>
-            <a:srgbClr val="E8892B"/>
-          </a:solidFill>
-          <a:ln w="12700">
-            <a:solidFill>
-              <a:srgbClr val="E8892B"/>
-            </a:solidFill>
-            <a:prstDash val="solid"/>
-          </a:ln>
-        </p:spPr>
-      </p:sp>
-      <p:sp>
-        <p:nvSpPr>
-          <p:cNvPr id="5" name="Text 3"/>
-          <p:cNvSpPr txBox="1"/>
-          <p:nvPr/>
-        </p:nvSpPr>
-        <p:spPr>
-          <a:xfrm>
-            <a:off x="8183880" y="1325880"/>
-            <a:ext cx="329184" cy="329184"/>
-          </a:xfrm>
-          <a:prstGeom prst="rect">
-            <a:avLst/>
-          </a:prstGeom>
-          <a:noFill/>
-          <a:ln/>
-        </p:spPr>
-        <p:txBody>
-          <a:bodyPr wrap="square" lIns="0" tIns="0" rIns="0" bIns="0" rtlCol="0" anchor="ctr"/>
-          <a:lstStyle/>
-          <a:p>
-            <a:pPr algn="ctr" indent="0" marL="0">
-              <a:buNone/>
-            </a:pPr>
-            <a:r>
-              <a:rPr lang="en-US" sz="1200" b="1" dirty="0">
-                <a:solidFill>
-                  <a:srgbClr val="FFFFFF"/>
-                </a:solidFill>
-                <a:latin typeface="Arial" pitchFamily="34" charset="0"/>
-                <a:ea typeface="Arial" pitchFamily="34" charset="-122"/>
-                <a:cs typeface="Arial" pitchFamily="34" charset="-120"/>
-              </a:rPr>
-              <a:t>1</a:t>
-            </a:r>
-            <a:endParaRPr lang="en-US" sz="1200" dirty="0"/>
-          </a:p>
-        </p:txBody>
-      </p:sp>
-      <p:sp>
-        <p:nvSpPr>
-          <p:cNvPr id="6" name="Text 4"/>
-          <p:cNvSpPr txBox="1"/>
-          <p:nvPr/>
-        </p:nvSpPr>
-        <p:spPr>
-          <a:xfrm>
-            <a:off x="5989320" y="1261872"/>
-            <a:ext cx="2103120" cy="457200"/>
-          </a:xfrm>
-          <a:prstGeom prst="rect">
-            <a:avLst/>
-          </a:prstGeom>
-          <a:noFill/>
-          <a:ln/>
-        </p:spPr>
-        <p:txBody>
-          <a:bodyPr wrap="square" lIns="0" tIns="0" rIns="0" bIns="0" rtlCol="0" anchor="ctr"/>
-          <a:lstStyle/>
-          <a:p>
-            <a:pPr rtl="1" algn="r" indent="0" marL="0">
-              <a:buNone/>
-            </a:pPr>
-            <a:r>
-              <a:rPr lang="en-US" sz="1200" b="1" dirty="0">
-                <a:solidFill>
-                  <a:srgbClr val="1F3A5F"/>
-                </a:solidFill>
-                <a:latin typeface="Arial" pitchFamily="34" charset="0"/>
-                <a:ea typeface="Arial" pitchFamily="34" charset="-122"/>
-                <a:cs typeface="Arial" pitchFamily="34" charset="-120"/>
-              </a:rPr>
-              <a:t>ועקנין (2024)</a:t>
-            </a:r>
-            <a:endParaRPr lang="en-US" sz="1200" dirty="0"/>
-          </a:p>
-        </p:txBody>
-      </p:sp>
-      <p:sp>
-        <p:nvSpPr>
-          <p:cNvPr id="7" name="Text 5"/>
-          <p:cNvSpPr txBox="1"/>
-          <p:nvPr/>
-        </p:nvSpPr>
-        <p:spPr>
-          <a:xfrm>
-            <a:off x="640080" y="1243584"/>
-            <a:ext cx="5257800" cy="502920"/>
-          </a:xfrm>
-          <a:prstGeom prst="rect">
-            <a:avLst/>
-          </a:prstGeom>
-          <a:noFill/>
-          <a:ln/>
-        </p:spPr>
-        <p:txBody>
-          <a:bodyPr wrap="square" lIns="0" tIns="0" rIns="0" bIns="0" rtlCol="0" anchor="ctr"/>
-          <a:lstStyle/>
-          <a:p>
-            <a:pPr rtl="1" algn="r" indent="0" marL="0">
-              <a:buNone/>
-            </a:pPr>
-            <a:r>
-              <a:rPr lang="he-IL" altLang="en-US" sz="1150" dirty="0">
-                <a:solidFill>
-                  <a:srgbClr val="22303F"/>
-                </a:solidFill>
-                <a:latin typeface="Arial" pitchFamily="34" charset="0"/>
-                <a:ea typeface="Arial" pitchFamily="34" charset="-122"/>
-                <a:cs typeface="Arial" pitchFamily="34" charset="-120"/>
-              </a:rPr>
-              <a:t>סקר שב"ס, 3,790 כלואים: הלגיטימיות ממתנת את הקשר בין תנאי מחיה לשביעות רצון משיקום; שפוטים גבוהים מעצורים בלגיטימיות.</a:t>
-            </a:r>
-            <a:endParaRPr lang="he-IL" sz="1150" dirty="0"/>
-          </a:p>
-        </p:txBody>
-      </p:sp>
-      <p:sp>
-        <p:nvSpPr>
-          <p:cNvPr id="8" name="Shape 6"/>
-          <p:cNvSpPr/>
-          <p:nvPr/>
-        </p:nvSpPr>
-        <p:spPr>
-          <a:xfrm>
-            <a:off x="457200" y="1883664"/>
-            <a:ext cx="8229600" cy="603504"/>
+            <a:off x="457200" y="2880360"/>
+            <a:ext cx="8229600" cy="1737360"/>
           </a:xfrm>
           <a:prstGeom prst="roundRect">
             <a:avLst>
-              <a:gd name="adj" fmla="val 12121"/>
+              <a:gd name="adj" fmla="val 5263"/>
             </a:avLst>
           </a:prstGeom>
           <a:solidFill>
@@ -3134,7 +3116,7 @@
           </a:solidFill>
           <a:ln w="12700">
             <a:solidFill>
-              <a:srgbClr val="EAF0F7"/>
+              <a:srgbClr val="C9D6E4"/>
             </a:solidFill>
             <a:prstDash val="solid"/>
           </a:ln>
@@ -3142,695 +3124,127 @@
       </p:sp>
       <p:sp>
         <p:nvSpPr>
-          <p:cNvPr id="9" name="Shape 7"/>
-          <p:cNvSpPr/>
-          <p:nvPr/>
-        </p:nvSpPr>
-        <p:spPr>
-          <a:xfrm>
-            <a:off x="8183880" y="2020824"/>
-            <a:ext cx="329184" cy="329184"/>
-          </a:xfrm>
-          <a:prstGeom prst="ellipse">
-            <a:avLst/>
-          </a:prstGeom>
-          <a:solidFill>
-            <a:srgbClr val="E8892B"/>
-          </a:solidFill>
-          <a:ln w="12700">
-            <a:solidFill>
-              <a:srgbClr val="E8892B"/>
-            </a:solidFill>
-            <a:prstDash val="solid"/>
-          </a:ln>
-        </p:spPr>
+          <p:cNvPr id="7" name="Text 5"/>
+          <p:cNvSpPr txBox="1"/>
+          <p:nvPr/>
+        </p:nvSpPr>
+        <p:spPr>
+          <a:xfrm>
+            <a:off x="685800" y="2990088"/>
+            <a:ext cx="7772400" cy="320040"/>
+          </a:xfrm>
+          <a:prstGeom prst="rect">
+            <a:avLst/>
+          </a:prstGeom>
+          <a:noFill/>
+          <a:ln/>
+        </p:spPr>
+        <p:txBody>
+          <a:bodyPr wrap="square" lIns="0" tIns="0" rIns="0" bIns="0" rtlCol="0" anchor="t"/>
+          <a:lstStyle/>
+          <a:p>
+            <a:pPr rtl="1" algn="r" indent="0" marL="0">
+              <a:buNone/>
+            </a:pPr>
+            <a:r>
+              <a:rPr lang="he-IL" altLang="en-US" sz="1400" b="1" dirty="0">
+                <a:solidFill>
+                  <a:srgbClr val="E8892B"/>
+                </a:solidFill>
+                <a:latin typeface="Arial" pitchFamily="34" charset="0"/>
+                <a:ea typeface="Arial" pitchFamily="34" charset="-122"/>
+                <a:cs typeface="Arial" pitchFamily="34" charset="-120"/>
+              </a:rPr>
+              <a:t>לגיטימיות של סגל הכליאה</a:t>
+            </a:r>
+            <a:endParaRPr lang="he-IL" sz="1400" dirty="0"/>
+          </a:p>
+        </p:txBody>
+      </p:sp>
+      <p:sp>
+        <p:nvSpPr>
+          <p:cNvPr id="8" name="Text 6"/>
+          <p:cNvSpPr txBox="1"/>
+          <p:nvPr/>
+        </p:nvSpPr>
+        <p:spPr>
+          <a:xfrm>
+            <a:off x="685800" y="3337560"/>
+            <a:ext cx="7772400" cy="1234440"/>
+          </a:xfrm>
+          <a:prstGeom prst="rect">
+            <a:avLst/>
+          </a:prstGeom>
+          <a:noFill/>
+          <a:ln/>
+        </p:spPr>
+        <p:txBody>
+          <a:bodyPr wrap="square" lIns="0" tIns="0" rIns="0" bIns="0" rtlCol="0" anchor="t"/>
+          <a:lstStyle/>
+          <a:p>
+            <a:pPr rtl="1" algn="just" indent="0" marL="0">
+              <a:lnSpc>
+                <a:spcPct val="115000"/>
+              </a:lnSpc>
+              <a:buNone/>
+            </a:pPr>
+            <a:r>
+              <a:rPr lang="he-IL" altLang="en-US" sz="1150" dirty="0">
+                <a:solidFill>
+                  <a:srgbClr val="22303F"/>
+                </a:solidFill>
+                <a:latin typeface="Arial" pitchFamily="34" charset="0"/>
+                <a:ea typeface="Arial" pitchFamily="34" charset="-122"/>
+                <a:cs typeface="Arial" pitchFamily="34" charset="-120"/>
+              </a:rPr>
+              <a:t>ברנטון-סמית ומקארתי (2016) ניתחו סקר של יותר מ-3,000 אסירים באנגליה ובוויילס ומצאו שההוגנות הפרוצדורלית היא המנבא החזק ביותר של לגיטימיות, ופרנקה ואחרים (2010) הראו בניסוי אקראי שדלות סביבתית וחוויות שליליות הן שמכרסמות בלגיטימיות במהלך המאסר. בישראל מצא ועקנין (2024) לגיטימיות גבוהה יחסית, גבוהה יותר בקרב שפוטים מאשר בקרב עצורים, והציע לראות בה כלי ניהולי באגף. הקשר הישיר בין רווחה נפשית ללגיטימיות בקרב שפוטים טרם נבחן, וזהו הפער שהמחקר הנוכחי מבקש למלא.</a:t>
+            </a:r>
+            <a:endParaRPr lang="he-IL" sz="1150" dirty="0"/>
+          </a:p>
+        </p:txBody>
+      </p:sp>
+      <p:sp>
+        <p:nvSpPr>
+          <p:cNvPr id="9" name="Text 7"/>
+          <p:cNvSpPr txBox="1"/>
+          <p:nvPr/>
+        </p:nvSpPr>
+        <p:spPr>
+          <a:xfrm>
+            <a:off x="457200" y="4754880"/>
+            <a:ext cx="6858000" cy="274320"/>
+          </a:xfrm>
+          <a:prstGeom prst="rect">
+            <a:avLst/>
+          </a:prstGeom>
+          <a:noFill/>
+          <a:ln/>
+        </p:spPr>
+        <p:txBody>
+          <a:bodyPr wrap="square" lIns="0" tIns="0" rIns="0" bIns="0" rtlCol="0" anchor="t"/>
+          <a:lstStyle/>
+          <a:p>
+            <a:pPr rtl="1" algn="r" indent="0" marL="0">
+              <a:buNone/>
+            </a:pPr>
+            <a:r>
+              <a:rPr lang="he-IL" altLang="en-US" sz="1000" dirty="0">
+                <a:solidFill>
+                  <a:srgbClr val="5B6B7C"/>
+                </a:solidFill>
+                <a:latin typeface="Arial" pitchFamily="34" charset="0"/>
+                <a:ea typeface="Arial" pitchFamily="34" charset="-122"/>
+                <a:cs typeface="Arial" pitchFamily="34" charset="-120"/>
+              </a:rPr>
+              <a:t>רווחה נפשית ותפיסת הלגיטימיות של סגל הכליאה בקרב אסירים שפוטים בישראל</a:t>
+            </a:r>
+            <a:endParaRPr lang="he-IL" sz="1000" dirty="0"/>
+          </a:p>
+        </p:txBody>
       </p:sp>
       <p:sp>
         <p:nvSpPr>
           <p:cNvPr id="10" name="Text 8"/>
-          <p:cNvSpPr txBox="1"/>
-          <p:nvPr/>
-        </p:nvSpPr>
-        <p:spPr>
-          <a:xfrm>
-            <a:off x="8183880" y="2020824"/>
-            <a:ext cx="329184" cy="329184"/>
-          </a:xfrm>
-          <a:prstGeom prst="rect">
-            <a:avLst/>
-          </a:prstGeom>
-          <a:noFill/>
-          <a:ln/>
-        </p:spPr>
-        <p:txBody>
-          <a:bodyPr wrap="square" lIns="0" tIns="0" rIns="0" bIns="0" rtlCol="0" anchor="ctr"/>
-          <a:lstStyle/>
-          <a:p>
-            <a:pPr algn="ctr" indent="0" marL="0">
-              <a:buNone/>
-            </a:pPr>
-            <a:r>
-              <a:rPr lang="en-US" sz="1200" b="1" dirty="0">
-                <a:solidFill>
-                  <a:srgbClr val="FFFFFF"/>
-                </a:solidFill>
-                <a:latin typeface="Arial" pitchFamily="34" charset="0"/>
-                <a:ea typeface="Arial" pitchFamily="34" charset="-122"/>
-                <a:cs typeface="Arial" pitchFamily="34" charset="-120"/>
-              </a:rPr>
-              <a:t>2</a:t>
-            </a:r>
-            <a:endParaRPr lang="en-US" sz="1200" dirty="0"/>
-          </a:p>
-        </p:txBody>
-      </p:sp>
-      <p:sp>
-        <p:nvSpPr>
-          <p:cNvPr id="11" name="Text 9"/>
-          <p:cNvSpPr txBox="1"/>
-          <p:nvPr/>
-        </p:nvSpPr>
-        <p:spPr>
-          <a:xfrm>
-            <a:off x="5989320" y="1956816"/>
-            <a:ext cx="2103120" cy="457200"/>
-          </a:xfrm>
-          <a:prstGeom prst="rect">
-            <a:avLst/>
-          </a:prstGeom>
-          <a:noFill/>
-          <a:ln/>
-        </p:spPr>
-        <p:txBody>
-          <a:bodyPr wrap="square" lIns="0" tIns="0" rIns="0" bIns="0" rtlCol="0" anchor="ctr"/>
-          <a:lstStyle/>
-          <a:p>
-            <a:pPr rtl="1" algn="r" indent="0" marL="0">
-              <a:buNone/>
-            </a:pPr>
-            <a:r>
-              <a:rPr lang="en-US" sz="1200" b="1" dirty="0">
-                <a:solidFill>
-                  <a:srgbClr val="1F3A5F"/>
-                </a:solidFill>
-                <a:latin typeface="Arial" pitchFamily="34" charset="0"/>
-                <a:ea typeface="Arial" pitchFamily="34" charset="-122"/>
-                <a:cs typeface="Arial" pitchFamily="34" charset="-120"/>
-              </a:rPr>
-              <a:t>Sparks &amp; Bottoms (1995)</a:t>
-            </a:r>
-            <a:endParaRPr lang="en-US" sz="1200" dirty="0"/>
-          </a:p>
-        </p:txBody>
-      </p:sp>
-      <p:sp>
-        <p:nvSpPr>
-          <p:cNvPr id="12" name="Text 10"/>
-          <p:cNvSpPr txBox="1"/>
-          <p:nvPr/>
-        </p:nvSpPr>
-        <p:spPr>
-          <a:xfrm>
-            <a:off x="640080" y="1938528"/>
-            <a:ext cx="5257800" cy="502920"/>
-          </a:xfrm>
-          <a:prstGeom prst="rect">
-            <a:avLst/>
-          </a:prstGeom>
-          <a:noFill/>
-          <a:ln/>
-        </p:spPr>
-        <p:txBody>
-          <a:bodyPr wrap="square" lIns="0" tIns="0" rIns="0" bIns="0" rtlCol="0" anchor="ctr"/>
-          <a:lstStyle/>
-          <a:p>
-            <a:pPr rtl="1" algn="r" indent="0" marL="0">
-              <a:buNone/>
-            </a:pPr>
-            <a:r>
-              <a:rPr lang="he-IL" altLang="en-US" sz="1150" dirty="0">
-                <a:solidFill>
-                  <a:srgbClr val="22303F"/>
-                </a:solidFill>
-                <a:latin typeface="Arial" pitchFamily="34" charset="0"/>
-                <a:ea typeface="Arial" pitchFamily="34" charset="-122"/>
-                <a:cs typeface="Arial" pitchFamily="34" charset="-120"/>
-              </a:rPr>
-              <a:t>לגיטימיות בבתי סוהר נבנית מהוגנות פרוצדורלית, סדירות השירות ואיכות אנושית בשגרה.</a:t>
-            </a:r>
-            <a:endParaRPr lang="he-IL" sz="1150" dirty="0"/>
-          </a:p>
-        </p:txBody>
-      </p:sp>
-      <p:sp>
-        <p:nvSpPr>
-          <p:cNvPr id="13" name="Shape 11"/>
-          <p:cNvSpPr/>
-          <p:nvPr/>
-        </p:nvSpPr>
-        <p:spPr>
-          <a:xfrm>
-            <a:off x="457200" y="2578608"/>
-            <a:ext cx="8229600" cy="603504"/>
-          </a:xfrm>
-          <a:prstGeom prst="roundRect">
-            <a:avLst>
-              <a:gd name="adj" fmla="val 12121"/>
-            </a:avLst>
-          </a:prstGeom>
-          <a:solidFill>
-            <a:srgbClr val="EAF0F7"/>
-          </a:solidFill>
-          <a:ln w="12700">
-            <a:solidFill>
-              <a:srgbClr val="EAF0F7"/>
-            </a:solidFill>
-            <a:prstDash val="solid"/>
-          </a:ln>
-        </p:spPr>
-      </p:sp>
-      <p:sp>
-        <p:nvSpPr>
-          <p:cNvPr id="14" name="Shape 12"/>
-          <p:cNvSpPr/>
-          <p:nvPr/>
-        </p:nvSpPr>
-        <p:spPr>
-          <a:xfrm>
-            <a:off x="8183880" y="2715768"/>
-            <a:ext cx="329184" cy="329184"/>
-          </a:xfrm>
-          <a:prstGeom prst="ellipse">
-            <a:avLst/>
-          </a:prstGeom>
-          <a:solidFill>
-            <a:srgbClr val="E8892B"/>
-          </a:solidFill>
-          <a:ln w="12700">
-            <a:solidFill>
-              <a:srgbClr val="E8892B"/>
-            </a:solidFill>
-            <a:prstDash val="solid"/>
-          </a:ln>
-        </p:spPr>
-      </p:sp>
-      <p:sp>
-        <p:nvSpPr>
-          <p:cNvPr id="15" name="Text 13"/>
-          <p:cNvSpPr txBox="1"/>
-          <p:nvPr/>
-        </p:nvSpPr>
-        <p:spPr>
-          <a:xfrm>
-            <a:off x="8183880" y="2715768"/>
-            <a:ext cx="329184" cy="329184"/>
-          </a:xfrm>
-          <a:prstGeom prst="rect">
-            <a:avLst/>
-          </a:prstGeom>
-          <a:noFill/>
-          <a:ln/>
-        </p:spPr>
-        <p:txBody>
-          <a:bodyPr wrap="square" lIns="0" tIns="0" rIns="0" bIns="0" rtlCol="0" anchor="ctr"/>
-          <a:lstStyle/>
-          <a:p>
-            <a:pPr algn="ctr" indent="0" marL="0">
-              <a:buNone/>
-            </a:pPr>
-            <a:r>
-              <a:rPr lang="en-US" sz="1200" b="1" dirty="0">
-                <a:solidFill>
-                  <a:srgbClr val="FFFFFF"/>
-                </a:solidFill>
-                <a:latin typeface="Arial" pitchFamily="34" charset="0"/>
-                <a:ea typeface="Arial" pitchFamily="34" charset="-122"/>
-                <a:cs typeface="Arial" pitchFamily="34" charset="-120"/>
-              </a:rPr>
-              <a:t>3</a:t>
-            </a:r>
-            <a:endParaRPr lang="en-US" sz="1200" dirty="0"/>
-          </a:p>
-        </p:txBody>
-      </p:sp>
-      <p:sp>
-        <p:nvSpPr>
-          <p:cNvPr id="16" name="Text 14"/>
-          <p:cNvSpPr txBox="1"/>
-          <p:nvPr/>
-        </p:nvSpPr>
-        <p:spPr>
-          <a:xfrm>
-            <a:off x="5989320" y="2651760"/>
-            <a:ext cx="2103120" cy="457200"/>
-          </a:xfrm>
-          <a:prstGeom prst="rect">
-            <a:avLst/>
-          </a:prstGeom>
-          <a:noFill/>
-          <a:ln/>
-        </p:spPr>
-        <p:txBody>
-          <a:bodyPr wrap="square" lIns="0" tIns="0" rIns="0" bIns="0" rtlCol="0" anchor="ctr"/>
-          <a:lstStyle/>
-          <a:p>
-            <a:pPr rtl="1" algn="r" indent="0" marL="0">
-              <a:buNone/>
-            </a:pPr>
-            <a:r>
-              <a:rPr lang="en-US" sz="1200" b="1" dirty="0">
-                <a:solidFill>
-                  <a:srgbClr val="1F3A5F"/>
-                </a:solidFill>
-                <a:latin typeface="Arial" pitchFamily="34" charset="0"/>
-                <a:ea typeface="Arial" pitchFamily="34" charset="-122"/>
-                <a:cs typeface="Arial" pitchFamily="34" charset="-120"/>
-              </a:rPr>
-              <a:t>Brunton-Smith &amp; McCarthy (2016)</a:t>
-            </a:r>
-            <a:endParaRPr lang="en-US" sz="1200" dirty="0"/>
-          </a:p>
-        </p:txBody>
-      </p:sp>
-      <p:sp>
-        <p:nvSpPr>
-          <p:cNvPr id="17" name="Text 15"/>
-          <p:cNvSpPr txBox="1"/>
-          <p:nvPr/>
-        </p:nvSpPr>
-        <p:spPr>
-          <a:xfrm>
-            <a:off x="640080" y="2633472"/>
-            <a:ext cx="5257800" cy="502920"/>
-          </a:xfrm>
-          <a:prstGeom prst="rect">
-            <a:avLst/>
-          </a:prstGeom>
-          <a:noFill/>
-          <a:ln/>
-        </p:spPr>
-        <p:txBody>
-          <a:bodyPr wrap="square" lIns="0" tIns="0" rIns="0" bIns="0" rtlCol="0" anchor="ctr"/>
-          <a:lstStyle/>
-          <a:p>
-            <a:pPr rtl="1" algn="r" indent="0" marL="0">
-              <a:buNone/>
-            </a:pPr>
-            <a:r>
-              <a:rPr lang="he-IL" altLang="en-US" sz="1150" dirty="0">
-                <a:solidFill>
-                  <a:srgbClr val="22303F"/>
-                </a:solidFill>
-                <a:latin typeface="Arial" pitchFamily="34" charset="0"/>
-                <a:ea typeface="Arial" pitchFamily="34" charset="-122"/>
-                <a:cs typeface="Arial" pitchFamily="34" charset="-120"/>
-              </a:rPr>
-              <a:t>יותר מ-3,000 אסירים באנגליה: ההוגנות הפרוצדורלית היא המנבא החזק ביותר של לגיטימיות.</a:t>
-            </a:r>
-            <a:endParaRPr lang="he-IL" sz="1150" dirty="0"/>
-          </a:p>
-        </p:txBody>
-      </p:sp>
-      <p:sp>
-        <p:nvSpPr>
-          <p:cNvPr id="18" name="Shape 16"/>
-          <p:cNvSpPr/>
-          <p:nvPr/>
-        </p:nvSpPr>
-        <p:spPr>
-          <a:xfrm>
-            <a:off x="457200" y="3273552"/>
-            <a:ext cx="8229600" cy="603504"/>
-          </a:xfrm>
-          <a:prstGeom prst="roundRect">
-            <a:avLst>
-              <a:gd name="adj" fmla="val 12121"/>
-            </a:avLst>
-          </a:prstGeom>
-          <a:solidFill>
-            <a:srgbClr val="FFFFFF"/>
-          </a:solidFill>
-          <a:ln w="12700">
-            <a:solidFill>
-              <a:srgbClr val="EAF0F7"/>
-            </a:solidFill>
-            <a:prstDash val="solid"/>
-          </a:ln>
-        </p:spPr>
-      </p:sp>
-      <p:sp>
-        <p:nvSpPr>
-          <p:cNvPr id="19" name="Shape 17"/>
-          <p:cNvSpPr/>
-          <p:nvPr/>
-        </p:nvSpPr>
-        <p:spPr>
-          <a:xfrm>
-            <a:off x="8183880" y="3410712"/>
-            <a:ext cx="329184" cy="329184"/>
-          </a:xfrm>
-          <a:prstGeom prst="ellipse">
-            <a:avLst/>
-          </a:prstGeom>
-          <a:solidFill>
-            <a:srgbClr val="E8892B"/>
-          </a:solidFill>
-          <a:ln w="12700">
-            <a:solidFill>
-              <a:srgbClr val="E8892B"/>
-            </a:solidFill>
-            <a:prstDash val="solid"/>
-          </a:ln>
-        </p:spPr>
-      </p:sp>
-      <p:sp>
-        <p:nvSpPr>
-          <p:cNvPr id="20" name="Text 18"/>
-          <p:cNvSpPr txBox="1"/>
-          <p:nvPr/>
-        </p:nvSpPr>
-        <p:spPr>
-          <a:xfrm>
-            <a:off x="8183880" y="3410712"/>
-            <a:ext cx="329184" cy="329184"/>
-          </a:xfrm>
-          <a:prstGeom prst="rect">
-            <a:avLst/>
-          </a:prstGeom>
-          <a:noFill/>
-          <a:ln/>
-        </p:spPr>
-        <p:txBody>
-          <a:bodyPr wrap="square" lIns="0" tIns="0" rIns="0" bIns="0" rtlCol="0" anchor="ctr"/>
-          <a:lstStyle/>
-          <a:p>
-            <a:pPr algn="ctr" indent="0" marL="0">
-              <a:buNone/>
-            </a:pPr>
-            <a:r>
-              <a:rPr lang="en-US" sz="1200" b="1" dirty="0">
-                <a:solidFill>
-                  <a:srgbClr val="FFFFFF"/>
-                </a:solidFill>
-                <a:latin typeface="Arial" pitchFamily="34" charset="0"/>
-                <a:ea typeface="Arial" pitchFamily="34" charset="-122"/>
-                <a:cs typeface="Arial" pitchFamily="34" charset="-120"/>
-              </a:rPr>
-              <a:t>4</a:t>
-            </a:r>
-            <a:endParaRPr lang="en-US" sz="1200" dirty="0"/>
-          </a:p>
-        </p:txBody>
-      </p:sp>
-      <p:sp>
-        <p:nvSpPr>
-          <p:cNvPr id="21" name="Text 19"/>
-          <p:cNvSpPr txBox="1"/>
-          <p:nvPr/>
-        </p:nvSpPr>
-        <p:spPr>
-          <a:xfrm>
-            <a:off x="5989320" y="3346704"/>
-            <a:ext cx="2103120" cy="457200"/>
-          </a:xfrm>
-          <a:prstGeom prst="rect">
-            <a:avLst/>
-          </a:prstGeom>
-          <a:noFill/>
-          <a:ln/>
-        </p:spPr>
-        <p:txBody>
-          <a:bodyPr wrap="square" lIns="0" tIns="0" rIns="0" bIns="0" rtlCol="0" anchor="ctr"/>
-          <a:lstStyle/>
-          <a:p>
-            <a:pPr rtl="1" algn="r" indent="0" marL="0">
-              <a:buNone/>
-            </a:pPr>
-            <a:r>
-              <a:rPr lang="en-US" sz="1200" b="1" dirty="0">
-                <a:solidFill>
-                  <a:srgbClr val="1F3A5F"/>
-                </a:solidFill>
-                <a:latin typeface="Arial" pitchFamily="34" charset="0"/>
-                <a:ea typeface="Arial" pitchFamily="34" charset="-122"/>
-                <a:cs typeface="Arial" pitchFamily="34" charset="-120"/>
-              </a:rPr>
-              <a:t>Sargeant et al. (2026)</a:t>
-            </a:r>
-            <a:endParaRPr lang="en-US" sz="1200" dirty="0"/>
-          </a:p>
-        </p:txBody>
-      </p:sp>
-      <p:sp>
-        <p:nvSpPr>
-          <p:cNvPr id="22" name="Text 20"/>
-          <p:cNvSpPr txBox="1"/>
-          <p:nvPr/>
-        </p:nvSpPr>
-        <p:spPr>
-          <a:xfrm>
-            <a:off x="640080" y="3328416"/>
-            <a:ext cx="5257800" cy="502920"/>
-          </a:xfrm>
-          <a:prstGeom prst="rect">
-            <a:avLst/>
-          </a:prstGeom>
-          <a:noFill/>
-          <a:ln/>
-        </p:spPr>
-        <p:txBody>
-          <a:bodyPr wrap="square" lIns="0" tIns="0" rIns="0" bIns="0" rtlCol="0" anchor="ctr"/>
-          <a:lstStyle/>
-          <a:p>
-            <a:pPr rtl="1" algn="r" indent="0" marL="0">
-              <a:buNone/>
-            </a:pPr>
-            <a:r>
-              <a:rPr lang="he-IL" altLang="en-US" sz="1150" dirty="0">
-                <a:solidFill>
-                  <a:srgbClr val="22303F"/>
-                </a:solidFill>
-                <a:latin typeface="Arial" pitchFamily="34" charset="0"/>
-                <a:ea typeface="Arial" pitchFamily="34" charset="-122"/>
-                <a:cs typeface="Arial" pitchFamily="34" charset="-120"/>
-              </a:rPr>
-              <a:t>מערך אורך באוסטרליה: צדק פרוצדורלי מעלה רווחה נפשית, והיחסים עם הסגל מתווכים את הקשר.</a:t>
-            </a:r>
-            <a:endParaRPr lang="he-IL" sz="1150" dirty="0"/>
-          </a:p>
-        </p:txBody>
-      </p:sp>
-      <p:sp>
-        <p:nvSpPr>
-          <p:cNvPr id="23" name="Shape 21"/>
-          <p:cNvSpPr/>
-          <p:nvPr/>
-        </p:nvSpPr>
-        <p:spPr>
-          <a:xfrm>
-            <a:off x="457200" y="3968496"/>
-            <a:ext cx="8229600" cy="603504"/>
-          </a:xfrm>
-          <a:prstGeom prst="roundRect">
-            <a:avLst>
-              <a:gd name="adj" fmla="val 12121"/>
-            </a:avLst>
-          </a:prstGeom>
-          <a:solidFill>
-            <a:srgbClr val="EAF0F7"/>
-          </a:solidFill>
-          <a:ln w="12700">
-            <a:solidFill>
-              <a:srgbClr val="EAF0F7"/>
-            </a:solidFill>
-            <a:prstDash val="solid"/>
-          </a:ln>
-        </p:spPr>
-      </p:sp>
-      <p:sp>
-        <p:nvSpPr>
-          <p:cNvPr id="24" name="Shape 22"/>
-          <p:cNvSpPr/>
-          <p:nvPr/>
-        </p:nvSpPr>
-        <p:spPr>
-          <a:xfrm>
-            <a:off x="8183880" y="4105656"/>
-            <a:ext cx="329184" cy="329184"/>
-          </a:xfrm>
-          <a:prstGeom prst="ellipse">
-            <a:avLst/>
-          </a:prstGeom>
-          <a:solidFill>
-            <a:srgbClr val="E8892B"/>
-          </a:solidFill>
-          <a:ln w="12700">
-            <a:solidFill>
-              <a:srgbClr val="E8892B"/>
-            </a:solidFill>
-            <a:prstDash val="solid"/>
-          </a:ln>
-        </p:spPr>
-      </p:sp>
-      <p:sp>
-        <p:nvSpPr>
-          <p:cNvPr id="25" name="Text 23"/>
-          <p:cNvSpPr txBox="1"/>
-          <p:nvPr/>
-        </p:nvSpPr>
-        <p:spPr>
-          <a:xfrm>
-            <a:off x="8183880" y="4105656"/>
-            <a:ext cx="329184" cy="329184"/>
-          </a:xfrm>
-          <a:prstGeom prst="rect">
-            <a:avLst/>
-          </a:prstGeom>
-          <a:noFill/>
-          <a:ln/>
-        </p:spPr>
-        <p:txBody>
-          <a:bodyPr wrap="square" lIns="0" tIns="0" rIns="0" bIns="0" rtlCol="0" anchor="ctr"/>
-          <a:lstStyle/>
-          <a:p>
-            <a:pPr algn="ctr" indent="0" marL="0">
-              <a:buNone/>
-            </a:pPr>
-            <a:r>
-              <a:rPr lang="en-US" sz="1200" b="1" dirty="0">
-                <a:solidFill>
-                  <a:srgbClr val="FFFFFF"/>
-                </a:solidFill>
-                <a:latin typeface="Arial" pitchFamily="34" charset="0"/>
-                <a:ea typeface="Arial" pitchFamily="34" charset="-122"/>
-                <a:cs typeface="Arial" pitchFamily="34" charset="-120"/>
-              </a:rPr>
-              <a:t>5</a:t>
-            </a:r>
-            <a:endParaRPr lang="en-US" sz="1200" dirty="0"/>
-          </a:p>
-        </p:txBody>
-      </p:sp>
-      <p:sp>
-        <p:nvSpPr>
-          <p:cNvPr id="26" name="Text 24"/>
-          <p:cNvSpPr txBox="1"/>
-          <p:nvPr/>
-        </p:nvSpPr>
-        <p:spPr>
-          <a:xfrm>
-            <a:off x="5989320" y="4041648"/>
-            <a:ext cx="2103120" cy="457200"/>
-          </a:xfrm>
-          <a:prstGeom prst="rect">
-            <a:avLst/>
-          </a:prstGeom>
-          <a:noFill/>
-          <a:ln/>
-        </p:spPr>
-        <p:txBody>
-          <a:bodyPr wrap="square" lIns="0" tIns="0" rIns="0" bIns="0" rtlCol="0" anchor="ctr"/>
-          <a:lstStyle/>
-          <a:p>
-            <a:pPr rtl="1" algn="r" indent="0" marL="0">
-              <a:buNone/>
-            </a:pPr>
-            <a:r>
-              <a:rPr lang="en-US" sz="1200" b="1" dirty="0">
-                <a:solidFill>
-                  <a:srgbClr val="1F3A5F"/>
-                </a:solidFill>
-                <a:latin typeface="Arial" pitchFamily="34" charset="0"/>
-                <a:ea typeface="Arial" pitchFamily="34" charset="-122"/>
-                <a:cs typeface="Arial" pitchFamily="34" charset="-120"/>
-              </a:rPr>
-              <a:t>Auty &amp; Liebling (2024)</a:t>
-            </a:r>
-            <a:endParaRPr lang="en-US" sz="1200" dirty="0"/>
-          </a:p>
-        </p:txBody>
-      </p:sp>
-      <p:sp>
-        <p:nvSpPr>
-          <p:cNvPr id="27" name="Text 25"/>
-          <p:cNvSpPr txBox="1"/>
-          <p:nvPr/>
-        </p:nvSpPr>
-        <p:spPr>
-          <a:xfrm>
-            <a:off x="640080" y="4023360"/>
-            <a:ext cx="5257800" cy="502920"/>
-          </a:xfrm>
-          <a:prstGeom prst="rect">
-            <a:avLst/>
-          </a:prstGeom>
-          <a:noFill/>
-          <a:ln/>
-        </p:spPr>
-        <p:txBody>
-          <a:bodyPr wrap="square" lIns="0" tIns="0" rIns="0" bIns="0" rtlCol="0" anchor="ctr"/>
-          <a:lstStyle/>
-          <a:p>
-            <a:pPr rtl="1" algn="r" indent="0" marL="0">
-              <a:buNone/>
-            </a:pPr>
-            <a:r>
-              <a:rPr lang="he-IL" altLang="en-US" sz="1150" dirty="0">
-                <a:solidFill>
-                  <a:srgbClr val="22303F"/>
-                </a:solidFill>
-                <a:latin typeface="Arial" pitchFamily="34" charset="0"/>
-                <a:ea typeface="Arial" pitchFamily="34" charset="-122"/>
-                <a:cs typeface="Arial" pitchFamily="34" charset="-120"/>
-              </a:rPr>
-              <a:t>518 סקרי MQPL: מתחת לסף 3.05 ביחסי סגל-אסירים עולים בחדות שיעורי האלימות והפגיעה העצמית.</a:t>
-            </a:r>
-            <a:endParaRPr lang="he-IL" sz="1150" dirty="0"/>
-          </a:p>
-        </p:txBody>
-      </p:sp>
-      <p:sp>
-        <p:nvSpPr>
-          <p:cNvPr id="28" name="Text 26"/>
-          <p:cNvSpPr txBox="1"/>
-          <p:nvPr/>
-        </p:nvSpPr>
-        <p:spPr>
-          <a:xfrm>
-            <a:off x="457200" y="4754880"/>
-            <a:ext cx="6400800" cy="274320"/>
-          </a:xfrm>
-          <a:prstGeom prst="rect">
-            <a:avLst/>
-          </a:prstGeom>
-          <a:noFill/>
-          <a:ln/>
-        </p:spPr>
-        <p:txBody>
-          <a:bodyPr wrap="square" lIns="0" tIns="0" rIns="0" bIns="0" rtlCol="0" anchor="t"/>
-          <a:lstStyle/>
-          <a:p>
-            <a:pPr rtl="1" algn="r" indent="0" marL="0">
-              <a:buNone/>
-            </a:pPr>
-            <a:r>
-              <a:rPr lang="he-IL" altLang="en-US" sz="1000" dirty="0">
-                <a:solidFill>
-                  <a:srgbClr val="5B6B7C"/>
-                </a:solidFill>
-                <a:latin typeface="Arial" pitchFamily="34" charset="0"/>
-                <a:ea typeface="Arial" pitchFamily="34" charset="-122"/>
-                <a:cs typeface="Arial" pitchFamily="34" charset="-120"/>
-              </a:rPr>
-              <a:t>רווחה נפשית ולגיטימיות הסגל בקרב אסירים שפוטים</a:t>
-            </a:r>
-            <a:endParaRPr lang="he-IL" sz="1000" dirty="0"/>
-          </a:p>
-        </p:txBody>
-      </p:sp>
-      <p:sp>
-        <p:nvSpPr>
-          <p:cNvPr id="29" name="Text 27"/>
           <p:cNvSpPr txBox="1"/>
           <p:nvPr/>
         </p:nvSpPr>
@@ -3907,8 +3321,8 @@
         </p:nvSpPr>
         <p:spPr>
           <a:xfrm>
-            <a:off x="457200" y="320040"/>
-            <a:ext cx="8229600" cy="731520"/>
+            <a:off x="457200" y="274320"/>
+            <a:ext cx="8229600" cy="640080"/>
           </a:xfrm>
           <a:prstGeom prst="rect">
             <a:avLst/>
@@ -3924,7 +3338,7 @@
               <a:buNone/>
             </a:pPr>
             <a:r>
-              <a:rPr lang="he-IL" altLang="en-US" sz="3200" b="1" dirty="0">
+              <a:rPr lang="he-IL" altLang="en-US" sz="3000" b="1" dirty="0">
                 <a:solidFill>
                   <a:srgbClr val="1F3A5F"/>
                 </a:solidFill>
@@ -3932,9 +3346,9 @@
                 <a:ea typeface="Arial" pitchFamily="34" charset="-122"/>
                 <a:cs typeface="Arial" pitchFamily="34" charset="-120"/>
               </a:rPr>
-              <a:t>שאלת המחקר</a:t>
-            </a:r>
-            <a:endParaRPr lang="he-IL" sz="3200" dirty="0"/>
+              <a:t>שאלת המחקר והשערת המחקר</a:t>
+            </a:r>
+            <a:endParaRPr lang="he-IL" sz="3000" dirty="0"/>
           </a:p>
         </p:txBody>
       </p:sp>
@@ -3946,12 +3360,12 @@
         </p:nvSpPr>
         <p:spPr>
           <a:xfrm>
-            <a:off x="457200" y="1188720"/>
-            <a:ext cx="8229600" cy="1005840"/>
+            <a:off x="457200" y="1051560"/>
+            <a:ext cx="8229600" cy="914400"/>
           </a:xfrm>
           <a:prstGeom prst="roundRect">
             <a:avLst>
-              <a:gd name="adj" fmla="val 10909"/>
+              <a:gd name="adj" fmla="val 12000"/>
             </a:avLst>
           </a:prstGeom>
           <a:solidFill>
@@ -3973,8 +3387,8 @@
         </p:nvSpPr>
         <p:spPr>
           <a:xfrm>
-            <a:off x="731520" y="1280160"/>
-            <a:ext cx="7680960" cy="822960"/>
+            <a:off x="731520" y="1115568"/>
+            <a:ext cx="7680960" cy="786384"/>
           </a:xfrm>
           <a:prstGeom prst="rect">
             <a:avLst/>
@@ -3990,7 +3404,7 @@
               <a:buNone/>
             </a:pPr>
             <a:r>
-              <a:rPr lang="he-IL" altLang="en-US" sz="1800" b="1" dirty="0">
+              <a:rPr lang="he-IL" altLang="en-US" sz="1700" b="1" dirty="0">
                 <a:solidFill>
                   <a:srgbClr val="FFFFFF"/>
                 </a:solidFill>
@@ -4000,7 +3414,7 @@
               </a:rPr>
               <a:t>באיזו מידה קיים קשר בין רווחה נפשית לבין תפיסת הלגיטימיות של סגל הכליאה בקרב אסירים שפוטים בלבד?</a:t>
             </a:r>
-            <a:endParaRPr lang="he-IL" sz="1800" dirty="0"/>
+            <a:endParaRPr lang="he-IL" sz="1700" dirty="0"/>
           </a:p>
         </p:txBody>
       </p:sp>
@@ -4012,12 +3426,12 @@
         </p:nvSpPr>
         <p:spPr>
           <a:xfrm>
-            <a:off x="6035040" y="2423160"/>
-            <a:ext cx="2651760" cy="2148840"/>
+            <a:off x="4663440" y="2148840"/>
+            <a:ext cx="4023360" cy="2468880"/>
           </a:xfrm>
           <a:prstGeom prst="roundRect">
             <a:avLst>
-              <a:gd name="adj" fmla="val 4255"/>
+              <a:gd name="adj" fmla="val 3704"/>
             </a:avLst>
           </a:prstGeom>
           <a:solidFill>
@@ -4039,8 +3453,8 @@
         </p:nvSpPr>
         <p:spPr>
           <a:xfrm>
-            <a:off x="6217920" y="2542032"/>
-            <a:ext cx="2286000" cy="365760"/>
+            <a:off x="4846320" y="2258568"/>
+            <a:ext cx="3657600" cy="320040"/>
           </a:xfrm>
           <a:prstGeom prst="rect">
             <a:avLst/>
@@ -4064,7 +3478,7 @@
                 <a:ea typeface="Arial" pitchFamily="34" charset="-122"/>
                 <a:cs typeface="Arial" pitchFamily="34" charset="-120"/>
               </a:rPr>
-              <a:t>משתנה תלוי</a:t>
+              <a:t>משתני המחקר</a:t>
             </a:r>
             <a:endParaRPr lang="he-IL" sz="1400" dirty="0"/>
           </a:p>
@@ -4078,8 +3492,8 @@
         </p:nvSpPr>
         <p:spPr>
           <a:xfrm>
-            <a:off x="6217920" y="2926080"/>
-            <a:ext cx="2286000" cy="1554480"/>
+            <a:off x="4846320" y="2606040"/>
+            <a:ext cx="3657600" cy="1965960"/>
           </a:xfrm>
           <a:prstGeom prst="rect">
             <a:avLst/>
@@ -4091,11 +3505,14 @@
           <a:bodyPr wrap="square" lIns="0" tIns="0" rIns="0" bIns="0" rtlCol="0" anchor="t"/>
           <a:lstStyle/>
           <a:p>
-            <a:pPr algn="r" indent="0" marL="0">
-              <a:buNone/>
-            </a:pPr>
-            <a:r>
-              <a:rPr lang="he-IL" altLang="en-US" sz="1200" b="1" dirty="0">
+            <a:pPr rtl="1" algn="just" indent="0" marL="0">
+              <a:lnSpc>
+                <a:spcPct val="115000"/>
+              </a:lnSpc>
+              <a:buNone/>
+            </a:pPr>
+            <a:r>
+              <a:rPr lang="he-IL" altLang="en-US" sz="1150" dirty="0">
                 <a:solidFill>
                   <a:srgbClr val="22303F"/>
                 </a:solidFill>
@@ -4103,26 +3520,9 @@
                 <a:ea typeface="Arial" pitchFamily="34" charset="-122"/>
                 <a:cs typeface="Arial" pitchFamily="34" charset="-120"/>
               </a:rPr>
-              <a:t>לגיטימיות הסגל</a:t>
-            </a:r>
-            <a:endParaRPr lang="he-IL" sz="1200" dirty="0"/>
-          </a:p>
-          <a:p>
-            <a:pPr algn="r" indent="0" marL="0">
-              <a:buNone/>
-            </a:pPr>
-            <a:r>
-              <a:rPr lang="he-IL" altLang="en-US" sz="1200" dirty="0">
-                <a:solidFill>
-                  <a:srgbClr val="22303F"/>
-                </a:solidFill>
-                <a:latin typeface="Arial" pitchFamily="34" charset="0"/>
-                <a:ea typeface="Arial" pitchFamily="34" charset="-122"/>
-                <a:cs typeface="Arial" pitchFamily="34" charset="-120"/>
-              </a:rPr>
-              <a:t>3 פריטים: אפשר לדבר עם הסוהרים, יחס מכבד, טיפול בבקשות. סולם 1 עד 5, α = 0.67</a:t>
-            </a:r>
-            <a:endParaRPr lang="he-IL" sz="1200" dirty="0"/>
+              <a:t>המשתנה התלוי הוא תפיסת הלגיטימיות של הסגל, הנמדדת בשלושה פריטים: האפשרות לדבר עם הסוהרים כשמודאגים או עצובים, היחס המכבד של הסוהרים ושביעות הרצון מהטיפול בבקשות (α = 0.67). המשתנה הבלתי תלוי הוא הרווחה הנפשית, הנמדדת בחמישה פריטים של בריאות גופנית ונפשית, שיפור בבריאות מאז המאסר, שמחה ושביעות רצון מהחיים (α = 0.81). שני הסולמות בטווח של 1 עד 5.</a:t>
+            </a:r>
+            <a:endParaRPr lang="he-IL" sz="1150" dirty="0"/>
           </a:p>
         </p:txBody>
       </p:sp>
@@ -4134,20 +3534,20 @@
         </p:nvSpPr>
         <p:spPr>
           <a:xfrm>
-            <a:off x="3246120" y="2423160"/>
-            <a:ext cx="2651760" cy="2148840"/>
+            <a:off x="457200" y="2148840"/>
+            <a:ext cx="4023360" cy="2468880"/>
           </a:xfrm>
           <a:prstGeom prst="roundRect">
             <a:avLst>
-              <a:gd name="adj" fmla="val 4255"/>
+              <a:gd name="adj" fmla="val 3704"/>
             </a:avLst>
           </a:prstGeom>
           <a:solidFill>
-            <a:srgbClr val="EAF0F7"/>
+            <a:srgbClr val="FFFFFF"/>
           </a:solidFill>
           <a:ln w="12700">
             <a:solidFill>
-              <a:srgbClr val="EAF0F7"/>
+              <a:srgbClr val="C9D6E4"/>
             </a:solidFill>
             <a:prstDash val="solid"/>
           </a:ln>
@@ -4161,8 +3561,8 @@
         </p:nvSpPr>
         <p:spPr>
           <a:xfrm>
-            <a:off x="3429000" y="2542032"/>
-            <a:ext cx="2286000" cy="365760"/>
+            <a:off x="640080" y="2258568"/>
+            <a:ext cx="3657600" cy="320040"/>
           </a:xfrm>
           <a:prstGeom prst="rect">
             <a:avLst/>
@@ -4186,7 +3586,7 @@
                 <a:ea typeface="Arial" pitchFamily="34" charset="-122"/>
                 <a:cs typeface="Arial" pitchFamily="34" charset="-120"/>
               </a:rPr>
-              <a:t>משתנה בלתי תלוי</a:t>
+              <a:t>השערה ושיטה</a:t>
             </a:r>
             <a:endParaRPr lang="he-IL" sz="1400" dirty="0"/>
           </a:p>
@@ -4200,8 +3600,8 @@
         </p:nvSpPr>
         <p:spPr>
           <a:xfrm>
-            <a:off x="3429000" y="2926080"/>
-            <a:ext cx="2286000" cy="1554480"/>
+            <a:off x="640080" y="2606040"/>
+            <a:ext cx="3657600" cy="1965960"/>
           </a:xfrm>
           <a:prstGeom prst="rect">
             <a:avLst/>
@@ -4213,11 +3613,14 @@
           <a:bodyPr wrap="square" lIns="0" tIns="0" rIns="0" bIns="0" rtlCol="0" anchor="t"/>
           <a:lstStyle/>
           <a:p>
-            <a:pPr algn="r" indent="0" marL="0">
-              <a:buNone/>
-            </a:pPr>
-            <a:r>
-              <a:rPr lang="he-IL" altLang="en-US" sz="1200" b="1" dirty="0">
+            <a:pPr rtl="1" algn="just" indent="0" marL="0">
+              <a:lnSpc>
+                <a:spcPct val="115000"/>
+              </a:lnSpc>
+              <a:buNone/>
+            </a:pPr>
+            <a:r>
+              <a:rPr lang="he-IL" altLang="en-US" sz="1150" dirty="0">
                 <a:solidFill>
                   <a:srgbClr val="22303F"/>
                 </a:solidFill>
@@ -4225,193 +3628,54 @@
                 <a:ea typeface="Arial" pitchFamily="34" charset="-122"/>
                 <a:cs typeface="Arial" pitchFamily="34" charset="-120"/>
               </a:rPr>
-              <a:t>רווחה נפשית</a:t>
-            </a:r>
-            <a:endParaRPr lang="he-IL" sz="1200" dirty="0"/>
-          </a:p>
-          <a:p>
-            <a:pPr algn="r" indent="0" marL="0">
-              <a:buNone/>
-            </a:pPr>
-            <a:r>
-              <a:rPr lang="he-IL" altLang="en-US" sz="1200" dirty="0">
-                <a:solidFill>
-                  <a:srgbClr val="22303F"/>
-                </a:solidFill>
-                <a:latin typeface="Arial" pitchFamily="34" charset="0"/>
-                <a:ea typeface="Arial" pitchFamily="34" charset="-122"/>
-                <a:cs typeface="Arial" pitchFamily="34" charset="-120"/>
-              </a:rPr>
-              <a:t>5 פריטים: בריאות גופנית ונפשית, שיפור מאז המאסר, שמחה ושביעות רצון מהחיים. סולם 1 עד 5, α = 0.81</a:t>
-            </a:r>
-            <a:endParaRPr lang="he-IL" sz="1200" dirty="0"/>
-          </a:p>
-        </p:txBody>
-      </p:sp>
-      <p:sp>
-        <p:nvSpPr>
-          <p:cNvPr id="11" name="Shape 9"/>
-          <p:cNvSpPr/>
-          <p:nvPr/>
-        </p:nvSpPr>
-        <p:spPr>
-          <a:xfrm>
-            <a:off x="457200" y="2423160"/>
-            <a:ext cx="2651760" cy="2148840"/>
-          </a:xfrm>
-          <a:prstGeom prst="roundRect">
-            <a:avLst>
-              <a:gd name="adj" fmla="val 4255"/>
-            </a:avLst>
-          </a:prstGeom>
-          <a:solidFill>
-            <a:srgbClr val="EAF0F7"/>
-          </a:solidFill>
-          <a:ln w="12700">
-            <a:solidFill>
-              <a:srgbClr val="EAF0F7"/>
-            </a:solidFill>
-            <a:prstDash val="solid"/>
-          </a:ln>
-        </p:spPr>
+              <a:t>השערת המחקר היא שיימצא קשר חיובי מובהק בין רווחה נפשית לבין לגיטימיות, כך שככל שהרווחה גבוהה יותר, הלגיטימיות המיוחסת לסגל גבוהה יותר, ולהפך. המחקר הוא מחקר כמותי מתאמי במערך חתך, המבוסס על נתונים סינתטיים שנבנו על פי סקר תנאי המחיה של שב"ס משנת 2021, וצומצם ל-2,379 שפוטים. הניתוח נערך ב-SPSS וכלל סטטיסטיקה תיאורית, בדיקת מהימנות ומתאמי פירסון וספירמן.</a:t>
+            </a:r>
+            <a:endParaRPr lang="he-IL" sz="1150" dirty="0"/>
+          </a:p>
+        </p:txBody>
+      </p:sp>
+      <p:sp>
+        <p:nvSpPr>
+          <p:cNvPr id="11" name="Text 9"/>
+          <p:cNvSpPr txBox="1"/>
+          <p:nvPr/>
+        </p:nvSpPr>
+        <p:spPr>
+          <a:xfrm>
+            <a:off x="457200" y="4754880"/>
+            <a:ext cx="6858000" cy="274320"/>
+          </a:xfrm>
+          <a:prstGeom prst="rect">
+            <a:avLst/>
+          </a:prstGeom>
+          <a:noFill/>
+          <a:ln/>
+        </p:spPr>
+        <p:txBody>
+          <a:bodyPr wrap="square" lIns="0" tIns="0" rIns="0" bIns="0" rtlCol="0" anchor="t"/>
+          <a:lstStyle/>
+          <a:p>
+            <a:pPr rtl="1" algn="r" indent="0" marL="0">
+              <a:buNone/>
+            </a:pPr>
+            <a:r>
+              <a:rPr lang="he-IL" altLang="en-US" sz="1000" dirty="0">
+                <a:solidFill>
+                  <a:srgbClr val="5B6B7C"/>
+                </a:solidFill>
+                <a:latin typeface="Arial" pitchFamily="34" charset="0"/>
+                <a:ea typeface="Arial" pitchFamily="34" charset="-122"/>
+                <a:cs typeface="Arial" pitchFamily="34" charset="-120"/>
+              </a:rPr>
+              <a:t>רווחה נפשית ותפיסת הלגיטימיות של סגל הכליאה בקרב אסירים שפוטים בישראל</a:t>
+            </a:r>
+            <a:endParaRPr lang="he-IL" sz="1000" dirty="0"/>
+          </a:p>
+        </p:txBody>
       </p:sp>
       <p:sp>
         <p:nvSpPr>
           <p:cNvPr id="12" name="Text 10"/>
-          <p:cNvSpPr txBox="1"/>
-          <p:nvPr/>
-        </p:nvSpPr>
-        <p:spPr>
-          <a:xfrm>
-            <a:off x="640080" y="2542032"/>
-            <a:ext cx="2286000" cy="365760"/>
-          </a:xfrm>
-          <a:prstGeom prst="rect">
-            <a:avLst/>
-          </a:prstGeom>
-          <a:noFill/>
-          <a:ln/>
-        </p:spPr>
-        <p:txBody>
-          <a:bodyPr wrap="square" lIns="0" tIns="0" rIns="0" bIns="0" rtlCol="0" anchor="t"/>
-          <a:lstStyle/>
-          <a:p>
-            <a:pPr rtl="1" algn="r" indent="0" marL="0">
-              <a:buNone/>
-            </a:pPr>
-            <a:r>
-              <a:rPr lang="he-IL" altLang="en-US" sz="1400" b="1" dirty="0">
-                <a:solidFill>
-                  <a:srgbClr val="E8892B"/>
-                </a:solidFill>
-                <a:latin typeface="Arial" pitchFamily="34" charset="0"/>
-                <a:ea typeface="Arial" pitchFamily="34" charset="-122"/>
-                <a:cs typeface="Arial" pitchFamily="34" charset="-120"/>
-              </a:rPr>
-              <a:t>השערה ושיטה</a:t>
-            </a:r>
-            <a:endParaRPr lang="he-IL" sz="1400" dirty="0"/>
-          </a:p>
-        </p:txBody>
-      </p:sp>
-      <p:sp>
-        <p:nvSpPr>
-          <p:cNvPr id="13" name="Text 11"/>
-          <p:cNvSpPr txBox="1"/>
-          <p:nvPr/>
-        </p:nvSpPr>
-        <p:spPr>
-          <a:xfrm>
-            <a:off x="640080" y="2926080"/>
-            <a:ext cx="2286000" cy="1554480"/>
-          </a:xfrm>
-          <a:prstGeom prst="rect">
-            <a:avLst/>
-          </a:prstGeom>
-          <a:noFill/>
-          <a:ln/>
-        </p:spPr>
-        <p:txBody>
-          <a:bodyPr wrap="square" lIns="0" tIns="0" rIns="0" bIns="0" rtlCol="0" anchor="t"/>
-          <a:lstStyle/>
-          <a:p>
-            <a:pPr algn="r" indent="0" marL="0">
-              <a:buNone/>
-            </a:pPr>
-            <a:r>
-              <a:rPr lang="he-IL" altLang="en-US" sz="1200" dirty="0">
-                <a:solidFill>
-                  <a:srgbClr val="22303F"/>
-                </a:solidFill>
-                <a:latin typeface="Arial" pitchFamily="34" charset="0"/>
-                <a:ea typeface="Arial" pitchFamily="34" charset="-122"/>
-                <a:cs typeface="Arial" pitchFamily="34" charset="-120"/>
-              </a:rPr>
-              <a:t>קשר חיובי מובהק: ככל שהרווחה גבוהה יותר, הלגיטימיות גבוהה יותר.</a:t>
-            </a:r>
-            <a:endParaRPr lang="he-IL" sz="1200" dirty="0"/>
-          </a:p>
-          <a:p>
-            <a:pPr algn="r" indent="0" marL="0">
-              <a:buNone/>
-            </a:pPr>
-            <a:r>
-              <a:rPr lang="he-IL" altLang="en-US" sz="1200" dirty="0">
-                <a:solidFill>
-                  <a:srgbClr val="22303F"/>
-                </a:solidFill>
-                <a:latin typeface="Arial" pitchFamily="34" charset="0"/>
-                <a:ea typeface="Arial" pitchFamily="34" charset="-122"/>
-                <a:cs typeface="Arial" pitchFamily="34" charset="-120"/>
-              </a:rPr>
-              <a:t>נתונים סינתטיים המבוססים על סקר שב"ס 2021, שפוטים בלבד (N = 2,379). ניתוח ב-SPSS: תיאורי, מהימנות, מתאם פירסון וספירמן.</a:t>
-            </a:r>
-            <a:endParaRPr lang="he-IL" sz="1200" dirty="0"/>
-          </a:p>
-        </p:txBody>
-      </p:sp>
-      <p:sp>
-        <p:nvSpPr>
-          <p:cNvPr id="14" name="Text 12"/>
-          <p:cNvSpPr txBox="1"/>
-          <p:nvPr/>
-        </p:nvSpPr>
-        <p:spPr>
-          <a:xfrm>
-            <a:off x="457200" y="4754880"/>
-            <a:ext cx="6400800" cy="274320"/>
-          </a:xfrm>
-          <a:prstGeom prst="rect">
-            <a:avLst/>
-          </a:prstGeom>
-          <a:noFill/>
-          <a:ln/>
-        </p:spPr>
-        <p:txBody>
-          <a:bodyPr wrap="square" lIns="0" tIns="0" rIns="0" bIns="0" rtlCol="0" anchor="t"/>
-          <a:lstStyle/>
-          <a:p>
-            <a:pPr rtl="1" algn="r" indent="0" marL="0">
-              <a:buNone/>
-            </a:pPr>
-            <a:r>
-              <a:rPr lang="he-IL" altLang="en-US" sz="1000" dirty="0">
-                <a:solidFill>
-                  <a:srgbClr val="5B6B7C"/>
-                </a:solidFill>
-                <a:latin typeface="Arial" pitchFamily="34" charset="0"/>
-                <a:ea typeface="Arial" pitchFamily="34" charset="-122"/>
-                <a:cs typeface="Arial" pitchFamily="34" charset="-120"/>
-              </a:rPr>
-              <a:t>רווחה נפשית ולגיטימיות הסגל בקרב אסירים שפוטים</a:t>
-            </a:r>
-            <a:endParaRPr lang="he-IL" sz="1000" dirty="0"/>
-          </a:p>
-        </p:txBody>
-      </p:sp>
-      <p:sp>
-        <p:nvSpPr>
-          <p:cNvPr id="15" name="Text 13"/>
           <p:cNvSpPr txBox="1"/>
           <p:nvPr/>
         </p:nvSpPr>
@@ -4488,8 +3752,8 @@
         </p:nvSpPr>
         <p:spPr>
           <a:xfrm>
-            <a:off x="457200" y="320040"/>
-            <a:ext cx="8229600" cy="731520"/>
+            <a:off x="457200" y="274320"/>
+            <a:ext cx="8229600" cy="640080"/>
           </a:xfrm>
           <a:prstGeom prst="rect">
             <a:avLst/>
@@ -4505,7 +3769,7 @@
               <a:buNone/>
             </a:pPr>
             <a:r>
-              <a:rPr lang="he-IL" altLang="en-US" sz="3200" b="1" dirty="0">
+              <a:rPr lang="he-IL" altLang="en-US" sz="3000" b="1" dirty="0">
                 <a:solidFill>
                   <a:srgbClr val="1F3A5F"/>
                 </a:solidFill>
@@ -4513,9 +3777,9 @@
                 <a:ea typeface="Arial" pitchFamily="34" charset="-122"/>
                 <a:cs typeface="Arial" pitchFamily="34" charset="-120"/>
               </a:rPr>
-              <a:t>ממצאים: אוכלוסיית המחקר (N = 2,379)</a:t>
-            </a:r>
-            <a:endParaRPr lang="he-IL" sz="3200" dirty="0"/>
+              <a:t>ממצאים: אוכלוסיית המחקר</a:t>
+            </a:r>
+            <a:endParaRPr lang="he-IL" sz="3000" dirty="0"/>
           </a:p>
         </p:txBody>
       </p:sp>
@@ -4526,8 +3790,8 @@
           <p:nvPr/>
         </p:nvGraphicFramePr>
         <p:xfrm>
-          <a:off x="3291840" y="1143000"/>
-          <a:ext cx="5394960" cy="3474720"/>
+          <a:off x="3657600" y="1005840"/>
+          <a:ext cx="5029200" cy="3611880"/>
         </p:xfrm>
         <a:graphic xmlns:a="http://schemas.openxmlformats.org/drawingml/2006/main">
           <a:graphicData uri="http://schemas.openxmlformats.org/drawingml/2006/chart">
@@ -4543,12 +3807,12 @@
         </p:nvSpPr>
         <p:spPr>
           <a:xfrm>
-            <a:off x="457200" y="1143000"/>
-            <a:ext cx="2651760" cy="3474720"/>
+            <a:off x="457200" y="1051560"/>
+            <a:ext cx="3017520" cy="3566160"/>
           </a:xfrm>
           <a:prstGeom prst="roundRect">
             <a:avLst>
-              <a:gd name="adj" fmla="val 3448"/>
+              <a:gd name="adj" fmla="val 3030"/>
             </a:avLst>
           </a:prstGeom>
           <a:solidFill>
@@ -4570,8 +3834,8 @@
         </p:nvSpPr>
         <p:spPr>
           <a:xfrm>
-            <a:off x="640080" y="1280160"/>
-            <a:ext cx="2286000" cy="365760"/>
+            <a:off x="640080" y="1161288"/>
+            <a:ext cx="2651760" cy="320040"/>
           </a:xfrm>
           <a:prstGeom prst="rect">
             <a:avLst/>
@@ -4595,7 +3859,7 @@
                 <a:ea typeface="Arial" pitchFamily="34" charset="-122"/>
                 <a:cs typeface="Arial" pitchFamily="34" charset="-120"/>
               </a:rPr>
-              <a:t>מי הם השפוטים?</a:t>
+              <a:t>מי הם השפוטים</a:t>
             </a:r>
             <a:endParaRPr lang="he-IL" sz="1400" dirty="0"/>
           </a:p>
@@ -4609,8 +3873,8 @@
         </p:nvSpPr>
         <p:spPr>
           <a:xfrm>
-            <a:off x="640080" y="1691640"/>
-            <a:ext cx="2331720" cy="2834640"/>
+            <a:off x="640080" y="1508760"/>
+            <a:ext cx="2651760" cy="3017520"/>
           </a:xfrm>
           <a:prstGeom prst="rect">
             <a:avLst/>
@@ -4622,15 +3886,14 @@
           <a:bodyPr wrap="square" lIns="0" tIns="0" rIns="0" bIns="0" rtlCol="0" anchor="t"/>
           <a:lstStyle/>
           <a:p>
-            <a:pPr algn="r" marL="342900" indent="-342900">
-              <a:spcAft>
-                <a:spcPts val="600"/>
-              </a:spcAft>
-              <a:buSzPct val="100000"/>
-              <a:buChar char="•"/>
-            </a:pPr>
-            <a:r>
-              <a:rPr lang="he-IL" altLang="en-US" sz="1200" dirty="0">
+            <a:pPr rtl="1" algn="just" indent="0" marL="0">
+              <a:lnSpc>
+                <a:spcPct val="115000"/>
+              </a:lnSpc>
+              <a:buNone/>
+            </a:pPr>
+            <a:r>
+              <a:rPr lang="he-IL" altLang="en-US" sz="1150" dirty="0">
                 <a:solidFill>
                   <a:srgbClr val="22303F"/>
                 </a:solidFill>
@@ -4638,93 +3901,9 @@
                 <a:ea typeface="Arial" pitchFamily="34" charset="-122"/>
                 <a:cs typeface="Arial" pitchFamily="34" charset="-120"/>
               </a:rPr>
-              <a:t>גיל ממוצע 37.9 (טווח 18 עד 82)</a:t>
-            </a:r>
-            <a:endParaRPr lang="he-IL" sz="1200" dirty="0"/>
-          </a:p>
-          <a:p>
-            <a:pPr algn="r" marL="342900" indent="-342900">
-              <a:spcAft>
-                <a:spcPts val="600"/>
-              </a:spcAft>
-              <a:buSzPct val="100000"/>
-              <a:buChar char="•"/>
-            </a:pPr>
-            <a:r>
-              <a:rPr lang="he-IL" altLang="en-US" sz="1200" dirty="0">
-                <a:solidFill>
-                  <a:srgbClr val="22303F"/>
-                </a:solidFill>
-                <a:latin typeface="Arial" pitchFamily="34" charset="0"/>
-                <a:ea typeface="Arial" pitchFamily="34" charset="-122"/>
-                <a:cs typeface="Arial" pitchFamily="34" charset="-120"/>
-              </a:rPr>
-              <a:t>כמחצית במאסרם הראשון</a:t>
-            </a:r>
-            <a:endParaRPr lang="he-IL" sz="1200" dirty="0"/>
-          </a:p>
-          <a:p>
-            <a:pPr algn="r" marL="342900" indent="-342900">
-              <a:spcAft>
-                <a:spcPts val="600"/>
-              </a:spcAft>
-              <a:buSzPct val="100000"/>
-              <a:buChar char="•"/>
-            </a:pPr>
-            <a:r>
-              <a:rPr lang="he-IL" altLang="en-US" sz="1200" dirty="0">
-                <a:solidFill>
-                  <a:srgbClr val="22303F"/>
-                </a:solidFill>
-                <a:latin typeface="Arial" pitchFamily="34" charset="0"/>
-                <a:ea typeface="Arial" pitchFamily="34" charset="-122"/>
-                <a:cs typeface="Arial" pitchFamily="34" charset="-120"/>
-              </a:rPr>
-              <a:t>שני שלישים שוהים באגף מעל שלושה חודשים</a:t>
-            </a:r>
-            <a:endParaRPr lang="he-IL" sz="1200" dirty="0"/>
-          </a:p>
-          <a:p>
-            <a:pPr algn="r" marL="342900" indent="-342900">
-              <a:spcAft>
-                <a:spcPts val="600"/>
-              </a:spcAft>
-              <a:buSzPct val="100000"/>
-              <a:buChar char="•"/>
-            </a:pPr>
-            <a:r>
-              <a:rPr lang="he-IL" altLang="en-US" sz="1200" dirty="0">
-                <a:solidFill>
-                  <a:srgbClr val="22303F"/>
-                </a:solidFill>
-                <a:latin typeface="Arial" pitchFamily="34" charset="0"/>
-                <a:ea typeface="Arial" pitchFamily="34" charset="-122"/>
-                <a:cs typeface="Arial" pitchFamily="34" charset="-120"/>
-              </a:rPr>
-              <a:t>77 נשים בלבד (3.2%)</a:t>
-            </a:r>
-            <a:endParaRPr lang="he-IL" sz="1200" dirty="0"/>
-          </a:p>
-          <a:p>
-            <a:pPr algn="r" marL="342900" indent="-342900">
-              <a:spcAft>
-                <a:spcPts val="600"/>
-              </a:spcAft>
-              <a:buSzPct val="100000"/>
-              <a:buChar char="•"/>
-            </a:pPr>
-            <a:r>
-              <a:rPr lang="he-IL" altLang="en-US" sz="1200" dirty="0">
-                <a:solidFill>
-                  <a:srgbClr val="22303F"/>
-                </a:solidFill>
-                <a:latin typeface="Arial" pitchFamily="34" charset="0"/>
-                <a:ea typeface="Arial" pitchFamily="34" charset="-122"/>
-                <a:cs typeface="Arial" pitchFamily="34" charset="-120"/>
-              </a:rPr>
-              <a:t>התפלגות דומה לסקר המקורי (ועקנין, 2024)</a:t>
-            </a:r>
-            <a:endParaRPr lang="he-IL" sz="1200" dirty="0"/>
+              <a:t>אוכלוסיית המחקר כוללת 2,379 אסירים שפוטים, רובם המכריע גברים, בגיל ממוצע של 37.9 שנים ובטווח של 18 עד 82. מעט יותר ממחציתם לא יהודים, כמחציתם במאסרם הראשון ולמעלה ממחציתם ריצו מאסר קודם. יותר משני שלישים שוהים באגף הנוכחי מעל שלושה חודשים, וכאחד מכל חמישה נמצא במסלול שיקום. ההתפלגות דומה לזו שדווחה בסקר המקורי (ועקנין, 2024).</a:t>
+            </a:r>
+            <a:endParaRPr lang="he-IL" sz="1150" dirty="0"/>
           </a:p>
         </p:txBody>
       </p:sp>
@@ -4737,7 +3916,7 @@
         <p:spPr>
           <a:xfrm>
             <a:off x="457200" y="4754880"/>
-            <a:ext cx="6400800" cy="274320"/>
+            <a:ext cx="6858000" cy="274320"/>
           </a:xfrm>
           <a:prstGeom prst="rect">
             <a:avLst/>
@@ -4761,7 +3940,7 @@
                 <a:ea typeface="Arial" pitchFamily="34" charset="-122"/>
                 <a:cs typeface="Arial" pitchFamily="34" charset="-120"/>
               </a:rPr>
-              <a:t>רווחה נפשית ולגיטימיות הסגל בקרב אסירים שפוטים</a:t>
+              <a:t>רווחה נפשית ותפיסת הלגיטימיות של סגל הכליאה בקרב אסירים שפוטים בישראל</a:t>
             </a:r>
             <a:endParaRPr lang="he-IL" sz="1000" dirty="0"/>
           </a:p>
@@ -4846,8 +4025,8 @@
         </p:nvSpPr>
         <p:spPr>
           <a:xfrm>
-            <a:off x="457200" y="320040"/>
-            <a:ext cx="8229600" cy="731520"/>
+            <a:off x="457200" y="274320"/>
+            <a:ext cx="8229600" cy="640080"/>
           </a:xfrm>
           <a:prstGeom prst="rect">
             <a:avLst/>
@@ -4863,7 +4042,7 @@
               <a:buNone/>
             </a:pPr>
             <a:r>
-              <a:rPr lang="he-IL" altLang="en-US" sz="3200" b="1" dirty="0">
+              <a:rPr lang="he-IL" altLang="en-US" sz="3000" b="1" dirty="0">
                 <a:solidFill>
                   <a:srgbClr val="1F3A5F"/>
                 </a:solidFill>
@@ -4873,7 +4052,7 @@
               </a:rPr>
               <a:t>ממצאים: הקשר בין רווחה נפשית ללגיטימיות</a:t>
             </a:r>
-            <a:endParaRPr lang="he-IL" sz="3200" dirty="0"/>
+            <a:endParaRPr lang="he-IL" sz="3000" dirty="0"/>
           </a:p>
         </p:txBody>
       </p:sp>
@@ -4885,12 +4064,12 @@
         </p:nvSpPr>
         <p:spPr>
           <a:xfrm>
-            <a:off x="5943600" y="1143000"/>
-            <a:ext cx="2743200" cy="1417320"/>
+            <a:off x="5852160" y="1005840"/>
+            <a:ext cx="2834640" cy="1188720"/>
           </a:xfrm>
           <a:prstGeom prst="roundRect">
             <a:avLst>
-              <a:gd name="adj" fmla="val 7742"/>
+              <a:gd name="adj" fmla="val 9231"/>
             </a:avLst>
           </a:prstGeom>
           <a:solidFill>
@@ -4912,8 +4091,8 @@
         </p:nvSpPr>
         <p:spPr>
           <a:xfrm>
-            <a:off x="6035040" y="1207008"/>
-            <a:ext cx="2560320" cy="685800"/>
+            <a:off x="5943600" y="1051560"/>
+            <a:ext cx="2651760" cy="640080"/>
           </a:xfrm>
           <a:prstGeom prst="rect">
             <a:avLst/>
@@ -4929,7 +4108,7 @@
               <a:buNone/>
             </a:pPr>
             <a:r>
-              <a:rPr lang="en-US" sz="4000" b="1" dirty="0">
+              <a:rPr lang="en-US" sz="3800" b="1" dirty="0">
                 <a:solidFill>
                   <a:srgbClr val="E8892B"/>
                 </a:solidFill>
@@ -4939,7 +4118,7 @@
               </a:rPr>
               <a:t>r = 0.32</a:t>
             </a:r>
-            <a:endParaRPr lang="en-US" sz="4000" dirty="0"/>
+            <a:endParaRPr lang="en-US" sz="3800" dirty="0"/>
           </a:p>
         </p:txBody>
       </p:sp>
@@ -4951,8 +4130,8 @@
         </p:nvSpPr>
         <p:spPr>
           <a:xfrm>
-            <a:off x="6035040" y="1874520"/>
-            <a:ext cx="2560320" cy="594360"/>
+            <a:off x="5943600" y="1719072"/>
+            <a:ext cx="2651760" cy="365760"/>
           </a:xfrm>
           <a:prstGeom prst="rect">
             <a:avLst/>
@@ -4977,23 +4156,6 @@
                 <a:cs typeface="Arial" pitchFamily="34" charset="-120"/>
               </a:rPr>
               <a:t>מתאם פירסון, p &lt; 0.001, N = 2,344</a:t>
-            </a:r>
-            <a:endParaRPr lang="he-IL" sz="1100" dirty="0"/>
-          </a:p>
-          <a:p>
-            <a:pPr rtl="1" algn="ctr" indent="0" marL="0">
-              <a:buNone/>
-            </a:pPr>
-            <a:r>
-              <a:rPr lang="he-IL" altLang="en-US" sz="1100" dirty="0">
-                <a:solidFill>
-                  <a:srgbClr val="CFDBEA"/>
-                </a:solidFill>
-                <a:latin typeface="Arial" pitchFamily="34" charset="0"/>
-                <a:ea typeface="Arial" pitchFamily="34" charset="-122"/>
-                <a:cs typeface="Arial" pitchFamily="34" charset="-120"/>
-              </a:rPr>
-              <a:t>ספירמן rs = 0.34</a:t>
             </a:r>
             <a:endParaRPr lang="he-IL" sz="1100" dirty="0"/>
           </a:p>
@@ -5007,12 +4169,12 @@
         </p:nvSpPr>
         <p:spPr>
           <a:xfrm>
-            <a:off x="5943600" y="2697480"/>
-            <a:ext cx="2743200" cy="1920240"/>
+            <a:off x="5852160" y="2331720"/>
+            <a:ext cx="2834640" cy="2286000"/>
           </a:xfrm>
           <a:prstGeom prst="roundRect">
             <a:avLst>
-              <a:gd name="adj" fmla="val 5714"/>
+              <a:gd name="adj" fmla="val 4800"/>
             </a:avLst>
           </a:prstGeom>
           <a:solidFill>
@@ -5034,8 +4196,8 @@
         </p:nvSpPr>
         <p:spPr>
           <a:xfrm>
-            <a:off x="6080760" y="2816352"/>
-            <a:ext cx="2514600" cy="1737360"/>
+            <a:off x="6035040" y="2423160"/>
+            <a:ext cx="2468880" cy="320040"/>
           </a:xfrm>
           <a:prstGeom prst="rect">
             <a:avLst/>
@@ -5047,12 +4209,50 @@
           <a:bodyPr wrap="square" lIns="0" tIns="0" rIns="0" bIns="0" rtlCol="0" anchor="t"/>
           <a:lstStyle/>
           <a:p>
-            <a:pPr algn="r" marL="342900" indent="-342900">
-              <a:spcAft>
-                <a:spcPts val="500"/>
-              </a:spcAft>
-              <a:buSzPct val="100000"/>
-              <a:buChar char="•"/>
+            <a:pPr rtl="1" algn="r" indent="0" marL="0">
+              <a:buNone/>
+            </a:pPr>
+            <a:r>
+              <a:rPr lang="he-IL" altLang="en-US" sz="1400" b="1" dirty="0">
+                <a:solidFill>
+                  <a:srgbClr val="E8892B"/>
+                </a:solidFill>
+                <a:latin typeface="Arial" pitchFamily="34" charset="0"/>
+                <a:ea typeface="Arial" pitchFamily="34" charset="-122"/>
+                <a:cs typeface="Arial" pitchFamily="34" charset="-120"/>
+              </a:rPr>
+              <a:t>פירוש הממצא</a:t>
+            </a:r>
+            <a:endParaRPr lang="he-IL" sz="1400" dirty="0"/>
+          </a:p>
+        </p:txBody>
+      </p:sp>
+      <p:sp>
+        <p:nvSpPr>
+          <p:cNvPr id="8" name="Text 6"/>
+          <p:cNvSpPr txBox="1"/>
+          <p:nvPr/>
+        </p:nvSpPr>
+        <p:spPr>
+          <a:xfrm>
+            <a:off x="6035040" y="2743200"/>
+            <a:ext cx="2468880" cy="1828800"/>
+          </a:xfrm>
+          <a:prstGeom prst="rect">
+            <a:avLst/>
+          </a:prstGeom>
+          <a:noFill/>
+          <a:ln/>
+        </p:spPr>
+        <p:txBody>
+          <a:bodyPr wrap="square" lIns="0" tIns="0" rIns="0" bIns="0" rtlCol="0" anchor="t"/>
+          <a:lstStyle/>
+          <a:p>
+            <a:pPr rtl="1" algn="just" indent="0" marL="0">
+              <a:lnSpc>
+                <a:spcPct val="115000"/>
+              </a:lnSpc>
+              <a:buNone/>
             </a:pPr>
             <a:r>
               <a:rPr lang="he-IL" altLang="en-US" sz="1100" dirty="0">
@@ -5063,70 +4263,7 @@
                 <a:ea typeface="Arial" pitchFamily="34" charset="-122"/>
                 <a:cs typeface="Arial" pitchFamily="34" charset="-120"/>
               </a:rPr>
-              <a:t>ממוצע לגיטימיות 4.24 (SD 0.83); ממוצע רווחה 3.78 (SD 0.87)</a:t>
-            </a:r>
-            <a:endParaRPr lang="he-IL" sz="1100" dirty="0"/>
-          </a:p>
-          <a:p>
-            <a:pPr algn="r" marL="342900" indent="-342900">
-              <a:spcAft>
-                <a:spcPts val="500"/>
-              </a:spcAft>
-              <a:buSzPct val="100000"/>
-              <a:buChar char="•"/>
-            </a:pPr>
-            <a:r>
-              <a:rPr lang="he-IL" altLang="en-US" sz="1100" dirty="0">
-                <a:solidFill>
-                  <a:srgbClr val="22303F"/>
-                </a:solidFill>
-                <a:latin typeface="Arial" pitchFamily="34" charset="0"/>
-                <a:ea typeface="Arial" pitchFamily="34" charset="-122"/>
-                <a:cs typeface="Arial" pitchFamily="34" charset="-120"/>
-              </a:rPr>
-              <a:t>קשר חיובי בכל שלושת פריטי הלגיטימיות (0.25 עד 0.29)</a:t>
-            </a:r>
-            <a:endParaRPr lang="he-IL" sz="1100" dirty="0"/>
-          </a:p>
-          <a:p>
-            <a:pPr algn="r" marL="342900" indent="-342900">
-              <a:spcAft>
-                <a:spcPts val="500"/>
-              </a:spcAft>
-              <a:buSzPct val="100000"/>
-              <a:buChar char="•"/>
-            </a:pPr>
-            <a:r>
-              <a:rPr lang="he-IL" altLang="en-US" sz="1100" dirty="0">
-                <a:solidFill>
-                  <a:srgbClr val="22303F"/>
-                </a:solidFill>
-                <a:latin typeface="Arial" pitchFamily="34" charset="0"/>
-                <a:ea typeface="Arial" pitchFamily="34" charset="-122"/>
-                <a:cs typeface="Arial" pitchFamily="34" charset="-120"/>
-              </a:rPr>
-              <a:t>הרווחה חולקת עם הלגיטימיות כ-10% מהשונות</a:t>
-            </a:r>
-            <a:endParaRPr lang="he-IL" sz="1100" dirty="0"/>
-          </a:p>
-          <a:p>
-            <a:pPr algn="r" marL="342900" indent="-342900">
-              <a:spcAft>
-                <a:spcPts val="500"/>
-              </a:spcAft>
-              <a:buSzPct val="100000"/>
-              <a:buChar char="•"/>
-            </a:pPr>
-            <a:r>
-              <a:rPr lang="he-IL" altLang="en-US" sz="1100" dirty="0">
-                <a:solidFill>
-                  <a:srgbClr val="22303F"/>
-                </a:solidFill>
-                <a:latin typeface="Arial" pitchFamily="34" charset="0"/>
-                <a:ea typeface="Arial" pitchFamily="34" charset="-122"/>
-                <a:cs typeface="Arial" pitchFamily="34" charset="-120"/>
-              </a:rPr>
-              <a:t>ההשערה אוששה: ככל שהרווחה עולה, הלגיטימיות עולה, ולהפך</a:t>
+              <a:t>נמצא קשר חיובי מובהק ברמה בינונית בין רווחה נפשית ללגיטימיות, ומתאם ספירמן (0.34) קרוב לפירסון. הקשר קיים בכל שלושת פריטי הלגיטימיות, והחזק שבהם הוא האפשרות לדבר עם הסוהרים (0.29). הרווחה חולקת עם הלגיטימיות כעשרה אחוזים מהשונות, וההשערה אוששה.</a:t>
             </a:r>
             <a:endParaRPr lang="he-IL" sz="1100" dirty="0"/>
           </a:p>
@@ -5134,13 +4271,13 @@
       </p:sp>
       <p:graphicFrame>
         <p:nvGraphicFramePr>
-          <p:cNvPr id="8" name="Chart 0" descr=""/>
+          <p:cNvPr id="9" name="Chart 0" descr=""/>
           <p:cNvGraphicFramePr/>
           <p:nvPr/>
         </p:nvGraphicFramePr>
         <p:xfrm>
-          <a:off x="457200" y="1143000"/>
-          <a:ext cx="5303520" cy="3474720"/>
+          <a:off x="457200" y="1005840"/>
+          <a:ext cx="5212080" cy="2377440"/>
         </p:xfrm>
         <a:graphic xmlns:a="http://schemas.openxmlformats.org/drawingml/2006/main">
           <a:graphicData uri="http://schemas.openxmlformats.org/drawingml/2006/chart">
@@ -5150,14 +4287,83 @@
       </p:graphicFrame>
       <p:sp>
         <p:nvSpPr>
-          <p:cNvPr id="10" name="Text 6"/>
+          <p:cNvPr id="10" name="Shape 7"/>
+          <p:cNvSpPr/>
+          <p:nvPr/>
+        </p:nvSpPr>
+        <p:spPr>
+          <a:xfrm>
+            <a:off x="457200" y="3520440"/>
+            <a:ext cx="5212080" cy="1097280"/>
+          </a:xfrm>
+          <a:prstGeom prst="roundRect">
+            <a:avLst>
+              <a:gd name="adj" fmla="val 8333"/>
+            </a:avLst>
+          </a:prstGeom>
+          <a:solidFill>
+            <a:srgbClr val="FFFFFF"/>
+          </a:solidFill>
+          <a:ln w="12700">
+            <a:solidFill>
+              <a:srgbClr val="C9D6E4"/>
+            </a:solidFill>
+            <a:prstDash val="solid"/>
+          </a:ln>
+        </p:spPr>
+      </p:sp>
+      <p:sp>
+        <p:nvSpPr>
+          <p:cNvPr id="11" name="Text 8"/>
+          <p:cNvSpPr txBox="1"/>
+          <p:nvPr/>
+        </p:nvSpPr>
+        <p:spPr>
+          <a:xfrm>
+            <a:off x="640080" y="3611880"/>
+            <a:ext cx="4846320" cy="960120"/>
+          </a:xfrm>
+          <a:prstGeom prst="rect">
+            <a:avLst/>
+          </a:prstGeom>
+          <a:noFill/>
+          <a:ln/>
+        </p:spPr>
+        <p:txBody>
+          <a:bodyPr wrap="square" lIns="0" tIns="0" rIns="0" bIns="0" rtlCol="0" anchor="t"/>
+          <a:lstStyle/>
+          <a:p>
+            <a:pPr rtl="1" algn="just" indent="0" marL="0">
+              <a:lnSpc>
+                <a:spcPct val="115000"/>
+              </a:lnSpc>
+              <a:buNone/>
+            </a:pPr>
+            <a:r>
+              <a:rPr lang="he-IL" altLang="en-US" sz="1100" dirty="0">
+                <a:solidFill>
+                  <a:srgbClr val="22303F"/>
+                </a:solidFill>
+                <a:latin typeface="Arial" pitchFamily="34" charset="0"/>
+                <a:ea typeface="Arial" pitchFamily="34" charset="-122"/>
+                <a:cs typeface="Arial" pitchFamily="34" charset="-120"/>
+              </a:rPr>
+              <a:t>ממוצע הלגיטימיות עמד על 4.24 (סטיית תקן 0.83) וממוצע הרווחה הנפשית על 3.78 (סטיית תקן 0.87). השפוטים ברמת הלגיטימיות הנמוכה דיווחו על רווחה ממוצעת של 3.34, ואלו ברמה הגבוהה על 4.05, פער של כ-0.7 נקודות שהוא כ-80 אחוזים מסטיית תקן, בהלימה לממצאים מהולנד, מאנגליה ומאוסטרליה.</a:t>
+            </a:r>
+            <a:endParaRPr lang="he-IL" sz="1100" dirty="0"/>
+          </a:p>
+        </p:txBody>
+      </p:sp>
+      <p:sp>
+        <p:nvSpPr>
+          <p:cNvPr id="12" name="Text 9"/>
           <p:cNvSpPr txBox="1"/>
           <p:nvPr/>
         </p:nvSpPr>
         <p:spPr>
           <a:xfrm>
             <a:off x="457200" y="4754880"/>
-            <a:ext cx="6400800" cy="274320"/>
+            <a:ext cx="6858000" cy="274320"/>
           </a:xfrm>
           <a:prstGeom prst="rect">
             <a:avLst/>
@@ -5181,7 +4387,7 @@
                 <a:ea typeface="Arial" pitchFamily="34" charset="-122"/>
                 <a:cs typeface="Arial" pitchFamily="34" charset="-120"/>
               </a:rPr>
-              <a:t>רווחה נפשית ולגיטימיות הסגל בקרב אסירים שפוטים</a:t>
+              <a:t>רווחה נפשית ותפיסת הלגיטימיות של סגל הכליאה בקרב אסירים שפוטים בישראל</a:t>
             </a:r>
             <a:endParaRPr lang="he-IL" sz="1000" dirty="0"/>
           </a:p>
@@ -5189,7 +4395,7 @@
       </p:sp>
       <p:sp>
         <p:nvSpPr>
-          <p:cNvPr id="11" name="Text 7"/>
+          <p:cNvPr id="13" name="Text 10"/>
           <p:cNvSpPr txBox="1"/>
           <p:nvPr/>
         </p:nvSpPr>

</xml_diff>

<commit_message>
Presentation: one continuous integrative paragraph per slide
Co-Authored-By: Claude Fable 5.1 <noreply@anthropic.com>
Claude-Session: https://claude.ai/code/session_01KHo5ZcKCUwhCAvyoKeeMWs
</commit_message>
<xml_diff>
--- a/seminar/רפרט_רווחה_נפשית_ולגיטימיות.pptx
+++ b/seminar/רפרט_רווחה_נפשית_ולגיטימיות.pptx
@@ -2343,11 +2343,11 @@
         <p:spPr>
           <a:xfrm>
             <a:off x="457200" y="1051560"/>
-            <a:ext cx="5486400" cy="3520440"/>
+            <a:ext cx="8229600" cy="3566160"/>
           </a:xfrm>
           <a:prstGeom prst="roundRect">
             <a:avLst>
-              <a:gd name="adj" fmla="val 2597"/>
+              <a:gd name="adj" fmla="val 2564"/>
             </a:avLst>
           </a:prstGeom>
           <a:solidFill>
@@ -2369,47 +2369,8 @@
         </p:nvSpPr>
         <p:spPr>
           <a:xfrm>
-            <a:off x="685800" y="1188720"/>
-            <a:ext cx="5029200" cy="320040"/>
-          </a:xfrm>
-          <a:prstGeom prst="rect">
-            <a:avLst/>
-          </a:prstGeom>
-          <a:noFill/>
-          <a:ln/>
-        </p:spPr>
-        <p:txBody>
-          <a:bodyPr wrap="square" lIns="0" tIns="0" rIns="0" bIns="0" rtlCol="0" anchor="t"/>
-          <a:lstStyle/>
-          <a:p>
-            <a:pPr rtl="1" algn="r" indent="0" marL="0">
-              <a:buNone/>
-            </a:pPr>
-            <a:r>
-              <a:rPr lang="he-IL" altLang="en-US" sz="1400" b="1" dirty="0">
-                <a:solidFill>
-                  <a:srgbClr val="E8892B"/>
-                </a:solidFill>
-                <a:latin typeface="Arial" pitchFamily="34" charset="0"/>
-                <a:ea typeface="Arial" pitchFamily="34" charset="-122"/>
-                <a:cs typeface="Arial" pitchFamily="34" charset="-120"/>
-              </a:rPr>
-              <a:t>לגיטימיות כתנאי לסדר בבית הסוהר</a:t>
-            </a:r>
-            <a:endParaRPr lang="he-IL" sz="1400" dirty="0"/>
-          </a:p>
-        </p:txBody>
-      </p:sp>
-      <p:sp>
-        <p:nvSpPr>
-          <p:cNvPr id="5" name="Text 3"/>
-          <p:cNvSpPr txBox="1"/>
-          <p:nvPr/>
-        </p:nvSpPr>
-        <p:spPr>
-          <a:xfrm>
-            <a:off x="685800" y="1554480"/>
-            <a:ext cx="5029200" cy="1417320"/>
+            <a:off x="731520" y="1280160"/>
+            <a:ext cx="7680960" cy="3108960"/>
           </a:xfrm>
           <a:prstGeom prst="rect">
             <a:avLst/>
@@ -2428,7 +2389,7 @@
               <a:buNone/>
             </a:pPr>
             <a:r>
-              <a:rPr lang="he-IL" altLang="en-US" sz="1200" dirty="0">
+              <a:rPr lang="he-IL" altLang="en-US" sz="1400" dirty="0">
                 <a:solidFill>
                   <a:srgbClr val="22303F"/>
                 </a:solidFill>
@@ -2436,46 +2397,7 @@
                 <a:ea typeface="Arial" pitchFamily="34" charset="-122"/>
                 <a:cs typeface="Arial" pitchFamily="34" charset="-120"/>
               </a:rPr>
-              <a:t>בית הסוהר הוא מוסד שבו סמכות הסגל כמעט מוחלטת, ובכל זאת הסדר היומיומי באגף תלוי בשיתוף פעולה של האסירים. ספרקס ובוטומס (1995) טענו שסדר בבתי סוהר אינו מתקיים בכוח בלבד אלא נשען על תחושת האסירים שהמשטר הוגן ושמי שמפעיל אותו ראוי לציות. תחושה זו היא הלגיטימיות: המידה שבה האסיר תופס את הסגל כמכבד, כנגיש וכהוגן בטיפול בבקשותיו.</a:t>
-            </a:r>
-            <a:endParaRPr lang="he-IL" sz="1200" dirty="0"/>
-          </a:p>
-        </p:txBody>
-      </p:sp>
-      <p:sp>
-        <p:nvSpPr>
-          <p:cNvPr id="6" name="Text 4"/>
-          <p:cNvSpPr txBox="1"/>
-          <p:nvPr/>
-        </p:nvSpPr>
-        <p:spPr>
-          <a:xfrm>
-            <a:off x="685800" y="3017520"/>
-            <a:ext cx="5029200" cy="320040"/>
-          </a:xfrm>
-          <a:prstGeom prst="rect">
-            <a:avLst/>
-          </a:prstGeom>
-          <a:noFill/>
-          <a:ln/>
-        </p:spPr>
-        <p:txBody>
-          <a:bodyPr wrap="square" lIns="0" tIns="0" rIns="0" bIns="0" rtlCol="0" anchor="t"/>
-          <a:lstStyle/>
-          <a:p>
-            <a:pPr rtl="1" algn="r" indent="0" marL="0">
-              <a:buNone/>
-            </a:pPr>
-            <a:r>
-              <a:rPr lang="he-IL" altLang="en-US" sz="1400" b="1" dirty="0">
-                <a:solidFill>
-                  <a:srgbClr val="E8892B"/>
-                </a:solidFill>
-                <a:latin typeface="Arial" pitchFamily="34" charset="0"/>
-                <a:ea typeface="Arial" pitchFamily="34" charset="-122"/>
-                <a:cs typeface="Arial" pitchFamily="34" charset="-120"/>
-              </a:rPr>
-              <a:t>ההקשר הישראלי</a:t>
+              <a:t>בית הסוהר הוא מוסד שבו סמכות הסגל כמעט מוחלטת, ובכל זאת הסדר היומיומי באגף תלוי בשיתוף פעולה של האסירים. ספרקס ובוטומס (1995) טענו שסדר בבתי סוהר אינו מתקיים בכוח בלבד אלא נשען על תחושת האסירים שהמשטר הוגן ושמי שמפעיל אותו ראוי לציות, ותחושה זו היא הלגיטימיות: המידה שבה האסיר תופס את הסגל כמכבד, כנגיש וכהוגן בטיפול בבקשותיו. ההקשר הישראלי מוסיף לשאלה משקל, שכן במאי 2019 כ-80 אחוזים ממקומות הכליאה בישראל היו קטנים מתקן 4.5 מטרים רבועים לאסיר (יכימוביץ-כהן, 2020). על רקע זה נערך בסתיו 2021 סקר תנאי המחיה הראשון בהיקפו בשירות בתי הסוהר, בקרב 2,363 שפוטים ו-1,427 עצורים, ובו נמצא שהלגיטימיות ממתנת את הקשר בין תנאי המחיה לבין שביעות הרצון מפעילויות החינוך, הטיפול והשיקום (ועקנין, 2024). המחקר הנוכחי לוקח מאותו מערך נתונים חוט אחד ובוחן את הקשר הישיר בין רווחתו הנפשית של האסיר לבין האופן שבו הוא תופס את לגיטימיות הסגל, בקרב שפוטים בלבד, משום שלשפוט יש אופק ידוע ושהות ממושכת יותר מול אותו סגל.</a:t>
             </a:r>
             <a:endParaRPr lang="he-IL" sz="1400" dirty="0"/>
           </a:p>
@@ -2483,364 +2405,7 @@
       </p:sp>
       <p:sp>
         <p:nvSpPr>
-          <p:cNvPr id="7" name="Text 5"/>
-          <p:cNvSpPr txBox="1"/>
-          <p:nvPr/>
-        </p:nvSpPr>
-        <p:spPr>
-          <a:xfrm>
-            <a:off x="685800" y="3383280"/>
-            <a:ext cx="5029200" cy="1188720"/>
-          </a:xfrm>
-          <a:prstGeom prst="rect">
-            <a:avLst/>
-          </a:prstGeom>
-          <a:noFill/>
-          <a:ln/>
-        </p:spPr>
-        <p:txBody>
-          <a:bodyPr wrap="square" lIns="0" tIns="0" rIns="0" bIns="0" rtlCol="0" anchor="t"/>
-          <a:lstStyle/>
-          <a:p>
-            <a:pPr rtl="1" algn="just" indent="0" marL="0">
-              <a:lnSpc>
-                <a:spcPct val="115000"/>
-              </a:lnSpc>
-              <a:buNone/>
-            </a:pPr>
-            <a:r>
-              <a:rPr lang="he-IL" altLang="en-US" sz="1200" dirty="0">
-                <a:solidFill>
-                  <a:srgbClr val="22303F"/>
-                </a:solidFill>
-                <a:latin typeface="Arial" pitchFamily="34" charset="0"/>
-                <a:ea typeface="Arial" pitchFamily="34" charset="-122"/>
-                <a:cs typeface="Arial" pitchFamily="34" charset="-120"/>
-              </a:rPr>
-              <a:t>במאי 2019 כ-80 אחוזים ממקומות הכליאה בישראל היו קטנים מתקן 4.5 מטרים רבועים לאסיר (יכימוביץ-כהן, 2020). על רקע זה נערך בסתיו 2021 סקר תנאי המחיה הראשון בהיקפו בשירות בתי הסוהר, ובו נמצא שהלגיטימיות ממתנת את הקשר בין תנאי המחיה לשביעות הרצון מפעילויות השיקום (ועקנין, 2024). המחקר הנוכחי בוחן מאותו מערך את הקשר הישיר בין רווחה נפשית ללגיטימיות בקרב שפוטים.</a:t>
-            </a:r>
-            <a:endParaRPr lang="he-IL" sz="1200" dirty="0"/>
-          </a:p>
-        </p:txBody>
-      </p:sp>
-      <p:sp>
-        <p:nvSpPr>
-          <p:cNvPr id="8" name="Shape 6"/>
-          <p:cNvSpPr/>
-          <p:nvPr/>
-        </p:nvSpPr>
-        <p:spPr>
-          <a:xfrm>
-            <a:off x="6217920" y="1051560"/>
-            <a:ext cx="2468880" cy="1024128"/>
-          </a:xfrm>
-          <a:prstGeom prst="roundRect">
-            <a:avLst>
-              <a:gd name="adj" fmla="val 8929"/>
-            </a:avLst>
-          </a:prstGeom>
-          <a:solidFill>
-            <a:srgbClr val="1F3A5F"/>
-          </a:solidFill>
-          <a:ln w="12700">
-            <a:solidFill>
-              <a:srgbClr val="1F3A5F"/>
-            </a:solidFill>
-            <a:prstDash val="solid"/>
-          </a:ln>
-        </p:spPr>
-      </p:sp>
-      <p:sp>
-        <p:nvSpPr>
-          <p:cNvPr id="9" name="Text 7"/>
-          <p:cNvSpPr txBox="1"/>
-          <p:nvPr/>
-        </p:nvSpPr>
-        <p:spPr>
-          <a:xfrm>
-            <a:off x="6309360" y="1124712"/>
-            <a:ext cx="2286000" cy="548640"/>
-          </a:xfrm>
-          <a:prstGeom prst="rect">
-            <a:avLst/>
-          </a:prstGeom>
-          <a:noFill/>
-          <a:ln/>
-        </p:spPr>
-        <p:txBody>
-          <a:bodyPr wrap="square" lIns="0" tIns="0" rIns="0" bIns="0" rtlCol="0" anchor="ctr"/>
-          <a:lstStyle/>
-          <a:p>
-            <a:pPr algn="ctr" indent="0" marL="0">
-              <a:buNone/>
-            </a:pPr>
-            <a:r>
-              <a:rPr lang="en-US" sz="3000" b="1" dirty="0">
-                <a:solidFill>
-                  <a:srgbClr val="E8892B"/>
-                </a:solidFill>
-                <a:latin typeface="Arial" pitchFamily="34" charset="0"/>
-                <a:ea typeface="Arial" pitchFamily="34" charset="-122"/>
-                <a:cs typeface="Arial" pitchFamily="34" charset="-120"/>
-              </a:rPr>
-              <a:t>3,790</a:t>
-            </a:r>
-            <a:endParaRPr lang="en-US" sz="3000" dirty="0"/>
-          </a:p>
-        </p:txBody>
-      </p:sp>
-      <p:sp>
-        <p:nvSpPr>
-          <p:cNvPr id="10" name="Text 8"/>
-          <p:cNvSpPr txBox="1"/>
-          <p:nvPr/>
-        </p:nvSpPr>
-        <p:spPr>
-          <a:xfrm>
-            <a:off x="6309360" y="1691640"/>
-            <a:ext cx="2286000" cy="320040"/>
-          </a:xfrm>
-          <a:prstGeom prst="rect">
-            <a:avLst/>
-          </a:prstGeom>
-          <a:noFill/>
-          <a:ln/>
-        </p:spPr>
-        <p:txBody>
-          <a:bodyPr wrap="square" lIns="0" tIns="0" rIns="0" bIns="0" rtlCol="0" anchor="t"/>
-          <a:lstStyle/>
-          <a:p>
-            <a:pPr rtl="1" algn="ctr" indent="0" marL="0">
-              <a:buNone/>
-            </a:pPr>
-            <a:r>
-              <a:rPr lang="he-IL" altLang="en-US" sz="1100" dirty="0">
-                <a:solidFill>
-                  <a:srgbClr val="CFDBEA"/>
-                </a:solidFill>
-                <a:latin typeface="Arial" pitchFamily="34" charset="0"/>
-                <a:ea typeface="Arial" pitchFamily="34" charset="-122"/>
-                <a:cs typeface="Arial" pitchFamily="34" charset="-120"/>
-              </a:rPr>
-              <a:t>משתתפים בסקר שב"ס 2021</a:t>
-            </a:r>
-            <a:endParaRPr lang="he-IL" sz="1100" dirty="0"/>
-          </a:p>
-        </p:txBody>
-      </p:sp>
-      <p:sp>
-        <p:nvSpPr>
-          <p:cNvPr id="11" name="Shape 9"/>
-          <p:cNvSpPr/>
-          <p:nvPr/>
-        </p:nvSpPr>
-        <p:spPr>
-          <a:xfrm>
-            <a:off x="6217920" y="2304288"/>
-            <a:ext cx="2468880" cy="1024128"/>
-          </a:xfrm>
-          <a:prstGeom prst="roundRect">
-            <a:avLst>
-              <a:gd name="adj" fmla="val 8929"/>
-            </a:avLst>
-          </a:prstGeom>
-          <a:solidFill>
-            <a:srgbClr val="1F3A5F"/>
-          </a:solidFill>
-          <a:ln w="12700">
-            <a:solidFill>
-              <a:srgbClr val="1F3A5F"/>
-            </a:solidFill>
-            <a:prstDash val="solid"/>
-          </a:ln>
-        </p:spPr>
-      </p:sp>
-      <p:sp>
-        <p:nvSpPr>
-          <p:cNvPr id="12" name="Text 10"/>
-          <p:cNvSpPr txBox="1"/>
-          <p:nvPr/>
-        </p:nvSpPr>
-        <p:spPr>
-          <a:xfrm>
-            <a:off x="6309360" y="2377440"/>
-            <a:ext cx="2286000" cy="548640"/>
-          </a:xfrm>
-          <a:prstGeom prst="rect">
-            <a:avLst/>
-          </a:prstGeom>
-          <a:noFill/>
-          <a:ln/>
-        </p:spPr>
-        <p:txBody>
-          <a:bodyPr wrap="square" lIns="0" tIns="0" rIns="0" bIns="0" rtlCol="0" anchor="ctr"/>
-          <a:lstStyle/>
-          <a:p>
-            <a:pPr algn="ctr" indent="0" marL="0">
-              <a:buNone/>
-            </a:pPr>
-            <a:r>
-              <a:rPr lang="en-US" sz="3000" b="1" dirty="0">
-                <a:solidFill>
-                  <a:srgbClr val="E8892B"/>
-                </a:solidFill>
-                <a:latin typeface="Arial" pitchFamily="34" charset="0"/>
-                <a:ea typeface="Arial" pitchFamily="34" charset="-122"/>
-                <a:cs typeface="Arial" pitchFamily="34" charset="-120"/>
-              </a:rPr>
-              <a:t>2,379</a:t>
-            </a:r>
-            <a:endParaRPr lang="en-US" sz="3000" dirty="0"/>
-          </a:p>
-        </p:txBody>
-      </p:sp>
-      <p:sp>
-        <p:nvSpPr>
-          <p:cNvPr id="13" name="Text 11"/>
-          <p:cNvSpPr txBox="1"/>
-          <p:nvPr/>
-        </p:nvSpPr>
-        <p:spPr>
-          <a:xfrm>
-            <a:off x="6309360" y="2944368"/>
-            <a:ext cx="2286000" cy="320040"/>
-          </a:xfrm>
-          <a:prstGeom prst="rect">
-            <a:avLst/>
-          </a:prstGeom>
-          <a:noFill/>
-          <a:ln/>
-        </p:spPr>
-        <p:txBody>
-          <a:bodyPr wrap="square" lIns="0" tIns="0" rIns="0" bIns="0" rtlCol="0" anchor="t"/>
-          <a:lstStyle/>
-          <a:p>
-            <a:pPr rtl="1" algn="ctr" indent="0" marL="0">
-              <a:buNone/>
-            </a:pPr>
-            <a:r>
-              <a:rPr lang="he-IL" altLang="en-US" sz="1100" dirty="0">
-                <a:solidFill>
-                  <a:srgbClr val="CFDBEA"/>
-                </a:solidFill>
-                <a:latin typeface="Arial" pitchFamily="34" charset="0"/>
-                <a:ea typeface="Arial" pitchFamily="34" charset="-122"/>
-                <a:cs typeface="Arial" pitchFamily="34" charset="-120"/>
-              </a:rPr>
-              <a:t>שפוטים בניתוח הנוכחי</a:t>
-            </a:r>
-            <a:endParaRPr lang="he-IL" sz="1100" dirty="0"/>
-          </a:p>
-        </p:txBody>
-      </p:sp>
-      <p:sp>
-        <p:nvSpPr>
-          <p:cNvPr id="14" name="Shape 12"/>
-          <p:cNvSpPr/>
-          <p:nvPr/>
-        </p:nvSpPr>
-        <p:spPr>
-          <a:xfrm>
-            <a:off x="6217920" y="3547872"/>
-            <a:ext cx="2468880" cy="1024128"/>
-          </a:xfrm>
-          <a:prstGeom prst="roundRect">
-            <a:avLst>
-              <a:gd name="adj" fmla="val 8929"/>
-            </a:avLst>
-          </a:prstGeom>
-          <a:solidFill>
-            <a:srgbClr val="1F3A5F"/>
-          </a:solidFill>
-          <a:ln w="12700">
-            <a:solidFill>
-              <a:srgbClr val="1F3A5F"/>
-            </a:solidFill>
-            <a:prstDash val="solid"/>
-          </a:ln>
-        </p:spPr>
-      </p:sp>
-      <p:sp>
-        <p:nvSpPr>
-          <p:cNvPr id="15" name="Text 13"/>
-          <p:cNvSpPr txBox="1"/>
-          <p:nvPr/>
-        </p:nvSpPr>
-        <p:spPr>
-          <a:xfrm>
-            <a:off x="6309360" y="3621024"/>
-            <a:ext cx="2286000" cy="548640"/>
-          </a:xfrm>
-          <a:prstGeom prst="rect">
-            <a:avLst/>
-          </a:prstGeom>
-          <a:noFill/>
-          <a:ln/>
-        </p:spPr>
-        <p:txBody>
-          <a:bodyPr wrap="square" lIns="0" tIns="0" rIns="0" bIns="0" rtlCol="0" anchor="ctr"/>
-          <a:lstStyle/>
-          <a:p>
-            <a:pPr algn="ctr" indent="0" marL="0">
-              <a:buNone/>
-            </a:pPr>
-            <a:r>
-              <a:rPr lang="en-US" sz="3000" b="1" dirty="0">
-                <a:solidFill>
-                  <a:srgbClr val="E8892B"/>
-                </a:solidFill>
-                <a:latin typeface="Arial" pitchFamily="34" charset="0"/>
-                <a:ea typeface="Arial" pitchFamily="34" charset="-122"/>
-                <a:cs typeface="Arial" pitchFamily="34" charset="-120"/>
-              </a:rPr>
-              <a:t>9</a:t>
-            </a:r>
-            <a:endParaRPr lang="en-US" sz="3000" dirty="0"/>
-          </a:p>
-        </p:txBody>
-      </p:sp>
-      <p:sp>
-        <p:nvSpPr>
-          <p:cNvPr id="16" name="Text 14"/>
-          <p:cNvSpPr txBox="1"/>
-          <p:nvPr/>
-        </p:nvSpPr>
-        <p:spPr>
-          <a:xfrm>
-            <a:off x="6309360" y="4187952"/>
-            <a:ext cx="2286000" cy="320040"/>
-          </a:xfrm>
-          <a:prstGeom prst="rect">
-            <a:avLst/>
-          </a:prstGeom>
-          <a:noFill/>
-          <a:ln/>
-        </p:spPr>
-        <p:txBody>
-          <a:bodyPr wrap="square" lIns="0" tIns="0" rIns="0" bIns="0" rtlCol="0" anchor="t"/>
-          <a:lstStyle/>
-          <a:p>
-            <a:pPr rtl="1" algn="ctr" indent="0" marL="0">
-              <a:buNone/>
-            </a:pPr>
-            <a:r>
-              <a:rPr lang="he-IL" altLang="en-US" sz="1100" dirty="0">
-                <a:solidFill>
-                  <a:srgbClr val="CFDBEA"/>
-                </a:solidFill>
-                <a:latin typeface="Arial" pitchFamily="34" charset="0"/>
-                <a:ea typeface="Arial" pitchFamily="34" charset="-122"/>
-                <a:cs typeface="Arial" pitchFamily="34" charset="-120"/>
-              </a:rPr>
-              <a:t>תחומי תנאי מחיה בשאלון</a:t>
-            </a:r>
-            <a:endParaRPr lang="he-IL" sz="1100" dirty="0"/>
-          </a:p>
-        </p:txBody>
-      </p:sp>
-      <p:sp>
-        <p:nvSpPr>
-          <p:cNvPr id="17" name="Text 15"/>
+          <p:cNvPr id="5" name="Text 3"/>
           <p:cNvSpPr txBox="1"/>
           <p:nvPr/>
         </p:nvSpPr>
@@ -2879,7 +2444,7 @@
       </p:sp>
       <p:sp>
         <p:nvSpPr>
-          <p:cNvPr id="18" name="Text 16"/>
+          <p:cNvPr id="6" name="Text 4"/>
           <p:cNvSpPr txBox="1"/>
           <p:nvPr/>
         </p:nvSpPr>
@@ -2996,11 +2561,11 @@
         <p:spPr>
           <a:xfrm>
             <a:off x="457200" y="1051560"/>
-            <a:ext cx="8229600" cy="1691640"/>
+            <a:ext cx="8229600" cy="3566160"/>
           </a:xfrm>
           <a:prstGeom prst="roundRect">
             <a:avLst>
-              <a:gd name="adj" fmla="val 5405"/>
+              <a:gd name="adj" fmla="val 2564"/>
             </a:avLst>
           </a:prstGeom>
           <a:solidFill>
@@ -3022,47 +2587,8 @@
         </p:nvSpPr>
         <p:spPr>
           <a:xfrm>
-            <a:off x="685800" y="1161288"/>
-            <a:ext cx="7772400" cy="320040"/>
-          </a:xfrm>
-          <a:prstGeom prst="rect">
-            <a:avLst/>
-          </a:prstGeom>
-          <a:noFill/>
-          <a:ln/>
-        </p:spPr>
-        <p:txBody>
-          <a:bodyPr wrap="square" lIns="0" tIns="0" rIns="0" bIns="0" rtlCol="0" anchor="t"/>
-          <a:lstStyle/>
-          <a:p>
-            <a:pPr rtl="1" algn="r" indent="0" marL="0">
-              <a:buNone/>
-            </a:pPr>
-            <a:r>
-              <a:rPr lang="he-IL" altLang="en-US" sz="1400" b="1" dirty="0">
-                <a:solidFill>
-                  <a:srgbClr val="E8892B"/>
-                </a:solidFill>
-                <a:latin typeface="Arial" pitchFamily="34" charset="0"/>
-                <a:ea typeface="Arial" pitchFamily="34" charset="-122"/>
-                <a:cs typeface="Arial" pitchFamily="34" charset="-120"/>
-              </a:rPr>
-              <a:t>הסתגלות למאסר ורווחה נפשית</a:t>
-            </a:r>
-            <a:endParaRPr lang="he-IL" sz="1400" dirty="0"/>
-          </a:p>
-        </p:txBody>
-      </p:sp>
-      <p:sp>
-        <p:nvSpPr>
-          <p:cNvPr id="5" name="Text 3"/>
-          <p:cNvSpPr txBox="1"/>
-          <p:nvPr/>
-        </p:nvSpPr>
-        <p:spPr>
-          <a:xfrm>
-            <a:off x="685800" y="1508760"/>
-            <a:ext cx="7772400" cy="1188720"/>
+            <a:off x="731520" y="1234440"/>
+            <a:ext cx="7680960" cy="3246120"/>
           </a:xfrm>
           <a:prstGeom prst="rect">
             <a:avLst/>
@@ -3081,7 +2607,7 @@
               <a:buNone/>
             </a:pPr>
             <a:r>
-              <a:rPr lang="he-IL" altLang="en-US" sz="1150" dirty="0">
+              <a:rPr lang="he-IL" altLang="en-US" sz="1250" dirty="0">
                 <a:solidFill>
                   <a:srgbClr val="22303F"/>
                 </a:solidFill>
@@ -3089,123 +2615,15 @@
                 <a:ea typeface="Arial" pitchFamily="34" charset="-122"/>
                 <a:cs typeface="Arial" pitchFamily="34" charset="-120"/>
               </a:rPr>
-              <a:t>הספרות עברה מתיאור כללי של כאבי המאסר לבחינה של ההבדלים בין בתי סוהר. אוטי וליבלינג (2024) זיהו על בסיס 518 סקרי איכות חיים באנגליה שמתחת לסף של 3.05 ביחסי סגל ואסירים עולים בחדות שיעורי האלימות והפגיעה העצמית, וון גינקן ואחרים (2019) מצאו בקרב 4,538 אסירים בהולנד שתפיסות אישיות של אוטונומיה וביטחון קשורות לרווחה. במערך אורך באוסטרליה הראו סרג'נט ואחרים (2026) שצדק פרוצדורלי מעלה את הרווחה הנפשית, ושהיחסים עם הסגל הם המנגנון המתווך.</a:t>
-            </a:r>
-            <a:endParaRPr lang="he-IL" sz="1150" dirty="0"/>
-          </a:p>
-        </p:txBody>
-      </p:sp>
-      <p:sp>
-        <p:nvSpPr>
-          <p:cNvPr id="6" name="Shape 4"/>
-          <p:cNvSpPr/>
-          <p:nvPr/>
-        </p:nvSpPr>
-        <p:spPr>
-          <a:xfrm>
-            <a:off x="457200" y="2880360"/>
-            <a:ext cx="8229600" cy="1737360"/>
-          </a:xfrm>
-          <a:prstGeom prst="roundRect">
-            <a:avLst>
-              <a:gd name="adj" fmla="val 5263"/>
-            </a:avLst>
-          </a:prstGeom>
-          <a:solidFill>
-            <a:srgbClr val="FFFFFF"/>
-          </a:solidFill>
-          <a:ln w="12700">
-            <a:solidFill>
-              <a:srgbClr val="C9D6E4"/>
-            </a:solidFill>
-            <a:prstDash val="solid"/>
-          </a:ln>
-        </p:spPr>
-      </p:sp>
-      <p:sp>
-        <p:nvSpPr>
-          <p:cNvPr id="7" name="Text 5"/>
-          <p:cNvSpPr txBox="1"/>
-          <p:nvPr/>
-        </p:nvSpPr>
-        <p:spPr>
-          <a:xfrm>
-            <a:off x="685800" y="2990088"/>
-            <a:ext cx="7772400" cy="320040"/>
-          </a:xfrm>
-          <a:prstGeom prst="rect">
-            <a:avLst/>
-          </a:prstGeom>
-          <a:noFill/>
-          <a:ln/>
-        </p:spPr>
-        <p:txBody>
-          <a:bodyPr wrap="square" lIns="0" tIns="0" rIns="0" bIns="0" rtlCol="0" anchor="t"/>
-          <a:lstStyle/>
-          <a:p>
-            <a:pPr rtl="1" algn="r" indent="0" marL="0">
-              <a:buNone/>
-            </a:pPr>
-            <a:r>
-              <a:rPr lang="he-IL" altLang="en-US" sz="1400" b="1" dirty="0">
-                <a:solidFill>
-                  <a:srgbClr val="E8892B"/>
-                </a:solidFill>
-                <a:latin typeface="Arial" pitchFamily="34" charset="0"/>
-                <a:ea typeface="Arial" pitchFamily="34" charset="-122"/>
-                <a:cs typeface="Arial" pitchFamily="34" charset="-120"/>
-              </a:rPr>
-              <a:t>לגיטימיות של סגל הכליאה</a:t>
-            </a:r>
-            <a:endParaRPr lang="he-IL" sz="1400" dirty="0"/>
-          </a:p>
-        </p:txBody>
-      </p:sp>
-      <p:sp>
-        <p:nvSpPr>
-          <p:cNvPr id="8" name="Text 6"/>
-          <p:cNvSpPr txBox="1"/>
-          <p:nvPr/>
-        </p:nvSpPr>
-        <p:spPr>
-          <a:xfrm>
-            <a:off x="685800" y="3337560"/>
-            <a:ext cx="7772400" cy="1234440"/>
-          </a:xfrm>
-          <a:prstGeom prst="rect">
-            <a:avLst/>
-          </a:prstGeom>
-          <a:noFill/>
-          <a:ln/>
-        </p:spPr>
-        <p:txBody>
-          <a:bodyPr wrap="square" lIns="0" tIns="0" rIns="0" bIns="0" rtlCol="0" anchor="t"/>
-          <a:lstStyle/>
-          <a:p>
-            <a:pPr rtl="1" algn="just" indent="0" marL="0">
-              <a:lnSpc>
-                <a:spcPct val="115000"/>
-              </a:lnSpc>
-              <a:buNone/>
-            </a:pPr>
-            <a:r>
-              <a:rPr lang="he-IL" altLang="en-US" sz="1150" dirty="0">
-                <a:solidFill>
-                  <a:srgbClr val="22303F"/>
-                </a:solidFill>
-                <a:latin typeface="Arial" pitchFamily="34" charset="0"/>
-                <a:ea typeface="Arial" pitchFamily="34" charset="-122"/>
-                <a:cs typeface="Arial" pitchFamily="34" charset="-120"/>
-              </a:rPr>
-              <a:t>ברנטון-סמית ומקארתי (2016) ניתחו סקר של יותר מ-3,000 אסירים באנגליה ובוויילס ומצאו שההוגנות הפרוצדורלית היא המנבא החזק ביותר של לגיטימיות, ופרנקה ואחרים (2010) הראו בניסוי אקראי שדלות סביבתית וחוויות שליליות הן שמכרסמות בלגיטימיות במהלך המאסר. בישראל מצא ועקנין (2024) לגיטימיות גבוהה יחסית, גבוהה יותר בקרב שפוטים מאשר בקרב עצורים, והציע לראות בה כלי ניהולי באגף. הקשר הישיר בין רווחה נפשית ללגיטימיות בקרב שפוטים טרם נבחן, וזהו הפער שהמחקר הנוכחי מבקש למלא.</a:t>
-            </a:r>
-            <a:endParaRPr lang="he-IL" sz="1150" dirty="0"/>
-          </a:p>
-        </p:txBody>
-      </p:sp>
-      <p:sp>
-        <p:nvSpPr>
-          <p:cNvPr id="9" name="Text 7"/>
+              <a:t>הספרות על הסתגלות למאסר עברה מתיאור כללי של כאבי המאסר לבחינה של ההבדלים בין בתי סוהר ובין אסירים. אוטי וליבלינג (2024) זיהו, על בסיס 518 סקרי איכות חיים באנגליה ובוויילס, שמתחת לסף של 3.05 ביחסי סגל ואסירים עולים בחדות שיעורי האלימות והפגיעה העצמית, וון גינקן ואחרים (2019) מצאו בקרב 4,538 אסירים בהולנד שתפיסות אישיות של אוטונומיה וביטחון קשורות לרווחה הנפשית. במערך אורך באוסטרליה הראו סרג'נט ואחרים (2026) שצדק פרוצדורלי מעלה את הרווחה הנפשית ושהיחסים עם הסגל הם המנגנון המתווך. בתחום הלגיטימיות ניתחו ברנטון-סמית ומקארתי (2016) סקר של יותר מ-3,000 אסירים ומצאו שההוגנות הפרוצדורלית היא המנבא החזק ביותר של לגיטימיות, ופרנקה ואחרים (2010) הראו בניסוי אקראי שדלות סביבתית וחוויות שליליות הן שמכרסמות בלגיטימיות במהלך המאסר. בישראל מצא ועקנין (2024) לגיטימיות גבוהה יחסית, גבוהה יותר בקרב שפוטים מאשר בקרב עצורים, והציע לראות בה כלי ניהולי באגף. הקשר הישיר בין רווחה נפשית ללגיטימיות בקרב שפוטים טרם נבחן, וזהו הפער שהמחקר הנוכחי מבקש למלא.</a:t>
+            </a:r>
+            <a:endParaRPr lang="he-IL" sz="1250" dirty="0"/>
+          </a:p>
+        </p:txBody>
+      </p:sp>
+      <p:sp>
+        <p:nvSpPr>
+          <p:cNvPr id="5" name="Text 3"/>
           <p:cNvSpPr txBox="1"/>
           <p:nvPr/>
         </p:nvSpPr>
@@ -3244,7 +2662,7 @@
       </p:sp>
       <p:sp>
         <p:nvSpPr>
-          <p:cNvPr id="10" name="Text 8"/>
+          <p:cNvPr id="6" name="Text 4"/>
           <p:cNvSpPr txBox="1"/>
           <p:nvPr/>
         </p:nvSpPr>
@@ -3346,7 +2764,7 @@
                 <a:ea typeface="Arial" pitchFamily="34" charset="-122"/>
                 <a:cs typeface="Arial" pitchFamily="34" charset="-120"/>
               </a:rPr>
-              <a:t>שאלת המחקר והשערת המחקר</a:t>
+              <a:t>שאלת המחקר</a:t>
             </a:r>
             <a:endParaRPr lang="he-IL" sz="3000" dirty="0"/>
           </a:p>
@@ -3426,8 +2844,8 @@
         </p:nvSpPr>
         <p:spPr>
           <a:xfrm>
-            <a:off x="4663440" y="2148840"/>
-            <a:ext cx="4023360" cy="2468880"/>
+            <a:off x="457200" y="2148840"/>
+            <a:ext cx="8229600" cy="2468880"/>
           </a:xfrm>
           <a:prstGeom prst="roundRect">
             <a:avLst>
@@ -3453,47 +2871,8 @@
         </p:nvSpPr>
         <p:spPr>
           <a:xfrm>
-            <a:off x="4846320" y="2258568"/>
-            <a:ext cx="3657600" cy="320040"/>
-          </a:xfrm>
-          <a:prstGeom prst="rect">
-            <a:avLst/>
-          </a:prstGeom>
-          <a:noFill/>
-          <a:ln/>
-        </p:spPr>
-        <p:txBody>
-          <a:bodyPr wrap="square" lIns="0" tIns="0" rIns="0" bIns="0" rtlCol="0" anchor="t"/>
-          <a:lstStyle/>
-          <a:p>
-            <a:pPr rtl="1" algn="r" indent="0" marL="0">
-              <a:buNone/>
-            </a:pPr>
-            <a:r>
-              <a:rPr lang="he-IL" altLang="en-US" sz="1400" b="1" dirty="0">
-                <a:solidFill>
-                  <a:srgbClr val="E8892B"/>
-                </a:solidFill>
-                <a:latin typeface="Arial" pitchFamily="34" charset="0"/>
-                <a:ea typeface="Arial" pitchFamily="34" charset="-122"/>
-                <a:cs typeface="Arial" pitchFamily="34" charset="-120"/>
-              </a:rPr>
-              <a:t>משתני המחקר</a:t>
-            </a:r>
-            <a:endParaRPr lang="he-IL" sz="1400" dirty="0"/>
-          </a:p>
-        </p:txBody>
-      </p:sp>
-      <p:sp>
-        <p:nvSpPr>
-          <p:cNvPr id="7" name="Text 5"/>
-          <p:cNvSpPr txBox="1"/>
-          <p:nvPr/>
-        </p:nvSpPr>
-        <p:spPr>
-          <a:xfrm>
-            <a:off x="4846320" y="2606040"/>
-            <a:ext cx="3657600" cy="1965960"/>
+            <a:off x="731520" y="2331720"/>
+            <a:ext cx="7680960" cy="2148840"/>
           </a:xfrm>
           <a:prstGeom prst="rect">
             <a:avLst/>
@@ -3512,7 +2891,7 @@
               <a:buNone/>
             </a:pPr>
             <a:r>
-              <a:rPr lang="he-IL" altLang="en-US" sz="1150" dirty="0">
+              <a:rPr lang="he-IL" altLang="en-US" sz="1300" dirty="0">
                 <a:solidFill>
                   <a:srgbClr val="22303F"/>
                 </a:solidFill>
@@ -3520,123 +2899,15 @@
                 <a:ea typeface="Arial" pitchFamily="34" charset="-122"/>
                 <a:cs typeface="Arial" pitchFamily="34" charset="-120"/>
               </a:rPr>
-              <a:t>המשתנה התלוי הוא תפיסת הלגיטימיות של הסגל, הנמדדת בשלושה פריטים: האפשרות לדבר עם הסוהרים כשמודאגים או עצובים, היחס המכבד של הסוהרים ושביעות הרצון מהטיפול בבקשות (α = 0.67). המשתנה הבלתי תלוי הוא הרווחה הנפשית, הנמדדת בחמישה פריטים של בריאות גופנית ונפשית, שיפור בבריאות מאז המאסר, שמחה ושביעות רצון מהחיים (α = 0.81). שני הסולמות בטווח של 1 עד 5.</a:t>
-            </a:r>
-            <a:endParaRPr lang="he-IL" sz="1150" dirty="0"/>
-          </a:p>
-        </p:txBody>
-      </p:sp>
-      <p:sp>
-        <p:nvSpPr>
-          <p:cNvPr id="8" name="Shape 6"/>
-          <p:cNvSpPr/>
-          <p:nvPr/>
-        </p:nvSpPr>
-        <p:spPr>
-          <a:xfrm>
-            <a:off x="457200" y="2148840"/>
-            <a:ext cx="4023360" cy="2468880"/>
-          </a:xfrm>
-          <a:prstGeom prst="roundRect">
-            <a:avLst>
-              <a:gd name="adj" fmla="val 3704"/>
-            </a:avLst>
-          </a:prstGeom>
-          <a:solidFill>
-            <a:srgbClr val="FFFFFF"/>
-          </a:solidFill>
-          <a:ln w="12700">
-            <a:solidFill>
-              <a:srgbClr val="C9D6E4"/>
-            </a:solidFill>
-            <a:prstDash val="solid"/>
-          </a:ln>
-        </p:spPr>
-      </p:sp>
-      <p:sp>
-        <p:nvSpPr>
-          <p:cNvPr id="9" name="Text 7"/>
-          <p:cNvSpPr txBox="1"/>
-          <p:nvPr/>
-        </p:nvSpPr>
-        <p:spPr>
-          <a:xfrm>
-            <a:off x="640080" y="2258568"/>
-            <a:ext cx="3657600" cy="320040"/>
-          </a:xfrm>
-          <a:prstGeom prst="rect">
-            <a:avLst/>
-          </a:prstGeom>
-          <a:noFill/>
-          <a:ln/>
-        </p:spPr>
-        <p:txBody>
-          <a:bodyPr wrap="square" lIns="0" tIns="0" rIns="0" bIns="0" rtlCol="0" anchor="t"/>
-          <a:lstStyle/>
-          <a:p>
-            <a:pPr rtl="1" algn="r" indent="0" marL="0">
-              <a:buNone/>
-            </a:pPr>
-            <a:r>
-              <a:rPr lang="he-IL" altLang="en-US" sz="1400" b="1" dirty="0">
-                <a:solidFill>
-                  <a:srgbClr val="E8892B"/>
-                </a:solidFill>
-                <a:latin typeface="Arial" pitchFamily="34" charset="0"/>
-                <a:ea typeface="Arial" pitchFamily="34" charset="-122"/>
-                <a:cs typeface="Arial" pitchFamily="34" charset="-120"/>
-              </a:rPr>
-              <a:t>השערה ושיטה</a:t>
-            </a:r>
-            <a:endParaRPr lang="he-IL" sz="1400" dirty="0"/>
-          </a:p>
-        </p:txBody>
-      </p:sp>
-      <p:sp>
-        <p:nvSpPr>
-          <p:cNvPr id="10" name="Text 8"/>
-          <p:cNvSpPr txBox="1"/>
-          <p:nvPr/>
-        </p:nvSpPr>
-        <p:spPr>
-          <a:xfrm>
-            <a:off x="640080" y="2606040"/>
-            <a:ext cx="3657600" cy="1965960"/>
-          </a:xfrm>
-          <a:prstGeom prst="rect">
-            <a:avLst/>
-          </a:prstGeom>
-          <a:noFill/>
-          <a:ln/>
-        </p:spPr>
-        <p:txBody>
-          <a:bodyPr wrap="square" lIns="0" tIns="0" rIns="0" bIns="0" rtlCol="0" anchor="t"/>
-          <a:lstStyle/>
-          <a:p>
-            <a:pPr rtl="1" algn="just" indent="0" marL="0">
-              <a:lnSpc>
-                <a:spcPct val="115000"/>
-              </a:lnSpc>
-              <a:buNone/>
-            </a:pPr>
-            <a:r>
-              <a:rPr lang="he-IL" altLang="en-US" sz="1150" dirty="0">
-                <a:solidFill>
-                  <a:srgbClr val="22303F"/>
-                </a:solidFill>
-                <a:latin typeface="Arial" pitchFamily="34" charset="0"/>
-                <a:ea typeface="Arial" pitchFamily="34" charset="-122"/>
-                <a:cs typeface="Arial" pitchFamily="34" charset="-120"/>
-              </a:rPr>
-              <a:t>השערת המחקר היא שיימצא קשר חיובי מובהק בין רווחה נפשית לבין לגיטימיות, כך שככל שהרווחה גבוהה יותר, הלגיטימיות המיוחסת לסגל גבוהה יותר, ולהפך. המחקר הוא מחקר כמותי מתאמי במערך חתך, המבוסס על נתונים סינתטיים שנבנו על פי סקר תנאי המחיה של שב"ס משנת 2021, וצומצם ל-2,379 שפוטים. הניתוח נערך ב-SPSS וכלל סטטיסטיקה תיאורית, בדיקת מהימנות ומתאמי פירסון וספירמן.</a:t>
-            </a:r>
-            <a:endParaRPr lang="he-IL" sz="1150" dirty="0"/>
-          </a:p>
-        </p:txBody>
-      </p:sp>
-      <p:sp>
-        <p:nvSpPr>
-          <p:cNvPr id="11" name="Text 9"/>
+              <a:t>המשתנה התלוי הוא תפיסת הלגיטימיות של הסגל, הנמדדת בשלושה פריטים מתוך שאלון סקר תנאי המחיה: האפשרות לדבר עם הסוהרים כשמודאגים או עצובים, היחס המכבד של הסוהרים ושביעות הרצון מהטיפול בבקשות (α = 0.67). המשתנה הבלתי תלוי הוא הרווחה הנפשית, הנמדדת בחמישה פריטים של בריאות גופנית ונפשית, שיפור בבריאות מאז המאסר, שמחה ושביעות רצון מהחיים בחודש האחרון (α = 0.81), ושני הסולמות נעים בטווח של 1 עד 5. השערת המחקר היא שיימצא קשר חיובי מובהק בין רווחה נפשית לבין לגיטימיות, כך שככל שהרווחה גבוהה יותר, הלגיטימיות המיוחסת לסגל גבוהה יותר, ולהפך. המחקר הוא מחקר כמותי מתאמי במערך חתך, המבוסס על נתונים סינתטיים שנבנו על פי סקר שירות בתי הסוהר משנת 2021 וצומצמו ל-2,379 שפוטים, והניתוח נערך ב-SPSS וכלל סטטיסטיקה תיאורית, בדיקת מהימנות ומתאמי פירסון וספירמן.</a:t>
+            </a:r>
+            <a:endParaRPr lang="he-IL" sz="1300" dirty="0"/>
+          </a:p>
+        </p:txBody>
+      </p:sp>
+      <p:sp>
+        <p:nvSpPr>
+          <p:cNvPr id="7" name="Text 5"/>
           <p:cNvSpPr txBox="1"/>
           <p:nvPr/>
         </p:nvSpPr>
@@ -3675,7 +2946,7 @@
       </p:sp>
       <p:sp>
         <p:nvSpPr>
-          <p:cNvPr id="12" name="Text 10"/>
+          <p:cNvPr id="8" name="Text 6"/>
           <p:cNvSpPr txBox="1"/>
           <p:nvPr/>
         </p:nvSpPr>
@@ -3834,47 +3105,8 @@
         </p:nvSpPr>
         <p:spPr>
           <a:xfrm>
-            <a:off x="640080" y="1161288"/>
-            <a:ext cx="2651760" cy="320040"/>
-          </a:xfrm>
-          <a:prstGeom prst="rect">
-            <a:avLst/>
-          </a:prstGeom>
-          <a:noFill/>
-          <a:ln/>
-        </p:spPr>
-        <p:txBody>
-          <a:bodyPr wrap="square" lIns="0" tIns="0" rIns="0" bIns="0" rtlCol="0" anchor="t"/>
-          <a:lstStyle/>
-          <a:p>
-            <a:pPr rtl="1" algn="r" indent="0" marL="0">
-              <a:buNone/>
-            </a:pPr>
-            <a:r>
-              <a:rPr lang="he-IL" altLang="en-US" sz="1400" b="1" dirty="0">
-                <a:solidFill>
-                  <a:srgbClr val="E8892B"/>
-                </a:solidFill>
-                <a:latin typeface="Arial" pitchFamily="34" charset="0"/>
-                <a:ea typeface="Arial" pitchFamily="34" charset="-122"/>
-                <a:cs typeface="Arial" pitchFamily="34" charset="-120"/>
-              </a:rPr>
-              <a:t>מי הם השפוטים</a:t>
-            </a:r>
-            <a:endParaRPr lang="he-IL" sz="1400" dirty="0"/>
-          </a:p>
-        </p:txBody>
-      </p:sp>
-      <p:sp>
-        <p:nvSpPr>
-          <p:cNvPr id="6" name="Text 3"/>
-          <p:cNvSpPr txBox="1"/>
-          <p:nvPr/>
-        </p:nvSpPr>
-        <p:spPr>
-          <a:xfrm>
-            <a:off x="640080" y="1508760"/>
-            <a:ext cx="2651760" cy="3017520"/>
+            <a:off x="640080" y="1234440"/>
+            <a:ext cx="2651760" cy="3246120"/>
           </a:xfrm>
           <a:prstGeom prst="rect">
             <a:avLst/>
@@ -3893,7 +3125,7 @@
               <a:buNone/>
             </a:pPr>
             <a:r>
-              <a:rPr lang="he-IL" altLang="en-US" sz="1150" dirty="0">
+              <a:rPr lang="he-IL" altLang="en-US" sz="1200" dirty="0">
                 <a:solidFill>
                   <a:srgbClr val="22303F"/>
                 </a:solidFill>
@@ -3903,13 +3135,13 @@
               </a:rPr>
               <a:t>אוכלוסיית המחקר כוללת 2,379 אסירים שפוטים, רובם המכריע גברים, בגיל ממוצע של 37.9 שנים ובטווח של 18 עד 82. מעט יותר ממחציתם לא יהודים, כמחציתם במאסרם הראשון ולמעלה ממחציתם ריצו מאסר קודם. יותר משני שלישים שוהים באגף הנוכחי מעל שלושה חודשים, וכאחד מכל חמישה נמצא במסלול שיקום. ההתפלגות דומה לזו שדווחה בסקר המקורי (ועקנין, 2024).</a:t>
             </a:r>
-            <a:endParaRPr lang="he-IL" sz="1150" dirty="0"/>
-          </a:p>
-        </p:txBody>
-      </p:sp>
-      <p:sp>
-        <p:nvSpPr>
-          <p:cNvPr id="7" name="Text 4"/>
+            <a:endParaRPr lang="he-IL" sz="1200" dirty="0"/>
+          </a:p>
+        </p:txBody>
+      </p:sp>
+      <p:sp>
+        <p:nvSpPr>
+          <p:cNvPr id="6" name="Text 3"/>
           <p:cNvSpPr txBox="1"/>
           <p:nvPr/>
         </p:nvSpPr>
@@ -3948,7 +3180,7 @@
       </p:sp>
       <p:sp>
         <p:nvSpPr>
-          <p:cNvPr id="8" name="Text 5"/>
+          <p:cNvPr id="7" name="Text 4"/>
           <p:cNvSpPr txBox="1"/>
           <p:nvPr/>
         </p:nvSpPr>
@@ -4064,12 +3296,12 @@
         </p:nvSpPr>
         <p:spPr>
           <a:xfrm>
-            <a:off x="5852160" y="1005840"/>
-            <a:ext cx="2834640" cy="1188720"/>
+            <a:off x="6035040" y="1005840"/>
+            <a:ext cx="2651760" cy="2377440"/>
           </a:xfrm>
           <a:prstGeom prst="roundRect">
             <a:avLst>
-              <a:gd name="adj" fmla="val 9231"/>
+              <a:gd name="adj" fmla="val 4615"/>
             </a:avLst>
           </a:prstGeom>
           <a:solidFill>
@@ -4091,8 +3323,8 @@
         </p:nvSpPr>
         <p:spPr>
           <a:xfrm>
-            <a:off x="5943600" y="1051560"/>
-            <a:ext cx="2651760" cy="640080"/>
+            <a:off x="6126480" y="1234440"/>
+            <a:ext cx="2468880" cy="731520"/>
           </a:xfrm>
           <a:prstGeom prst="rect">
             <a:avLst/>
@@ -4108,7 +3340,7 @@
               <a:buNone/>
             </a:pPr>
             <a:r>
-              <a:rPr lang="en-US" sz="3800" b="1" dirty="0">
+              <a:rPr lang="en-US" sz="4000" b="1" dirty="0">
                 <a:solidFill>
                   <a:srgbClr val="E8892B"/>
                 </a:solidFill>
@@ -4118,7 +3350,7 @@
               </a:rPr>
               <a:t>r = 0.32</a:t>
             </a:r>
-            <a:endParaRPr lang="en-US" sz="3800" dirty="0"/>
+            <a:endParaRPr lang="en-US" sz="4000" dirty="0"/>
           </a:p>
         </p:txBody>
       </p:sp>
@@ -4130,8 +3362,8 @@
         </p:nvSpPr>
         <p:spPr>
           <a:xfrm>
-            <a:off x="5943600" y="1719072"/>
-            <a:ext cx="2651760" cy="365760"/>
+            <a:off x="6217920" y="2057400"/>
+            <a:ext cx="2286000" cy="1188720"/>
           </a:xfrm>
           <a:prstGeom prst="rect">
             <a:avLst/>
@@ -4147,7 +3379,7 @@
               <a:buNone/>
             </a:pPr>
             <a:r>
-              <a:rPr lang="he-IL" altLang="en-US" sz="1100" dirty="0">
+              <a:rPr lang="he-IL" altLang="en-US" sz="1200" dirty="0">
                 <a:solidFill>
                   <a:srgbClr val="CFDBEA"/>
                 </a:solidFill>
@@ -4155,26 +3387,42 @@
                 <a:ea typeface="Arial" pitchFamily="34" charset="-122"/>
                 <a:cs typeface="Arial" pitchFamily="34" charset="-120"/>
               </a:rPr>
-              <a:t>מתאם פירסון, p &lt; 0.001, N = 2,344</a:t>
-            </a:r>
-            <a:endParaRPr lang="he-IL" sz="1100" dirty="0"/>
-          </a:p>
-        </p:txBody>
-      </p:sp>
-      <p:sp>
-        <p:nvSpPr>
-          <p:cNvPr id="6" name="Shape 4"/>
+              <a:t>מתאם פירסון בין רווחה נפשית ללגיטימיות, p &lt; 0.001, N = 2,344. מתאם ספירמן rs = 0.34.</a:t>
+            </a:r>
+            <a:endParaRPr lang="he-IL" sz="1200" dirty="0"/>
+          </a:p>
+        </p:txBody>
+      </p:sp>
+      <p:graphicFrame>
+        <p:nvGraphicFramePr>
+          <p:cNvPr id="6" name="Chart 0" descr=""/>
+          <p:cNvGraphicFramePr/>
+          <p:nvPr/>
+        </p:nvGraphicFramePr>
+        <p:xfrm>
+          <a:off x="457200" y="1005840"/>
+          <a:ext cx="5394960" cy="2377440"/>
+        </p:xfrm>
+        <a:graphic xmlns:a="http://schemas.openxmlformats.org/drawingml/2006/main">
+          <a:graphicData uri="http://schemas.openxmlformats.org/drawingml/2006/chart">
+            <c:chart xmlns:c="http://schemas.openxmlformats.org/drawingml/2006/chart" r:id="rId1"/>
+          </a:graphicData>
+        </a:graphic>
+      </p:graphicFrame>
+      <p:sp>
+        <p:nvSpPr>
+          <p:cNvPr id="7" name="Shape 4"/>
           <p:cNvSpPr/>
           <p:nvPr/>
         </p:nvSpPr>
         <p:spPr>
           <a:xfrm>
-            <a:off x="5852160" y="2331720"/>
-            <a:ext cx="2834640" cy="2286000"/>
+            <a:off x="457200" y="3520440"/>
+            <a:ext cx="8229600" cy="1097280"/>
           </a:xfrm>
           <a:prstGeom prst="roundRect">
             <a:avLst>
-              <a:gd name="adj" fmla="val 4800"/>
+              <a:gd name="adj" fmla="val 8333"/>
             </a:avLst>
           </a:prstGeom>
           <a:solidFill>
@@ -4190,53 +3438,14 @@
       </p:sp>
       <p:sp>
         <p:nvSpPr>
-          <p:cNvPr id="7" name="Text 5"/>
+          <p:cNvPr id="8" name="Text 5"/>
           <p:cNvSpPr txBox="1"/>
           <p:nvPr/>
         </p:nvSpPr>
         <p:spPr>
           <a:xfrm>
-            <a:off x="6035040" y="2423160"/>
-            <a:ext cx="2468880" cy="320040"/>
-          </a:xfrm>
-          <a:prstGeom prst="rect">
-            <a:avLst/>
-          </a:prstGeom>
-          <a:noFill/>
-          <a:ln/>
-        </p:spPr>
-        <p:txBody>
-          <a:bodyPr wrap="square" lIns="0" tIns="0" rIns="0" bIns="0" rtlCol="0" anchor="t"/>
-          <a:lstStyle/>
-          <a:p>
-            <a:pPr rtl="1" algn="r" indent="0" marL="0">
-              <a:buNone/>
-            </a:pPr>
-            <a:r>
-              <a:rPr lang="he-IL" altLang="en-US" sz="1400" b="1" dirty="0">
-                <a:solidFill>
-                  <a:srgbClr val="E8892B"/>
-                </a:solidFill>
-                <a:latin typeface="Arial" pitchFamily="34" charset="0"/>
-                <a:ea typeface="Arial" pitchFamily="34" charset="-122"/>
-                <a:cs typeface="Arial" pitchFamily="34" charset="-120"/>
-              </a:rPr>
-              <a:t>פירוש הממצא</a:t>
-            </a:r>
-            <a:endParaRPr lang="he-IL" sz="1400" dirty="0"/>
-          </a:p>
-        </p:txBody>
-      </p:sp>
-      <p:sp>
-        <p:nvSpPr>
-          <p:cNvPr id="8" name="Text 6"/>
-          <p:cNvSpPr txBox="1"/>
-          <p:nvPr/>
-        </p:nvSpPr>
-        <p:spPr>
-          <a:xfrm>
-            <a:off x="6035040" y="2743200"/>
-            <a:ext cx="2468880" cy="1828800"/>
+            <a:off x="685800" y="3611880"/>
+            <a:ext cx="7772400" cy="960120"/>
           </a:xfrm>
           <a:prstGeom prst="rect">
             <a:avLst/>
@@ -4263,100 +3472,15 @@
                 <a:ea typeface="Arial" pitchFamily="34" charset="-122"/>
                 <a:cs typeface="Arial" pitchFamily="34" charset="-120"/>
               </a:rPr>
-              <a:t>נמצא קשר חיובי מובהק ברמה בינונית בין רווחה נפשית ללגיטימיות, ומתאם ספירמן (0.34) קרוב לפירסון. הקשר קיים בכל שלושת פריטי הלגיטימיות, והחזק שבהם הוא האפשרות לדבר עם הסוהרים (0.29). הרווחה חולקת עם הלגיטימיות כעשרה אחוזים מהשונות, וההשערה אוששה.</a:t>
+              <a:t>נמצא קשר חיובי מובהק ברמה בינונית בין רווחה נפשית ללגיטימיות, והוא קיים בכל שלושת פריטי הלגיטימיות, כשהחזק שבהם הוא האפשרות לדבר עם הסוהרים (0.29). ממוצע הלגיטימיות עמד על 4.24 (סטיית תקן 0.83) וממוצע הרווחה על 3.78 (סטיית תקן 0.87), והשפוטים ברמת הלגיטימיות הנמוכה דיווחו על רווחה ממוצעת של 3.34 לעומת 4.05 ברמה הגבוהה, פער של כ-0.7 נקודות שהוא כ-80 אחוזים מסטיית תקן. הרווחה חולקת עם הלגיטימיות כעשרה אחוזים מהשונות, ההשערה אוששה, והממצא עולה בקנה אחד עם המחקרים מהולנד, מאנגליה ומאוסטרליה.</a:t>
             </a:r>
             <a:endParaRPr lang="he-IL" sz="1100" dirty="0"/>
           </a:p>
         </p:txBody>
       </p:sp>
-      <p:graphicFrame>
-        <p:nvGraphicFramePr>
-          <p:cNvPr id="9" name="Chart 0" descr=""/>
-          <p:cNvGraphicFramePr/>
-          <p:nvPr/>
-        </p:nvGraphicFramePr>
-        <p:xfrm>
-          <a:off x="457200" y="1005840"/>
-          <a:ext cx="5212080" cy="2377440"/>
-        </p:xfrm>
-        <a:graphic xmlns:a="http://schemas.openxmlformats.org/drawingml/2006/main">
-          <a:graphicData uri="http://schemas.openxmlformats.org/drawingml/2006/chart">
-            <c:chart xmlns:c="http://schemas.openxmlformats.org/drawingml/2006/chart" r:id="rId1"/>
-          </a:graphicData>
-        </a:graphic>
-      </p:graphicFrame>
-      <p:sp>
-        <p:nvSpPr>
-          <p:cNvPr id="10" name="Shape 7"/>
-          <p:cNvSpPr/>
-          <p:nvPr/>
-        </p:nvSpPr>
-        <p:spPr>
-          <a:xfrm>
-            <a:off x="457200" y="3520440"/>
-            <a:ext cx="5212080" cy="1097280"/>
-          </a:xfrm>
-          <a:prstGeom prst="roundRect">
-            <a:avLst>
-              <a:gd name="adj" fmla="val 8333"/>
-            </a:avLst>
-          </a:prstGeom>
-          <a:solidFill>
-            <a:srgbClr val="FFFFFF"/>
-          </a:solidFill>
-          <a:ln w="12700">
-            <a:solidFill>
-              <a:srgbClr val="C9D6E4"/>
-            </a:solidFill>
-            <a:prstDash val="solid"/>
-          </a:ln>
-        </p:spPr>
-      </p:sp>
-      <p:sp>
-        <p:nvSpPr>
-          <p:cNvPr id="11" name="Text 8"/>
-          <p:cNvSpPr txBox="1"/>
-          <p:nvPr/>
-        </p:nvSpPr>
-        <p:spPr>
-          <a:xfrm>
-            <a:off x="640080" y="3611880"/>
-            <a:ext cx="4846320" cy="960120"/>
-          </a:xfrm>
-          <a:prstGeom prst="rect">
-            <a:avLst/>
-          </a:prstGeom>
-          <a:noFill/>
-          <a:ln/>
-        </p:spPr>
-        <p:txBody>
-          <a:bodyPr wrap="square" lIns="0" tIns="0" rIns="0" bIns="0" rtlCol="0" anchor="t"/>
-          <a:lstStyle/>
-          <a:p>
-            <a:pPr rtl="1" algn="just" indent="0" marL="0">
-              <a:lnSpc>
-                <a:spcPct val="115000"/>
-              </a:lnSpc>
-              <a:buNone/>
-            </a:pPr>
-            <a:r>
-              <a:rPr lang="he-IL" altLang="en-US" sz="1100" dirty="0">
-                <a:solidFill>
-                  <a:srgbClr val="22303F"/>
-                </a:solidFill>
-                <a:latin typeface="Arial" pitchFamily="34" charset="0"/>
-                <a:ea typeface="Arial" pitchFamily="34" charset="-122"/>
-                <a:cs typeface="Arial" pitchFamily="34" charset="-120"/>
-              </a:rPr>
-              <a:t>ממוצע הלגיטימיות עמד על 4.24 (סטיית תקן 0.83) וממוצע הרווחה הנפשית על 3.78 (סטיית תקן 0.87). השפוטים ברמת הלגיטימיות הנמוכה דיווחו על רווחה ממוצעת של 3.34, ואלו ברמה הגבוהה על 4.05, פער של כ-0.7 נקודות שהוא כ-80 אחוזים מסטיית תקן, בהלימה לממצאים מהולנד, מאנגליה ומאוסטרליה.</a:t>
-            </a:r>
-            <a:endParaRPr lang="he-IL" sz="1100" dirty="0"/>
-          </a:p>
-        </p:txBody>
-      </p:sp>
-      <p:sp>
-        <p:nvSpPr>
-          <p:cNvPr id="12" name="Text 9"/>
+      <p:sp>
+        <p:nvSpPr>
+          <p:cNvPr id="9" name="Text 6"/>
           <p:cNvSpPr txBox="1"/>
           <p:nvPr/>
         </p:nvSpPr>
@@ -4395,7 +3519,7 @@
       </p:sp>
       <p:sp>
         <p:nvSpPr>
-          <p:cNvPr id="13" name="Text 10"/>
+          <p:cNvPr id="10" name="Text 7"/>
           <p:cNvSpPr txBox="1"/>
           <p:nvPr/>
         </p:nvSpPr>

</xml_diff>

<commit_message>
Fix RTL text direction in slides and rebuild findings with tables
Text bodies now carry rtlCol=1, so a trailing period lands at the end of the
line instead of its start. The two findings slides present a background-
characteristics table and a means table beside the correlation chart.

Co-Authored-By: Claude Opus 5 <noreply@anthropic.com>
Claude-Session: https://claude.ai/code/session_01KHo5ZcKCUwhCAvyoKeeMWs
</commit_message>
<xml_diff>
--- a/seminar/רפרט_רווחה_נפשית_ולגיטימיות.pptx
+++ b/seminar/רפרט_רווחה_נפשית_ולגיטימיות.pptx
@@ -138,296 +138,7 @@
                 </a:solidFill>
                 <a:latin typeface="Arial"/>
               </a:rPr>
-              <a:t>מאפייני הרקע של השפוטים באחוזים (N = 2,379)</a:t>
-            </a:r>
-          </a:p>
-        </c:rich>
-      </c:tx>
-      <c:layout/>
-      <c:overlay val="0"/>
-    </c:title>
-    <c:autoTitleDeleted val="0"/>
-    <c:plotArea>
-      <c:layout/>
-      <c:barChart>
-        <c:barDir val="bar"/>
-        <c:grouping val="clustered"/>
-        <c:varyColors val="0"/>
-        <c:ser>
-          <c:idx val="0"/>
-          <c:order val="0"/>
-          <c:tx>
-            <c:strRef>
-              <c:f>Sheet1!$B$1</c:f>
-              <c:strCache>
-                <c:ptCount val="1"/>
-                <c:pt idx="0">
-                  <c:v>אחוז מהשפוטים</c:v>
-                </c:pt>
-              </c:strCache>
-            </c:strRef>
-          </c:tx>
-          <c:spPr>
-            <a:solidFill>
-              <a:srgbClr val="1F3A5F"/>
-            </a:solidFill>
-            <a:effectLst/>
-          </c:spPr>
-          <c:invertIfNegative val="0"/>
-          <c:dLbls>
-            <c:numFmt formatCode="0.0&quot;%&quot;" sourceLinked="0"/>
-            <c:txPr>
-              <a:bodyPr/>
-              <a:lstStyle/>
-              <a:p>
-                <a:pPr>
-                  <a:defRPr b="0" i="0" strike="noStrike" sz="1000" u="none">
-                    <a:solidFill>
-                      <a:srgbClr val="22303F"/>
-                    </a:solidFill>
-                    <a:latin typeface="Arial"/>
-                  </a:defRPr>
-                </a:pPr>
-              </a:p>
-            </c:txPr>
-            <c:showLegendKey val="0"/>
-            <c:showVal val="1"/>
-            <c:showCatName val="0"/>
-            <c:showSerName val="0"/>
-            <c:showPercent val="0"/>
-            <c:showBubbleSize val="0"/>
-            <c:showLeaderLines val="0"/>
-          </c:dLbls>
-          <c:cat>
-            <c:multiLvlStrRef>
-              <c:f>Sheet1!$A$2:$A$9</c:f>
-              <c:multiLvlStrCache>
-                <c:ptCount val="8"/>
-                <c:lvl>
-                  <c:pt idx="0">
-                    <c:v>גברים</c:v>
-                  </c:pt>
-                  <c:pt idx="1">
-                    <c:v>יהודים</c:v>
-                  </c:pt>
-                  <c:pt idx="2">
-                    <c:v>לא יהודים</c:v>
-                  </c:pt>
-                  <c:pt idx="3">
-                    <c:v>מאסר ראשון</c:v>
-                  </c:pt>
-                  <c:pt idx="4">
-                    <c:v>מאסר שני</c:v>
-                  </c:pt>
-                  <c:pt idx="5">
-                    <c:v>מאסר שלישי ומעלה</c:v>
-                  </c:pt>
-                  <c:pt idx="6">
-                    <c:v>מעל 3 חודשים באגף</c:v>
-                  </c:pt>
-                  <c:pt idx="7">
-                    <c:v>במסלול שיקום</c:v>
-                  </c:pt>
-                </c:lvl>
-              </c:multiLvlStrCache>
-            </c:multiLvlStrRef>
-          </c:cat>
-          <c:val>
-            <c:numRef>
-              <c:f>Sheet1!$B$2:$B$9</c:f>
-              <c:numCache>
-                <c:formatCode>General</c:formatCode>
-                <c:ptCount val="8"/>
-                <c:pt idx="0">
-                  <c:v>96.8</c:v>
-                </c:pt>
-                <c:pt idx="1">
-                  <c:v>47.8</c:v>
-                </c:pt>
-                <c:pt idx="2">
-                  <c:v>52.2</c:v>
-                </c:pt>
-                <c:pt idx="3">
-                  <c:v>48.8</c:v>
-                </c:pt>
-                <c:pt idx="4">
-                  <c:v>22.2</c:v>
-                </c:pt>
-                <c:pt idx="5">
-                  <c:v>29</c:v>
-                </c:pt>
-                <c:pt idx="6">
-                  <c:v>68.3</c:v>
-                </c:pt>
-                <c:pt idx="7">
-                  <c:v>20.4</c:v>
-                </c:pt>
-              </c:numCache>
-            </c:numRef>
-          </c:val>
-        </c:ser>
-        <c:dLbls>
-          <c:numFmt formatCode="0.0&quot;%&quot;" sourceLinked="0"/>
-          <c:txPr>
-            <a:bodyPr/>
-            <a:lstStyle/>
-            <a:p>
-              <a:pPr>
-                <a:defRPr b="0" i="0" strike="noStrike" sz="1000" u="none">
-                  <a:solidFill>
-                    <a:srgbClr val="22303F"/>
-                  </a:solidFill>
-                  <a:latin typeface="Arial"/>
-                </a:defRPr>
-              </a:pPr>
-            </a:p>
-          </c:txPr>
-          <c:showLegendKey val="0"/>
-          <c:showVal val="1"/>
-          <c:showCatName val="0"/>
-          <c:showSerName val="0"/>
-          <c:showPercent val="0"/>
-          <c:showBubbleSize val="0"/>
-          <c:showLeaderLines val="0"/>
-        </c:dLbls>
-        <c:gapWidth val="150"/>
-        <c:overlap val="0"/>
-        <c:axId val="2094734554"/>
-        <c:axId val="2094734552"/>
-        <c:axId val="2094734556"/>
-      </c:barChart>
-      <c:catAx>
-        <c:axId val="2094734554"/>
-        <c:scaling>
-          <c:orientation val="maxMin"/>
-        </c:scaling>
-        <c:delete val="0"/>
-        <c:axPos val="l"/>
-        <c:numFmt formatCode="General" sourceLinked="1"/>
-        <c:majorTickMark val="out"/>
-        <c:minorTickMark val="none"/>
-        <c:tickLblPos val="nextTo"/>
-        <c:spPr>
-          <a:ln w="12700" cap="flat">
-            <a:solidFill>
-              <a:srgbClr val="888888"/>
-            </a:solidFill>
-            <a:prstDash val="solid"/>
-            <a:round/>
-          </a:ln>
-        </c:spPr>
-        <c:txPr>
-          <a:bodyPr/>
-          <a:lstStyle/>
-          <a:p>
-            <a:pPr>
-              <a:defRPr sz="1000" b="0" i="0" u="none" strike="noStrike">
-                <a:solidFill>
-                  <a:srgbClr val="22303F"/>
-                </a:solidFill>
-                <a:latin typeface="Arial"/>
-              </a:defRPr>
-            </a:pPr>
-            <a:endParaRPr lang="en-US"/>
-          </a:p>
-        </c:txPr>
-        <c:crossAx val="2094734552"/>
-        <c:crosses val="autoZero"/>
-        <c:auto val="1"/>
-        <c:lblAlgn val="ctr"/>
-        <c:noMultiLvlLbl val="1"/>
-      </c:catAx>
-      <c:valAx>
-        <c:axId val="2094734552"/>
-        <c:scaling>
-          <c:orientation val="minMax"/>
-          <c:max val="115"/>
-        </c:scaling>
-        <c:delete val="1"/>
-        <c:axPos val="b"/>
-        <c:numFmt formatCode="General" sourceLinked="0"/>
-        <c:majorTickMark val="out"/>
-        <c:minorTickMark val="none"/>
-        <c:tickLblPos val="low"/>
-        <c:spPr>
-          <a:ln w="12700" cap="flat">
-            <a:solidFill>
-              <a:srgbClr val="888888"/>
-            </a:solidFill>
-            <a:prstDash val="solid"/>
-            <a:round/>
-          </a:ln>
-        </c:spPr>
-        <c:txPr>
-          <a:bodyPr/>
-          <a:lstStyle/>
-          <a:p>
-            <a:pPr>
-              <a:defRPr sz="1200" b="0" i="0" u="none" strike="noStrike">
-                <a:solidFill>
-                  <a:srgbClr val="000000"/>
-                </a:solidFill>
-                <a:latin typeface="Arial"/>
-              </a:defRPr>
-            </a:pPr>
-            <a:endParaRPr lang="en-US"/>
-          </a:p>
-        </c:txPr>
-        <c:crossAx val="2094734554"/>
-        <c:crosses val="autoZero"/>
-        <c:crossBetween val="between"/>
-      </c:valAx>
-      <c:spPr>
-        <a:noFill/>
-        <a:ln>
-          <a:noFill/>
-        </a:ln>
-        <a:effectLst/>
-      </c:spPr>
-    </c:plotArea>
-    <c:plotVisOnly val="1"/>
-    <c:dispBlanksAs val="span"/>
-  </c:chart>
-  <c:spPr>
-    <a:noFill/>
-    <a:ln>
-      <a:noFill/>
-    </a:ln>
-    <a:effectLst/>
-  </c:spPr>
-  <c:externalData r:id="rId1">
-    <c:autoUpdate val="0"/>
-  </c:externalData>
-</c:chartSpace>
-</file>
-
-<file path=ppt/charts/chart2.xml><?xml version="1.0" encoding="utf-8"?>
-<c:chartSpace xmlns:c="http://schemas.openxmlformats.org/drawingml/2006/chart" xmlns:a="http://schemas.openxmlformats.org/drawingml/2006/main" xmlns:r="http://schemas.openxmlformats.org/officeDocument/2006/relationships">
-  <c:date1904 val="0"/>
-  <c:roundedCorners val="1"/>
-  <c:chart>
-    <c:title>
-      <c:tx>
-        <c:rich>
-          <a:bodyPr/>
-          <a:lstStyle/>
-          <a:p>
-            <a:pPr>
-              <a:defRPr sz="1100" b="0" i="0" u="none" strike="noStrike">
-                <a:solidFill>
-                  <a:srgbClr val="1F3A5F"/>
-                </a:solidFill>
-                <a:latin typeface="Arial"/>
-              </a:defRPr>
-            </a:pPr>
-            <a:r>
-              <a:rPr sz="1100" b="0" i="0" u="none" strike="noStrike">
-                <a:solidFill>
-                  <a:srgbClr val="1F3A5F"/>
-                </a:solidFill>
-                <a:latin typeface="Arial"/>
-              </a:rPr>
-              <a:t>רווחה נפשית ממוצעת לפי רמת לגיטימיות (סולם 1 עד 5)</a:t>
+              <a:t>רווחה נפשית ממוצעת לפי רמת לגיטימיות</a:t>
             </a:r>
           </a:p>
         </c:rich>
@@ -470,7 +181,7 @@
               <a:lstStyle/>
               <a:p>
                 <a:pPr>
-                  <a:defRPr b="0" i="0" strike="noStrike" sz="1100" u="none">
+                  <a:defRPr b="0" i="0" strike="noStrike" sz="1200" u="none">
                     <a:solidFill>
                       <a:srgbClr val="22303F"/>
                     </a:solidFill>
@@ -494,13 +205,13 @@
                 <c:ptCount val="3"/>
                 <c:lvl>
                   <c:pt idx="0">
-                    <c:v>לגיטימיות נמוכה (עד 3.5)</c:v>
+                    <c:v>לגיטימיות נמוכה</c:v>
                   </c:pt>
                   <c:pt idx="1">
-                    <c:v>לגיטימיות בינונית (3.5 עד 4.5)</c:v>
+                    <c:v>לגיטימיות בינונית</c:v>
                   </c:pt>
                   <c:pt idx="2">
-                    <c:v>לגיטימיות גבוהה (מעל 4.5)</c:v>
+                    <c:v>לגיטימיות גבוהה</c:v>
                   </c:pt>
                 </c:lvl>
               </c:multiLvlStrCache>
@@ -532,7 +243,7 @@
             <a:lstStyle/>
             <a:p>
               <a:pPr>
-                <a:defRPr b="0" i="0" strike="noStrike" sz="1100" u="none">
+                <a:defRPr b="0" i="0" strike="noStrike" sz="1200" u="none">
                   <a:solidFill>
                     <a:srgbClr val="22303F"/>
                   </a:solidFill>
@@ -549,7 +260,7 @@
           <c:showBubbleSize val="0"/>
           <c:showLeaderLines val="0"/>
         </c:dLbls>
-        <c:gapWidth val="60"/>
+        <c:gapWidth val="55"/>
         <c:overlap val="0"/>
         <c:axId val="2094734554"/>
         <c:axId val="2094734552"/>
@@ -580,7 +291,7 @@
           <a:lstStyle/>
           <a:p>
             <a:pPr>
-              <a:defRPr sz="900" b="0" i="0" u="none" strike="noStrike">
+              <a:defRPr sz="1000" b="0" i="0" u="none" strike="noStrike">
                 <a:solidFill>
                   <a:srgbClr val="22303F"/>
                 </a:solidFill>
@@ -600,8 +311,8 @@
         <c:axId val="2094734552"/>
         <c:scaling>
           <c:orientation val="minMax"/>
-          <c:max val="5"/>
-          <c:min val="1"/>
+          <c:max val="4.4"/>
+          <c:min val="3"/>
         </c:scaling>
         <c:delete val="0"/>
         <c:axPos val="l"/>
@@ -1942,7 +1653,7 @@
           <a:ln/>
         </p:spPr>
         <p:txBody>
-          <a:bodyPr wrap="square" lIns="0" tIns="0" rIns="0" bIns="0" rtlCol="0" anchor="t"/>
+          <a:bodyPr wrap="square" lIns="0" tIns="0" rIns="0" bIns="0" rtlCol="1" anchor="t"/>
           <a:lstStyle/>
           <a:p>
             <a:pPr rtl="1" algn="r" indent="0" marL="0">
@@ -1981,7 +1692,7 @@
           <a:ln/>
         </p:spPr>
         <p:txBody>
-          <a:bodyPr wrap="square" lIns="0" tIns="0" rIns="0" bIns="0" rtlCol="0" anchor="t"/>
+          <a:bodyPr wrap="square" lIns="0" tIns="0" rIns="0" bIns="0" rtlCol="1" anchor="t"/>
           <a:lstStyle/>
           <a:p>
             <a:pPr rtl="1" algn="r" indent="0" marL="0">
@@ -2020,7 +1731,7 @@
           <a:ln/>
         </p:spPr>
         <p:txBody>
-          <a:bodyPr wrap="square" lIns="0" tIns="0" rIns="0" bIns="0" rtlCol="0" anchor="t"/>
+          <a:bodyPr wrap="square" lIns="0" tIns="0" rIns="0" bIns="0" rtlCol="1" anchor="t"/>
           <a:lstStyle/>
           <a:p>
             <a:pPr rtl="1" algn="r" indent="0" marL="0">
@@ -2059,7 +1770,7 @@
           <a:ln/>
         </p:spPr>
         <p:txBody>
-          <a:bodyPr wrap="square" lIns="0" tIns="0" rIns="0" bIns="0" rtlCol="0" anchor="ctr"/>
+          <a:bodyPr wrap="square" lIns="0" tIns="0" rIns="0" bIns="0" rtlCol="1" anchor="ctr"/>
           <a:lstStyle/>
           <a:p>
             <a:pPr rtl="1" algn="r" indent="0" marL="0">
@@ -2098,7 +1809,7 @@
           <a:ln/>
         </p:spPr>
         <p:txBody>
-          <a:bodyPr wrap="square" lIns="0" tIns="0" rIns="0" bIns="0" rtlCol="0" anchor="ctr"/>
+          <a:bodyPr wrap="square" lIns="0" tIns="0" rIns="0" bIns="0" rtlCol="1" anchor="ctr"/>
           <a:lstStyle/>
           <a:p>
             <a:pPr rtl="1" algn="r" indent="0" marL="0">
@@ -2164,7 +1875,7 @@
           <a:ln/>
         </p:spPr>
         <p:txBody>
-          <a:bodyPr wrap="square" lIns="0" tIns="0" rIns="0" bIns="0" rtlCol="0" anchor="t"/>
+          <a:bodyPr wrap="square" lIns="0" tIns="0" rIns="0" bIns="0" rtlCol="1" anchor="t"/>
           <a:lstStyle/>
           <a:p>
             <a:pPr rtl="1" algn="r" indent="0" marL="0">
@@ -2203,7 +1914,7 @@
           <a:ln/>
         </p:spPr>
         <p:txBody>
-          <a:bodyPr wrap="square" lIns="0" tIns="0" rIns="0" bIns="0" rtlCol="0" anchor="t"/>
+          <a:bodyPr wrap="square" lIns="0" tIns="0" rIns="0" bIns="0" rtlCol="1" anchor="t"/>
           <a:lstStyle/>
           <a:p>
             <a:pPr rtl="1" algn="r" indent="0" marL="0">
@@ -2242,7 +1953,7 @@
           <a:ln/>
         </p:spPr>
         <p:txBody>
-          <a:bodyPr wrap="square" lIns="0" tIns="0" rIns="0" bIns="0" rtlCol="0" anchor="t"/>
+          <a:bodyPr wrap="square" lIns="0" tIns="0" rIns="0" bIns="0" rtlCol="1" anchor="t"/>
           <a:lstStyle/>
           <a:p>
             <a:pPr rtl="1" algn="r" indent="0" marL="0">
@@ -2303,8 +2014,8 @@
         </p:nvSpPr>
         <p:spPr>
           <a:xfrm>
-            <a:off x="457200" y="274320"/>
-            <a:ext cx="8229600" cy="640080"/>
+            <a:off x="457200" y="256032"/>
+            <a:ext cx="8229600" cy="621792"/>
           </a:xfrm>
           <a:prstGeom prst="rect">
             <a:avLst/>
@@ -2313,7 +2024,7 @@
           <a:ln/>
         </p:spPr>
         <p:txBody>
-          <a:bodyPr wrap="square" lIns="0" tIns="0" rIns="0" bIns="0" rtlCol="0" anchor="t"/>
+          <a:bodyPr wrap="square" lIns="0" tIns="0" rIns="0" bIns="0" rtlCol="1" anchor="t"/>
           <a:lstStyle/>
           <a:p>
             <a:pPr rtl="1" algn="r" indent="0" marL="0">
@@ -2342,12 +2053,12 @@
         </p:nvSpPr>
         <p:spPr>
           <a:xfrm>
-            <a:off x="457200" y="1051560"/>
-            <a:ext cx="8229600" cy="3566160"/>
+            <a:off x="457200" y="1005840"/>
+            <a:ext cx="8229600" cy="3611880"/>
           </a:xfrm>
           <a:prstGeom prst="roundRect">
             <a:avLst>
-              <a:gd name="adj" fmla="val 2564"/>
+              <a:gd name="adj" fmla="val 2532"/>
             </a:avLst>
           </a:prstGeom>
           <a:solidFill>
@@ -2369,8 +2080,8 @@
         </p:nvSpPr>
         <p:spPr>
           <a:xfrm>
-            <a:off x="731520" y="1280160"/>
-            <a:ext cx="7680960" cy="3108960"/>
+            <a:off x="731520" y="1234440"/>
+            <a:ext cx="7680960" cy="3154680"/>
           </a:xfrm>
           <a:prstGeom prst="rect">
             <a:avLst/>
@@ -2379,7 +2090,7 @@
           <a:ln/>
         </p:spPr>
         <p:txBody>
-          <a:bodyPr wrap="square" lIns="0" tIns="0" rIns="0" bIns="0" rtlCol="0" anchor="t"/>
+          <a:bodyPr wrap="square" lIns="0" tIns="0" rIns="0" bIns="0" rtlCol="1" anchor="t"/>
           <a:lstStyle/>
           <a:p>
             <a:pPr rtl="1" algn="just" indent="0" marL="0">
@@ -2421,7 +2132,7 @@
           <a:ln/>
         </p:spPr>
         <p:txBody>
-          <a:bodyPr wrap="square" lIns="0" tIns="0" rIns="0" bIns="0" rtlCol="0" anchor="t"/>
+          <a:bodyPr wrap="square" lIns="0" tIns="0" rIns="0" bIns="0" rtlCol="1" anchor="t"/>
           <a:lstStyle/>
           <a:p>
             <a:pPr rtl="1" algn="r" indent="0" marL="0">
@@ -2521,8 +2232,8 @@
         </p:nvSpPr>
         <p:spPr>
           <a:xfrm>
-            <a:off x="457200" y="274320"/>
-            <a:ext cx="8229600" cy="640080"/>
+            <a:off x="457200" y="256032"/>
+            <a:ext cx="8229600" cy="621792"/>
           </a:xfrm>
           <a:prstGeom prst="rect">
             <a:avLst/>
@@ -2531,7 +2242,7 @@
           <a:ln/>
         </p:spPr>
         <p:txBody>
-          <a:bodyPr wrap="square" lIns="0" tIns="0" rIns="0" bIns="0" rtlCol="0" anchor="t"/>
+          <a:bodyPr wrap="square" lIns="0" tIns="0" rIns="0" bIns="0" rtlCol="1" anchor="t"/>
           <a:lstStyle/>
           <a:p>
             <a:pPr rtl="1" algn="r" indent="0" marL="0">
@@ -2560,12 +2271,12 @@
         </p:nvSpPr>
         <p:spPr>
           <a:xfrm>
-            <a:off x="457200" y="1051560"/>
-            <a:ext cx="8229600" cy="3566160"/>
+            <a:off x="457200" y="1005840"/>
+            <a:ext cx="8229600" cy="3611880"/>
           </a:xfrm>
           <a:prstGeom prst="roundRect">
             <a:avLst>
-              <a:gd name="adj" fmla="val 2564"/>
+              <a:gd name="adj" fmla="val 2532"/>
             </a:avLst>
           </a:prstGeom>
           <a:solidFill>
@@ -2588,7 +2299,7 @@
         <p:spPr>
           <a:xfrm>
             <a:off x="731520" y="1234440"/>
-            <a:ext cx="7680960" cy="3246120"/>
+            <a:ext cx="7680960" cy="3154680"/>
           </a:xfrm>
           <a:prstGeom prst="rect">
             <a:avLst/>
@@ -2597,7 +2308,7 @@
           <a:ln/>
         </p:spPr>
         <p:txBody>
-          <a:bodyPr wrap="square" lIns="0" tIns="0" rIns="0" bIns="0" rtlCol="0" anchor="t"/>
+          <a:bodyPr wrap="square" lIns="0" tIns="0" rIns="0" bIns="0" rtlCol="1" anchor="t"/>
           <a:lstStyle/>
           <a:p>
             <a:pPr rtl="1" algn="just" indent="0" marL="0">
@@ -2639,7 +2350,7 @@
           <a:ln/>
         </p:spPr>
         <p:txBody>
-          <a:bodyPr wrap="square" lIns="0" tIns="0" rIns="0" bIns="0" rtlCol="0" anchor="t"/>
+          <a:bodyPr wrap="square" lIns="0" tIns="0" rIns="0" bIns="0" rtlCol="1" anchor="t"/>
           <a:lstStyle/>
           <a:p>
             <a:pPr rtl="1" algn="r" indent="0" marL="0">
@@ -2739,8 +2450,8 @@
         </p:nvSpPr>
         <p:spPr>
           <a:xfrm>
-            <a:off x="457200" y="274320"/>
-            <a:ext cx="8229600" cy="640080"/>
+            <a:off x="457200" y="256032"/>
+            <a:ext cx="8229600" cy="621792"/>
           </a:xfrm>
           <a:prstGeom prst="rect">
             <a:avLst/>
@@ -2749,7 +2460,7 @@
           <a:ln/>
         </p:spPr>
         <p:txBody>
-          <a:bodyPr wrap="square" lIns="0" tIns="0" rIns="0" bIns="0" rtlCol="0" anchor="t"/>
+          <a:bodyPr wrap="square" lIns="0" tIns="0" rIns="0" bIns="0" rtlCol="1" anchor="t"/>
           <a:lstStyle/>
           <a:p>
             <a:pPr rtl="1" algn="r" indent="0" marL="0">
@@ -2778,7 +2489,7 @@
         </p:nvSpPr>
         <p:spPr>
           <a:xfrm>
-            <a:off x="457200" y="1051560"/>
+            <a:off x="457200" y="1005840"/>
             <a:ext cx="8229600" cy="914400"/>
           </a:xfrm>
           <a:prstGeom prst="roundRect">
@@ -2805,7 +2516,7 @@
         </p:nvSpPr>
         <p:spPr>
           <a:xfrm>
-            <a:off x="731520" y="1115568"/>
+            <a:off x="731520" y="1069848"/>
             <a:ext cx="7680960" cy="786384"/>
           </a:xfrm>
           <a:prstGeom prst="rect">
@@ -2815,7 +2526,7 @@
           <a:ln/>
         </p:spPr>
         <p:txBody>
-          <a:bodyPr wrap="square" lIns="0" tIns="0" rIns="0" bIns="0" rtlCol="0" anchor="ctr"/>
+          <a:bodyPr wrap="square" lIns="0" tIns="0" rIns="0" bIns="0" rtlCol="1" anchor="ctr"/>
           <a:lstStyle/>
           <a:p>
             <a:pPr rtl="1" algn="r" indent="0" marL="0">
@@ -2844,12 +2555,12 @@
         </p:nvSpPr>
         <p:spPr>
           <a:xfrm>
-            <a:off x="457200" y="2148840"/>
-            <a:ext cx="8229600" cy="2468880"/>
+            <a:off x="457200" y="2103120"/>
+            <a:ext cx="8229600" cy="2514600"/>
           </a:xfrm>
           <a:prstGeom prst="roundRect">
             <a:avLst>
-              <a:gd name="adj" fmla="val 3704"/>
+              <a:gd name="adj" fmla="val 3636"/>
             </a:avLst>
           </a:prstGeom>
           <a:solidFill>
@@ -2871,8 +2582,8 @@
         </p:nvSpPr>
         <p:spPr>
           <a:xfrm>
-            <a:off x="731520" y="2331720"/>
-            <a:ext cx="7680960" cy="2148840"/>
+            <a:off x="731520" y="2286000"/>
+            <a:ext cx="7680960" cy="2194560"/>
           </a:xfrm>
           <a:prstGeom prst="rect">
             <a:avLst/>
@@ -2881,7 +2592,7 @@
           <a:ln/>
         </p:spPr>
         <p:txBody>
-          <a:bodyPr wrap="square" lIns="0" tIns="0" rIns="0" bIns="0" rtlCol="0" anchor="t"/>
+          <a:bodyPr wrap="square" lIns="0" tIns="0" rIns="0" bIns="0" rtlCol="1" anchor="t"/>
           <a:lstStyle/>
           <a:p>
             <a:pPr rtl="1" algn="just" indent="0" marL="0">
@@ -2923,7 +2634,7 @@
           <a:ln/>
         </p:spPr>
         <p:txBody>
-          <a:bodyPr wrap="square" lIns="0" tIns="0" rIns="0" bIns="0" rtlCol="0" anchor="t"/>
+          <a:bodyPr wrap="square" lIns="0" tIns="0" rIns="0" bIns="0" rtlCol="1" anchor="t"/>
           <a:lstStyle/>
           <a:p>
             <a:pPr rtl="1" algn="r" indent="0" marL="0">
@@ -3023,8 +2734,8 @@
         </p:nvSpPr>
         <p:spPr>
           <a:xfrm>
-            <a:off x="457200" y="274320"/>
-            <a:ext cx="8229600" cy="640080"/>
+            <a:off x="457200" y="256032"/>
+            <a:ext cx="8229600" cy="621792"/>
           </a:xfrm>
           <a:prstGeom prst="rect">
             <a:avLst/>
@@ -3033,7 +2744,7 @@
           <a:ln/>
         </p:spPr>
         <p:txBody>
-          <a:bodyPr wrap="square" lIns="0" tIns="0" rIns="0" bIns="0" rtlCol="0" anchor="t"/>
+          <a:bodyPr wrap="square" lIns="0" tIns="0" rIns="0" bIns="0" rtlCol="1" anchor="t"/>
           <a:lstStyle/>
           <a:p>
             <a:pPr rtl="1" algn="r" indent="0" marL="0">
@@ -3054,49 +2765,3036 @@
           </a:p>
         </p:txBody>
       </p:sp>
-      <p:graphicFrame>
-        <p:nvGraphicFramePr>
-          <p:cNvPr id="3" name="Chart 0" descr=""/>
-          <p:cNvGraphicFramePr/>
-          <p:nvPr/>
-        </p:nvGraphicFramePr>
-        <p:xfrm>
-          <a:off x="3657600" y="1005840"/>
-          <a:ext cx="5029200" cy="3611880"/>
-        </p:xfrm>
-        <a:graphic xmlns:a="http://schemas.openxmlformats.org/drawingml/2006/main">
-          <a:graphicData uri="http://schemas.openxmlformats.org/drawingml/2006/chart">
-            <c:chart xmlns:c="http://schemas.openxmlformats.org/drawingml/2006/chart" r:id="rId1"/>
-          </a:graphicData>
-        </a:graphic>
-      </p:graphicFrame>
       <p:sp>
         <p:nvSpPr>
-          <p:cNvPr id="4" name="Shape 1"/>
-          <p:cNvSpPr/>
+          <p:cNvPr id="3" name="Text 1"/>
+          <p:cNvSpPr txBox="1"/>
           <p:nvPr/>
         </p:nvSpPr>
         <p:spPr>
           <a:xfrm>
-            <a:off x="457200" y="1051560"/>
-            <a:ext cx="3017520" cy="3566160"/>
+            <a:off x="457200" y="932688"/>
+            <a:ext cx="8229600" cy="256032"/>
           </a:xfrm>
-          <a:prstGeom prst="roundRect">
-            <a:avLst>
-              <a:gd name="adj" fmla="val 3030"/>
-            </a:avLst>
+          <a:prstGeom prst="rect">
+            <a:avLst/>
           </a:prstGeom>
-          <a:solidFill>
-            <a:srgbClr val="EAF0F7"/>
-          </a:solidFill>
-          <a:ln w="12700">
-            <a:solidFill>
-              <a:srgbClr val="EAF0F7"/>
-            </a:solidFill>
-            <a:prstDash val="solid"/>
-          </a:ln>
+          <a:noFill/>
+          <a:ln/>
         </p:spPr>
+        <p:txBody>
+          <a:bodyPr wrap="square" lIns="0" tIns="0" rIns="0" bIns="0" rtlCol="1" anchor="t"/>
+          <a:lstStyle/>
+          <a:p>
+            <a:pPr rtl="1" algn="r" indent="0" marL="0">
+              <a:buNone/>
+            </a:pPr>
+            <a:r>
+              <a:rPr lang="he-IL" altLang="en-US" sz="1200" b="1" dirty="0">
+                <a:solidFill>
+                  <a:srgbClr val="1F3A5F"/>
+                </a:solidFill>
+                <a:latin typeface="Arial" pitchFamily="34" charset="0"/>
+                <a:ea typeface="Arial" pitchFamily="34" charset="-122"/>
+                <a:cs typeface="Arial" pitchFamily="34" charset="-120"/>
+              </a:rPr>
+              <a:t>לוח 1: מאפייני הרקע של השפוטים (N = 2,379)</a:t>
+            </a:r>
+            <a:endParaRPr lang="he-IL" sz="1200" dirty="0"/>
+          </a:p>
+        </p:txBody>
       </p:sp>
+      <p:graphicFrame>
+        <p:nvGraphicFramePr>
+          <p:cNvPr id="6" name="Table 0"/>
+          <p:cNvGraphicFramePr>
+            <a:graphicFrameLocks noGrp="1"/>
+          </p:cNvGraphicFramePr>
+          <p:nvPr>
+            <p:extLst>
+              <p:ext uri="{D42A27DB-BD31-4B8C-83A1-F6EECF244321}">
+                <p14:modId xmlns:p14="http://schemas.microsoft.com/office/powerpoint/2010/main" val="1579011935"/>
+              </p:ext>
+            </p:extLst>
+          </p:nvPr>
+        </p:nvGraphicFramePr>
+        <p:xfrm>
+          <a:off x="457200" y="1225296"/>
+          <a:ext cx="8229600" cy="914400"/>
+        </p:xfrm>
+        <a:graphic>
+          <a:graphicData uri="http://schemas.openxmlformats.org/drawingml/2006/table">
+            <a:tbl>
+              <a:tblPr/>
+              <a:tblGrid>
+                <a:gridCol w="1371600"/>
+                <a:gridCol w="1371600"/>
+                <a:gridCol w="3108960"/>
+                <a:gridCol w="2377440"/>
+              </a:tblGrid>
+              <a:tr h="224028">
+                <a:tc>
+                  <a:txBody>
+                    <a:bodyPr rtlCol="1"/>
+                    <a:lstStyle/>
+                    <a:p>
+                      <a:pPr rtl="1" algn="ctr" indent="0" marL="0">
+                        <a:buNone/>
+                      </a:pPr>
+                      <a:r>
+                        <a:rPr lang="he-IL" altLang="en-US" sz="1100" b="1" dirty="0">
+                          <a:solidFill>
+                            <a:srgbClr val="FFFFFF"/>
+                          </a:solidFill>
+                          <a:latin typeface="Arial" pitchFamily="34" charset="0"/>
+                          <a:ea typeface="Arial" pitchFamily="34" charset="-122"/>
+                          <a:cs typeface="Arial" pitchFamily="34" charset="-120"/>
+                        </a:rPr>
+                        <a:t>%</a:t>
+                      </a:r>
+                      <a:endParaRPr lang="he-IL" sz="1100" dirty="0">
+                        <a:latin typeface="Arial" charset="0"/>
+                        <a:ea typeface="Arial" charset="0"/>
+                        <a:cs typeface="Arial" charset="0"/>
+                      </a:endParaRPr>
+                    </a:p>
+                  </a:txBody>
+                  <a:tcPr marL="50800" marR="50800" marT="50800" marB="50800" anchor="ctr">
+                    <a:lnL w="9525" cap="flat" cmpd="sng" algn="ctr">
+                      <a:solidFill>
+                        <a:srgbClr val="C9D6E4"/>
+                      </a:solidFill>
+                      <a:prstDash val="solid"/>
+                      <a:round/>
+                      <a:headEnd type="none" w="med" len="med"/>
+                      <a:tailEnd type="none" w="med" len="med"/>
+                    </a:lnL>
+                    <a:lnR w="9525" cap="flat" cmpd="sng" algn="ctr">
+                      <a:solidFill>
+                        <a:srgbClr val="C9D6E4"/>
+                      </a:solidFill>
+                      <a:prstDash val="solid"/>
+                      <a:round/>
+                      <a:headEnd type="none" w="med" len="med"/>
+                      <a:tailEnd type="none" w="med" len="med"/>
+                    </a:lnR>
+                    <a:lnT w="9525" cap="flat" cmpd="sng" algn="ctr">
+                      <a:solidFill>
+                        <a:srgbClr val="C9D6E4"/>
+                      </a:solidFill>
+                      <a:prstDash val="solid"/>
+                      <a:round/>
+                      <a:headEnd type="none" w="med" len="med"/>
+                      <a:tailEnd type="none" w="med" len="med"/>
+                    </a:lnT>
+                    <a:lnB w="9525" cap="flat" cmpd="sng" algn="ctr">
+                      <a:solidFill>
+                        <a:srgbClr val="C9D6E4"/>
+                      </a:solidFill>
+                      <a:prstDash val="solid"/>
+                      <a:round/>
+                      <a:headEnd type="none" w="med" len="med"/>
+                      <a:tailEnd type="none" w="med" len="med"/>
+                    </a:lnB>
+                    <a:solidFill>
+                      <a:srgbClr val="1F3A5F"/>
+                    </a:solidFill>
+                  </a:tcPr>
+                </a:tc>
+                <a:tc>
+                  <a:txBody>
+                    <a:bodyPr rtlCol="1"/>
+                    <a:lstStyle/>
+                    <a:p>
+                      <a:pPr rtl="1" algn="ctr" indent="0" marL="0">
+                        <a:buNone/>
+                      </a:pPr>
+                      <a:r>
+                        <a:rPr lang="he-IL" altLang="en-US" sz="1100" b="1" dirty="0">
+                          <a:solidFill>
+                            <a:srgbClr val="FFFFFF"/>
+                          </a:solidFill>
+                          <a:latin typeface="Arial" pitchFamily="34" charset="0"/>
+                          <a:ea typeface="Arial" pitchFamily="34" charset="-122"/>
+                          <a:cs typeface="Arial" pitchFamily="34" charset="-120"/>
+                        </a:rPr>
+                        <a:t>N</a:t>
+                      </a:r>
+                      <a:endParaRPr lang="he-IL" sz="1100" dirty="0">
+                        <a:latin typeface="Arial" charset="0"/>
+                        <a:ea typeface="Arial" charset="0"/>
+                        <a:cs typeface="Arial" charset="0"/>
+                      </a:endParaRPr>
+                    </a:p>
+                  </a:txBody>
+                  <a:tcPr marL="50800" marR="50800" marT="50800" marB="50800" anchor="ctr">
+                    <a:lnL w="9525" cap="flat" cmpd="sng" algn="ctr">
+                      <a:solidFill>
+                        <a:srgbClr val="C9D6E4"/>
+                      </a:solidFill>
+                      <a:prstDash val="solid"/>
+                      <a:round/>
+                      <a:headEnd type="none" w="med" len="med"/>
+                      <a:tailEnd type="none" w="med" len="med"/>
+                    </a:lnL>
+                    <a:lnR w="9525" cap="flat" cmpd="sng" algn="ctr">
+                      <a:solidFill>
+                        <a:srgbClr val="C9D6E4"/>
+                      </a:solidFill>
+                      <a:prstDash val="solid"/>
+                      <a:round/>
+                      <a:headEnd type="none" w="med" len="med"/>
+                      <a:tailEnd type="none" w="med" len="med"/>
+                    </a:lnR>
+                    <a:lnT w="9525" cap="flat" cmpd="sng" algn="ctr">
+                      <a:solidFill>
+                        <a:srgbClr val="C9D6E4"/>
+                      </a:solidFill>
+                      <a:prstDash val="solid"/>
+                      <a:round/>
+                      <a:headEnd type="none" w="med" len="med"/>
+                      <a:tailEnd type="none" w="med" len="med"/>
+                    </a:lnT>
+                    <a:lnB w="9525" cap="flat" cmpd="sng" algn="ctr">
+                      <a:solidFill>
+                        <a:srgbClr val="C9D6E4"/>
+                      </a:solidFill>
+                      <a:prstDash val="solid"/>
+                      <a:round/>
+                      <a:headEnd type="none" w="med" len="med"/>
+                      <a:tailEnd type="none" w="med" len="med"/>
+                    </a:lnB>
+                    <a:solidFill>
+                      <a:srgbClr val="1F3A5F"/>
+                    </a:solidFill>
+                  </a:tcPr>
+                </a:tc>
+                <a:tc>
+                  <a:txBody>
+                    <a:bodyPr rtlCol="1"/>
+                    <a:lstStyle/>
+                    <a:p>
+                      <a:pPr rtl="1" algn="ctr" indent="0" marL="0">
+                        <a:buNone/>
+                      </a:pPr>
+                      <a:r>
+                        <a:rPr lang="he-IL" altLang="en-US" sz="1100" b="1" dirty="0">
+                          <a:solidFill>
+                            <a:srgbClr val="FFFFFF"/>
+                          </a:solidFill>
+                          <a:latin typeface="Arial" pitchFamily="34" charset="0"/>
+                          <a:ea typeface="Arial" pitchFamily="34" charset="-122"/>
+                          <a:cs typeface="Arial" pitchFamily="34" charset="-120"/>
+                        </a:rPr>
+                        <a:t>קטגוריה</a:t>
+                      </a:r>
+                      <a:endParaRPr lang="he-IL" sz="1100" dirty="0">
+                        <a:latin typeface="Arial" charset="0"/>
+                        <a:ea typeface="Arial" charset="0"/>
+                        <a:cs typeface="Arial" charset="0"/>
+                      </a:endParaRPr>
+                    </a:p>
+                  </a:txBody>
+                  <a:tcPr marL="50800" marR="50800" marT="50800" marB="50800" anchor="ctr">
+                    <a:lnL w="9525" cap="flat" cmpd="sng" algn="ctr">
+                      <a:solidFill>
+                        <a:srgbClr val="C9D6E4"/>
+                      </a:solidFill>
+                      <a:prstDash val="solid"/>
+                      <a:round/>
+                      <a:headEnd type="none" w="med" len="med"/>
+                      <a:tailEnd type="none" w="med" len="med"/>
+                    </a:lnL>
+                    <a:lnR w="9525" cap="flat" cmpd="sng" algn="ctr">
+                      <a:solidFill>
+                        <a:srgbClr val="C9D6E4"/>
+                      </a:solidFill>
+                      <a:prstDash val="solid"/>
+                      <a:round/>
+                      <a:headEnd type="none" w="med" len="med"/>
+                      <a:tailEnd type="none" w="med" len="med"/>
+                    </a:lnR>
+                    <a:lnT w="9525" cap="flat" cmpd="sng" algn="ctr">
+                      <a:solidFill>
+                        <a:srgbClr val="C9D6E4"/>
+                      </a:solidFill>
+                      <a:prstDash val="solid"/>
+                      <a:round/>
+                      <a:headEnd type="none" w="med" len="med"/>
+                      <a:tailEnd type="none" w="med" len="med"/>
+                    </a:lnT>
+                    <a:lnB w="9525" cap="flat" cmpd="sng" algn="ctr">
+                      <a:solidFill>
+                        <a:srgbClr val="C9D6E4"/>
+                      </a:solidFill>
+                      <a:prstDash val="solid"/>
+                      <a:round/>
+                      <a:headEnd type="none" w="med" len="med"/>
+                      <a:tailEnd type="none" w="med" len="med"/>
+                    </a:lnB>
+                    <a:solidFill>
+                      <a:srgbClr val="1F3A5F"/>
+                    </a:solidFill>
+                  </a:tcPr>
+                </a:tc>
+                <a:tc>
+                  <a:txBody>
+                    <a:bodyPr rtlCol="1"/>
+                    <a:lstStyle/>
+                    <a:p>
+                      <a:pPr rtl="1" algn="ctr" indent="0" marL="0">
+                        <a:buNone/>
+                      </a:pPr>
+                      <a:r>
+                        <a:rPr lang="he-IL" altLang="en-US" sz="1100" b="1" dirty="0">
+                          <a:solidFill>
+                            <a:srgbClr val="FFFFFF"/>
+                          </a:solidFill>
+                          <a:latin typeface="Arial" pitchFamily="34" charset="0"/>
+                          <a:ea typeface="Arial" pitchFamily="34" charset="-122"/>
+                          <a:cs typeface="Arial" pitchFamily="34" charset="-120"/>
+                        </a:rPr>
+                        <a:t>משתנה</a:t>
+                      </a:r>
+                      <a:endParaRPr lang="he-IL" sz="1100" dirty="0">
+                        <a:latin typeface="Arial" charset="0"/>
+                        <a:ea typeface="Arial" charset="0"/>
+                        <a:cs typeface="Arial" charset="0"/>
+                      </a:endParaRPr>
+                    </a:p>
+                  </a:txBody>
+                  <a:tcPr marL="50800" marR="50800" marT="50800" marB="50800" anchor="ctr">
+                    <a:lnL w="9525" cap="flat" cmpd="sng" algn="ctr">
+                      <a:solidFill>
+                        <a:srgbClr val="C9D6E4"/>
+                      </a:solidFill>
+                      <a:prstDash val="solid"/>
+                      <a:round/>
+                      <a:headEnd type="none" w="med" len="med"/>
+                      <a:tailEnd type="none" w="med" len="med"/>
+                    </a:lnL>
+                    <a:lnR w="9525" cap="flat" cmpd="sng" algn="ctr">
+                      <a:solidFill>
+                        <a:srgbClr val="C9D6E4"/>
+                      </a:solidFill>
+                      <a:prstDash val="solid"/>
+                      <a:round/>
+                      <a:headEnd type="none" w="med" len="med"/>
+                      <a:tailEnd type="none" w="med" len="med"/>
+                    </a:lnR>
+                    <a:lnT w="9525" cap="flat" cmpd="sng" algn="ctr">
+                      <a:solidFill>
+                        <a:srgbClr val="C9D6E4"/>
+                      </a:solidFill>
+                      <a:prstDash val="solid"/>
+                      <a:round/>
+                      <a:headEnd type="none" w="med" len="med"/>
+                      <a:tailEnd type="none" w="med" len="med"/>
+                    </a:lnT>
+                    <a:lnB w="9525" cap="flat" cmpd="sng" algn="ctr">
+                      <a:solidFill>
+                        <a:srgbClr val="C9D6E4"/>
+                      </a:solidFill>
+                      <a:prstDash val="solid"/>
+                      <a:round/>
+                      <a:headEnd type="none" w="med" len="med"/>
+                      <a:tailEnd type="none" w="med" len="med"/>
+                    </a:lnB>
+                    <a:solidFill>
+                      <a:srgbClr val="1F3A5F"/>
+                    </a:solidFill>
+                  </a:tcPr>
+                </a:tc>
+              </a:tr>
+              <a:tr h="224028">
+                <a:tc>
+                  <a:txBody>
+                    <a:bodyPr rtlCol="1"/>
+                    <a:lstStyle/>
+                    <a:p>
+                      <a:pPr rtl="1" algn="ctr" indent="0" marL="0">
+                        <a:buNone/>
+                      </a:pPr>
+                      <a:r>
+                        <a:rPr lang="he-IL" altLang="en-US" sz="1100" dirty="0">
+                          <a:solidFill>
+                            <a:srgbClr val="22303F"/>
+                          </a:solidFill>
+                          <a:latin typeface="Arial" pitchFamily="34" charset="0"/>
+                          <a:ea typeface="Arial" pitchFamily="34" charset="-122"/>
+                          <a:cs typeface="Arial" pitchFamily="34" charset="-120"/>
+                        </a:rPr>
+                        <a:t>96.8</a:t>
+                      </a:r>
+                      <a:endParaRPr lang="he-IL" sz="1100" dirty="0">
+                        <a:latin typeface="Arial" charset="0"/>
+                        <a:ea typeface="Arial" charset="0"/>
+                        <a:cs typeface="Arial" charset="0"/>
+                      </a:endParaRPr>
+                    </a:p>
+                  </a:txBody>
+                  <a:tcPr marL="50800" marR="50800" marT="50800" marB="50800" anchor="ctr">
+                    <a:lnL w="9525" cap="flat" cmpd="sng" algn="ctr">
+                      <a:solidFill>
+                        <a:srgbClr val="C9D6E4"/>
+                      </a:solidFill>
+                      <a:prstDash val="solid"/>
+                      <a:round/>
+                      <a:headEnd type="none" w="med" len="med"/>
+                      <a:tailEnd type="none" w="med" len="med"/>
+                    </a:lnL>
+                    <a:lnR w="9525" cap="flat" cmpd="sng" algn="ctr">
+                      <a:solidFill>
+                        <a:srgbClr val="C9D6E4"/>
+                      </a:solidFill>
+                      <a:prstDash val="solid"/>
+                      <a:round/>
+                      <a:headEnd type="none" w="med" len="med"/>
+                      <a:tailEnd type="none" w="med" len="med"/>
+                    </a:lnR>
+                    <a:lnT w="9525" cap="flat" cmpd="sng" algn="ctr">
+                      <a:solidFill>
+                        <a:srgbClr val="C9D6E4"/>
+                      </a:solidFill>
+                      <a:prstDash val="solid"/>
+                      <a:round/>
+                      <a:headEnd type="none" w="med" len="med"/>
+                      <a:tailEnd type="none" w="med" len="med"/>
+                    </a:lnT>
+                    <a:lnB w="9525" cap="flat" cmpd="sng" algn="ctr">
+                      <a:solidFill>
+                        <a:srgbClr val="C9D6E4"/>
+                      </a:solidFill>
+                      <a:prstDash val="solid"/>
+                      <a:round/>
+                      <a:headEnd type="none" w="med" len="med"/>
+                      <a:tailEnd type="none" w="med" len="med"/>
+                    </a:lnB>
+                    <a:solidFill>
+                      <a:srgbClr val="EAF0F7"/>
+                    </a:solidFill>
+                  </a:tcPr>
+                </a:tc>
+                <a:tc>
+                  <a:txBody>
+                    <a:bodyPr rtlCol="1"/>
+                    <a:lstStyle/>
+                    <a:p>
+                      <a:pPr rtl="1" algn="ctr" indent="0" marL="0">
+                        <a:buNone/>
+                      </a:pPr>
+                      <a:r>
+                        <a:rPr lang="he-IL" altLang="en-US" sz="1100" dirty="0">
+                          <a:solidFill>
+                            <a:srgbClr val="22303F"/>
+                          </a:solidFill>
+                          <a:latin typeface="Arial" pitchFamily="34" charset="0"/>
+                          <a:ea typeface="Arial" pitchFamily="34" charset="-122"/>
+                          <a:cs typeface="Arial" pitchFamily="34" charset="-120"/>
+                        </a:rPr>
+                        <a:t>2,302</a:t>
+                      </a:r>
+                      <a:endParaRPr lang="he-IL" sz="1100" dirty="0">
+                        <a:latin typeface="Arial" charset="0"/>
+                        <a:ea typeface="Arial" charset="0"/>
+                        <a:cs typeface="Arial" charset="0"/>
+                      </a:endParaRPr>
+                    </a:p>
+                  </a:txBody>
+                  <a:tcPr marL="50800" marR="50800" marT="50800" marB="50800" anchor="ctr">
+                    <a:lnL w="9525" cap="flat" cmpd="sng" algn="ctr">
+                      <a:solidFill>
+                        <a:srgbClr val="C9D6E4"/>
+                      </a:solidFill>
+                      <a:prstDash val="solid"/>
+                      <a:round/>
+                      <a:headEnd type="none" w="med" len="med"/>
+                      <a:tailEnd type="none" w="med" len="med"/>
+                    </a:lnL>
+                    <a:lnR w="9525" cap="flat" cmpd="sng" algn="ctr">
+                      <a:solidFill>
+                        <a:srgbClr val="C9D6E4"/>
+                      </a:solidFill>
+                      <a:prstDash val="solid"/>
+                      <a:round/>
+                      <a:headEnd type="none" w="med" len="med"/>
+                      <a:tailEnd type="none" w="med" len="med"/>
+                    </a:lnR>
+                    <a:lnT w="9525" cap="flat" cmpd="sng" algn="ctr">
+                      <a:solidFill>
+                        <a:srgbClr val="C9D6E4"/>
+                      </a:solidFill>
+                      <a:prstDash val="solid"/>
+                      <a:round/>
+                      <a:headEnd type="none" w="med" len="med"/>
+                      <a:tailEnd type="none" w="med" len="med"/>
+                    </a:lnT>
+                    <a:lnB w="9525" cap="flat" cmpd="sng" algn="ctr">
+                      <a:solidFill>
+                        <a:srgbClr val="C9D6E4"/>
+                      </a:solidFill>
+                      <a:prstDash val="solid"/>
+                      <a:round/>
+                      <a:headEnd type="none" w="med" len="med"/>
+                      <a:tailEnd type="none" w="med" len="med"/>
+                    </a:lnB>
+                    <a:solidFill>
+                      <a:srgbClr val="EAF0F7"/>
+                    </a:solidFill>
+                  </a:tcPr>
+                </a:tc>
+                <a:tc>
+                  <a:txBody>
+                    <a:bodyPr rtlCol="1"/>
+                    <a:lstStyle/>
+                    <a:p>
+                      <a:pPr rtl="1" algn="ctr" indent="0" marL="0">
+                        <a:buNone/>
+                      </a:pPr>
+                      <a:r>
+                        <a:rPr lang="he-IL" altLang="en-US" sz="1100" dirty="0">
+                          <a:solidFill>
+                            <a:srgbClr val="22303F"/>
+                          </a:solidFill>
+                          <a:latin typeface="Arial" pitchFamily="34" charset="0"/>
+                          <a:ea typeface="Arial" pitchFamily="34" charset="-122"/>
+                          <a:cs typeface="Arial" pitchFamily="34" charset="-120"/>
+                        </a:rPr>
+                        <a:t>גברים</a:t>
+                      </a:r>
+                      <a:endParaRPr lang="he-IL" sz="1100" dirty="0">
+                        <a:latin typeface="Arial" charset="0"/>
+                        <a:ea typeface="Arial" charset="0"/>
+                        <a:cs typeface="Arial" charset="0"/>
+                      </a:endParaRPr>
+                    </a:p>
+                  </a:txBody>
+                  <a:tcPr marL="50800" marR="50800" marT="50800" marB="50800" anchor="ctr">
+                    <a:lnL w="9525" cap="flat" cmpd="sng" algn="ctr">
+                      <a:solidFill>
+                        <a:srgbClr val="C9D6E4"/>
+                      </a:solidFill>
+                      <a:prstDash val="solid"/>
+                      <a:round/>
+                      <a:headEnd type="none" w="med" len="med"/>
+                      <a:tailEnd type="none" w="med" len="med"/>
+                    </a:lnL>
+                    <a:lnR w="9525" cap="flat" cmpd="sng" algn="ctr">
+                      <a:solidFill>
+                        <a:srgbClr val="C9D6E4"/>
+                      </a:solidFill>
+                      <a:prstDash val="solid"/>
+                      <a:round/>
+                      <a:headEnd type="none" w="med" len="med"/>
+                      <a:tailEnd type="none" w="med" len="med"/>
+                    </a:lnR>
+                    <a:lnT w="9525" cap="flat" cmpd="sng" algn="ctr">
+                      <a:solidFill>
+                        <a:srgbClr val="C9D6E4"/>
+                      </a:solidFill>
+                      <a:prstDash val="solid"/>
+                      <a:round/>
+                      <a:headEnd type="none" w="med" len="med"/>
+                      <a:tailEnd type="none" w="med" len="med"/>
+                    </a:lnT>
+                    <a:lnB w="9525" cap="flat" cmpd="sng" algn="ctr">
+                      <a:solidFill>
+                        <a:srgbClr val="C9D6E4"/>
+                      </a:solidFill>
+                      <a:prstDash val="solid"/>
+                      <a:round/>
+                      <a:headEnd type="none" w="med" len="med"/>
+                      <a:tailEnd type="none" w="med" len="med"/>
+                    </a:lnB>
+                    <a:solidFill>
+                      <a:srgbClr val="EAF0F7"/>
+                    </a:solidFill>
+                  </a:tcPr>
+                </a:tc>
+                <a:tc>
+                  <a:txBody>
+                    <a:bodyPr rtlCol="1"/>
+                    <a:lstStyle/>
+                    <a:p>
+                      <a:pPr rtl="1" algn="r" indent="0" marL="0">
+                        <a:buNone/>
+                      </a:pPr>
+                      <a:r>
+                        <a:rPr lang="he-IL" altLang="en-US" sz="1100" b="1" dirty="0">
+                          <a:solidFill>
+                            <a:srgbClr val="22303F"/>
+                          </a:solidFill>
+                          <a:latin typeface="Arial" pitchFamily="34" charset="0"/>
+                          <a:ea typeface="Arial" pitchFamily="34" charset="-122"/>
+                          <a:cs typeface="Arial" pitchFamily="34" charset="-120"/>
+                        </a:rPr>
+                        <a:t>מגדר</a:t>
+                      </a:r>
+                      <a:endParaRPr lang="he-IL" sz="1100" dirty="0">
+                        <a:latin typeface="Arial" charset="0"/>
+                        <a:ea typeface="Arial" charset="0"/>
+                        <a:cs typeface="Arial" charset="0"/>
+                      </a:endParaRPr>
+                    </a:p>
+                  </a:txBody>
+                  <a:tcPr marL="50800" marR="50800" marT="50800" marB="50800" anchor="ctr">
+                    <a:lnL w="9525" cap="flat" cmpd="sng" algn="ctr">
+                      <a:solidFill>
+                        <a:srgbClr val="C9D6E4"/>
+                      </a:solidFill>
+                      <a:prstDash val="solid"/>
+                      <a:round/>
+                      <a:headEnd type="none" w="med" len="med"/>
+                      <a:tailEnd type="none" w="med" len="med"/>
+                    </a:lnL>
+                    <a:lnR w="9525" cap="flat" cmpd="sng" algn="ctr">
+                      <a:solidFill>
+                        <a:srgbClr val="C9D6E4"/>
+                      </a:solidFill>
+                      <a:prstDash val="solid"/>
+                      <a:round/>
+                      <a:headEnd type="none" w="med" len="med"/>
+                      <a:tailEnd type="none" w="med" len="med"/>
+                    </a:lnR>
+                    <a:lnT w="9525" cap="flat" cmpd="sng" algn="ctr">
+                      <a:solidFill>
+                        <a:srgbClr val="C9D6E4"/>
+                      </a:solidFill>
+                      <a:prstDash val="solid"/>
+                      <a:round/>
+                      <a:headEnd type="none" w="med" len="med"/>
+                      <a:tailEnd type="none" w="med" len="med"/>
+                    </a:lnT>
+                    <a:lnB w="9525" cap="flat" cmpd="sng" algn="ctr">
+                      <a:solidFill>
+                        <a:srgbClr val="C9D6E4"/>
+                      </a:solidFill>
+                      <a:prstDash val="solid"/>
+                      <a:round/>
+                      <a:headEnd type="none" w="med" len="med"/>
+                      <a:tailEnd type="none" w="med" len="med"/>
+                    </a:lnB>
+                    <a:solidFill>
+                      <a:srgbClr val="EAF0F7"/>
+                    </a:solidFill>
+                  </a:tcPr>
+                </a:tc>
+              </a:tr>
+              <a:tr h="224028">
+                <a:tc>
+                  <a:txBody>
+                    <a:bodyPr rtlCol="1"/>
+                    <a:lstStyle/>
+                    <a:p>
+                      <a:pPr rtl="1" algn="ctr" indent="0" marL="0">
+                        <a:buNone/>
+                      </a:pPr>
+                      <a:r>
+                        <a:rPr lang="he-IL" altLang="en-US" sz="1100" dirty="0">
+                          <a:solidFill>
+                            <a:srgbClr val="22303F"/>
+                          </a:solidFill>
+                          <a:latin typeface="Arial" pitchFamily="34" charset="0"/>
+                          <a:ea typeface="Arial" pitchFamily="34" charset="-122"/>
+                          <a:cs typeface="Arial" pitchFamily="34" charset="-120"/>
+                        </a:rPr>
+                        <a:t>3.2</a:t>
+                      </a:r>
+                      <a:endParaRPr lang="he-IL" sz="1100" dirty="0">
+                        <a:latin typeface="Arial" charset="0"/>
+                        <a:ea typeface="Arial" charset="0"/>
+                        <a:cs typeface="Arial" charset="0"/>
+                      </a:endParaRPr>
+                    </a:p>
+                  </a:txBody>
+                  <a:tcPr marL="50800" marR="50800" marT="50800" marB="50800" anchor="ctr">
+                    <a:lnL w="9525" cap="flat" cmpd="sng" algn="ctr">
+                      <a:solidFill>
+                        <a:srgbClr val="C9D6E4"/>
+                      </a:solidFill>
+                      <a:prstDash val="solid"/>
+                      <a:round/>
+                      <a:headEnd type="none" w="med" len="med"/>
+                      <a:tailEnd type="none" w="med" len="med"/>
+                    </a:lnL>
+                    <a:lnR w="9525" cap="flat" cmpd="sng" algn="ctr">
+                      <a:solidFill>
+                        <a:srgbClr val="C9D6E4"/>
+                      </a:solidFill>
+                      <a:prstDash val="solid"/>
+                      <a:round/>
+                      <a:headEnd type="none" w="med" len="med"/>
+                      <a:tailEnd type="none" w="med" len="med"/>
+                    </a:lnR>
+                    <a:lnT w="9525" cap="flat" cmpd="sng" algn="ctr">
+                      <a:solidFill>
+                        <a:srgbClr val="C9D6E4"/>
+                      </a:solidFill>
+                      <a:prstDash val="solid"/>
+                      <a:round/>
+                      <a:headEnd type="none" w="med" len="med"/>
+                      <a:tailEnd type="none" w="med" len="med"/>
+                    </a:lnT>
+                    <a:lnB w="9525" cap="flat" cmpd="sng" algn="ctr">
+                      <a:solidFill>
+                        <a:srgbClr val="C9D6E4"/>
+                      </a:solidFill>
+                      <a:prstDash val="solid"/>
+                      <a:round/>
+                      <a:headEnd type="none" w="med" len="med"/>
+                      <a:tailEnd type="none" w="med" len="med"/>
+                    </a:lnB>
+                    <a:solidFill>
+                      <a:srgbClr val="FFFFFF"/>
+                    </a:solidFill>
+                  </a:tcPr>
+                </a:tc>
+                <a:tc>
+                  <a:txBody>
+                    <a:bodyPr rtlCol="1"/>
+                    <a:lstStyle/>
+                    <a:p>
+                      <a:pPr rtl="1" algn="ctr" indent="0" marL="0">
+                        <a:buNone/>
+                      </a:pPr>
+                      <a:r>
+                        <a:rPr lang="he-IL" altLang="en-US" sz="1100" dirty="0">
+                          <a:solidFill>
+                            <a:srgbClr val="22303F"/>
+                          </a:solidFill>
+                          <a:latin typeface="Arial" pitchFamily="34" charset="0"/>
+                          <a:ea typeface="Arial" pitchFamily="34" charset="-122"/>
+                          <a:cs typeface="Arial" pitchFamily="34" charset="-120"/>
+                        </a:rPr>
+                        <a:t>77</a:t>
+                      </a:r>
+                      <a:endParaRPr lang="he-IL" sz="1100" dirty="0">
+                        <a:latin typeface="Arial" charset="0"/>
+                        <a:ea typeface="Arial" charset="0"/>
+                        <a:cs typeface="Arial" charset="0"/>
+                      </a:endParaRPr>
+                    </a:p>
+                  </a:txBody>
+                  <a:tcPr marL="50800" marR="50800" marT="50800" marB="50800" anchor="ctr">
+                    <a:lnL w="9525" cap="flat" cmpd="sng" algn="ctr">
+                      <a:solidFill>
+                        <a:srgbClr val="C9D6E4"/>
+                      </a:solidFill>
+                      <a:prstDash val="solid"/>
+                      <a:round/>
+                      <a:headEnd type="none" w="med" len="med"/>
+                      <a:tailEnd type="none" w="med" len="med"/>
+                    </a:lnL>
+                    <a:lnR w="9525" cap="flat" cmpd="sng" algn="ctr">
+                      <a:solidFill>
+                        <a:srgbClr val="C9D6E4"/>
+                      </a:solidFill>
+                      <a:prstDash val="solid"/>
+                      <a:round/>
+                      <a:headEnd type="none" w="med" len="med"/>
+                      <a:tailEnd type="none" w="med" len="med"/>
+                    </a:lnR>
+                    <a:lnT w="9525" cap="flat" cmpd="sng" algn="ctr">
+                      <a:solidFill>
+                        <a:srgbClr val="C9D6E4"/>
+                      </a:solidFill>
+                      <a:prstDash val="solid"/>
+                      <a:round/>
+                      <a:headEnd type="none" w="med" len="med"/>
+                      <a:tailEnd type="none" w="med" len="med"/>
+                    </a:lnT>
+                    <a:lnB w="9525" cap="flat" cmpd="sng" algn="ctr">
+                      <a:solidFill>
+                        <a:srgbClr val="C9D6E4"/>
+                      </a:solidFill>
+                      <a:prstDash val="solid"/>
+                      <a:round/>
+                      <a:headEnd type="none" w="med" len="med"/>
+                      <a:tailEnd type="none" w="med" len="med"/>
+                    </a:lnB>
+                    <a:solidFill>
+                      <a:srgbClr val="FFFFFF"/>
+                    </a:solidFill>
+                  </a:tcPr>
+                </a:tc>
+                <a:tc>
+                  <a:txBody>
+                    <a:bodyPr rtlCol="1"/>
+                    <a:lstStyle/>
+                    <a:p>
+                      <a:pPr rtl="1" algn="ctr" indent="0" marL="0">
+                        <a:buNone/>
+                      </a:pPr>
+                      <a:r>
+                        <a:rPr lang="he-IL" altLang="en-US" sz="1100" dirty="0">
+                          <a:solidFill>
+                            <a:srgbClr val="22303F"/>
+                          </a:solidFill>
+                          <a:latin typeface="Arial" pitchFamily="34" charset="0"/>
+                          <a:ea typeface="Arial" pitchFamily="34" charset="-122"/>
+                          <a:cs typeface="Arial" pitchFamily="34" charset="-120"/>
+                        </a:rPr>
+                        <a:t>נשים</a:t>
+                      </a:r>
+                      <a:endParaRPr lang="he-IL" sz="1100" dirty="0">
+                        <a:latin typeface="Arial" charset="0"/>
+                        <a:ea typeface="Arial" charset="0"/>
+                        <a:cs typeface="Arial" charset="0"/>
+                      </a:endParaRPr>
+                    </a:p>
+                  </a:txBody>
+                  <a:tcPr marL="50800" marR="50800" marT="50800" marB="50800" anchor="ctr">
+                    <a:lnL w="9525" cap="flat" cmpd="sng" algn="ctr">
+                      <a:solidFill>
+                        <a:srgbClr val="C9D6E4"/>
+                      </a:solidFill>
+                      <a:prstDash val="solid"/>
+                      <a:round/>
+                      <a:headEnd type="none" w="med" len="med"/>
+                      <a:tailEnd type="none" w="med" len="med"/>
+                    </a:lnL>
+                    <a:lnR w="9525" cap="flat" cmpd="sng" algn="ctr">
+                      <a:solidFill>
+                        <a:srgbClr val="C9D6E4"/>
+                      </a:solidFill>
+                      <a:prstDash val="solid"/>
+                      <a:round/>
+                      <a:headEnd type="none" w="med" len="med"/>
+                      <a:tailEnd type="none" w="med" len="med"/>
+                    </a:lnR>
+                    <a:lnT w="9525" cap="flat" cmpd="sng" algn="ctr">
+                      <a:solidFill>
+                        <a:srgbClr val="C9D6E4"/>
+                      </a:solidFill>
+                      <a:prstDash val="solid"/>
+                      <a:round/>
+                      <a:headEnd type="none" w="med" len="med"/>
+                      <a:tailEnd type="none" w="med" len="med"/>
+                    </a:lnT>
+                    <a:lnB w="9525" cap="flat" cmpd="sng" algn="ctr">
+                      <a:solidFill>
+                        <a:srgbClr val="C9D6E4"/>
+                      </a:solidFill>
+                      <a:prstDash val="solid"/>
+                      <a:round/>
+                      <a:headEnd type="none" w="med" len="med"/>
+                      <a:tailEnd type="none" w="med" len="med"/>
+                    </a:lnB>
+                    <a:solidFill>
+                      <a:srgbClr val="FFFFFF"/>
+                    </a:solidFill>
+                  </a:tcPr>
+                </a:tc>
+                <a:tc>
+                  <a:txBody>
+                    <a:bodyPr rtlCol="1"/>
+                    <a:lstStyle/>
+                    <a:p>
+                      <a:pPr rtl="1" algn="r" indent="0" marL="0">
+                        <a:buNone/>
+                      </a:pPr>
+                      <a:endParaRPr lang="he-IL" sz="1100" dirty="0">
+                        <a:latin typeface="Arial" charset="0"/>
+                        <a:ea typeface="Arial" charset="0"/>
+                        <a:cs typeface="Arial" charset="0"/>
+                      </a:endParaRPr>
+                    </a:p>
+                  </a:txBody>
+                  <a:tcPr marL="50800" marR="50800" marT="50800" marB="50800" anchor="ctr">
+                    <a:lnL w="9525" cap="flat" cmpd="sng" algn="ctr">
+                      <a:solidFill>
+                        <a:srgbClr val="C9D6E4"/>
+                      </a:solidFill>
+                      <a:prstDash val="solid"/>
+                      <a:round/>
+                      <a:headEnd type="none" w="med" len="med"/>
+                      <a:tailEnd type="none" w="med" len="med"/>
+                    </a:lnL>
+                    <a:lnR w="9525" cap="flat" cmpd="sng" algn="ctr">
+                      <a:solidFill>
+                        <a:srgbClr val="C9D6E4"/>
+                      </a:solidFill>
+                      <a:prstDash val="solid"/>
+                      <a:round/>
+                      <a:headEnd type="none" w="med" len="med"/>
+                      <a:tailEnd type="none" w="med" len="med"/>
+                    </a:lnR>
+                    <a:lnT w="9525" cap="flat" cmpd="sng" algn="ctr">
+                      <a:solidFill>
+                        <a:srgbClr val="C9D6E4"/>
+                      </a:solidFill>
+                      <a:prstDash val="solid"/>
+                      <a:round/>
+                      <a:headEnd type="none" w="med" len="med"/>
+                      <a:tailEnd type="none" w="med" len="med"/>
+                    </a:lnT>
+                    <a:lnB w="9525" cap="flat" cmpd="sng" algn="ctr">
+                      <a:solidFill>
+                        <a:srgbClr val="C9D6E4"/>
+                      </a:solidFill>
+                      <a:prstDash val="solid"/>
+                      <a:round/>
+                      <a:headEnd type="none" w="med" len="med"/>
+                      <a:tailEnd type="none" w="med" len="med"/>
+                    </a:lnB>
+                    <a:solidFill>
+                      <a:srgbClr val="FFFFFF"/>
+                    </a:solidFill>
+                  </a:tcPr>
+                </a:tc>
+              </a:tr>
+              <a:tr h="224028">
+                <a:tc>
+                  <a:txBody>
+                    <a:bodyPr rtlCol="1"/>
+                    <a:lstStyle/>
+                    <a:p>
+                      <a:pPr rtl="1" algn="ctr" indent="0" marL="0">
+                        <a:buNone/>
+                      </a:pPr>
+                      <a:r>
+                        <a:rPr lang="he-IL" altLang="en-US" sz="1100" dirty="0">
+                          <a:solidFill>
+                            <a:srgbClr val="22303F"/>
+                          </a:solidFill>
+                          <a:latin typeface="Arial" pitchFamily="34" charset="0"/>
+                          <a:ea typeface="Arial" pitchFamily="34" charset="-122"/>
+                          <a:cs typeface="Arial" pitchFamily="34" charset="-120"/>
+                        </a:rPr>
+                        <a:t>47.8</a:t>
+                      </a:r>
+                      <a:endParaRPr lang="he-IL" sz="1100" dirty="0">
+                        <a:latin typeface="Arial" charset="0"/>
+                        <a:ea typeface="Arial" charset="0"/>
+                        <a:cs typeface="Arial" charset="0"/>
+                      </a:endParaRPr>
+                    </a:p>
+                  </a:txBody>
+                  <a:tcPr marL="50800" marR="50800" marT="50800" marB="50800" anchor="ctr">
+                    <a:lnL w="9525" cap="flat" cmpd="sng" algn="ctr">
+                      <a:solidFill>
+                        <a:srgbClr val="C9D6E4"/>
+                      </a:solidFill>
+                      <a:prstDash val="solid"/>
+                      <a:round/>
+                      <a:headEnd type="none" w="med" len="med"/>
+                      <a:tailEnd type="none" w="med" len="med"/>
+                    </a:lnL>
+                    <a:lnR w="9525" cap="flat" cmpd="sng" algn="ctr">
+                      <a:solidFill>
+                        <a:srgbClr val="C9D6E4"/>
+                      </a:solidFill>
+                      <a:prstDash val="solid"/>
+                      <a:round/>
+                      <a:headEnd type="none" w="med" len="med"/>
+                      <a:tailEnd type="none" w="med" len="med"/>
+                    </a:lnR>
+                    <a:lnT w="9525" cap="flat" cmpd="sng" algn="ctr">
+                      <a:solidFill>
+                        <a:srgbClr val="C9D6E4"/>
+                      </a:solidFill>
+                      <a:prstDash val="solid"/>
+                      <a:round/>
+                      <a:headEnd type="none" w="med" len="med"/>
+                      <a:tailEnd type="none" w="med" len="med"/>
+                    </a:lnT>
+                    <a:lnB w="9525" cap="flat" cmpd="sng" algn="ctr">
+                      <a:solidFill>
+                        <a:srgbClr val="C9D6E4"/>
+                      </a:solidFill>
+                      <a:prstDash val="solid"/>
+                      <a:round/>
+                      <a:headEnd type="none" w="med" len="med"/>
+                      <a:tailEnd type="none" w="med" len="med"/>
+                    </a:lnB>
+                    <a:solidFill>
+                      <a:srgbClr val="EAF0F7"/>
+                    </a:solidFill>
+                  </a:tcPr>
+                </a:tc>
+                <a:tc>
+                  <a:txBody>
+                    <a:bodyPr rtlCol="1"/>
+                    <a:lstStyle/>
+                    <a:p>
+                      <a:pPr rtl="1" algn="ctr" indent="0" marL="0">
+                        <a:buNone/>
+                      </a:pPr>
+                      <a:r>
+                        <a:rPr lang="he-IL" altLang="en-US" sz="1100" dirty="0">
+                          <a:solidFill>
+                            <a:srgbClr val="22303F"/>
+                          </a:solidFill>
+                          <a:latin typeface="Arial" pitchFamily="34" charset="0"/>
+                          <a:ea typeface="Arial" pitchFamily="34" charset="-122"/>
+                          <a:cs typeface="Arial" pitchFamily="34" charset="-120"/>
+                        </a:rPr>
+                        <a:t>1,136</a:t>
+                      </a:r>
+                      <a:endParaRPr lang="he-IL" sz="1100" dirty="0">
+                        <a:latin typeface="Arial" charset="0"/>
+                        <a:ea typeface="Arial" charset="0"/>
+                        <a:cs typeface="Arial" charset="0"/>
+                      </a:endParaRPr>
+                    </a:p>
+                  </a:txBody>
+                  <a:tcPr marL="50800" marR="50800" marT="50800" marB="50800" anchor="ctr">
+                    <a:lnL w="9525" cap="flat" cmpd="sng" algn="ctr">
+                      <a:solidFill>
+                        <a:srgbClr val="C9D6E4"/>
+                      </a:solidFill>
+                      <a:prstDash val="solid"/>
+                      <a:round/>
+                      <a:headEnd type="none" w="med" len="med"/>
+                      <a:tailEnd type="none" w="med" len="med"/>
+                    </a:lnL>
+                    <a:lnR w="9525" cap="flat" cmpd="sng" algn="ctr">
+                      <a:solidFill>
+                        <a:srgbClr val="C9D6E4"/>
+                      </a:solidFill>
+                      <a:prstDash val="solid"/>
+                      <a:round/>
+                      <a:headEnd type="none" w="med" len="med"/>
+                      <a:tailEnd type="none" w="med" len="med"/>
+                    </a:lnR>
+                    <a:lnT w="9525" cap="flat" cmpd="sng" algn="ctr">
+                      <a:solidFill>
+                        <a:srgbClr val="C9D6E4"/>
+                      </a:solidFill>
+                      <a:prstDash val="solid"/>
+                      <a:round/>
+                      <a:headEnd type="none" w="med" len="med"/>
+                      <a:tailEnd type="none" w="med" len="med"/>
+                    </a:lnT>
+                    <a:lnB w="9525" cap="flat" cmpd="sng" algn="ctr">
+                      <a:solidFill>
+                        <a:srgbClr val="C9D6E4"/>
+                      </a:solidFill>
+                      <a:prstDash val="solid"/>
+                      <a:round/>
+                      <a:headEnd type="none" w="med" len="med"/>
+                      <a:tailEnd type="none" w="med" len="med"/>
+                    </a:lnB>
+                    <a:solidFill>
+                      <a:srgbClr val="EAF0F7"/>
+                    </a:solidFill>
+                  </a:tcPr>
+                </a:tc>
+                <a:tc>
+                  <a:txBody>
+                    <a:bodyPr rtlCol="1"/>
+                    <a:lstStyle/>
+                    <a:p>
+                      <a:pPr rtl="1" algn="ctr" indent="0" marL="0">
+                        <a:buNone/>
+                      </a:pPr>
+                      <a:r>
+                        <a:rPr lang="he-IL" altLang="en-US" sz="1100" dirty="0">
+                          <a:solidFill>
+                            <a:srgbClr val="22303F"/>
+                          </a:solidFill>
+                          <a:latin typeface="Arial" pitchFamily="34" charset="0"/>
+                          <a:ea typeface="Arial" pitchFamily="34" charset="-122"/>
+                          <a:cs typeface="Arial" pitchFamily="34" charset="-120"/>
+                        </a:rPr>
+                        <a:t>יהודים</a:t>
+                      </a:r>
+                      <a:endParaRPr lang="he-IL" sz="1100" dirty="0">
+                        <a:latin typeface="Arial" charset="0"/>
+                        <a:ea typeface="Arial" charset="0"/>
+                        <a:cs typeface="Arial" charset="0"/>
+                      </a:endParaRPr>
+                    </a:p>
+                  </a:txBody>
+                  <a:tcPr marL="50800" marR="50800" marT="50800" marB="50800" anchor="ctr">
+                    <a:lnL w="9525" cap="flat" cmpd="sng" algn="ctr">
+                      <a:solidFill>
+                        <a:srgbClr val="C9D6E4"/>
+                      </a:solidFill>
+                      <a:prstDash val="solid"/>
+                      <a:round/>
+                      <a:headEnd type="none" w="med" len="med"/>
+                      <a:tailEnd type="none" w="med" len="med"/>
+                    </a:lnL>
+                    <a:lnR w="9525" cap="flat" cmpd="sng" algn="ctr">
+                      <a:solidFill>
+                        <a:srgbClr val="C9D6E4"/>
+                      </a:solidFill>
+                      <a:prstDash val="solid"/>
+                      <a:round/>
+                      <a:headEnd type="none" w="med" len="med"/>
+                      <a:tailEnd type="none" w="med" len="med"/>
+                    </a:lnR>
+                    <a:lnT w="9525" cap="flat" cmpd="sng" algn="ctr">
+                      <a:solidFill>
+                        <a:srgbClr val="C9D6E4"/>
+                      </a:solidFill>
+                      <a:prstDash val="solid"/>
+                      <a:round/>
+                      <a:headEnd type="none" w="med" len="med"/>
+                      <a:tailEnd type="none" w="med" len="med"/>
+                    </a:lnT>
+                    <a:lnB w="9525" cap="flat" cmpd="sng" algn="ctr">
+                      <a:solidFill>
+                        <a:srgbClr val="C9D6E4"/>
+                      </a:solidFill>
+                      <a:prstDash val="solid"/>
+                      <a:round/>
+                      <a:headEnd type="none" w="med" len="med"/>
+                      <a:tailEnd type="none" w="med" len="med"/>
+                    </a:lnB>
+                    <a:solidFill>
+                      <a:srgbClr val="EAF0F7"/>
+                    </a:solidFill>
+                  </a:tcPr>
+                </a:tc>
+                <a:tc>
+                  <a:txBody>
+                    <a:bodyPr rtlCol="1"/>
+                    <a:lstStyle/>
+                    <a:p>
+                      <a:pPr rtl="1" algn="r" indent="0" marL="0">
+                        <a:buNone/>
+                      </a:pPr>
+                      <a:r>
+                        <a:rPr lang="he-IL" altLang="en-US" sz="1100" b="1" dirty="0">
+                          <a:solidFill>
+                            <a:srgbClr val="22303F"/>
+                          </a:solidFill>
+                          <a:latin typeface="Arial" pitchFamily="34" charset="0"/>
+                          <a:ea typeface="Arial" pitchFamily="34" charset="-122"/>
+                          <a:cs typeface="Arial" pitchFamily="34" charset="-120"/>
+                        </a:rPr>
+                        <a:t>לאום</a:t>
+                      </a:r>
+                      <a:endParaRPr lang="he-IL" sz="1100" dirty="0">
+                        <a:latin typeface="Arial" charset="0"/>
+                        <a:ea typeface="Arial" charset="0"/>
+                        <a:cs typeface="Arial" charset="0"/>
+                      </a:endParaRPr>
+                    </a:p>
+                  </a:txBody>
+                  <a:tcPr marL="50800" marR="50800" marT="50800" marB="50800" anchor="ctr">
+                    <a:lnL w="9525" cap="flat" cmpd="sng" algn="ctr">
+                      <a:solidFill>
+                        <a:srgbClr val="C9D6E4"/>
+                      </a:solidFill>
+                      <a:prstDash val="solid"/>
+                      <a:round/>
+                      <a:headEnd type="none" w="med" len="med"/>
+                      <a:tailEnd type="none" w="med" len="med"/>
+                    </a:lnL>
+                    <a:lnR w="9525" cap="flat" cmpd="sng" algn="ctr">
+                      <a:solidFill>
+                        <a:srgbClr val="C9D6E4"/>
+                      </a:solidFill>
+                      <a:prstDash val="solid"/>
+                      <a:round/>
+                      <a:headEnd type="none" w="med" len="med"/>
+                      <a:tailEnd type="none" w="med" len="med"/>
+                    </a:lnR>
+                    <a:lnT w="9525" cap="flat" cmpd="sng" algn="ctr">
+                      <a:solidFill>
+                        <a:srgbClr val="C9D6E4"/>
+                      </a:solidFill>
+                      <a:prstDash val="solid"/>
+                      <a:round/>
+                      <a:headEnd type="none" w="med" len="med"/>
+                      <a:tailEnd type="none" w="med" len="med"/>
+                    </a:lnT>
+                    <a:lnB w="9525" cap="flat" cmpd="sng" algn="ctr">
+                      <a:solidFill>
+                        <a:srgbClr val="C9D6E4"/>
+                      </a:solidFill>
+                      <a:prstDash val="solid"/>
+                      <a:round/>
+                      <a:headEnd type="none" w="med" len="med"/>
+                      <a:tailEnd type="none" w="med" len="med"/>
+                    </a:lnB>
+                    <a:solidFill>
+                      <a:srgbClr val="EAF0F7"/>
+                    </a:solidFill>
+                  </a:tcPr>
+                </a:tc>
+              </a:tr>
+              <a:tr h="224028">
+                <a:tc>
+                  <a:txBody>
+                    <a:bodyPr rtlCol="1"/>
+                    <a:lstStyle/>
+                    <a:p>
+                      <a:pPr rtl="1" algn="ctr" indent="0" marL="0">
+                        <a:buNone/>
+                      </a:pPr>
+                      <a:r>
+                        <a:rPr lang="he-IL" altLang="en-US" sz="1100" dirty="0">
+                          <a:solidFill>
+                            <a:srgbClr val="22303F"/>
+                          </a:solidFill>
+                          <a:latin typeface="Arial" pitchFamily="34" charset="0"/>
+                          <a:ea typeface="Arial" pitchFamily="34" charset="-122"/>
+                          <a:cs typeface="Arial" pitchFamily="34" charset="-120"/>
+                        </a:rPr>
+                        <a:t>52.2</a:t>
+                      </a:r>
+                      <a:endParaRPr lang="he-IL" sz="1100" dirty="0">
+                        <a:latin typeface="Arial" charset="0"/>
+                        <a:ea typeface="Arial" charset="0"/>
+                        <a:cs typeface="Arial" charset="0"/>
+                      </a:endParaRPr>
+                    </a:p>
+                  </a:txBody>
+                  <a:tcPr marL="50800" marR="50800" marT="50800" marB="50800" anchor="ctr">
+                    <a:lnL w="9525" cap="flat" cmpd="sng" algn="ctr">
+                      <a:solidFill>
+                        <a:srgbClr val="C9D6E4"/>
+                      </a:solidFill>
+                      <a:prstDash val="solid"/>
+                      <a:round/>
+                      <a:headEnd type="none" w="med" len="med"/>
+                      <a:tailEnd type="none" w="med" len="med"/>
+                    </a:lnL>
+                    <a:lnR w="9525" cap="flat" cmpd="sng" algn="ctr">
+                      <a:solidFill>
+                        <a:srgbClr val="C9D6E4"/>
+                      </a:solidFill>
+                      <a:prstDash val="solid"/>
+                      <a:round/>
+                      <a:headEnd type="none" w="med" len="med"/>
+                      <a:tailEnd type="none" w="med" len="med"/>
+                    </a:lnR>
+                    <a:lnT w="9525" cap="flat" cmpd="sng" algn="ctr">
+                      <a:solidFill>
+                        <a:srgbClr val="C9D6E4"/>
+                      </a:solidFill>
+                      <a:prstDash val="solid"/>
+                      <a:round/>
+                      <a:headEnd type="none" w="med" len="med"/>
+                      <a:tailEnd type="none" w="med" len="med"/>
+                    </a:lnT>
+                    <a:lnB w="9525" cap="flat" cmpd="sng" algn="ctr">
+                      <a:solidFill>
+                        <a:srgbClr val="C9D6E4"/>
+                      </a:solidFill>
+                      <a:prstDash val="solid"/>
+                      <a:round/>
+                      <a:headEnd type="none" w="med" len="med"/>
+                      <a:tailEnd type="none" w="med" len="med"/>
+                    </a:lnB>
+                    <a:solidFill>
+                      <a:srgbClr val="FFFFFF"/>
+                    </a:solidFill>
+                  </a:tcPr>
+                </a:tc>
+                <a:tc>
+                  <a:txBody>
+                    <a:bodyPr rtlCol="1"/>
+                    <a:lstStyle/>
+                    <a:p>
+                      <a:pPr rtl="1" algn="ctr" indent="0" marL="0">
+                        <a:buNone/>
+                      </a:pPr>
+                      <a:r>
+                        <a:rPr lang="he-IL" altLang="en-US" sz="1100" dirty="0">
+                          <a:solidFill>
+                            <a:srgbClr val="22303F"/>
+                          </a:solidFill>
+                          <a:latin typeface="Arial" pitchFamily="34" charset="0"/>
+                          <a:ea typeface="Arial" pitchFamily="34" charset="-122"/>
+                          <a:cs typeface="Arial" pitchFamily="34" charset="-120"/>
+                        </a:rPr>
+                        <a:t>1,243</a:t>
+                      </a:r>
+                      <a:endParaRPr lang="he-IL" sz="1100" dirty="0">
+                        <a:latin typeface="Arial" charset="0"/>
+                        <a:ea typeface="Arial" charset="0"/>
+                        <a:cs typeface="Arial" charset="0"/>
+                      </a:endParaRPr>
+                    </a:p>
+                  </a:txBody>
+                  <a:tcPr marL="50800" marR="50800" marT="50800" marB="50800" anchor="ctr">
+                    <a:lnL w="9525" cap="flat" cmpd="sng" algn="ctr">
+                      <a:solidFill>
+                        <a:srgbClr val="C9D6E4"/>
+                      </a:solidFill>
+                      <a:prstDash val="solid"/>
+                      <a:round/>
+                      <a:headEnd type="none" w="med" len="med"/>
+                      <a:tailEnd type="none" w="med" len="med"/>
+                    </a:lnL>
+                    <a:lnR w="9525" cap="flat" cmpd="sng" algn="ctr">
+                      <a:solidFill>
+                        <a:srgbClr val="C9D6E4"/>
+                      </a:solidFill>
+                      <a:prstDash val="solid"/>
+                      <a:round/>
+                      <a:headEnd type="none" w="med" len="med"/>
+                      <a:tailEnd type="none" w="med" len="med"/>
+                    </a:lnR>
+                    <a:lnT w="9525" cap="flat" cmpd="sng" algn="ctr">
+                      <a:solidFill>
+                        <a:srgbClr val="C9D6E4"/>
+                      </a:solidFill>
+                      <a:prstDash val="solid"/>
+                      <a:round/>
+                      <a:headEnd type="none" w="med" len="med"/>
+                      <a:tailEnd type="none" w="med" len="med"/>
+                    </a:lnT>
+                    <a:lnB w="9525" cap="flat" cmpd="sng" algn="ctr">
+                      <a:solidFill>
+                        <a:srgbClr val="C9D6E4"/>
+                      </a:solidFill>
+                      <a:prstDash val="solid"/>
+                      <a:round/>
+                      <a:headEnd type="none" w="med" len="med"/>
+                      <a:tailEnd type="none" w="med" len="med"/>
+                    </a:lnB>
+                    <a:solidFill>
+                      <a:srgbClr val="FFFFFF"/>
+                    </a:solidFill>
+                  </a:tcPr>
+                </a:tc>
+                <a:tc>
+                  <a:txBody>
+                    <a:bodyPr rtlCol="1"/>
+                    <a:lstStyle/>
+                    <a:p>
+                      <a:pPr rtl="1" algn="ctr" indent="0" marL="0">
+                        <a:buNone/>
+                      </a:pPr>
+                      <a:r>
+                        <a:rPr lang="he-IL" altLang="en-US" sz="1100" dirty="0">
+                          <a:solidFill>
+                            <a:srgbClr val="22303F"/>
+                          </a:solidFill>
+                          <a:latin typeface="Arial" pitchFamily="34" charset="0"/>
+                          <a:ea typeface="Arial" pitchFamily="34" charset="-122"/>
+                          <a:cs typeface="Arial" pitchFamily="34" charset="-120"/>
+                        </a:rPr>
+                        <a:t>לא יהודים</a:t>
+                      </a:r>
+                      <a:endParaRPr lang="he-IL" sz="1100" dirty="0">
+                        <a:latin typeface="Arial" charset="0"/>
+                        <a:ea typeface="Arial" charset="0"/>
+                        <a:cs typeface="Arial" charset="0"/>
+                      </a:endParaRPr>
+                    </a:p>
+                  </a:txBody>
+                  <a:tcPr marL="50800" marR="50800" marT="50800" marB="50800" anchor="ctr">
+                    <a:lnL w="9525" cap="flat" cmpd="sng" algn="ctr">
+                      <a:solidFill>
+                        <a:srgbClr val="C9D6E4"/>
+                      </a:solidFill>
+                      <a:prstDash val="solid"/>
+                      <a:round/>
+                      <a:headEnd type="none" w="med" len="med"/>
+                      <a:tailEnd type="none" w="med" len="med"/>
+                    </a:lnL>
+                    <a:lnR w="9525" cap="flat" cmpd="sng" algn="ctr">
+                      <a:solidFill>
+                        <a:srgbClr val="C9D6E4"/>
+                      </a:solidFill>
+                      <a:prstDash val="solid"/>
+                      <a:round/>
+                      <a:headEnd type="none" w="med" len="med"/>
+                      <a:tailEnd type="none" w="med" len="med"/>
+                    </a:lnR>
+                    <a:lnT w="9525" cap="flat" cmpd="sng" algn="ctr">
+                      <a:solidFill>
+                        <a:srgbClr val="C9D6E4"/>
+                      </a:solidFill>
+                      <a:prstDash val="solid"/>
+                      <a:round/>
+                      <a:headEnd type="none" w="med" len="med"/>
+                      <a:tailEnd type="none" w="med" len="med"/>
+                    </a:lnT>
+                    <a:lnB w="9525" cap="flat" cmpd="sng" algn="ctr">
+                      <a:solidFill>
+                        <a:srgbClr val="C9D6E4"/>
+                      </a:solidFill>
+                      <a:prstDash val="solid"/>
+                      <a:round/>
+                      <a:headEnd type="none" w="med" len="med"/>
+                      <a:tailEnd type="none" w="med" len="med"/>
+                    </a:lnB>
+                    <a:solidFill>
+                      <a:srgbClr val="FFFFFF"/>
+                    </a:solidFill>
+                  </a:tcPr>
+                </a:tc>
+                <a:tc>
+                  <a:txBody>
+                    <a:bodyPr rtlCol="1"/>
+                    <a:lstStyle/>
+                    <a:p>
+                      <a:pPr rtl="1" algn="r" indent="0" marL="0">
+                        <a:buNone/>
+                      </a:pPr>
+                      <a:endParaRPr lang="he-IL" sz="1100" dirty="0">
+                        <a:latin typeface="Arial" charset="0"/>
+                        <a:ea typeface="Arial" charset="0"/>
+                        <a:cs typeface="Arial" charset="0"/>
+                      </a:endParaRPr>
+                    </a:p>
+                  </a:txBody>
+                  <a:tcPr marL="50800" marR="50800" marT="50800" marB="50800" anchor="ctr">
+                    <a:lnL w="9525" cap="flat" cmpd="sng" algn="ctr">
+                      <a:solidFill>
+                        <a:srgbClr val="C9D6E4"/>
+                      </a:solidFill>
+                      <a:prstDash val="solid"/>
+                      <a:round/>
+                      <a:headEnd type="none" w="med" len="med"/>
+                      <a:tailEnd type="none" w="med" len="med"/>
+                    </a:lnL>
+                    <a:lnR w="9525" cap="flat" cmpd="sng" algn="ctr">
+                      <a:solidFill>
+                        <a:srgbClr val="C9D6E4"/>
+                      </a:solidFill>
+                      <a:prstDash val="solid"/>
+                      <a:round/>
+                      <a:headEnd type="none" w="med" len="med"/>
+                      <a:tailEnd type="none" w="med" len="med"/>
+                    </a:lnR>
+                    <a:lnT w="9525" cap="flat" cmpd="sng" algn="ctr">
+                      <a:solidFill>
+                        <a:srgbClr val="C9D6E4"/>
+                      </a:solidFill>
+                      <a:prstDash val="solid"/>
+                      <a:round/>
+                      <a:headEnd type="none" w="med" len="med"/>
+                      <a:tailEnd type="none" w="med" len="med"/>
+                    </a:lnT>
+                    <a:lnB w="9525" cap="flat" cmpd="sng" algn="ctr">
+                      <a:solidFill>
+                        <a:srgbClr val="C9D6E4"/>
+                      </a:solidFill>
+                      <a:prstDash val="solid"/>
+                      <a:round/>
+                      <a:headEnd type="none" w="med" len="med"/>
+                      <a:tailEnd type="none" w="med" len="med"/>
+                    </a:lnB>
+                    <a:solidFill>
+                      <a:srgbClr val="FFFFFF"/>
+                    </a:solidFill>
+                  </a:tcPr>
+                </a:tc>
+              </a:tr>
+              <a:tr h="224028">
+                <a:tc>
+                  <a:txBody>
+                    <a:bodyPr rtlCol="1"/>
+                    <a:lstStyle/>
+                    <a:p>
+                      <a:pPr rtl="1" algn="ctr" indent="0" marL="0">
+                        <a:buNone/>
+                      </a:pPr>
+                      <a:r>
+                        <a:rPr lang="he-IL" altLang="en-US" sz="1100" dirty="0">
+                          <a:solidFill>
+                            <a:srgbClr val="22303F"/>
+                          </a:solidFill>
+                          <a:latin typeface="Arial" pitchFamily="34" charset="0"/>
+                          <a:ea typeface="Arial" pitchFamily="34" charset="-122"/>
+                          <a:cs typeface="Arial" pitchFamily="34" charset="-120"/>
+                        </a:rPr>
+                        <a:t>48.8</a:t>
+                      </a:r>
+                      <a:endParaRPr lang="he-IL" sz="1100" dirty="0">
+                        <a:latin typeface="Arial" charset="0"/>
+                        <a:ea typeface="Arial" charset="0"/>
+                        <a:cs typeface="Arial" charset="0"/>
+                      </a:endParaRPr>
+                    </a:p>
+                  </a:txBody>
+                  <a:tcPr marL="50800" marR="50800" marT="50800" marB="50800" anchor="ctr">
+                    <a:lnL w="9525" cap="flat" cmpd="sng" algn="ctr">
+                      <a:solidFill>
+                        <a:srgbClr val="C9D6E4"/>
+                      </a:solidFill>
+                      <a:prstDash val="solid"/>
+                      <a:round/>
+                      <a:headEnd type="none" w="med" len="med"/>
+                      <a:tailEnd type="none" w="med" len="med"/>
+                    </a:lnL>
+                    <a:lnR w="9525" cap="flat" cmpd="sng" algn="ctr">
+                      <a:solidFill>
+                        <a:srgbClr val="C9D6E4"/>
+                      </a:solidFill>
+                      <a:prstDash val="solid"/>
+                      <a:round/>
+                      <a:headEnd type="none" w="med" len="med"/>
+                      <a:tailEnd type="none" w="med" len="med"/>
+                    </a:lnR>
+                    <a:lnT w="9525" cap="flat" cmpd="sng" algn="ctr">
+                      <a:solidFill>
+                        <a:srgbClr val="C9D6E4"/>
+                      </a:solidFill>
+                      <a:prstDash val="solid"/>
+                      <a:round/>
+                      <a:headEnd type="none" w="med" len="med"/>
+                      <a:tailEnd type="none" w="med" len="med"/>
+                    </a:lnT>
+                    <a:lnB w="9525" cap="flat" cmpd="sng" algn="ctr">
+                      <a:solidFill>
+                        <a:srgbClr val="C9D6E4"/>
+                      </a:solidFill>
+                      <a:prstDash val="solid"/>
+                      <a:round/>
+                      <a:headEnd type="none" w="med" len="med"/>
+                      <a:tailEnd type="none" w="med" len="med"/>
+                    </a:lnB>
+                    <a:solidFill>
+                      <a:srgbClr val="EAF0F7"/>
+                    </a:solidFill>
+                  </a:tcPr>
+                </a:tc>
+                <a:tc>
+                  <a:txBody>
+                    <a:bodyPr rtlCol="1"/>
+                    <a:lstStyle/>
+                    <a:p>
+                      <a:pPr rtl="1" algn="ctr" indent="0" marL="0">
+                        <a:buNone/>
+                      </a:pPr>
+                      <a:r>
+                        <a:rPr lang="he-IL" altLang="en-US" sz="1100" dirty="0">
+                          <a:solidFill>
+                            <a:srgbClr val="22303F"/>
+                          </a:solidFill>
+                          <a:latin typeface="Arial" pitchFamily="34" charset="0"/>
+                          <a:ea typeface="Arial" pitchFamily="34" charset="-122"/>
+                          <a:cs typeface="Arial" pitchFamily="34" charset="-120"/>
+                        </a:rPr>
+                        <a:t>1,162</a:t>
+                      </a:r>
+                      <a:endParaRPr lang="he-IL" sz="1100" dirty="0">
+                        <a:latin typeface="Arial" charset="0"/>
+                        <a:ea typeface="Arial" charset="0"/>
+                        <a:cs typeface="Arial" charset="0"/>
+                      </a:endParaRPr>
+                    </a:p>
+                  </a:txBody>
+                  <a:tcPr marL="50800" marR="50800" marT="50800" marB="50800" anchor="ctr">
+                    <a:lnL w="9525" cap="flat" cmpd="sng" algn="ctr">
+                      <a:solidFill>
+                        <a:srgbClr val="C9D6E4"/>
+                      </a:solidFill>
+                      <a:prstDash val="solid"/>
+                      <a:round/>
+                      <a:headEnd type="none" w="med" len="med"/>
+                      <a:tailEnd type="none" w="med" len="med"/>
+                    </a:lnL>
+                    <a:lnR w="9525" cap="flat" cmpd="sng" algn="ctr">
+                      <a:solidFill>
+                        <a:srgbClr val="C9D6E4"/>
+                      </a:solidFill>
+                      <a:prstDash val="solid"/>
+                      <a:round/>
+                      <a:headEnd type="none" w="med" len="med"/>
+                      <a:tailEnd type="none" w="med" len="med"/>
+                    </a:lnR>
+                    <a:lnT w="9525" cap="flat" cmpd="sng" algn="ctr">
+                      <a:solidFill>
+                        <a:srgbClr val="C9D6E4"/>
+                      </a:solidFill>
+                      <a:prstDash val="solid"/>
+                      <a:round/>
+                      <a:headEnd type="none" w="med" len="med"/>
+                      <a:tailEnd type="none" w="med" len="med"/>
+                    </a:lnT>
+                    <a:lnB w="9525" cap="flat" cmpd="sng" algn="ctr">
+                      <a:solidFill>
+                        <a:srgbClr val="C9D6E4"/>
+                      </a:solidFill>
+                      <a:prstDash val="solid"/>
+                      <a:round/>
+                      <a:headEnd type="none" w="med" len="med"/>
+                      <a:tailEnd type="none" w="med" len="med"/>
+                    </a:lnB>
+                    <a:solidFill>
+                      <a:srgbClr val="EAF0F7"/>
+                    </a:solidFill>
+                  </a:tcPr>
+                </a:tc>
+                <a:tc>
+                  <a:txBody>
+                    <a:bodyPr rtlCol="1"/>
+                    <a:lstStyle/>
+                    <a:p>
+                      <a:pPr rtl="1" algn="ctr" indent="0" marL="0">
+                        <a:buNone/>
+                      </a:pPr>
+                      <a:r>
+                        <a:rPr lang="he-IL" altLang="en-US" sz="1100" dirty="0">
+                          <a:solidFill>
+                            <a:srgbClr val="22303F"/>
+                          </a:solidFill>
+                          <a:latin typeface="Arial" pitchFamily="34" charset="0"/>
+                          <a:ea typeface="Arial" pitchFamily="34" charset="-122"/>
+                          <a:cs typeface="Arial" pitchFamily="34" charset="-120"/>
+                        </a:rPr>
+                        <a:t>מאסר ראשון</a:t>
+                      </a:r>
+                      <a:endParaRPr lang="he-IL" sz="1100" dirty="0">
+                        <a:latin typeface="Arial" charset="0"/>
+                        <a:ea typeface="Arial" charset="0"/>
+                        <a:cs typeface="Arial" charset="0"/>
+                      </a:endParaRPr>
+                    </a:p>
+                  </a:txBody>
+                  <a:tcPr marL="50800" marR="50800" marT="50800" marB="50800" anchor="ctr">
+                    <a:lnL w="9525" cap="flat" cmpd="sng" algn="ctr">
+                      <a:solidFill>
+                        <a:srgbClr val="C9D6E4"/>
+                      </a:solidFill>
+                      <a:prstDash val="solid"/>
+                      <a:round/>
+                      <a:headEnd type="none" w="med" len="med"/>
+                      <a:tailEnd type="none" w="med" len="med"/>
+                    </a:lnL>
+                    <a:lnR w="9525" cap="flat" cmpd="sng" algn="ctr">
+                      <a:solidFill>
+                        <a:srgbClr val="C9D6E4"/>
+                      </a:solidFill>
+                      <a:prstDash val="solid"/>
+                      <a:round/>
+                      <a:headEnd type="none" w="med" len="med"/>
+                      <a:tailEnd type="none" w="med" len="med"/>
+                    </a:lnR>
+                    <a:lnT w="9525" cap="flat" cmpd="sng" algn="ctr">
+                      <a:solidFill>
+                        <a:srgbClr val="C9D6E4"/>
+                      </a:solidFill>
+                      <a:prstDash val="solid"/>
+                      <a:round/>
+                      <a:headEnd type="none" w="med" len="med"/>
+                      <a:tailEnd type="none" w="med" len="med"/>
+                    </a:lnT>
+                    <a:lnB w="9525" cap="flat" cmpd="sng" algn="ctr">
+                      <a:solidFill>
+                        <a:srgbClr val="C9D6E4"/>
+                      </a:solidFill>
+                      <a:prstDash val="solid"/>
+                      <a:round/>
+                      <a:headEnd type="none" w="med" len="med"/>
+                      <a:tailEnd type="none" w="med" len="med"/>
+                    </a:lnB>
+                    <a:solidFill>
+                      <a:srgbClr val="EAF0F7"/>
+                    </a:solidFill>
+                  </a:tcPr>
+                </a:tc>
+                <a:tc>
+                  <a:txBody>
+                    <a:bodyPr rtlCol="1"/>
+                    <a:lstStyle/>
+                    <a:p>
+                      <a:pPr rtl="1" algn="r" indent="0" marL="0">
+                        <a:buNone/>
+                      </a:pPr>
+                      <a:r>
+                        <a:rPr lang="he-IL" altLang="en-US" sz="1100" b="1" dirty="0">
+                          <a:solidFill>
+                            <a:srgbClr val="22303F"/>
+                          </a:solidFill>
+                          <a:latin typeface="Arial" pitchFamily="34" charset="0"/>
+                          <a:ea typeface="Arial" pitchFamily="34" charset="-122"/>
+                          <a:cs typeface="Arial" pitchFamily="34" charset="-120"/>
+                        </a:rPr>
+                        <a:t>מספר מאסרים כשפוט</a:t>
+                      </a:r>
+                      <a:endParaRPr lang="he-IL" sz="1100" dirty="0">
+                        <a:latin typeface="Arial" charset="0"/>
+                        <a:ea typeface="Arial" charset="0"/>
+                        <a:cs typeface="Arial" charset="0"/>
+                      </a:endParaRPr>
+                    </a:p>
+                  </a:txBody>
+                  <a:tcPr marL="50800" marR="50800" marT="50800" marB="50800" anchor="ctr">
+                    <a:lnL w="9525" cap="flat" cmpd="sng" algn="ctr">
+                      <a:solidFill>
+                        <a:srgbClr val="C9D6E4"/>
+                      </a:solidFill>
+                      <a:prstDash val="solid"/>
+                      <a:round/>
+                      <a:headEnd type="none" w="med" len="med"/>
+                      <a:tailEnd type="none" w="med" len="med"/>
+                    </a:lnL>
+                    <a:lnR w="9525" cap="flat" cmpd="sng" algn="ctr">
+                      <a:solidFill>
+                        <a:srgbClr val="C9D6E4"/>
+                      </a:solidFill>
+                      <a:prstDash val="solid"/>
+                      <a:round/>
+                      <a:headEnd type="none" w="med" len="med"/>
+                      <a:tailEnd type="none" w="med" len="med"/>
+                    </a:lnR>
+                    <a:lnT w="9525" cap="flat" cmpd="sng" algn="ctr">
+                      <a:solidFill>
+                        <a:srgbClr val="C9D6E4"/>
+                      </a:solidFill>
+                      <a:prstDash val="solid"/>
+                      <a:round/>
+                      <a:headEnd type="none" w="med" len="med"/>
+                      <a:tailEnd type="none" w="med" len="med"/>
+                    </a:lnT>
+                    <a:lnB w="9525" cap="flat" cmpd="sng" algn="ctr">
+                      <a:solidFill>
+                        <a:srgbClr val="C9D6E4"/>
+                      </a:solidFill>
+                      <a:prstDash val="solid"/>
+                      <a:round/>
+                      <a:headEnd type="none" w="med" len="med"/>
+                      <a:tailEnd type="none" w="med" len="med"/>
+                    </a:lnB>
+                    <a:solidFill>
+                      <a:srgbClr val="EAF0F7"/>
+                    </a:solidFill>
+                  </a:tcPr>
+                </a:tc>
+              </a:tr>
+              <a:tr h="224028">
+                <a:tc>
+                  <a:txBody>
+                    <a:bodyPr rtlCol="1"/>
+                    <a:lstStyle/>
+                    <a:p>
+                      <a:pPr rtl="1" algn="ctr" indent="0" marL="0">
+                        <a:buNone/>
+                      </a:pPr>
+                      <a:r>
+                        <a:rPr lang="he-IL" altLang="en-US" sz="1100" dirty="0">
+                          <a:solidFill>
+                            <a:srgbClr val="22303F"/>
+                          </a:solidFill>
+                          <a:latin typeface="Arial" pitchFamily="34" charset="0"/>
+                          <a:ea typeface="Arial" pitchFamily="34" charset="-122"/>
+                          <a:cs typeface="Arial" pitchFamily="34" charset="-120"/>
+                        </a:rPr>
+                        <a:t>22.2</a:t>
+                      </a:r>
+                      <a:endParaRPr lang="he-IL" sz="1100" dirty="0">
+                        <a:latin typeface="Arial" charset="0"/>
+                        <a:ea typeface="Arial" charset="0"/>
+                        <a:cs typeface="Arial" charset="0"/>
+                      </a:endParaRPr>
+                    </a:p>
+                  </a:txBody>
+                  <a:tcPr marL="50800" marR="50800" marT="50800" marB="50800" anchor="ctr">
+                    <a:lnL w="9525" cap="flat" cmpd="sng" algn="ctr">
+                      <a:solidFill>
+                        <a:srgbClr val="C9D6E4"/>
+                      </a:solidFill>
+                      <a:prstDash val="solid"/>
+                      <a:round/>
+                      <a:headEnd type="none" w="med" len="med"/>
+                      <a:tailEnd type="none" w="med" len="med"/>
+                    </a:lnL>
+                    <a:lnR w="9525" cap="flat" cmpd="sng" algn="ctr">
+                      <a:solidFill>
+                        <a:srgbClr val="C9D6E4"/>
+                      </a:solidFill>
+                      <a:prstDash val="solid"/>
+                      <a:round/>
+                      <a:headEnd type="none" w="med" len="med"/>
+                      <a:tailEnd type="none" w="med" len="med"/>
+                    </a:lnR>
+                    <a:lnT w="9525" cap="flat" cmpd="sng" algn="ctr">
+                      <a:solidFill>
+                        <a:srgbClr val="C9D6E4"/>
+                      </a:solidFill>
+                      <a:prstDash val="solid"/>
+                      <a:round/>
+                      <a:headEnd type="none" w="med" len="med"/>
+                      <a:tailEnd type="none" w="med" len="med"/>
+                    </a:lnT>
+                    <a:lnB w="9525" cap="flat" cmpd="sng" algn="ctr">
+                      <a:solidFill>
+                        <a:srgbClr val="C9D6E4"/>
+                      </a:solidFill>
+                      <a:prstDash val="solid"/>
+                      <a:round/>
+                      <a:headEnd type="none" w="med" len="med"/>
+                      <a:tailEnd type="none" w="med" len="med"/>
+                    </a:lnB>
+                    <a:solidFill>
+                      <a:srgbClr val="FFFFFF"/>
+                    </a:solidFill>
+                  </a:tcPr>
+                </a:tc>
+                <a:tc>
+                  <a:txBody>
+                    <a:bodyPr rtlCol="1"/>
+                    <a:lstStyle/>
+                    <a:p>
+                      <a:pPr rtl="1" algn="ctr" indent="0" marL="0">
+                        <a:buNone/>
+                      </a:pPr>
+                      <a:r>
+                        <a:rPr lang="he-IL" altLang="en-US" sz="1100" dirty="0">
+                          <a:solidFill>
+                            <a:srgbClr val="22303F"/>
+                          </a:solidFill>
+                          <a:latin typeface="Arial" pitchFamily="34" charset="0"/>
+                          <a:ea typeface="Arial" pitchFamily="34" charset="-122"/>
+                          <a:cs typeface="Arial" pitchFamily="34" charset="-120"/>
+                        </a:rPr>
+                        <a:t>528</a:t>
+                      </a:r>
+                      <a:endParaRPr lang="he-IL" sz="1100" dirty="0">
+                        <a:latin typeface="Arial" charset="0"/>
+                        <a:ea typeface="Arial" charset="0"/>
+                        <a:cs typeface="Arial" charset="0"/>
+                      </a:endParaRPr>
+                    </a:p>
+                  </a:txBody>
+                  <a:tcPr marL="50800" marR="50800" marT="50800" marB="50800" anchor="ctr">
+                    <a:lnL w="9525" cap="flat" cmpd="sng" algn="ctr">
+                      <a:solidFill>
+                        <a:srgbClr val="C9D6E4"/>
+                      </a:solidFill>
+                      <a:prstDash val="solid"/>
+                      <a:round/>
+                      <a:headEnd type="none" w="med" len="med"/>
+                      <a:tailEnd type="none" w="med" len="med"/>
+                    </a:lnL>
+                    <a:lnR w="9525" cap="flat" cmpd="sng" algn="ctr">
+                      <a:solidFill>
+                        <a:srgbClr val="C9D6E4"/>
+                      </a:solidFill>
+                      <a:prstDash val="solid"/>
+                      <a:round/>
+                      <a:headEnd type="none" w="med" len="med"/>
+                      <a:tailEnd type="none" w="med" len="med"/>
+                    </a:lnR>
+                    <a:lnT w="9525" cap="flat" cmpd="sng" algn="ctr">
+                      <a:solidFill>
+                        <a:srgbClr val="C9D6E4"/>
+                      </a:solidFill>
+                      <a:prstDash val="solid"/>
+                      <a:round/>
+                      <a:headEnd type="none" w="med" len="med"/>
+                      <a:tailEnd type="none" w="med" len="med"/>
+                    </a:lnT>
+                    <a:lnB w="9525" cap="flat" cmpd="sng" algn="ctr">
+                      <a:solidFill>
+                        <a:srgbClr val="C9D6E4"/>
+                      </a:solidFill>
+                      <a:prstDash val="solid"/>
+                      <a:round/>
+                      <a:headEnd type="none" w="med" len="med"/>
+                      <a:tailEnd type="none" w="med" len="med"/>
+                    </a:lnB>
+                    <a:solidFill>
+                      <a:srgbClr val="FFFFFF"/>
+                    </a:solidFill>
+                  </a:tcPr>
+                </a:tc>
+                <a:tc>
+                  <a:txBody>
+                    <a:bodyPr rtlCol="1"/>
+                    <a:lstStyle/>
+                    <a:p>
+                      <a:pPr rtl="1" algn="ctr" indent="0" marL="0">
+                        <a:buNone/>
+                      </a:pPr>
+                      <a:r>
+                        <a:rPr lang="he-IL" altLang="en-US" sz="1100" dirty="0">
+                          <a:solidFill>
+                            <a:srgbClr val="22303F"/>
+                          </a:solidFill>
+                          <a:latin typeface="Arial" pitchFamily="34" charset="0"/>
+                          <a:ea typeface="Arial" pitchFamily="34" charset="-122"/>
+                          <a:cs typeface="Arial" pitchFamily="34" charset="-120"/>
+                        </a:rPr>
+                        <a:t>שני מאסרים</a:t>
+                      </a:r>
+                      <a:endParaRPr lang="he-IL" sz="1100" dirty="0">
+                        <a:latin typeface="Arial" charset="0"/>
+                        <a:ea typeface="Arial" charset="0"/>
+                        <a:cs typeface="Arial" charset="0"/>
+                      </a:endParaRPr>
+                    </a:p>
+                  </a:txBody>
+                  <a:tcPr marL="50800" marR="50800" marT="50800" marB="50800" anchor="ctr">
+                    <a:lnL w="9525" cap="flat" cmpd="sng" algn="ctr">
+                      <a:solidFill>
+                        <a:srgbClr val="C9D6E4"/>
+                      </a:solidFill>
+                      <a:prstDash val="solid"/>
+                      <a:round/>
+                      <a:headEnd type="none" w="med" len="med"/>
+                      <a:tailEnd type="none" w="med" len="med"/>
+                    </a:lnL>
+                    <a:lnR w="9525" cap="flat" cmpd="sng" algn="ctr">
+                      <a:solidFill>
+                        <a:srgbClr val="C9D6E4"/>
+                      </a:solidFill>
+                      <a:prstDash val="solid"/>
+                      <a:round/>
+                      <a:headEnd type="none" w="med" len="med"/>
+                      <a:tailEnd type="none" w="med" len="med"/>
+                    </a:lnR>
+                    <a:lnT w="9525" cap="flat" cmpd="sng" algn="ctr">
+                      <a:solidFill>
+                        <a:srgbClr val="C9D6E4"/>
+                      </a:solidFill>
+                      <a:prstDash val="solid"/>
+                      <a:round/>
+                      <a:headEnd type="none" w="med" len="med"/>
+                      <a:tailEnd type="none" w="med" len="med"/>
+                    </a:lnT>
+                    <a:lnB w="9525" cap="flat" cmpd="sng" algn="ctr">
+                      <a:solidFill>
+                        <a:srgbClr val="C9D6E4"/>
+                      </a:solidFill>
+                      <a:prstDash val="solid"/>
+                      <a:round/>
+                      <a:headEnd type="none" w="med" len="med"/>
+                      <a:tailEnd type="none" w="med" len="med"/>
+                    </a:lnB>
+                    <a:solidFill>
+                      <a:srgbClr val="FFFFFF"/>
+                    </a:solidFill>
+                  </a:tcPr>
+                </a:tc>
+                <a:tc>
+                  <a:txBody>
+                    <a:bodyPr rtlCol="1"/>
+                    <a:lstStyle/>
+                    <a:p>
+                      <a:pPr rtl="1" algn="r" indent="0" marL="0">
+                        <a:buNone/>
+                      </a:pPr>
+                      <a:endParaRPr lang="he-IL" sz="1100" dirty="0">
+                        <a:latin typeface="Arial" charset="0"/>
+                        <a:ea typeface="Arial" charset="0"/>
+                        <a:cs typeface="Arial" charset="0"/>
+                      </a:endParaRPr>
+                    </a:p>
+                  </a:txBody>
+                  <a:tcPr marL="50800" marR="50800" marT="50800" marB="50800" anchor="ctr">
+                    <a:lnL w="9525" cap="flat" cmpd="sng" algn="ctr">
+                      <a:solidFill>
+                        <a:srgbClr val="C9D6E4"/>
+                      </a:solidFill>
+                      <a:prstDash val="solid"/>
+                      <a:round/>
+                      <a:headEnd type="none" w="med" len="med"/>
+                      <a:tailEnd type="none" w="med" len="med"/>
+                    </a:lnL>
+                    <a:lnR w="9525" cap="flat" cmpd="sng" algn="ctr">
+                      <a:solidFill>
+                        <a:srgbClr val="C9D6E4"/>
+                      </a:solidFill>
+                      <a:prstDash val="solid"/>
+                      <a:round/>
+                      <a:headEnd type="none" w="med" len="med"/>
+                      <a:tailEnd type="none" w="med" len="med"/>
+                    </a:lnR>
+                    <a:lnT w="9525" cap="flat" cmpd="sng" algn="ctr">
+                      <a:solidFill>
+                        <a:srgbClr val="C9D6E4"/>
+                      </a:solidFill>
+                      <a:prstDash val="solid"/>
+                      <a:round/>
+                      <a:headEnd type="none" w="med" len="med"/>
+                      <a:tailEnd type="none" w="med" len="med"/>
+                    </a:lnT>
+                    <a:lnB w="9525" cap="flat" cmpd="sng" algn="ctr">
+                      <a:solidFill>
+                        <a:srgbClr val="C9D6E4"/>
+                      </a:solidFill>
+                      <a:prstDash val="solid"/>
+                      <a:round/>
+                      <a:headEnd type="none" w="med" len="med"/>
+                      <a:tailEnd type="none" w="med" len="med"/>
+                    </a:lnB>
+                    <a:solidFill>
+                      <a:srgbClr val="FFFFFF"/>
+                    </a:solidFill>
+                  </a:tcPr>
+                </a:tc>
+              </a:tr>
+              <a:tr h="224028">
+                <a:tc>
+                  <a:txBody>
+                    <a:bodyPr rtlCol="1"/>
+                    <a:lstStyle/>
+                    <a:p>
+                      <a:pPr rtl="1" algn="ctr" indent="0" marL="0">
+                        <a:buNone/>
+                      </a:pPr>
+                      <a:r>
+                        <a:rPr lang="he-IL" altLang="en-US" sz="1100" dirty="0">
+                          <a:solidFill>
+                            <a:srgbClr val="22303F"/>
+                          </a:solidFill>
+                          <a:latin typeface="Arial" pitchFamily="34" charset="0"/>
+                          <a:ea typeface="Arial" pitchFamily="34" charset="-122"/>
+                          <a:cs typeface="Arial" pitchFamily="34" charset="-120"/>
+                        </a:rPr>
+                        <a:t>29.0</a:t>
+                      </a:r>
+                      <a:endParaRPr lang="he-IL" sz="1100" dirty="0">
+                        <a:latin typeface="Arial" charset="0"/>
+                        <a:ea typeface="Arial" charset="0"/>
+                        <a:cs typeface="Arial" charset="0"/>
+                      </a:endParaRPr>
+                    </a:p>
+                  </a:txBody>
+                  <a:tcPr marL="50800" marR="50800" marT="50800" marB="50800" anchor="ctr">
+                    <a:lnL w="9525" cap="flat" cmpd="sng" algn="ctr">
+                      <a:solidFill>
+                        <a:srgbClr val="C9D6E4"/>
+                      </a:solidFill>
+                      <a:prstDash val="solid"/>
+                      <a:round/>
+                      <a:headEnd type="none" w="med" len="med"/>
+                      <a:tailEnd type="none" w="med" len="med"/>
+                    </a:lnL>
+                    <a:lnR w="9525" cap="flat" cmpd="sng" algn="ctr">
+                      <a:solidFill>
+                        <a:srgbClr val="C9D6E4"/>
+                      </a:solidFill>
+                      <a:prstDash val="solid"/>
+                      <a:round/>
+                      <a:headEnd type="none" w="med" len="med"/>
+                      <a:tailEnd type="none" w="med" len="med"/>
+                    </a:lnR>
+                    <a:lnT w="9525" cap="flat" cmpd="sng" algn="ctr">
+                      <a:solidFill>
+                        <a:srgbClr val="C9D6E4"/>
+                      </a:solidFill>
+                      <a:prstDash val="solid"/>
+                      <a:round/>
+                      <a:headEnd type="none" w="med" len="med"/>
+                      <a:tailEnd type="none" w="med" len="med"/>
+                    </a:lnT>
+                    <a:lnB w="9525" cap="flat" cmpd="sng" algn="ctr">
+                      <a:solidFill>
+                        <a:srgbClr val="C9D6E4"/>
+                      </a:solidFill>
+                      <a:prstDash val="solid"/>
+                      <a:round/>
+                      <a:headEnd type="none" w="med" len="med"/>
+                      <a:tailEnd type="none" w="med" len="med"/>
+                    </a:lnB>
+                    <a:solidFill>
+                      <a:srgbClr val="EAF0F7"/>
+                    </a:solidFill>
+                  </a:tcPr>
+                </a:tc>
+                <a:tc>
+                  <a:txBody>
+                    <a:bodyPr rtlCol="1"/>
+                    <a:lstStyle/>
+                    <a:p>
+                      <a:pPr rtl="1" algn="ctr" indent="0" marL="0">
+                        <a:buNone/>
+                      </a:pPr>
+                      <a:r>
+                        <a:rPr lang="he-IL" altLang="en-US" sz="1100" dirty="0">
+                          <a:solidFill>
+                            <a:srgbClr val="22303F"/>
+                          </a:solidFill>
+                          <a:latin typeface="Arial" pitchFamily="34" charset="0"/>
+                          <a:ea typeface="Arial" pitchFamily="34" charset="-122"/>
+                          <a:cs typeface="Arial" pitchFamily="34" charset="-120"/>
+                        </a:rPr>
+                        <a:t>689</a:t>
+                      </a:r>
+                      <a:endParaRPr lang="he-IL" sz="1100" dirty="0">
+                        <a:latin typeface="Arial" charset="0"/>
+                        <a:ea typeface="Arial" charset="0"/>
+                        <a:cs typeface="Arial" charset="0"/>
+                      </a:endParaRPr>
+                    </a:p>
+                  </a:txBody>
+                  <a:tcPr marL="50800" marR="50800" marT="50800" marB="50800" anchor="ctr">
+                    <a:lnL w="9525" cap="flat" cmpd="sng" algn="ctr">
+                      <a:solidFill>
+                        <a:srgbClr val="C9D6E4"/>
+                      </a:solidFill>
+                      <a:prstDash val="solid"/>
+                      <a:round/>
+                      <a:headEnd type="none" w="med" len="med"/>
+                      <a:tailEnd type="none" w="med" len="med"/>
+                    </a:lnL>
+                    <a:lnR w="9525" cap="flat" cmpd="sng" algn="ctr">
+                      <a:solidFill>
+                        <a:srgbClr val="C9D6E4"/>
+                      </a:solidFill>
+                      <a:prstDash val="solid"/>
+                      <a:round/>
+                      <a:headEnd type="none" w="med" len="med"/>
+                      <a:tailEnd type="none" w="med" len="med"/>
+                    </a:lnR>
+                    <a:lnT w="9525" cap="flat" cmpd="sng" algn="ctr">
+                      <a:solidFill>
+                        <a:srgbClr val="C9D6E4"/>
+                      </a:solidFill>
+                      <a:prstDash val="solid"/>
+                      <a:round/>
+                      <a:headEnd type="none" w="med" len="med"/>
+                      <a:tailEnd type="none" w="med" len="med"/>
+                    </a:lnT>
+                    <a:lnB w="9525" cap="flat" cmpd="sng" algn="ctr">
+                      <a:solidFill>
+                        <a:srgbClr val="C9D6E4"/>
+                      </a:solidFill>
+                      <a:prstDash val="solid"/>
+                      <a:round/>
+                      <a:headEnd type="none" w="med" len="med"/>
+                      <a:tailEnd type="none" w="med" len="med"/>
+                    </a:lnB>
+                    <a:solidFill>
+                      <a:srgbClr val="EAF0F7"/>
+                    </a:solidFill>
+                  </a:tcPr>
+                </a:tc>
+                <a:tc>
+                  <a:txBody>
+                    <a:bodyPr rtlCol="1"/>
+                    <a:lstStyle/>
+                    <a:p>
+                      <a:pPr rtl="1" algn="ctr" indent="0" marL="0">
+                        <a:buNone/>
+                      </a:pPr>
+                      <a:r>
+                        <a:rPr lang="he-IL" altLang="en-US" sz="1100" dirty="0">
+                          <a:solidFill>
+                            <a:srgbClr val="22303F"/>
+                          </a:solidFill>
+                          <a:latin typeface="Arial" pitchFamily="34" charset="0"/>
+                          <a:ea typeface="Arial" pitchFamily="34" charset="-122"/>
+                          <a:cs typeface="Arial" pitchFamily="34" charset="-120"/>
+                        </a:rPr>
+                        <a:t>שלושה מאסרים ומעלה</a:t>
+                      </a:r>
+                      <a:endParaRPr lang="he-IL" sz="1100" dirty="0">
+                        <a:latin typeface="Arial" charset="0"/>
+                        <a:ea typeface="Arial" charset="0"/>
+                        <a:cs typeface="Arial" charset="0"/>
+                      </a:endParaRPr>
+                    </a:p>
+                  </a:txBody>
+                  <a:tcPr marL="50800" marR="50800" marT="50800" marB="50800" anchor="ctr">
+                    <a:lnL w="9525" cap="flat" cmpd="sng" algn="ctr">
+                      <a:solidFill>
+                        <a:srgbClr val="C9D6E4"/>
+                      </a:solidFill>
+                      <a:prstDash val="solid"/>
+                      <a:round/>
+                      <a:headEnd type="none" w="med" len="med"/>
+                      <a:tailEnd type="none" w="med" len="med"/>
+                    </a:lnL>
+                    <a:lnR w="9525" cap="flat" cmpd="sng" algn="ctr">
+                      <a:solidFill>
+                        <a:srgbClr val="C9D6E4"/>
+                      </a:solidFill>
+                      <a:prstDash val="solid"/>
+                      <a:round/>
+                      <a:headEnd type="none" w="med" len="med"/>
+                      <a:tailEnd type="none" w="med" len="med"/>
+                    </a:lnR>
+                    <a:lnT w="9525" cap="flat" cmpd="sng" algn="ctr">
+                      <a:solidFill>
+                        <a:srgbClr val="C9D6E4"/>
+                      </a:solidFill>
+                      <a:prstDash val="solid"/>
+                      <a:round/>
+                      <a:headEnd type="none" w="med" len="med"/>
+                      <a:tailEnd type="none" w="med" len="med"/>
+                    </a:lnT>
+                    <a:lnB w="9525" cap="flat" cmpd="sng" algn="ctr">
+                      <a:solidFill>
+                        <a:srgbClr val="C9D6E4"/>
+                      </a:solidFill>
+                      <a:prstDash val="solid"/>
+                      <a:round/>
+                      <a:headEnd type="none" w="med" len="med"/>
+                      <a:tailEnd type="none" w="med" len="med"/>
+                    </a:lnB>
+                    <a:solidFill>
+                      <a:srgbClr val="EAF0F7"/>
+                    </a:solidFill>
+                  </a:tcPr>
+                </a:tc>
+                <a:tc>
+                  <a:txBody>
+                    <a:bodyPr rtlCol="1"/>
+                    <a:lstStyle/>
+                    <a:p>
+                      <a:pPr rtl="1" algn="r" indent="0" marL="0">
+                        <a:buNone/>
+                      </a:pPr>
+                      <a:endParaRPr lang="he-IL" sz="1100" dirty="0">
+                        <a:latin typeface="Arial" charset="0"/>
+                        <a:ea typeface="Arial" charset="0"/>
+                        <a:cs typeface="Arial" charset="0"/>
+                      </a:endParaRPr>
+                    </a:p>
+                  </a:txBody>
+                  <a:tcPr marL="50800" marR="50800" marT="50800" marB="50800" anchor="ctr">
+                    <a:lnL w="9525" cap="flat" cmpd="sng" algn="ctr">
+                      <a:solidFill>
+                        <a:srgbClr val="C9D6E4"/>
+                      </a:solidFill>
+                      <a:prstDash val="solid"/>
+                      <a:round/>
+                      <a:headEnd type="none" w="med" len="med"/>
+                      <a:tailEnd type="none" w="med" len="med"/>
+                    </a:lnL>
+                    <a:lnR w="9525" cap="flat" cmpd="sng" algn="ctr">
+                      <a:solidFill>
+                        <a:srgbClr val="C9D6E4"/>
+                      </a:solidFill>
+                      <a:prstDash val="solid"/>
+                      <a:round/>
+                      <a:headEnd type="none" w="med" len="med"/>
+                      <a:tailEnd type="none" w="med" len="med"/>
+                    </a:lnR>
+                    <a:lnT w="9525" cap="flat" cmpd="sng" algn="ctr">
+                      <a:solidFill>
+                        <a:srgbClr val="C9D6E4"/>
+                      </a:solidFill>
+                      <a:prstDash val="solid"/>
+                      <a:round/>
+                      <a:headEnd type="none" w="med" len="med"/>
+                      <a:tailEnd type="none" w="med" len="med"/>
+                    </a:lnT>
+                    <a:lnB w="9525" cap="flat" cmpd="sng" algn="ctr">
+                      <a:solidFill>
+                        <a:srgbClr val="C9D6E4"/>
+                      </a:solidFill>
+                      <a:prstDash val="solid"/>
+                      <a:round/>
+                      <a:headEnd type="none" w="med" len="med"/>
+                      <a:tailEnd type="none" w="med" len="med"/>
+                    </a:lnB>
+                    <a:solidFill>
+                      <a:srgbClr val="EAF0F7"/>
+                    </a:solidFill>
+                  </a:tcPr>
+                </a:tc>
+              </a:tr>
+              <a:tr h="224028">
+                <a:tc>
+                  <a:txBody>
+                    <a:bodyPr rtlCol="1"/>
+                    <a:lstStyle/>
+                    <a:p>
+                      <a:pPr rtl="1" algn="ctr" indent="0" marL="0">
+                        <a:buNone/>
+                      </a:pPr>
+                      <a:r>
+                        <a:rPr lang="he-IL" altLang="en-US" sz="1100" dirty="0">
+                          <a:solidFill>
+                            <a:srgbClr val="22303F"/>
+                          </a:solidFill>
+                          <a:latin typeface="Arial" pitchFamily="34" charset="0"/>
+                          <a:ea typeface="Arial" pitchFamily="34" charset="-122"/>
+                          <a:cs typeface="Arial" pitchFamily="34" charset="-120"/>
+                        </a:rPr>
+                        <a:t>31.7</a:t>
+                      </a:r>
+                      <a:endParaRPr lang="he-IL" sz="1100" dirty="0">
+                        <a:latin typeface="Arial" charset="0"/>
+                        <a:ea typeface="Arial" charset="0"/>
+                        <a:cs typeface="Arial" charset="0"/>
+                      </a:endParaRPr>
+                    </a:p>
+                  </a:txBody>
+                  <a:tcPr marL="50800" marR="50800" marT="50800" marB="50800" anchor="ctr">
+                    <a:lnL w="9525" cap="flat" cmpd="sng" algn="ctr">
+                      <a:solidFill>
+                        <a:srgbClr val="C9D6E4"/>
+                      </a:solidFill>
+                      <a:prstDash val="solid"/>
+                      <a:round/>
+                      <a:headEnd type="none" w="med" len="med"/>
+                      <a:tailEnd type="none" w="med" len="med"/>
+                    </a:lnL>
+                    <a:lnR w="9525" cap="flat" cmpd="sng" algn="ctr">
+                      <a:solidFill>
+                        <a:srgbClr val="C9D6E4"/>
+                      </a:solidFill>
+                      <a:prstDash val="solid"/>
+                      <a:round/>
+                      <a:headEnd type="none" w="med" len="med"/>
+                      <a:tailEnd type="none" w="med" len="med"/>
+                    </a:lnR>
+                    <a:lnT w="9525" cap="flat" cmpd="sng" algn="ctr">
+                      <a:solidFill>
+                        <a:srgbClr val="C9D6E4"/>
+                      </a:solidFill>
+                      <a:prstDash val="solid"/>
+                      <a:round/>
+                      <a:headEnd type="none" w="med" len="med"/>
+                      <a:tailEnd type="none" w="med" len="med"/>
+                    </a:lnT>
+                    <a:lnB w="9525" cap="flat" cmpd="sng" algn="ctr">
+                      <a:solidFill>
+                        <a:srgbClr val="C9D6E4"/>
+                      </a:solidFill>
+                      <a:prstDash val="solid"/>
+                      <a:round/>
+                      <a:headEnd type="none" w="med" len="med"/>
+                      <a:tailEnd type="none" w="med" len="med"/>
+                    </a:lnB>
+                    <a:solidFill>
+                      <a:srgbClr val="FFFFFF"/>
+                    </a:solidFill>
+                  </a:tcPr>
+                </a:tc>
+                <a:tc>
+                  <a:txBody>
+                    <a:bodyPr rtlCol="1"/>
+                    <a:lstStyle/>
+                    <a:p>
+                      <a:pPr rtl="1" algn="ctr" indent="0" marL="0">
+                        <a:buNone/>
+                      </a:pPr>
+                      <a:r>
+                        <a:rPr lang="he-IL" altLang="en-US" sz="1100" dirty="0">
+                          <a:solidFill>
+                            <a:srgbClr val="22303F"/>
+                          </a:solidFill>
+                          <a:latin typeface="Arial" pitchFamily="34" charset="0"/>
+                          <a:ea typeface="Arial" pitchFamily="34" charset="-122"/>
+                          <a:cs typeface="Arial" pitchFamily="34" charset="-120"/>
+                        </a:rPr>
+                        <a:t>755</a:t>
+                      </a:r>
+                      <a:endParaRPr lang="he-IL" sz="1100" dirty="0">
+                        <a:latin typeface="Arial" charset="0"/>
+                        <a:ea typeface="Arial" charset="0"/>
+                        <a:cs typeface="Arial" charset="0"/>
+                      </a:endParaRPr>
+                    </a:p>
+                  </a:txBody>
+                  <a:tcPr marL="50800" marR="50800" marT="50800" marB="50800" anchor="ctr">
+                    <a:lnL w="9525" cap="flat" cmpd="sng" algn="ctr">
+                      <a:solidFill>
+                        <a:srgbClr val="C9D6E4"/>
+                      </a:solidFill>
+                      <a:prstDash val="solid"/>
+                      <a:round/>
+                      <a:headEnd type="none" w="med" len="med"/>
+                      <a:tailEnd type="none" w="med" len="med"/>
+                    </a:lnL>
+                    <a:lnR w="9525" cap="flat" cmpd="sng" algn="ctr">
+                      <a:solidFill>
+                        <a:srgbClr val="C9D6E4"/>
+                      </a:solidFill>
+                      <a:prstDash val="solid"/>
+                      <a:round/>
+                      <a:headEnd type="none" w="med" len="med"/>
+                      <a:tailEnd type="none" w="med" len="med"/>
+                    </a:lnR>
+                    <a:lnT w="9525" cap="flat" cmpd="sng" algn="ctr">
+                      <a:solidFill>
+                        <a:srgbClr val="C9D6E4"/>
+                      </a:solidFill>
+                      <a:prstDash val="solid"/>
+                      <a:round/>
+                      <a:headEnd type="none" w="med" len="med"/>
+                      <a:tailEnd type="none" w="med" len="med"/>
+                    </a:lnT>
+                    <a:lnB w="9525" cap="flat" cmpd="sng" algn="ctr">
+                      <a:solidFill>
+                        <a:srgbClr val="C9D6E4"/>
+                      </a:solidFill>
+                      <a:prstDash val="solid"/>
+                      <a:round/>
+                      <a:headEnd type="none" w="med" len="med"/>
+                      <a:tailEnd type="none" w="med" len="med"/>
+                    </a:lnB>
+                    <a:solidFill>
+                      <a:srgbClr val="FFFFFF"/>
+                    </a:solidFill>
+                  </a:tcPr>
+                </a:tc>
+                <a:tc>
+                  <a:txBody>
+                    <a:bodyPr rtlCol="1"/>
+                    <a:lstStyle/>
+                    <a:p>
+                      <a:pPr rtl="1" algn="ctr" indent="0" marL="0">
+                        <a:buNone/>
+                      </a:pPr>
+                      <a:r>
+                        <a:rPr lang="he-IL" altLang="en-US" sz="1100" dirty="0">
+                          <a:solidFill>
+                            <a:srgbClr val="22303F"/>
+                          </a:solidFill>
+                          <a:latin typeface="Arial" pitchFamily="34" charset="0"/>
+                          <a:ea typeface="Arial" pitchFamily="34" charset="-122"/>
+                          <a:cs typeface="Arial" pitchFamily="34" charset="-120"/>
+                        </a:rPr>
+                        <a:t>עד שלושה חודשים</a:t>
+                      </a:r>
+                      <a:endParaRPr lang="he-IL" sz="1100" dirty="0">
+                        <a:latin typeface="Arial" charset="0"/>
+                        <a:ea typeface="Arial" charset="0"/>
+                        <a:cs typeface="Arial" charset="0"/>
+                      </a:endParaRPr>
+                    </a:p>
+                  </a:txBody>
+                  <a:tcPr marL="50800" marR="50800" marT="50800" marB="50800" anchor="ctr">
+                    <a:lnL w="9525" cap="flat" cmpd="sng" algn="ctr">
+                      <a:solidFill>
+                        <a:srgbClr val="C9D6E4"/>
+                      </a:solidFill>
+                      <a:prstDash val="solid"/>
+                      <a:round/>
+                      <a:headEnd type="none" w="med" len="med"/>
+                      <a:tailEnd type="none" w="med" len="med"/>
+                    </a:lnL>
+                    <a:lnR w="9525" cap="flat" cmpd="sng" algn="ctr">
+                      <a:solidFill>
+                        <a:srgbClr val="C9D6E4"/>
+                      </a:solidFill>
+                      <a:prstDash val="solid"/>
+                      <a:round/>
+                      <a:headEnd type="none" w="med" len="med"/>
+                      <a:tailEnd type="none" w="med" len="med"/>
+                    </a:lnR>
+                    <a:lnT w="9525" cap="flat" cmpd="sng" algn="ctr">
+                      <a:solidFill>
+                        <a:srgbClr val="C9D6E4"/>
+                      </a:solidFill>
+                      <a:prstDash val="solid"/>
+                      <a:round/>
+                      <a:headEnd type="none" w="med" len="med"/>
+                      <a:tailEnd type="none" w="med" len="med"/>
+                    </a:lnT>
+                    <a:lnB w="9525" cap="flat" cmpd="sng" algn="ctr">
+                      <a:solidFill>
+                        <a:srgbClr val="C9D6E4"/>
+                      </a:solidFill>
+                      <a:prstDash val="solid"/>
+                      <a:round/>
+                      <a:headEnd type="none" w="med" len="med"/>
+                      <a:tailEnd type="none" w="med" len="med"/>
+                    </a:lnB>
+                    <a:solidFill>
+                      <a:srgbClr val="FFFFFF"/>
+                    </a:solidFill>
+                  </a:tcPr>
+                </a:tc>
+                <a:tc>
+                  <a:txBody>
+                    <a:bodyPr rtlCol="1"/>
+                    <a:lstStyle/>
+                    <a:p>
+                      <a:pPr rtl="1" algn="r" indent="0" marL="0">
+                        <a:buNone/>
+                      </a:pPr>
+                      <a:r>
+                        <a:rPr lang="he-IL" altLang="en-US" sz="1100" b="1" dirty="0">
+                          <a:solidFill>
+                            <a:srgbClr val="22303F"/>
+                          </a:solidFill>
+                          <a:latin typeface="Arial" pitchFamily="34" charset="0"/>
+                          <a:ea typeface="Arial" pitchFamily="34" charset="-122"/>
+                          <a:cs typeface="Arial" pitchFamily="34" charset="-120"/>
+                        </a:rPr>
+                        <a:t>ותק באגף</a:t>
+                      </a:r>
+                      <a:endParaRPr lang="he-IL" sz="1100" dirty="0">
+                        <a:latin typeface="Arial" charset="0"/>
+                        <a:ea typeface="Arial" charset="0"/>
+                        <a:cs typeface="Arial" charset="0"/>
+                      </a:endParaRPr>
+                    </a:p>
+                  </a:txBody>
+                  <a:tcPr marL="50800" marR="50800" marT="50800" marB="50800" anchor="ctr">
+                    <a:lnL w="9525" cap="flat" cmpd="sng" algn="ctr">
+                      <a:solidFill>
+                        <a:srgbClr val="C9D6E4"/>
+                      </a:solidFill>
+                      <a:prstDash val="solid"/>
+                      <a:round/>
+                      <a:headEnd type="none" w="med" len="med"/>
+                      <a:tailEnd type="none" w="med" len="med"/>
+                    </a:lnL>
+                    <a:lnR w="9525" cap="flat" cmpd="sng" algn="ctr">
+                      <a:solidFill>
+                        <a:srgbClr val="C9D6E4"/>
+                      </a:solidFill>
+                      <a:prstDash val="solid"/>
+                      <a:round/>
+                      <a:headEnd type="none" w="med" len="med"/>
+                      <a:tailEnd type="none" w="med" len="med"/>
+                    </a:lnR>
+                    <a:lnT w="9525" cap="flat" cmpd="sng" algn="ctr">
+                      <a:solidFill>
+                        <a:srgbClr val="C9D6E4"/>
+                      </a:solidFill>
+                      <a:prstDash val="solid"/>
+                      <a:round/>
+                      <a:headEnd type="none" w="med" len="med"/>
+                      <a:tailEnd type="none" w="med" len="med"/>
+                    </a:lnT>
+                    <a:lnB w="9525" cap="flat" cmpd="sng" algn="ctr">
+                      <a:solidFill>
+                        <a:srgbClr val="C9D6E4"/>
+                      </a:solidFill>
+                      <a:prstDash val="solid"/>
+                      <a:round/>
+                      <a:headEnd type="none" w="med" len="med"/>
+                      <a:tailEnd type="none" w="med" len="med"/>
+                    </a:lnB>
+                    <a:solidFill>
+                      <a:srgbClr val="FFFFFF"/>
+                    </a:solidFill>
+                  </a:tcPr>
+                </a:tc>
+              </a:tr>
+              <a:tr h="224028">
+                <a:tc>
+                  <a:txBody>
+                    <a:bodyPr rtlCol="1"/>
+                    <a:lstStyle/>
+                    <a:p>
+                      <a:pPr rtl="1" algn="ctr" indent="0" marL="0">
+                        <a:buNone/>
+                      </a:pPr>
+                      <a:r>
+                        <a:rPr lang="he-IL" altLang="en-US" sz="1100" dirty="0">
+                          <a:solidFill>
+                            <a:srgbClr val="22303F"/>
+                          </a:solidFill>
+                          <a:latin typeface="Arial" pitchFamily="34" charset="0"/>
+                          <a:ea typeface="Arial" pitchFamily="34" charset="-122"/>
+                          <a:cs typeface="Arial" pitchFamily="34" charset="-120"/>
+                        </a:rPr>
+                        <a:t>68.3</a:t>
+                      </a:r>
+                      <a:endParaRPr lang="he-IL" sz="1100" dirty="0">
+                        <a:latin typeface="Arial" charset="0"/>
+                        <a:ea typeface="Arial" charset="0"/>
+                        <a:cs typeface="Arial" charset="0"/>
+                      </a:endParaRPr>
+                    </a:p>
+                  </a:txBody>
+                  <a:tcPr marL="50800" marR="50800" marT="50800" marB="50800" anchor="ctr">
+                    <a:lnL w="9525" cap="flat" cmpd="sng" algn="ctr">
+                      <a:solidFill>
+                        <a:srgbClr val="C9D6E4"/>
+                      </a:solidFill>
+                      <a:prstDash val="solid"/>
+                      <a:round/>
+                      <a:headEnd type="none" w="med" len="med"/>
+                      <a:tailEnd type="none" w="med" len="med"/>
+                    </a:lnL>
+                    <a:lnR w="9525" cap="flat" cmpd="sng" algn="ctr">
+                      <a:solidFill>
+                        <a:srgbClr val="C9D6E4"/>
+                      </a:solidFill>
+                      <a:prstDash val="solid"/>
+                      <a:round/>
+                      <a:headEnd type="none" w="med" len="med"/>
+                      <a:tailEnd type="none" w="med" len="med"/>
+                    </a:lnR>
+                    <a:lnT w="9525" cap="flat" cmpd="sng" algn="ctr">
+                      <a:solidFill>
+                        <a:srgbClr val="C9D6E4"/>
+                      </a:solidFill>
+                      <a:prstDash val="solid"/>
+                      <a:round/>
+                      <a:headEnd type="none" w="med" len="med"/>
+                      <a:tailEnd type="none" w="med" len="med"/>
+                    </a:lnT>
+                    <a:lnB w="9525" cap="flat" cmpd="sng" algn="ctr">
+                      <a:solidFill>
+                        <a:srgbClr val="C9D6E4"/>
+                      </a:solidFill>
+                      <a:prstDash val="solid"/>
+                      <a:round/>
+                      <a:headEnd type="none" w="med" len="med"/>
+                      <a:tailEnd type="none" w="med" len="med"/>
+                    </a:lnB>
+                    <a:solidFill>
+                      <a:srgbClr val="EAF0F7"/>
+                    </a:solidFill>
+                  </a:tcPr>
+                </a:tc>
+                <a:tc>
+                  <a:txBody>
+                    <a:bodyPr rtlCol="1"/>
+                    <a:lstStyle/>
+                    <a:p>
+                      <a:pPr rtl="1" algn="ctr" indent="0" marL="0">
+                        <a:buNone/>
+                      </a:pPr>
+                      <a:r>
+                        <a:rPr lang="he-IL" altLang="en-US" sz="1100" dirty="0">
+                          <a:solidFill>
+                            <a:srgbClr val="22303F"/>
+                          </a:solidFill>
+                          <a:latin typeface="Arial" pitchFamily="34" charset="0"/>
+                          <a:ea typeface="Arial" pitchFamily="34" charset="-122"/>
+                          <a:cs typeface="Arial" pitchFamily="34" charset="-120"/>
+                        </a:rPr>
+                        <a:t>1,624</a:t>
+                      </a:r>
+                      <a:endParaRPr lang="he-IL" sz="1100" dirty="0">
+                        <a:latin typeface="Arial" charset="0"/>
+                        <a:ea typeface="Arial" charset="0"/>
+                        <a:cs typeface="Arial" charset="0"/>
+                      </a:endParaRPr>
+                    </a:p>
+                  </a:txBody>
+                  <a:tcPr marL="50800" marR="50800" marT="50800" marB="50800" anchor="ctr">
+                    <a:lnL w="9525" cap="flat" cmpd="sng" algn="ctr">
+                      <a:solidFill>
+                        <a:srgbClr val="C9D6E4"/>
+                      </a:solidFill>
+                      <a:prstDash val="solid"/>
+                      <a:round/>
+                      <a:headEnd type="none" w="med" len="med"/>
+                      <a:tailEnd type="none" w="med" len="med"/>
+                    </a:lnL>
+                    <a:lnR w="9525" cap="flat" cmpd="sng" algn="ctr">
+                      <a:solidFill>
+                        <a:srgbClr val="C9D6E4"/>
+                      </a:solidFill>
+                      <a:prstDash val="solid"/>
+                      <a:round/>
+                      <a:headEnd type="none" w="med" len="med"/>
+                      <a:tailEnd type="none" w="med" len="med"/>
+                    </a:lnR>
+                    <a:lnT w="9525" cap="flat" cmpd="sng" algn="ctr">
+                      <a:solidFill>
+                        <a:srgbClr val="C9D6E4"/>
+                      </a:solidFill>
+                      <a:prstDash val="solid"/>
+                      <a:round/>
+                      <a:headEnd type="none" w="med" len="med"/>
+                      <a:tailEnd type="none" w="med" len="med"/>
+                    </a:lnT>
+                    <a:lnB w="9525" cap="flat" cmpd="sng" algn="ctr">
+                      <a:solidFill>
+                        <a:srgbClr val="C9D6E4"/>
+                      </a:solidFill>
+                      <a:prstDash val="solid"/>
+                      <a:round/>
+                      <a:headEnd type="none" w="med" len="med"/>
+                      <a:tailEnd type="none" w="med" len="med"/>
+                    </a:lnB>
+                    <a:solidFill>
+                      <a:srgbClr val="EAF0F7"/>
+                    </a:solidFill>
+                  </a:tcPr>
+                </a:tc>
+                <a:tc>
+                  <a:txBody>
+                    <a:bodyPr rtlCol="1"/>
+                    <a:lstStyle/>
+                    <a:p>
+                      <a:pPr rtl="1" algn="ctr" indent="0" marL="0">
+                        <a:buNone/>
+                      </a:pPr>
+                      <a:r>
+                        <a:rPr lang="he-IL" altLang="en-US" sz="1100" dirty="0">
+                          <a:solidFill>
+                            <a:srgbClr val="22303F"/>
+                          </a:solidFill>
+                          <a:latin typeface="Arial" pitchFamily="34" charset="0"/>
+                          <a:ea typeface="Arial" pitchFamily="34" charset="-122"/>
+                          <a:cs typeface="Arial" pitchFamily="34" charset="-120"/>
+                        </a:rPr>
+                        <a:t>מעל שלושה חודשים</a:t>
+                      </a:r>
+                      <a:endParaRPr lang="he-IL" sz="1100" dirty="0">
+                        <a:latin typeface="Arial" charset="0"/>
+                        <a:ea typeface="Arial" charset="0"/>
+                        <a:cs typeface="Arial" charset="0"/>
+                      </a:endParaRPr>
+                    </a:p>
+                  </a:txBody>
+                  <a:tcPr marL="50800" marR="50800" marT="50800" marB="50800" anchor="ctr">
+                    <a:lnL w="9525" cap="flat" cmpd="sng" algn="ctr">
+                      <a:solidFill>
+                        <a:srgbClr val="C9D6E4"/>
+                      </a:solidFill>
+                      <a:prstDash val="solid"/>
+                      <a:round/>
+                      <a:headEnd type="none" w="med" len="med"/>
+                      <a:tailEnd type="none" w="med" len="med"/>
+                    </a:lnL>
+                    <a:lnR w="9525" cap="flat" cmpd="sng" algn="ctr">
+                      <a:solidFill>
+                        <a:srgbClr val="C9D6E4"/>
+                      </a:solidFill>
+                      <a:prstDash val="solid"/>
+                      <a:round/>
+                      <a:headEnd type="none" w="med" len="med"/>
+                      <a:tailEnd type="none" w="med" len="med"/>
+                    </a:lnR>
+                    <a:lnT w="9525" cap="flat" cmpd="sng" algn="ctr">
+                      <a:solidFill>
+                        <a:srgbClr val="C9D6E4"/>
+                      </a:solidFill>
+                      <a:prstDash val="solid"/>
+                      <a:round/>
+                      <a:headEnd type="none" w="med" len="med"/>
+                      <a:tailEnd type="none" w="med" len="med"/>
+                    </a:lnT>
+                    <a:lnB w="9525" cap="flat" cmpd="sng" algn="ctr">
+                      <a:solidFill>
+                        <a:srgbClr val="C9D6E4"/>
+                      </a:solidFill>
+                      <a:prstDash val="solid"/>
+                      <a:round/>
+                      <a:headEnd type="none" w="med" len="med"/>
+                      <a:tailEnd type="none" w="med" len="med"/>
+                    </a:lnB>
+                    <a:solidFill>
+                      <a:srgbClr val="EAF0F7"/>
+                    </a:solidFill>
+                  </a:tcPr>
+                </a:tc>
+                <a:tc>
+                  <a:txBody>
+                    <a:bodyPr rtlCol="1"/>
+                    <a:lstStyle/>
+                    <a:p>
+                      <a:pPr rtl="1" algn="r" indent="0" marL="0">
+                        <a:buNone/>
+                      </a:pPr>
+                      <a:endParaRPr lang="he-IL" sz="1100" dirty="0">
+                        <a:latin typeface="Arial" charset="0"/>
+                        <a:ea typeface="Arial" charset="0"/>
+                        <a:cs typeface="Arial" charset="0"/>
+                      </a:endParaRPr>
+                    </a:p>
+                  </a:txBody>
+                  <a:tcPr marL="50800" marR="50800" marT="50800" marB="50800" anchor="ctr">
+                    <a:lnL w="9525" cap="flat" cmpd="sng" algn="ctr">
+                      <a:solidFill>
+                        <a:srgbClr val="C9D6E4"/>
+                      </a:solidFill>
+                      <a:prstDash val="solid"/>
+                      <a:round/>
+                      <a:headEnd type="none" w="med" len="med"/>
+                      <a:tailEnd type="none" w="med" len="med"/>
+                    </a:lnL>
+                    <a:lnR w="9525" cap="flat" cmpd="sng" algn="ctr">
+                      <a:solidFill>
+                        <a:srgbClr val="C9D6E4"/>
+                      </a:solidFill>
+                      <a:prstDash val="solid"/>
+                      <a:round/>
+                      <a:headEnd type="none" w="med" len="med"/>
+                      <a:tailEnd type="none" w="med" len="med"/>
+                    </a:lnR>
+                    <a:lnT w="9525" cap="flat" cmpd="sng" algn="ctr">
+                      <a:solidFill>
+                        <a:srgbClr val="C9D6E4"/>
+                      </a:solidFill>
+                      <a:prstDash val="solid"/>
+                      <a:round/>
+                      <a:headEnd type="none" w="med" len="med"/>
+                      <a:tailEnd type="none" w="med" len="med"/>
+                    </a:lnT>
+                    <a:lnB w="9525" cap="flat" cmpd="sng" algn="ctr">
+                      <a:solidFill>
+                        <a:srgbClr val="C9D6E4"/>
+                      </a:solidFill>
+                      <a:prstDash val="solid"/>
+                      <a:round/>
+                      <a:headEnd type="none" w="med" len="med"/>
+                      <a:tailEnd type="none" w="med" len="med"/>
+                    </a:lnB>
+                    <a:solidFill>
+                      <a:srgbClr val="EAF0F7"/>
+                    </a:solidFill>
+                  </a:tcPr>
+                </a:tc>
+              </a:tr>
+              <a:tr h="224028">
+                <a:tc>
+                  <a:txBody>
+                    <a:bodyPr rtlCol="1"/>
+                    <a:lstStyle/>
+                    <a:p>
+                      <a:pPr rtl="1" algn="ctr" indent="0" marL="0">
+                        <a:buNone/>
+                      </a:pPr>
+                      <a:r>
+                        <a:rPr lang="he-IL" altLang="en-US" sz="1100" dirty="0">
+                          <a:solidFill>
+                            <a:srgbClr val="22303F"/>
+                          </a:solidFill>
+                          <a:latin typeface="Arial" pitchFamily="34" charset="0"/>
+                          <a:ea typeface="Arial" pitchFamily="34" charset="-122"/>
+                          <a:cs typeface="Arial" pitchFamily="34" charset="-120"/>
+                        </a:rPr>
+                        <a:t>20.4</a:t>
+                      </a:r>
+                      <a:endParaRPr lang="he-IL" sz="1100" dirty="0">
+                        <a:latin typeface="Arial" charset="0"/>
+                        <a:ea typeface="Arial" charset="0"/>
+                        <a:cs typeface="Arial" charset="0"/>
+                      </a:endParaRPr>
+                    </a:p>
+                  </a:txBody>
+                  <a:tcPr marL="50800" marR="50800" marT="50800" marB="50800" anchor="ctr">
+                    <a:lnL w="9525" cap="flat" cmpd="sng" algn="ctr">
+                      <a:solidFill>
+                        <a:srgbClr val="C9D6E4"/>
+                      </a:solidFill>
+                      <a:prstDash val="solid"/>
+                      <a:round/>
+                      <a:headEnd type="none" w="med" len="med"/>
+                      <a:tailEnd type="none" w="med" len="med"/>
+                    </a:lnL>
+                    <a:lnR w="9525" cap="flat" cmpd="sng" algn="ctr">
+                      <a:solidFill>
+                        <a:srgbClr val="C9D6E4"/>
+                      </a:solidFill>
+                      <a:prstDash val="solid"/>
+                      <a:round/>
+                      <a:headEnd type="none" w="med" len="med"/>
+                      <a:tailEnd type="none" w="med" len="med"/>
+                    </a:lnR>
+                    <a:lnT w="9525" cap="flat" cmpd="sng" algn="ctr">
+                      <a:solidFill>
+                        <a:srgbClr val="C9D6E4"/>
+                      </a:solidFill>
+                      <a:prstDash val="solid"/>
+                      <a:round/>
+                      <a:headEnd type="none" w="med" len="med"/>
+                      <a:tailEnd type="none" w="med" len="med"/>
+                    </a:lnT>
+                    <a:lnB w="9525" cap="flat" cmpd="sng" algn="ctr">
+                      <a:solidFill>
+                        <a:srgbClr val="C9D6E4"/>
+                      </a:solidFill>
+                      <a:prstDash val="solid"/>
+                      <a:round/>
+                      <a:headEnd type="none" w="med" len="med"/>
+                      <a:tailEnd type="none" w="med" len="med"/>
+                    </a:lnB>
+                    <a:solidFill>
+                      <a:srgbClr val="FFFFFF"/>
+                    </a:solidFill>
+                  </a:tcPr>
+                </a:tc>
+                <a:tc>
+                  <a:txBody>
+                    <a:bodyPr rtlCol="1"/>
+                    <a:lstStyle/>
+                    <a:p>
+                      <a:pPr rtl="1" algn="ctr" indent="0" marL="0">
+                        <a:buNone/>
+                      </a:pPr>
+                      <a:r>
+                        <a:rPr lang="he-IL" altLang="en-US" sz="1100" dirty="0">
+                          <a:solidFill>
+                            <a:srgbClr val="22303F"/>
+                          </a:solidFill>
+                          <a:latin typeface="Arial" pitchFamily="34" charset="0"/>
+                          <a:ea typeface="Arial" pitchFamily="34" charset="-122"/>
+                          <a:cs typeface="Arial" pitchFamily="34" charset="-120"/>
+                        </a:rPr>
+                        <a:t>486</a:t>
+                      </a:r>
+                      <a:endParaRPr lang="he-IL" sz="1100" dirty="0">
+                        <a:latin typeface="Arial" charset="0"/>
+                        <a:ea typeface="Arial" charset="0"/>
+                        <a:cs typeface="Arial" charset="0"/>
+                      </a:endParaRPr>
+                    </a:p>
+                  </a:txBody>
+                  <a:tcPr marL="50800" marR="50800" marT="50800" marB="50800" anchor="ctr">
+                    <a:lnL w="9525" cap="flat" cmpd="sng" algn="ctr">
+                      <a:solidFill>
+                        <a:srgbClr val="C9D6E4"/>
+                      </a:solidFill>
+                      <a:prstDash val="solid"/>
+                      <a:round/>
+                      <a:headEnd type="none" w="med" len="med"/>
+                      <a:tailEnd type="none" w="med" len="med"/>
+                    </a:lnL>
+                    <a:lnR w="9525" cap="flat" cmpd="sng" algn="ctr">
+                      <a:solidFill>
+                        <a:srgbClr val="C9D6E4"/>
+                      </a:solidFill>
+                      <a:prstDash val="solid"/>
+                      <a:round/>
+                      <a:headEnd type="none" w="med" len="med"/>
+                      <a:tailEnd type="none" w="med" len="med"/>
+                    </a:lnR>
+                    <a:lnT w="9525" cap="flat" cmpd="sng" algn="ctr">
+                      <a:solidFill>
+                        <a:srgbClr val="C9D6E4"/>
+                      </a:solidFill>
+                      <a:prstDash val="solid"/>
+                      <a:round/>
+                      <a:headEnd type="none" w="med" len="med"/>
+                      <a:tailEnd type="none" w="med" len="med"/>
+                    </a:lnT>
+                    <a:lnB w="9525" cap="flat" cmpd="sng" algn="ctr">
+                      <a:solidFill>
+                        <a:srgbClr val="C9D6E4"/>
+                      </a:solidFill>
+                      <a:prstDash val="solid"/>
+                      <a:round/>
+                      <a:headEnd type="none" w="med" len="med"/>
+                      <a:tailEnd type="none" w="med" len="med"/>
+                    </a:lnB>
+                    <a:solidFill>
+                      <a:srgbClr val="FFFFFF"/>
+                    </a:solidFill>
+                  </a:tcPr>
+                </a:tc>
+                <a:tc>
+                  <a:txBody>
+                    <a:bodyPr rtlCol="1"/>
+                    <a:lstStyle/>
+                    <a:p>
+                      <a:pPr rtl="1" algn="ctr" indent="0" marL="0">
+                        <a:buNone/>
+                      </a:pPr>
+                      <a:r>
+                        <a:rPr lang="he-IL" altLang="en-US" sz="1100" dirty="0">
+                          <a:solidFill>
+                            <a:srgbClr val="22303F"/>
+                          </a:solidFill>
+                          <a:latin typeface="Arial" pitchFamily="34" charset="0"/>
+                          <a:ea typeface="Arial" pitchFamily="34" charset="-122"/>
+                          <a:cs typeface="Arial" pitchFamily="34" charset="-120"/>
+                        </a:rPr>
+                        <a:t>נמצא במסלול שיקום</a:t>
+                      </a:r>
+                      <a:endParaRPr lang="he-IL" sz="1100" dirty="0">
+                        <a:latin typeface="Arial" charset="0"/>
+                        <a:ea typeface="Arial" charset="0"/>
+                        <a:cs typeface="Arial" charset="0"/>
+                      </a:endParaRPr>
+                    </a:p>
+                  </a:txBody>
+                  <a:tcPr marL="50800" marR="50800" marT="50800" marB="50800" anchor="ctr">
+                    <a:lnL w="9525" cap="flat" cmpd="sng" algn="ctr">
+                      <a:solidFill>
+                        <a:srgbClr val="C9D6E4"/>
+                      </a:solidFill>
+                      <a:prstDash val="solid"/>
+                      <a:round/>
+                      <a:headEnd type="none" w="med" len="med"/>
+                      <a:tailEnd type="none" w="med" len="med"/>
+                    </a:lnL>
+                    <a:lnR w="9525" cap="flat" cmpd="sng" algn="ctr">
+                      <a:solidFill>
+                        <a:srgbClr val="C9D6E4"/>
+                      </a:solidFill>
+                      <a:prstDash val="solid"/>
+                      <a:round/>
+                      <a:headEnd type="none" w="med" len="med"/>
+                      <a:tailEnd type="none" w="med" len="med"/>
+                    </a:lnR>
+                    <a:lnT w="9525" cap="flat" cmpd="sng" algn="ctr">
+                      <a:solidFill>
+                        <a:srgbClr val="C9D6E4"/>
+                      </a:solidFill>
+                      <a:prstDash val="solid"/>
+                      <a:round/>
+                      <a:headEnd type="none" w="med" len="med"/>
+                      <a:tailEnd type="none" w="med" len="med"/>
+                    </a:lnT>
+                    <a:lnB w="9525" cap="flat" cmpd="sng" algn="ctr">
+                      <a:solidFill>
+                        <a:srgbClr val="C9D6E4"/>
+                      </a:solidFill>
+                      <a:prstDash val="solid"/>
+                      <a:round/>
+                      <a:headEnd type="none" w="med" len="med"/>
+                      <a:tailEnd type="none" w="med" len="med"/>
+                    </a:lnB>
+                    <a:solidFill>
+                      <a:srgbClr val="FFFFFF"/>
+                    </a:solidFill>
+                  </a:tcPr>
+                </a:tc>
+                <a:tc>
+                  <a:txBody>
+                    <a:bodyPr rtlCol="1"/>
+                    <a:lstStyle/>
+                    <a:p>
+                      <a:pPr rtl="1" algn="r" indent="0" marL="0">
+                        <a:buNone/>
+                      </a:pPr>
+                      <a:r>
+                        <a:rPr lang="he-IL" altLang="en-US" sz="1100" b="1" dirty="0">
+                          <a:solidFill>
+                            <a:srgbClr val="22303F"/>
+                          </a:solidFill>
+                          <a:latin typeface="Arial" pitchFamily="34" charset="0"/>
+                          <a:ea typeface="Arial" pitchFamily="34" charset="-122"/>
+                          <a:cs typeface="Arial" pitchFamily="34" charset="-120"/>
+                        </a:rPr>
+                        <a:t>מסלול שיקום</a:t>
+                      </a:r>
+                      <a:endParaRPr lang="he-IL" sz="1100" dirty="0">
+                        <a:latin typeface="Arial" charset="0"/>
+                        <a:ea typeface="Arial" charset="0"/>
+                        <a:cs typeface="Arial" charset="0"/>
+                      </a:endParaRPr>
+                    </a:p>
+                  </a:txBody>
+                  <a:tcPr marL="50800" marR="50800" marT="50800" marB="50800" anchor="ctr">
+                    <a:lnL w="9525" cap="flat" cmpd="sng" algn="ctr">
+                      <a:solidFill>
+                        <a:srgbClr val="C9D6E4"/>
+                      </a:solidFill>
+                      <a:prstDash val="solid"/>
+                      <a:round/>
+                      <a:headEnd type="none" w="med" len="med"/>
+                      <a:tailEnd type="none" w="med" len="med"/>
+                    </a:lnL>
+                    <a:lnR w="9525" cap="flat" cmpd="sng" algn="ctr">
+                      <a:solidFill>
+                        <a:srgbClr val="C9D6E4"/>
+                      </a:solidFill>
+                      <a:prstDash val="solid"/>
+                      <a:round/>
+                      <a:headEnd type="none" w="med" len="med"/>
+                      <a:tailEnd type="none" w="med" len="med"/>
+                    </a:lnR>
+                    <a:lnT w="9525" cap="flat" cmpd="sng" algn="ctr">
+                      <a:solidFill>
+                        <a:srgbClr val="C9D6E4"/>
+                      </a:solidFill>
+                      <a:prstDash val="solid"/>
+                      <a:round/>
+                      <a:headEnd type="none" w="med" len="med"/>
+                      <a:tailEnd type="none" w="med" len="med"/>
+                    </a:lnT>
+                    <a:lnB w="9525" cap="flat" cmpd="sng" algn="ctr">
+                      <a:solidFill>
+                        <a:srgbClr val="C9D6E4"/>
+                      </a:solidFill>
+                      <a:prstDash val="solid"/>
+                      <a:round/>
+                      <a:headEnd type="none" w="med" len="med"/>
+                      <a:tailEnd type="none" w="med" len="med"/>
+                    </a:lnB>
+                    <a:solidFill>
+                      <a:srgbClr val="FFFFFF"/>
+                    </a:solidFill>
+                  </a:tcPr>
+                </a:tc>
+              </a:tr>
+            </a:tbl>
+          </a:graphicData>
+        </a:graphic>
+      </p:graphicFrame>
       <p:sp>
         <p:nvSpPr>
           <p:cNvPr id="5" name="Text 2"/>
@@ -3105,8 +5803,8 @@
         </p:nvSpPr>
         <p:spPr>
           <a:xfrm>
-            <a:off x="640080" y="1234440"/>
-            <a:ext cx="2651760" cy="3246120"/>
+            <a:off x="457200" y="3840480"/>
+            <a:ext cx="8229600" cy="777240"/>
           </a:xfrm>
           <a:prstGeom prst="rect">
             <a:avLst/>
@@ -3115,7 +5813,7 @@
           <a:ln/>
         </p:spPr>
         <p:txBody>
-          <a:bodyPr wrap="square" lIns="0" tIns="0" rIns="0" bIns="0" rtlCol="0" anchor="t"/>
+          <a:bodyPr wrap="square" lIns="0" tIns="0" rIns="0" bIns="0" rtlCol="1" anchor="t"/>
           <a:lstStyle/>
           <a:p>
             <a:pPr rtl="1" algn="just" indent="0" marL="0">
@@ -3125,7 +5823,7 @@
               <a:buNone/>
             </a:pPr>
             <a:r>
-              <a:rPr lang="he-IL" altLang="en-US" sz="1200" dirty="0">
+              <a:rPr lang="he-IL" altLang="en-US" sz="1150" dirty="0">
                 <a:solidFill>
                   <a:srgbClr val="22303F"/>
                 </a:solidFill>
@@ -3133,9 +5831,9 @@
                 <a:ea typeface="Arial" pitchFamily="34" charset="-122"/>
                 <a:cs typeface="Arial" pitchFamily="34" charset="-120"/>
               </a:rPr>
-              <a:t>אוכלוסיית המחקר כוללת 2,379 אסירים שפוטים, רובם המכריע גברים, בגיל ממוצע של 37.9 שנים ובטווח של 18 עד 82. מעט יותר ממחציתם לא יהודים, כמחציתם במאסרם הראשון ולמעלה ממחציתם ריצו מאסר קודם. יותר משני שלישים שוהים באגף הנוכחי מעל שלושה חודשים, וכאחד מכל חמישה נמצא במסלול שיקום. ההתפלגות דומה לזו שדווחה בסקר המקורי (ועקנין, 2024).</a:t>
+              <a:t>אוכלוסיית המחקר כוללת 2,379 אסירים פליליים שפוטים, רובם המכריע גברים, בגיל ממוצע של 37.9 שנים ובטווח של 18 עד 82. מעט יותר ממחציתם אינם יהודים, כמחציתם מרצים את מאסרם הראשון ולמעלה ממחציתם ריצו מאסר קודם, יותר משני שלישים שוהים באגף הנוכחי מעל שלושה חודשים וכאחד מכל חמישה נמצא במסלול שיקום. התפלגות זו דומה לזו שדווחה בסקר המקורי, ומכאן שהמדגם משקף את אוכלוסיית האגפים הפליליים (ועקנין, 2024).</a:t>
             </a:r>
-            <a:endParaRPr lang="he-IL" sz="1200" dirty="0"/>
+            <a:endParaRPr lang="he-IL" sz="1150" dirty="0"/>
           </a:p>
         </p:txBody>
       </p:sp>
@@ -3157,7 +5855,7 @@
           <a:ln/>
         </p:spPr>
         <p:txBody>
-          <a:bodyPr wrap="square" lIns="0" tIns="0" rIns="0" bIns="0" rtlCol="0" anchor="t"/>
+          <a:bodyPr wrap="square" lIns="0" tIns="0" rIns="0" bIns="0" rtlCol="1" anchor="t"/>
           <a:lstStyle/>
           <a:p>
             <a:pPr rtl="1" algn="r" indent="0" marL="0">
@@ -3257,8 +5955,8 @@
         </p:nvSpPr>
         <p:spPr>
           <a:xfrm>
-            <a:off x="457200" y="274320"/>
-            <a:ext cx="8229600" cy="640080"/>
+            <a:off x="457200" y="256032"/>
+            <a:ext cx="8229600" cy="621792"/>
           </a:xfrm>
           <a:prstGeom prst="rect">
             <a:avLst/>
@@ -3267,7 +5965,7 @@
           <a:ln/>
         </p:spPr>
         <p:txBody>
-          <a:bodyPr wrap="square" lIns="0" tIns="0" rIns="0" bIns="0" rtlCol="0" anchor="t"/>
+          <a:bodyPr wrap="square" lIns="0" tIns="0" rIns="0" bIns="0" rtlCol="1" anchor="t"/>
           <a:lstStyle/>
           <a:p>
             <a:pPr rtl="1" algn="r" indent="0" marL="0">
@@ -3288,20 +5986,36 @@
           </a:p>
         </p:txBody>
       </p:sp>
+      <p:graphicFrame>
+        <p:nvGraphicFramePr>
+          <p:cNvPr id="3" name="Chart 0" descr=""/>
+          <p:cNvGraphicFramePr/>
+          <p:nvPr/>
+        </p:nvGraphicFramePr>
+        <p:xfrm>
+          <a:off x="457200" y="960120"/>
+          <a:ext cx="4846320" cy="2697480"/>
+        </p:xfrm>
+        <a:graphic xmlns:a="http://schemas.openxmlformats.org/drawingml/2006/main">
+          <a:graphicData uri="http://schemas.openxmlformats.org/drawingml/2006/chart">
+            <c:chart xmlns:c="http://schemas.openxmlformats.org/drawingml/2006/chart" r:id="rId1"/>
+          </a:graphicData>
+        </a:graphic>
+      </p:graphicFrame>
       <p:sp>
         <p:nvSpPr>
-          <p:cNvPr id="3" name="Shape 1"/>
+          <p:cNvPr id="4" name="Shape 1"/>
           <p:cNvSpPr/>
           <p:nvPr/>
         </p:nvSpPr>
         <p:spPr>
           <a:xfrm>
-            <a:off x="6035040" y="1005840"/>
-            <a:ext cx="2651760" cy="2377440"/>
+            <a:off x="5486400" y="960120"/>
+            <a:ext cx="3200400" cy="1143000"/>
           </a:xfrm>
           <a:prstGeom prst="roundRect">
             <a:avLst>
-              <a:gd name="adj" fmla="val 4615"/>
+              <a:gd name="adj" fmla="val 9600"/>
             </a:avLst>
           </a:prstGeom>
           <a:solidFill>
@@ -3317,14 +6031,14 @@
       </p:sp>
       <p:sp>
         <p:nvSpPr>
-          <p:cNvPr id="4" name="Text 2"/>
+          <p:cNvPr id="5" name="Text 2"/>
           <p:cNvSpPr txBox="1"/>
           <p:nvPr/>
         </p:nvSpPr>
         <p:spPr>
           <a:xfrm>
-            <a:off x="6126480" y="1234440"/>
-            <a:ext cx="2468880" cy="731520"/>
+            <a:off x="5577840" y="1033272"/>
+            <a:ext cx="3017520" cy="566928"/>
           </a:xfrm>
           <a:prstGeom prst="rect">
             <a:avLst/>
@@ -3340,7 +6054,7 @@
               <a:buNone/>
             </a:pPr>
             <a:r>
-              <a:rPr lang="en-US" sz="4000" b="1" dirty="0">
+              <a:rPr lang="en-US" sz="3400" b="1" dirty="0">
                 <a:solidFill>
                   <a:srgbClr val="E8892B"/>
                 </a:solidFill>
@@ -3350,20 +6064,20 @@
               </a:rPr>
               <a:t>r = 0.32</a:t>
             </a:r>
-            <a:endParaRPr lang="en-US" sz="4000" dirty="0"/>
+            <a:endParaRPr lang="en-US" sz="3400" dirty="0"/>
           </a:p>
         </p:txBody>
       </p:sp>
       <p:sp>
         <p:nvSpPr>
-          <p:cNvPr id="5" name="Text 3"/>
+          <p:cNvPr id="6" name="Text 3"/>
           <p:cNvSpPr txBox="1"/>
           <p:nvPr/>
         </p:nvSpPr>
         <p:spPr>
           <a:xfrm>
-            <a:off x="6217920" y="2057400"/>
-            <a:ext cx="2286000" cy="1188720"/>
+            <a:off x="5577840" y="1572768"/>
+            <a:ext cx="3017520" cy="457200"/>
           </a:xfrm>
           <a:prstGeom prst="rect">
             <a:avLst/>
@@ -3372,14 +6086,14 @@
           <a:ln/>
         </p:spPr>
         <p:txBody>
-          <a:bodyPr wrap="square" lIns="0" tIns="0" rIns="0" bIns="0" rtlCol="0" anchor="t"/>
+          <a:bodyPr wrap="square" lIns="0" tIns="0" rIns="0" bIns="0" rtlCol="1" anchor="t"/>
           <a:lstStyle/>
           <a:p>
             <a:pPr rtl="1" algn="ctr" indent="0" marL="0">
               <a:buNone/>
             </a:pPr>
             <a:r>
-              <a:rPr lang="he-IL" altLang="en-US" sz="1200" dirty="0">
+              <a:rPr lang="he-IL" altLang="en-US" sz="1100" dirty="0">
                 <a:solidFill>
                   <a:srgbClr val="CFDBEA"/>
                 </a:solidFill>
@@ -3387,42 +6101,731 @@
                 <a:ea typeface="Arial" pitchFamily="34" charset="-122"/>
                 <a:cs typeface="Arial" pitchFamily="34" charset="-120"/>
               </a:rPr>
-              <a:t>מתאם פירסון בין רווחה נפשית ללגיטימיות, p &lt; 0.001, N = 2,344. מתאם ספירמן rs = 0.34.</a:t>
+              <a:t>מתאם פירסון בין רווחה נפשית ללגיטימיות</a:t>
             </a:r>
-            <a:endParaRPr lang="he-IL" sz="1200" dirty="0"/>
+            <a:endParaRPr lang="he-IL" sz="1100" dirty="0"/>
+          </a:p>
+          <a:p>
+            <a:pPr rtl="1" algn="ctr" indent="0" marL="0">
+              <a:buNone/>
+            </a:pPr>
+            <a:r>
+              <a:rPr lang="he-IL" altLang="en-US" sz="1100" dirty="0">
+                <a:solidFill>
+                  <a:srgbClr val="CFDBEA"/>
+                </a:solidFill>
+                <a:latin typeface="Arial" pitchFamily="34" charset="0"/>
+                <a:ea typeface="Arial" pitchFamily="34" charset="-122"/>
+                <a:cs typeface="Arial" pitchFamily="34" charset="-120"/>
+              </a:rPr>
+              <a:t>p &lt; 0.001, N = 2,344; ספירמן rs = 0.34</a:t>
+            </a:r>
+            <a:endParaRPr lang="he-IL" sz="1100" dirty="0"/>
+          </a:p>
+        </p:txBody>
+      </p:sp>
+      <p:sp>
+        <p:nvSpPr>
+          <p:cNvPr id="7" name="Text 4"/>
+          <p:cNvSpPr txBox="1"/>
+          <p:nvPr/>
+        </p:nvSpPr>
+        <p:spPr>
+          <a:xfrm>
+            <a:off x="5486400" y="2240280"/>
+            <a:ext cx="3200400" cy="237744"/>
+          </a:xfrm>
+          <a:prstGeom prst="rect">
+            <a:avLst/>
+          </a:prstGeom>
+          <a:noFill/>
+          <a:ln/>
+        </p:spPr>
+        <p:txBody>
+          <a:bodyPr wrap="square" lIns="0" tIns="0" rIns="0" bIns="0" rtlCol="1" anchor="t"/>
+          <a:lstStyle/>
+          <a:p>
+            <a:pPr rtl="1" algn="r" indent="0" marL="0">
+              <a:buNone/>
+            </a:pPr>
+            <a:r>
+              <a:rPr lang="he-IL" altLang="en-US" sz="1100" b="1" dirty="0">
+                <a:solidFill>
+                  <a:srgbClr val="1F3A5F"/>
+                </a:solidFill>
+                <a:latin typeface="Arial" pitchFamily="34" charset="0"/>
+                <a:ea typeface="Arial" pitchFamily="34" charset="-122"/>
+                <a:cs typeface="Arial" pitchFamily="34" charset="-120"/>
+              </a:rPr>
+              <a:t>לוח 2: ממוצעים וסטיות תקן (סולם 1 עד 5)</a:t>
+            </a:r>
+            <a:endParaRPr lang="he-IL" sz="1100" dirty="0"/>
           </a:p>
         </p:txBody>
       </p:sp>
       <p:graphicFrame>
         <p:nvGraphicFramePr>
-          <p:cNvPr id="6" name="Chart 0" descr=""/>
-          <p:cNvGraphicFramePr/>
-          <p:nvPr/>
+          <p:cNvPr id="7" name="Table 0"/>
+          <p:cNvGraphicFramePr>
+            <a:graphicFrameLocks noGrp="1"/>
+          </p:cNvGraphicFramePr>
+          <p:nvPr>
+            <p:extLst>
+              <p:ext uri="{D42A27DB-BD31-4B8C-83A1-F6EECF244321}">
+                <p14:modId xmlns:p14="http://schemas.microsoft.com/office/powerpoint/2010/main" val="1579011935"/>
+              </p:ext>
+            </p:extLst>
+          </p:nvPr>
         </p:nvGraphicFramePr>
         <p:xfrm>
-          <a:off x="457200" y="1005840"/>
-          <a:ext cx="5394960" cy="2377440"/>
+          <a:off x="5486400" y="2514600"/>
+          <a:ext cx="3200400" cy="914400"/>
         </p:xfrm>
-        <a:graphic xmlns:a="http://schemas.openxmlformats.org/drawingml/2006/main">
-          <a:graphicData uri="http://schemas.openxmlformats.org/drawingml/2006/chart">
-            <c:chart xmlns:c="http://schemas.openxmlformats.org/drawingml/2006/chart" r:id="rId1"/>
+        <a:graphic>
+          <a:graphicData uri="http://schemas.openxmlformats.org/drawingml/2006/table">
+            <a:tbl>
+              <a:tblPr/>
+              <a:tblGrid>
+                <a:gridCol w="822960"/>
+                <a:gridCol w="822960"/>
+                <a:gridCol w="1554480"/>
+              </a:tblGrid>
+              <a:tr h="310896">
+                <a:tc>
+                  <a:txBody>
+                    <a:bodyPr rtlCol="1"/>
+                    <a:lstStyle/>
+                    <a:p>
+                      <a:pPr rtl="1" algn="ctr" indent="0" marL="0">
+                        <a:buNone/>
+                      </a:pPr>
+                      <a:r>
+                        <a:rPr lang="he-IL" altLang="en-US" sz="1100" b="1" dirty="0">
+                          <a:solidFill>
+                            <a:srgbClr val="FFFFFF"/>
+                          </a:solidFill>
+                          <a:latin typeface="Arial" pitchFamily="34" charset="0"/>
+                          <a:ea typeface="Arial" pitchFamily="34" charset="-122"/>
+                          <a:cs typeface="Arial" pitchFamily="34" charset="-120"/>
+                        </a:rPr>
+                        <a:t>SD</a:t>
+                      </a:r>
+                      <a:endParaRPr lang="he-IL" sz="1100" dirty="0">
+                        <a:latin typeface="Arial" charset="0"/>
+                        <a:ea typeface="Arial" charset="0"/>
+                        <a:cs typeface="Arial" charset="0"/>
+                      </a:endParaRPr>
+                    </a:p>
+                  </a:txBody>
+                  <a:tcPr marL="50800" marR="50800" marT="50800" marB="50800" anchor="ctr">
+                    <a:lnL w="9525" cap="flat" cmpd="sng" algn="ctr">
+                      <a:solidFill>
+                        <a:srgbClr val="C9D6E4"/>
+                      </a:solidFill>
+                      <a:prstDash val="solid"/>
+                      <a:round/>
+                      <a:headEnd type="none" w="med" len="med"/>
+                      <a:tailEnd type="none" w="med" len="med"/>
+                    </a:lnL>
+                    <a:lnR w="9525" cap="flat" cmpd="sng" algn="ctr">
+                      <a:solidFill>
+                        <a:srgbClr val="C9D6E4"/>
+                      </a:solidFill>
+                      <a:prstDash val="solid"/>
+                      <a:round/>
+                      <a:headEnd type="none" w="med" len="med"/>
+                      <a:tailEnd type="none" w="med" len="med"/>
+                    </a:lnR>
+                    <a:lnT w="9525" cap="flat" cmpd="sng" algn="ctr">
+                      <a:solidFill>
+                        <a:srgbClr val="C9D6E4"/>
+                      </a:solidFill>
+                      <a:prstDash val="solid"/>
+                      <a:round/>
+                      <a:headEnd type="none" w="med" len="med"/>
+                      <a:tailEnd type="none" w="med" len="med"/>
+                    </a:lnT>
+                    <a:lnB w="9525" cap="flat" cmpd="sng" algn="ctr">
+                      <a:solidFill>
+                        <a:srgbClr val="C9D6E4"/>
+                      </a:solidFill>
+                      <a:prstDash val="solid"/>
+                      <a:round/>
+                      <a:headEnd type="none" w="med" len="med"/>
+                      <a:tailEnd type="none" w="med" len="med"/>
+                    </a:lnB>
+                    <a:solidFill>
+                      <a:srgbClr val="1F3A5F"/>
+                    </a:solidFill>
+                  </a:tcPr>
+                </a:tc>
+                <a:tc>
+                  <a:txBody>
+                    <a:bodyPr rtlCol="1"/>
+                    <a:lstStyle/>
+                    <a:p>
+                      <a:pPr rtl="1" algn="ctr" indent="0" marL="0">
+                        <a:buNone/>
+                      </a:pPr>
+                      <a:r>
+                        <a:rPr lang="he-IL" altLang="en-US" sz="1100" b="1" dirty="0">
+                          <a:solidFill>
+                            <a:srgbClr val="FFFFFF"/>
+                          </a:solidFill>
+                          <a:latin typeface="Arial" pitchFamily="34" charset="0"/>
+                          <a:ea typeface="Arial" pitchFamily="34" charset="-122"/>
+                          <a:cs typeface="Arial" pitchFamily="34" charset="-120"/>
+                        </a:rPr>
+                        <a:t>M</a:t>
+                      </a:r>
+                      <a:endParaRPr lang="he-IL" sz="1100" dirty="0">
+                        <a:latin typeface="Arial" charset="0"/>
+                        <a:ea typeface="Arial" charset="0"/>
+                        <a:cs typeface="Arial" charset="0"/>
+                      </a:endParaRPr>
+                    </a:p>
+                  </a:txBody>
+                  <a:tcPr marL="50800" marR="50800" marT="50800" marB="50800" anchor="ctr">
+                    <a:lnL w="9525" cap="flat" cmpd="sng" algn="ctr">
+                      <a:solidFill>
+                        <a:srgbClr val="C9D6E4"/>
+                      </a:solidFill>
+                      <a:prstDash val="solid"/>
+                      <a:round/>
+                      <a:headEnd type="none" w="med" len="med"/>
+                      <a:tailEnd type="none" w="med" len="med"/>
+                    </a:lnL>
+                    <a:lnR w="9525" cap="flat" cmpd="sng" algn="ctr">
+                      <a:solidFill>
+                        <a:srgbClr val="C9D6E4"/>
+                      </a:solidFill>
+                      <a:prstDash val="solid"/>
+                      <a:round/>
+                      <a:headEnd type="none" w="med" len="med"/>
+                      <a:tailEnd type="none" w="med" len="med"/>
+                    </a:lnR>
+                    <a:lnT w="9525" cap="flat" cmpd="sng" algn="ctr">
+                      <a:solidFill>
+                        <a:srgbClr val="C9D6E4"/>
+                      </a:solidFill>
+                      <a:prstDash val="solid"/>
+                      <a:round/>
+                      <a:headEnd type="none" w="med" len="med"/>
+                      <a:tailEnd type="none" w="med" len="med"/>
+                    </a:lnT>
+                    <a:lnB w="9525" cap="flat" cmpd="sng" algn="ctr">
+                      <a:solidFill>
+                        <a:srgbClr val="C9D6E4"/>
+                      </a:solidFill>
+                      <a:prstDash val="solid"/>
+                      <a:round/>
+                      <a:headEnd type="none" w="med" len="med"/>
+                      <a:tailEnd type="none" w="med" len="med"/>
+                    </a:lnB>
+                    <a:solidFill>
+                      <a:srgbClr val="1F3A5F"/>
+                    </a:solidFill>
+                  </a:tcPr>
+                </a:tc>
+                <a:tc>
+                  <a:txBody>
+                    <a:bodyPr rtlCol="1"/>
+                    <a:lstStyle/>
+                    <a:p>
+                      <a:pPr rtl="1" algn="ctr" indent="0" marL="0">
+                        <a:buNone/>
+                      </a:pPr>
+                      <a:r>
+                        <a:rPr lang="he-IL" altLang="en-US" sz="1100" b="1" dirty="0">
+                          <a:solidFill>
+                            <a:srgbClr val="FFFFFF"/>
+                          </a:solidFill>
+                          <a:latin typeface="Arial" pitchFamily="34" charset="0"/>
+                          <a:ea typeface="Arial" pitchFamily="34" charset="-122"/>
+                          <a:cs typeface="Arial" pitchFamily="34" charset="-120"/>
+                        </a:rPr>
+                        <a:t>משתנה</a:t>
+                      </a:r>
+                      <a:endParaRPr lang="he-IL" sz="1100" dirty="0">
+                        <a:latin typeface="Arial" charset="0"/>
+                        <a:ea typeface="Arial" charset="0"/>
+                        <a:cs typeface="Arial" charset="0"/>
+                      </a:endParaRPr>
+                    </a:p>
+                  </a:txBody>
+                  <a:tcPr marL="50800" marR="50800" marT="50800" marB="50800" anchor="ctr">
+                    <a:lnL w="9525" cap="flat" cmpd="sng" algn="ctr">
+                      <a:solidFill>
+                        <a:srgbClr val="C9D6E4"/>
+                      </a:solidFill>
+                      <a:prstDash val="solid"/>
+                      <a:round/>
+                      <a:headEnd type="none" w="med" len="med"/>
+                      <a:tailEnd type="none" w="med" len="med"/>
+                    </a:lnL>
+                    <a:lnR w="9525" cap="flat" cmpd="sng" algn="ctr">
+                      <a:solidFill>
+                        <a:srgbClr val="C9D6E4"/>
+                      </a:solidFill>
+                      <a:prstDash val="solid"/>
+                      <a:round/>
+                      <a:headEnd type="none" w="med" len="med"/>
+                      <a:tailEnd type="none" w="med" len="med"/>
+                    </a:lnR>
+                    <a:lnT w="9525" cap="flat" cmpd="sng" algn="ctr">
+                      <a:solidFill>
+                        <a:srgbClr val="C9D6E4"/>
+                      </a:solidFill>
+                      <a:prstDash val="solid"/>
+                      <a:round/>
+                      <a:headEnd type="none" w="med" len="med"/>
+                      <a:tailEnd type="none" w="med" len="med"/>
+                    </a:lnT>
+                    <a:lnB w="9525" cap="flat" cmpd="sng" algn="ctr">
+                      <a:solidFill>
+                        <a:srgbClr val="C9D6E4"/>
+                      </a:solidFill>
+                      <a:prstDash val="solid"/>
+                      <a:round/>
+                      <a:headEnd type="none" w="med" len="med"/>
+                      <a:tailEnd type="none" w="med" len="med"/>
+                    </a:lnB>
+                    <a:solidFill>
+                      <a:srgbClr val="1F3A5F"/>
+                    </a:solidFill>
+                  </a:tcPr>
+                </a:tc>
+              </a:tr>
+              <a:tr h="310896">
+                <a:tc>
+                  <a:txBody>
+                    <a:bodyPr rtlCol="1"/>
+                    <a:lstStyle/>
+                    <a:p>
+                      <a:pPr rtl="1" algn="ctr" indent="0" marL="0">
+                        <a:buNone/>
+                      </a:pPr>
+                      <a:r>
+                        <a:rPr lang="he-IL" altLang="en-US" sz="1100" dirty="0">
+                          <a:solidFill>
+                            <a:srgbClr val="22303F"/>
+                          </a:solidFill>
+                          <a:latin typeface="Arial" pitchFamily="34" charset="0"/>
+                          <a:ea typeface="Arial" pitchFamily="34" charset="-122"/>
+                          <a:cs typeface="Arial" pitchFamily="34" charset="-120"/>
+                        </a:rPr>
+                        <a:t>0.83</a:t>
+                      </a:r>
+                      <a:endParaRPr lang="he-IL" sz="1100" dirty="0">
+                        <a:latin typeface="Arial" charset="0"/>
+                        <a:ea typeface="Arial" charset="0"/>
+                        <a:cs typeface="Arial" charset="0"/>
+                      </a:endParaRPr>
+                    </a:p>
+                  </a:txBody>
+                  <a:tcPr marL="50800" marR="50800" marT="50800" marB="50800" anchor="ctr">
+                    <a:lnL w="9525" cap="flat" cmpd="sng" algn="ctr">
+                      <a:solidFill>
+                        <a:srgbClr val="C9D6E4"/>
+                      </a:solidFill>
+                      <a:prstDash val="solid"/>
+                      <a:round/>
+                      <a:headEnd type="none" w="med" len="med"/>
+                      <a:tailEnd type="none" w="med" len="med"/>
+                    </a:lnL>
+                    <a:lnR w="9525" cap="flat" cmpd="sng" algn="ctr">
+                      <a:solidFill>
+                        <a:srgbClr val="C9D6E4"/>
+                      </a:solidFill>
+                      <a:prstDash val="solid"/>
+                      <a:round/>
+                      <a:headEnd type="none" w="med" len="med"/>
+                      <a:tailEnd type="none" w="med" len="med"/>
+                    </a:lnR>
+                    <a:lnT w="9525" cap="flat" cmpd="sng" algn="ctr">
+                      <a:solidFill>
+                        <a:srgbClr val="C9D6E4"/>
+                      </a:solidFill>
+                      <a:prstDash val="solid"/>
+                      <a:round/>
+                      <a:headEnd type="none" w="med" len="med"/>
+                      <a:tailEnd type="none" w="med" len="med"/>
+                    </a:lnT>
+                    <a:lnB w="9525" cap="flat" cmpd="sng" algn="ctr">
+                      <a:solidFill>
+                        <a:srgbClr val="C9D6E4"/>
+                      </a:solidFill>
+                      <a:prstDash val="solid"/>
+                      <a:round/>
+                      <a:headEnd type="none" w="med" len="med"/>
+                      <a:tailEnd type="none" w="med" len="med"/>
+                    </a:lnB>
+                    <a:solidFill>
+                      <a:srgbClr val="EAF0F7"/>
+                    </a:solidFill>
+                  </a:tcPr>
+                </a:tc>
+                <a:tc>
+                  <a:txBody>
+                    <a:bodyPr rtlCol="1"/>
+                    <a:lstStyle/>
+                    <a:p>
+                      <a:pPr rtl="1" algn="ctr" indent="0" marL="0">
+                        <a:buNone/>
+                      </a:pPr>
+                      <a:r>
+                        <a:rPr lang="he-IL" altLang="en-US" sz="1100" dirty="0">
+                          <a:solidFill>
+                            <a:srgbClr val="22303F"/>
+                          </a:solidFill>
+                          <a:latin typeface="Arial" pitchFamily="34" charset="0"/>
+                          <a:ea typeface="Arial" pitchFamily="34" charset="-122"/>
+                          <a:cs typeface="Arial" pitchFamily="34" charset="-120"/>
+                        </a:rPr>
+                        <a:t>4.24</a:t>
+                      </a:r>
+                      <a:endParaRPr lang="he-IL" sz="1100" dirty="0">
+                        <a:latin typeface="Arial" charset="0"/>
+                        <a:ea typeface="Arial" charset="0"/>
+                        <a:cs typeface="Arial" charset="0"/>
+                      </a:endParaRPr>
+                    </a:p>
+                  </a:txBody>
+                  <a:tcPr marL="50800" marR="50800" marT="50800" marB="50800" anchor="ctr">
+                    <a:lnL w="9525" cap="flat" cmpd="sng" algn="ctr">
+                      <a:solidFill>
+                        <a:srgbClr val="C9D6E4"/>
+                      </a:solidFill>
+                      <a:prstDash val="solid"/>
+                      <a:round/>
+                      <a:headEnd type="none" w="med" len="med"/>
+                      <a:tailEnd type="none" w="med" len="med"/>
+                    </a:lnL>
+                    <a:lnR w="9525" cap="flat" cmpd="sng" algn="ctr">
+                      <a:solidFill>
+                        <a:srgbClr val="C9D6E4"/>
+                      </a:solidFill>
+                      <a:prstDash val="solid"/>
+                      <a:round/>
+                      <a:headEnd type="none" w="med" len="med"/>
+                      <a:tailEnd type="none" w="med" len="med"/>
+                    </a:lnR>
+                    <a:lnT w="9525" cap="flat" cmpd="sng" algn="ctr">
+                      <a:solidFill>
+                        <a:srgbClr val="C9D6E4"/>
+                      </a:solidFill>
+                      <a:prstDash val="solid"/>
+                      <a:round/>
+                      <a:headEnd type="none" w="med" len="med"/>
+                      <a:tailEnd type="none" w="med" len="med"/>
+                    </a:lnT>
+                    <a:lnB w="9525" cap="flat" cmpd="sng" algn="ctr">
+                      <a:solidFill>
+                        <a:srgbClr val="C9D6E4"/>
+                      </a:solidFill>
+                      <a:prstDash val="solid"/>
+                      <a:round/>
+                      <a:headEnd type="none" w="med" len="med"/>
+                      <a:tailEnd type="none" w="med" len="med"/>
+                    </a:lnB>
+                    <a:solidFill>
+                      <a:srgbClr val="EAF0F7"/>
+                    </a:solidFill>
+                  </a:tcPr>
+                </a:tc>
+                <a:tc>
+                  <a:txBody>
+                    <a:bodyPr rtlCol="1"/>
+                    <a:lstStyle/>
+                    <a:p>
+                      <a:pPr rtl="1" algn="r" indent="0" marL="0">
+                        <a:buNone/>
+                      </a:pPr>
+                      <a:r>
+                        <a:rPr lang="he-IL" altLang="en-US" sz="1100" b="1" dirty="0">
+                          <a:solidFill>
+                            <a:srgbClr val="22303F"/>
+                          </a:solidFill>
+                          <a:latin typeface="Arial" pitchFamily="34" charset="0"/>
+                          <a:ea typeface="Arial" pitchFamily="34" charset="-122"/>
+                          <a:cs typeface="Arial" pitchFamily="34" charset="-120"/>
+                        </a:rPr>
+                        <a:t>לגיטימיות הסגל</a:t>
+                      </a:r>
+                      <a:endParaRPr lang="he-IL" sz="1100" dirty="0">
+                        <a:latin typeface="Arial" charset="0"/>
+                        <a:ea typeface="Arial" charset="0"/>
+                        <a:cs typeface="Arial" charset="0"/>
+                      </a:endParaRPr>
+                    </a:p>
+                  </a:txBody>
+                  <a:tcPr marL="50800" marR="50800" marT="50800" marB="50800" anchor="ctr">
+                    <a:lnL w="9525" cap="flat" cmpd="sng" algn="ctr">
+                      <a:solidFill>
+                        <a:srgbClr val="C9D6E4"/>
+                      </a:solidFill>
+                      <a:prstDash val="solid"/>
+                      <a:round/>
+                      <a:headEnd type="none" w="med" len="med"/>
+                      <a:tailEnd type="none" w="med" len="med"/>
+                    </a:lnL>
+                    <a:lnR w="9525" cap="flat" cmpd="sng" algn="ctr">
+                      <a:solidFill>
+                        <a:srgbClr val="C9D6E4"/>
+                      </a:solidFill>
+                      <a:prstDash val="solid"/>
+                      <a:round/>
+                      <a:headEnd type="none" w="med" len="med"/>
+                      <a:tailEnd type="none" w="med" len="med"/>
+                    </a:lnR>
+                    <a:lnT w="9525" cap="flat" cmpd="sng" algn="ctr">
+                      <a:solidFill>
+                        <a:srgbClr val="C9D6E4"/>
+                      </a:solidFill>
+                      <a:prstDash val="solid"/>
+                      <a:round/>
+                      <a:headEnd type="none" w="med" len="med"/>
+                      <a:tailEnd type="none" w="med" len="med"/>
+                    </a:lnT>
+                    <a:lnB w="9525" cap="flat" cmpd="sng" algn="ctr">
+                      <a:solidFill>
+                        <a:srgbClr val="C9D6E4"/>
+                      </a:solidFill>
+                      <a:prstDash val="solid"/>
+                      <a:round/>
+                      <a:headEnd type="none" w="med" len="med"/>
+                      <a:tailEnd type="none" w="med" len="med"/>
+                    </a:lnB>
+                    <a:solidFill>
+                      <a:srgbClr val="EAF0F7"/>
+                    </a:solidFill>
+                  </a:tcPr>
+                </a:tc>
+              </a:tr>
+              <a:tr h="310896">
+                <a:tc>
+                  <a:txBody>
+                    <a:bodyPr rtlCol="1"/>
+                    <a:lstStyle/>
+                    <a:p>
+                      <a:pPr rtl="1" algn="ctr" indent="0" marL="0">
+                        <a:buNone/>
+                      </a:pPr>
+                      <a:r>
+                        <a:rPr lang="he-IL" altLang="en-US" sz="1100" dirty="0">
+                          <a:solidFill>
+                            <a:srgbClr val="22303F"/>
+                          </a:solidFill>
+                          <a:latin typeface="Arial" pitchFamily="34" charset="0"/>
+                          <a:ea typeface="Arial" pitchFamily="34" charset="-122"/>
+                          <a:cs typeface="Arial" pitchFamily="34" charset="-120"/>
+                        </a:rPr>
+                        <a:t>0.87</a:t>
+                      </a:r>
+                      <a:endParaRPr lang="he-IL" sz="1100" dirty="0">
+                        <a:latin typeface="Arial" charset="0"/>
+                        <a:ea typeface="Arial" charset="0"/>
+                        <a:cs typeface="Arial" charset="0"/>
+                      </a:endParaRPr>
+                    </a:p>
+                  </a:txBody>
+                  <a:tcPr marL="50800" marR="50800" marT="50800" marB="50800" anchor="ctr">
+                    <a:lnL w="9525" cap="flat" cmpd="sng" algn="ctr">
+                      <a:solidFill>
+                        <a:srgbClr val="C9D6E4"/>
+                      </a:solidFill>
+                      <a:prstDash val="solid"/>
+                      <a:round/>
+                      <a:headEnd type="none" w="med" len="med"/>
+                      <a:tailEnd type="none" w="med" len="med"/>
+                    </a:lnL>
+                    <a:lnR w="9525" cap="flat" cmpd="sng" algn="ctr">
+                      <a:solidFill>
+                        <a:srgbClr val="C9D6E4"/>
+                      </a:solidFill>
+                      <a:prstDash val="solid"/>
+                      <a:round/>
+                      <a:headEnd type="none" w="med" len="med"/>
+                      <a:tailEnd type="none" w="med" len="med"/>
+                    </a:lnR>
+                    <a:lnT w="9525" cap="flat" cmpd="sng" algn="ctr">
+                      <a:solidFill>
+                        <a:srgbClr val="C9D6E4"/>
+                      </a:solidFill>
+                      <a:prstDash val="solid"/>
+                      <a:round/>
+                      <a:headEnd type="none" w="med" len="med"/>
+                      <a:tailEnd type="none" w="med" len="med"/>
+                    </a:lnT>
+                    <a:lnB w="9525" cap="flat" cmpd="sng" algn="ctr">
+                      <a:solidFill>
+                        <a:srgbClr val="C9D6E4"/>
+                      </a:solidFill>
+                      <a:prstDash val="solid"/>
+                      <a:round/>
+                      <a:headEnd type="none" w="med" len="med"/>
+                      <a:tailEnd type="none" w="med" len="med"/>
+                    </a:lnB>
+                    <a:solidFill>
+                      <a:srgbClr val="FFFFFF"/>
+                    </a:solidFill>
+                  </a:tcPr>
+                </a:tc>
+                <a:tc>
+                  <a:txBody>
+                    <a:bodyPr rtlCol="1"/>
+                    <a:lstStyle/>
+                    <a:p>
+                      <a:pPr rtl="1" algn="ctr" indent="0" marL="0">
+                        <a:buNone/>
+                      </a:pPr>
+                      <a:r>
+                        <a:rPr lang="he-IL" altLang="en-US" sz="1100" dirty="0">
+                          <a:solidFill>
+                            <a:srgbClr val="22303F"/>
+                          </a:solidFill>
+                          <a:latin typeface="Arial" pitchFamily="34" charset="0"/>
+                          <a:ea typeface="Arial" pitchFamily="34" charset="-122"/>
+                          <a:cs typeface="Arial" pitchFamily="34" charset="-120"/>
+                        </a:rPr>
+                        <a:t>3.78</a:t>
+                      </a:r>
+                      <a:endParaRPr lang="he-IL" sz="1100" dirty="0">
+                        <a:latin typeface="Arial" charset="0"/>
+                        <a:ea typeface="Arial" charset="0"/>
+                        <a:cs typeface="Arial" charset="0"/>
+                      </a:endParaRPr>
+                    </a:p>
+                  </a:txBody>
+                  <a:tcPr marL="50800" marR="50800" marT="50800" marB="50800" anchor="ctr">
+                    <a:lnL w="9525" cap="flat" cmpd="sng" algn="ctr">
+                      <a:solidFill>
+                        <a:srgbClr val="C9D6E4"/>
+                      </a:solidFill>
+                      <a:prstDash val="solid"/>
+                      <a:round/>
+                      <a:headEnd type="none" w="med" len="med"/>
+                      <a:tailEnd type="none" w="med" len="med"/>
+                    </a:lnL>
+                    <a:lnR w="9525" cap="flat" cmpd="sng" algn="ctr">
+                      <a:solidFill>
+                        <a:srgbClr val="C9D6E4"/>
+                      </a:solidFill>
+                      <a:prstDash val="solid"/>
+                      <a:round/>
+                      <a:headEnd type="none" w="med" len="med"/>
+                      <a:tailEnd type="none" w="med" len="med"/>
+                    </a:lnR>
+                    <a:lnT w="9525" cap="flat" cmpd="sng" algn="ctr">
+                      <a:solidFill>
+                        <a:srgbClr val="C9D6E4"/>
+                      </a:solidFill>
+                      <a:prstDash val="solid"/>
+                      <a:round/>
+                      <a:headEnd type="none" w="med" len="med"/>
+                      <a:tailEnd type="none" w="med" len="med"/>
+                    </a:lnT>
+                    <a:lnB w="9525" cap="flat" cmpd="sng" algn="ctr">
+                      <a:solidFill>
+                        <a:srgbClr val="C9D6E4"/>
+                      </a:solidFill>
+                      <a:prstDash val="solid"/>
+                      <a:round/>
+                      <a:headEnd type="none" w="med" len="med"/>
+                      <a:tailEnd type="none" w="med" len="med"/>
+                    </a:lnB>
+                    <a:solidFill>
+                      <a:srgbClr val="FFFFFF"/>
+                    </a:solidFill>
+                  </a:tcPr>
+                </a:tc>
+                <a:tc>
+                  <a:txBody>
+                    <a:bodyPr rtlCol="1"/>
+                    <a:lstStyle/>
+                    <a:p>
+                      <a:pPr rtl="1" algn="r" indent="0" marL="0">
+                        <a:buNone/>
+                      </a:pPr>
+                      <a:r>
+                        <a:rPr lang="he-IL" altLang="en-US" sz="1100" b="1" dirty="0">
+                          <a:solidFill>
+                            <a:srgbClr val="22303F"/>
+                          </a:solidFill>
+                          <a:latin typeface="Arial" pitchFamily="34" charset="0"/>
+                          <a:ea typeface="Arial" pitchFamily="34" charset="-122"/>
+                          <a:cs typeface="Arial" pitchFamily="34" charset="-120"/>
+                        </a:rPr>
+                        <a:t>רווחה נפשית</a:t>
+                      </a:r>
+                      <a:endParaRPr lang="he-IL" sz="1100" dirty="0">
+                        <a:latin typeface="Arial" charset="0"/>
+                        <a:ea typeface="Arial" charset="0"/>
+                        <a:cs typeface="Arial" charset="0"/>
+                      </a:endParaRPr>
+                    </a:p>
+                  </a:txBody>
+                  <a:tcPr marL="50800" marR="50800" marT="50800" marB="50800" anchor="ctr">
+                    <a:lnL w="9525" cap="flat" cmpd="sng" algn="ctr">
+                      <a:solidFill>
+                        <a:srgbClr val="C9D6E4"/>
+                      </a:solidFill>
+                      <a:prstDash val="solid"/>
+                      <a:round/>
+                      <a:headEnd type="none" w="med" len="med"/>
+                      <a:tailEnd type="none" w="med" len="med"/>
+                    </a:lnL>
+                    <a:lnR w="9525" cap="flat" cmpd="sng" algn="ctr">
+                      <a:solidFill>
+                        <a:srgbClr val="C9D6E4"/>
+                      </a:solidFill>
+                      <a:prstDash val="solid"/>
+                      <a:round/>
+                      <a:headEnd type="none" w="med" len="med"/>
+                      <a:tailEnd type="none" w="med" len="med"/>
+                    </a:lnR>
+                    <a:lnT w="9525" cap="flat" cmpd="sng" algn="ctr">
+                      <a:solidFill>
+                        <a:srgbClr val="C9D6E4"/>
+                      </a:solidFill>
+                      <a:prstDash val="solid"/>
+                      <a:round/>
+                      <a:headEnd type="none" w="med" len="med"/>
+                      <a:tailEnd type="none" w="med" len="med"/>
+                    </a:lnT>
+                    <a:lnB w="9525" cap="flat" cmpd="sng" algn="ctr">
+                      <a:solidFill>
+                        <a:srgbClr val="C9D6E4"/>
+                      </a:solidFill>
+                      <a:prstDash val="solid"/>
+                      <a:round/>
+                      <a:headEnd type="none" w="med" len="med"/>
+                      <a:tailEnd type="none" w="med" len="med"/>
+                    </a:lnB>
+                    <a:solidFill>
+                      <a:srgbClr val="FFFFFF"/>
+                    </a:solidFill>
+                  </a:tcPr>
+                </a:tc>
+              </a:tr>
+            </a:tbl>
           </a:graphicData>
         </a:graphic>
       </p:graphicFrame>
       <p:sp>
         <p:nvSpPr>
-          <p:cNvPr id="7" name="Shape 4"/>
+          <p:cNvPr id="9" name="Shape 5"/>
           <p:cNvSpPr/>
           <p:nvPr/>
         </p:nvSpPr>
         <p:spPr>
           <a:xfrm>
-            <a:off x="457200" y="3520440"/>
-            <a:ext cx="8229600" cy="1097280"/>
+            <a:off x="457200" y="3767328"/>
+            <a:ext cx="8229600" cy="868680"/>
           </a:xfrm>
           <a:prstGeom prst="roundRect">
             <a:avLst>
-              <a:gd name="adj" fmla="val 8333"/>
+              <a:gd name="adj" fmla="val 10526"/>
             </a:avLst>
           </a:prstGeom>
           <a:solidFill>
@@ -3438,14 +6841,14 @@
       </p:sp>
       <p:sp>
         <p:nvSpPr>
-          <p:cNvPr id="8" name="Text 5"/>
+          <p:cNvPr id="10" name="Text 6"/>
           <p:cNvSpPr txBox="1"/>
           <p:nvPr/>
         </p:nvSpPr>
         <p:spPr>
           <a:xfrm>
-            <a:off x="685800" y="3611880"/>
-            <a:ext cx="7772400" cy="960120"/>
+            <a:off x="640080" y="3858768"/>
+            <a:ext cx="7863840" cy="731520"/>
           </a:xfrm>
           <a:prstGeom prst="rect">
             <a:avLst/>
@@ -3454,7 +6857,7 @@
           <a:ln/>
         </p:spPr>
         <p:txBody>
-          <a:bodyPr wrap="square" lIns="0" tIns="0" rIns="0" bIns="0" rtlCol="0" anchor="t"/>
+          <a:bodyPr wrap="square" lIns="0" tIns="0" rIns="0" bIns="0" rtlCol="1" anchor="t"/>
           <a:lstStyle/>
           <a:p>
             <a:pPr rtl="1" algn="just" indent="0" marL="0">
@@ -3472,7 +6875,7 @@
                 <a:ea typeface="Arial" pitchFamily="34" charset="-122"/>
                 <a:cs typeface="Arial" pitchFamily="34" charset="-120"/>
               </a:rPr>
-              <a:t>נמצא קשר חיובי מובהק ברמה בינונית בין רווחה נפשית ללגיטימיות, והוא קיים בכל שלושת פריטי הלגיטימיות, כשהחזק שבהם הוא האפשרות לדבר עם הסוהרים (0.29). ממוצע הלגיטימיות עמד על 4.24 (סטיית תקן 0.83) וממוצע הרווחה על 3.78 (סטיית תקן 0.87), והשפוטים ברמת הלגיטימיות הנמוכה דיווחו על רווחה ממוצעת של 3.34 לעומת 4.05 ברמה הגבוהה, פער של כ-0.7 נקודות שהוא כ-80 אחוזים מסטיית תקן. הרווחה חולקת עם הלגיטימיות כעשרה אחוזים מהשונות, ההשערה אוששה, והממצא עולה בקנה אחד עם המחקרים מהולנד, מאנגליה ומאוסטרליה.</a:t>
+              <a:t>נמצא קשר חיובי מובהק ברמה בינונית בין רווחה נפשית לבין תפיסת הלגיטימיות, והוא קיים בכל שלושת פריטי הלגיטימיות כשהחזק שבהם הוא האפשרות לדבר עם הסוהרים. השפוטים ברמת הלגיטימיות הנמוכה דיווחו על רווחה ממוצעת של 3.34 לעומת 4.05 ברמה הגבוהה, פער של כ-0.7 נקודות שהוא כ-80 אחוזים מסטיית תקן, ומכאן שהרווחה חולקת עם הלגיטימיות כעשרה אחוזים מהשונות. השערת המחקר אוששה, והממצא עולה בקנה אחד עם המחקרים מהולנד, מאנגליה ומאוסטרליה.</a:t>
             </a:r>
             <a:endParaRPr lang="he-IL" sz="1100" dirty="0"/>
           </a:p>
@@ -3480,7 +6883,7 @@
       </p:sp>
       <p:sp>
         <p:nvSpPr>
-          <p:cNvPr id="9" name="Text 6"/>
+          <p:cNvPr id="11" name="Text 7"/>
           <p:cNvSpPr txBox="1"/>
           <p:nvPr/>
         </p:nvSpPr>
@@ -3496,7 +6899,7 @@
           <a:ln/>
         </p:spPr>
         <p:txBody>
-          <a:bodyPr wrap="square" lIns="0" tIns="0" rIns="0" bIns="0" rtlCol="0" anchor="t"/>
+          <a:bodyPr wrap="square" lIns="0" tIns="0" rIns="0" bIns="0" rtlCol="1" anchor="t"/>
           <a:lstStyle/>
           <a:p>
             <a:pPr rtl="1" algn="r" indent="0" marL="0">
@@ -3519,7 +6922,7 @@
       </p:sp>
       <p:sp>
         <p:nvSpPr>
-          <p:cNvPr id="10" name="Text 7"/>
+          <p:cNvPr id="12" name="Text 8"/>
           <p:cNvSpPr txBox="1"/>
           <p:nvPr/>
         </p:nvSpPr>

</xml_diff>

<commit_message>
Recolour deck to the college blue and orange; highlight the research question
Co-Authored-By: Claude Opus 5 <noreply@anthropic.com>
Claude-Session: https://claude.ai/code/session_01KHo5ZcKCUwhCAvyoKeeMWs
</commit_message>
<xml_diff>
--- a/seminar/רפרט_רווחה_נפשית_ולגיטימיות.pptx
+++ b/seminar/רפרט_רווחה_נפשית_ולגיטימיות.pptx
@@ -126,7 +126,7 @@
             <a:pPr>
               <a:defRPr sz="1100" b="0" i="0" u="none" strike="noStrike">
                 <a:solidFill>
-                  <a:srgbClr val="1F3A5F"/>
+                  <a:srgbClr val="2E6BA8"/>
                 </a:solidFill>
                 <a:latin typeface="Arial"/>
               </a:defRPr>
@@ -134,7 +134,7 @@
             <a:r>
               <a:rPr sz="1100" b="0" i="0" u="none" strike="noStrike">
                 <a:solidFill>
-                  <a:srgbClr val="1F3A5F"/>
+                  <a:srgbClr val="2E6BA8"/>
                 </a:solidFill>
                 <a:latin typeface="Arial"/>
               </a:rPr>
@@ -169,7 +169,7 @@
           </c:tx>
           <c:spPr>
             <a:solidFill>
-              <a:srgbClr val="E8892B"/>
+              <a:srgbClr val="E58220"/>
             </a:solidFill>
             <a:effectLst/>
           </c:spPr>
@@ -183,7 +183,7 @@
                 <a:pPr>
                   <a:defRPr b="0" i="0" strike="noStrike" sz="1200" u="none">
                     <a:solidFill>
-                      <a:srgbClr val="22303F"/>
+                      <a:srgbClr val="1F2933"/>
                     </a:solidFill>
                     <a:latin typeface="Arial"/>
                   </a:defRPr>
@@ -245,7 +245,7 @@
               <a:pPr>
                 <a:defRPr b="0" i="0" strike="noStrike" sz="1200" u="none">
                   <a:solidFill>
-                    <a:srgbClr val="22303F"/>
+                    <a:srgbClr val="1F2933"/>
                   </a:solidFill>
                   <a:latin typeface="Arial"/>
                 </a:defRPr>
@@ -293,7 +293,7 @@
             <a:pPr>
               <a:defRPr sz="1000" b="0" i="0" u="none" strike="noStrike">
                 <a:solidFill>
-                  <a:srgbClr val="22303F"/>
+                  <a:srgbClr val="1F2933"/>
                 </a:solidFill>
                 <a:latin typeface="Arial"/>
               </a:defRPr>
@@ -1573,7 +1573,7 @@
     <p:bg>
       <p:bgPr>
         <a:solidFill>
-          <a:srgbClr val="1F3A5F"/>
+          <a:srgbClr val="16375C"/>
         </a:solidFill>
       </p:bgPr>
     </p:bg>
@@ -1662,7 +1662,7 @@
             <a:r>
               <a:rPr lang="he-IL" altLang="en-US" sz="1400" b="1" dirty="0">
                 <a:solidFill>
-                  <a:srgbClr val="1F3A5F"/>
+                  <a:srgbClr val="2E6BA8"/>
                 </a:solidFill>
                 <a:latin typeface="Arial" pitchFamily="34" charset="0"/>
                 <a:ea typeface="Arial" pitchFamily="34" charset="-122"/>
@@ -1816,9 +1816,9 @@
               <a:buNone/>
             </a:pPr>
             <a:r>
-              <a:rPr lang="he-IL" altLang="en-US" sz="1500" dirty="0">
+              <a:rPr lang="he-IL" altLang="en-US" sz="1600" b="1" dirty="0">
                 <a:solidFill>
-                  <a:srgbClr val="CFDBEA"/>
+                  <a:srgbClr val="E58220"/>
                 </a:solidFill>
                 <a:latin typeface="Arial" pitchFamily="34" charset="0"/>
                 <a:ea typeface="Arial" pitchFamily="34" charset="-122"/>
@@ -1826,7 +1826,7 @@
               </a:rPr>
               <a:t>‏שאלת המחקר: באיזו מידה קיים קשר בין רווחה נפשית לבין תפיסת הלגיטימיות של סגל הכליאה בקרב אסירים שפוטים בלבד?‏</a:t>
             </a:r>
-            <a:endParaRPr lang="he-IL" sz="1500" dirty="0"/>
+            <a:endParaRPr lang="he-IL" sz="1600" dirty="0"/>
           </a:p>
         </p:txBody>
       </p:sp>
@@ -1847,11 +1847,11 @@
             </a:avLst>
           </a:prstGeom>
           <a:solidFill>
-            <a:srgbClr val="2B4C78"/>
+            <a:srgbClr val="204B7A"/>
           </a:solidFill>
           <a:ln w="12700">
             <a:solidFill>
-              <a:srgbClr val="2B4C78"/>
+              <a:srgbClr val="204B7A"/>
             </a:solidFill>
             <a:prstDash val="solid"/>
           </a:ln>
@@ -1884,7 +1884,7 @@
             <a:r>
               <a:rPr lang="he-IL" altLang="en-US" sz="1300" b="1" dirty="0">
                 <a:solidFill>
-                  <a:srgbClr val="E8892B"/>
+                  <a:srgbClr val="E58220"/>
                 </a:solidFill>
                 <a:latin typeface="Arial" pitchFamily="34" charset="0"/>
                 <a:ea typeface="Arial" pitchFamily="34" charset="-122"/>
@@ -2033,7 +2033,7 @@
             <a:r>
               <a:rPr lang="he-IL" altLang="en-US" sz="3000" b="1" dirty="0">
                 <a:solidFill>
-                  <a:srgbClr val="1F3A5F"/>
+                  <a:srgbClr val="2E6BA8"/>
                 </a:solidFill>
                 <a:latin typeface="Arial" pitchFamily="34" charset="0"/>
                 <a:ea typeface="Arial" pitchFamily="34" charset="-122"/>
@@ -2062,11 +2062,11 @@
             </a:avLst>
           </a:prstGeom>
           <a:solidFill>
-            <a:srgbClr val="EAF0F7"/>
+            <a:srgbClr val="E4EDF7"/>
           </a:solidFill>
           <a:ln w="12700">
             <a:solidFill>
-              <a:srgbClr val="EAF0F7"/>
+              <a:srgbClr val="E4EDF7"/>
             </a:solidFill>
             <a:prstDash val="solid"/>
           </a:ln>
@@ -2102,7 +2102,7 @@
             <a:r>
               <a:rPr lang="he-IL" altLang="en-US" sz="1400" dirty="0">
                 <a:solidFill>
-                  <a:srgbClr val="22303F"/>
+                  <a:srgbClr val="1F2933"/>
                 </a:solidFill>
                 <a:latin typeface="Arial" pitchFamily="34" charset="0"/>
                 <a:ea typeface="Arial" pitchFamily="34" charset="-122"/>
@@ -2251,7 +2251,7 @@
             <a:r>
               <a:rPr lang="he-IL" altLang="en-US" sz="3000" b="1" dirty="0">
                 <a:solidFill>
-                  <a:srgbClr val="1F3A5F"/>
+                  <a:srgbClr val="2E6BA8"/>
                 </a:solidFill>
                 <a:latin typeface="Arial" pitchFamily="34" charset="0"/>
                 <a:ea typeface="Arial" pitchFamily="34" charset="-122"/>
@@ -2280,11 +2280,11 @@
             </a:avLst>
           </a:prstGeom>
           <a:solidFill>
-            <a:srgbClr val="EAF0F7"/>
+            <a:srgbClr val="E4EDF7"/>
           </a:solidFill>
           <a:ln w="12700">
             <a:solidFill>
-              <a:srgbClr val="EAF0F7"/>
+              <a:srgbClr val="E4EDF7"/>
             </a:solidFill>
             <a:prstDash val="solid"/>
           </a:ln>
@@ -2320,7 +2320,7 @@
             <a:r>
               <a:rPr lang="he-IL" altLang="en-US" sz="1250" dirty="0">
                 <a:solidFill>
-                  <a:srgbClr val="22303F"/>
+                  <a:srgbClr val="1F2933"/>
                 </a:solidFill>
                 <a:latin typeface="Arial" pitchFamily="34" charset="0"/>
                 <a:ea typeface="Arial" pitchFamily="34" charset="-122"/>
@@ -2469,7 +2469,7 @@
             <a:r>
               <a:rPr lang="he-IL" altLang="en-US" sz="3000" b="1" dirty="0">
                 <a:solidFill>
-                  <a:srgbClr val="1F3A5F"/>
+                  <a:srgbClr val="2E6BA8"/>
                 </a:solidFill>
                 <a:latin typeface="Arial" pitchFamily="34" charset="0"/>
                 <a:ea typeface="Arial" pitchFamily="34" charset="-122"/>
@@ -2498,11 +2498,11 @@
             </a:avLst>
           </a:prstGeom>
           <a:solidFill>
-            <a:srgbClr val="1F3A5F"/>
+            <a:srgbClr val="E58220"/>
           </a:solidFill>
           <a:ln w="12700">
             <a:solidFill>
-              <a:srgbClr val="1F3A5F"/>
+              <a:srgbClr val="E58220"/>
             </a:solidFill>
             <a:prstDash val="solid"/>
           </a:ln>
@@ -2535,7 +2535,7 @@
             <a:r>
               <a:rPr lang="he-IL" altLang="en-US" sz="1700" b="1" dirty="0">
                 <a:solidFill>
-                  <a:srgbClr val="FFFFFF"/>
+                  <a:srgbClr val="16375C"/>
                 </a:solidFill>
                 <a:latin typeface="Arial" pitchFamily="34" charset="0"/>
                 <a:ea typeface="Arial" pitchFamily="34" charset="-122"/>
@@ -2564,11 +2564,11 @@
             </a:avLst>
           </a:prstGeom>
           <a:solidFill>
-            <a:srgbClr val="EAF0F7"/>
+            <a:srgbClr val="E4EDF7"/>
           </a:solidFill>
           <a:ln w="12700">
             <a:solidFill>
-              <a:srgbClr val="EAF0F7"/>
+              <a:srgbClr val="E4EDF7"/>
             </a:solidFill>
             <a:prstDash val="solid"/>
           </a:ln>
@@ -2604,7 +2604,7 @@
             <a:r>
               <a:rPr lang="he-IL" altLang="en-US" sz="1300" dirty="0">
                 <a:solidFill>
-                  <a:srgbClr val="22303F"/>
+                  <a:srgbClr val="1F2933"/>
                 </a:solidFill>
                 <a:latin typeface="Arial" pitchFamily="34" charset="0"/>
                 <a:ea typeface="Arial" pitchFamily="34" charset="-122"/>
@@ -2753,7 +2753,7 @@
             <a:r>
               <a:rPr lang="he-IL" altLang="en-US" sz="3000" b="1" dirty="0">
                 <a:solidFill>
-                  <a:srgbClr val="1F3A5F"/>
+                  <a:srgbClr val="2E6BA8"/>
                 </a:solidFill>
                 <a:latin typeface="Arial" pitchFamily="34" charset="0"/>
                 <a:ea typeface="Arial" pitchFamily="34" charset="-122"/>
@@ -2782,11 +2782,11 @@
             </a:avLst>
           </a:prstGeom>
           <a:solidFill>
-            <a:srgbClr val="EAF0F7"/>
+            <a:srgbClr val="FBEBD8"/>
           </a:solidFill>
           <a:ln w="12700">
             <a:solidFill>
-              <a:srgbClr val="EAF0F7"/>
+              <a:srgbClr val="FBEBD8"/>
             </a:solidFill>
             <a:prstDash val="solid"/>
           </a:ln>
@@ -2822,7 +2822,7 @@
             <a:r>
               <a:rPr lang="he-IL" altLang="en-US" sz="1350" dirty="0">
                 <a:solidFill>
-                  <a:srgbClr val="22303F"/>
+                  <a:srgbClr val="1F2933"/>
                 </a:solidFill>
                 <a:latin typeface="Arial" pitchFamily="34" charset="0"/>
                 <a:ea typeface="Arial" pitchFamily="34" charset="-122"/>
@@ -2971,7 +2971,7 @@
             <a:r>
               <a:rPr lang="he-IL" altLang="en-US" sz="3000" b="1" dirty="0">
                 <a:solidFill>
-                  <a:srgbClr val="1F3A5F"/>
+                  <a:srgbClr val="2E6BA8"/>
                 </a:solidFill>
                 <a:latin typeface="Arial" pitchFamily="34" charset="0"/>
                 <a:ea typeface="Arial" pitchFamily="34" charset="-122"/>
@@ -3016,11 +3016,11 @@
             </a:avLst>
           </a:prstGeom>
           <a:solidFill>
-            <a:srgbClr val="1F3A5F"/>
+            <a:srgbClr val="16375C"/>
           </a:solidFill>
           <a:ln w="12700">
             <a:solidFill>
-              <a:srgbClr val="1F3A5F"/>
+              <a:srgbClr val="16375C"/>
             </a:solidFill>
             <a:prstDash val="solid"/>
           </a:ln>
@@ -3053,7 +3053,7 @@
             <a:r>
               <a:rPr lang="en-US" sz="3600" b="1" dirty="0">
                 <a:solidFill>
-                  <a:srgbClr val="E8892B"/>
+                  <a:srgbClr val="E58220"/>
                 </a:solidFill>
                 <a:latin typeface="Arial" pitchFamily="34" charset="0"/>
                 <a:ea typeface="Arial" pitchFamily="34" charset="-122"/>
@@ -3095,7 +3095,7 @@
             <a:r>
               <a:rPr lang="he-IL" altLang="en-US" sz="1150" dirty="0">
                 <a:solidFill>
-                  <a:srgbClr val="CFDBEA"/>
+                  <a:srgbClr val="D4E2F0"/>
                 </a:solidFill>
                 <a:latin typeface="Arial" pitchFamily="34" charset="0"/>
                 <a:ea typeface="Arial" pitchFamily="34" charset="-122"/>
@@ -3124,11 +3124,11 @@
             </a:avLst>
           </a:prstGeom>
           <a:solidFill>
-            <a:srgbClr val="EAF0F7"/>
+            <a:srgbClr val="E4EDF7"/>
           </a:solidFill>
           <a:ln w="12700">
             <a:solidFill>
-              <a:srgbClr val="EAF0F7"/>
+              <a:srgbClr val="E4EDF7"/>
             </a:solidFill>
             <a:prstDash val="solid"/>
           </a:ln>
@@ -3164,7 +3164,7 @@
             <a:r>
               <a:rPr lang="he-IL" altLang="en-US" sz="1100" dirty="0">
                 <a:solidFill>
-                  <a:srgbClr val="22303F"/>
+                  <a:srgbClr val="1F2933"/>
                 </a:solidFill>
                 <a:latin typeface="Arial" pitchFamily="34" charset="0"/>
                 <a:ea typeface="Arial" pitchFamily="34" charset="-122"/>

</xml_diff>

<commit_message>
Right-align Hebrew paragraphs, glue hyphenated prefixes, lighten panels
Co-Authored-By: Claude Opus 5 <noreply@anthropic.com>
Claude-Session: https://claude.ai/code/session_01KHo5ZcKCUwhCAvyoKeeMWs
</commit_message>
<xml_diff>
--- a/seminar/רפרט_רווחה_נפשית_ולגיטימיות.pptx
+++ b/seminar/רפרט_רווחה_נפשית_ולגיטימיות.pptx
@@ -2062,11 +2062,11 @@
             </a:avLst>
           </a:prstGeom>
           <a:solidFill>
-            <a:srgbClr val="E4EDF7"/>
+            <a:srgbClr val="FFFFFF"/>
           </a:solidFill>
           <a:ln w="12700">
             <a:solidFill>
-              <a:srgbClr val="E4EDF7"/>
+              <a:srgbClr val="B9CCE0"/>
             </a:solidFill>
             <a:prstDash val="solid"/>
           </a:ln>
@@ -2093,9 +2093,9 @@
           <a:bodyPr wrap="square" lIns="0" tIns="0" rIns="0" bIns="0" rtlCol="1" anchor="t"/>
           <a:lstStyle/>
           <a:p>
-            <a:pPr rtl="1" algn="just" indent="0" marL="0">
+            <a:pPr rtl="1" algn="r" indent="0" marL="0">
               <a:lnSpc>
-                <a:spcPct val="115000"/>
+                <a:spcPct val="120000"/>
               </a:lnSpc>
               <a:buNone/>
             </a:pPr>
@@ -2108,7 +2108,7 @@
                 <a:ea typeface="Arial" pitchFamily="34" charset="-122"/>
                 <a:cs typeface="Arial" pitchFamily="34" charset="-120"/>
               </a:rPr>
-              <a:t>‏בית הסוהר הוא מוסד שבו סמכות הסגל כמעט מוחלטת, ובכל זאת הסדר היומיומי באגף תלוי בשיתוף פעולה של האסירים. ספרקס ובוטומס (1995) טענו שסדר בבתי סוהר אינו מתקיים בכוח בלבד אלא נשען על תחושת האסירים שהמשטר הוגן ושמי שמפעיל אותו ראוי לציות, ותחושה זו היא הלגיטימיות: המידה שבה האסיר תופס את הסגל כמכבד, כנגיש וכהוגן בטיפול בבקשותיו. ההקשר הישראלי מוסיף לשאלה משקל, שכן במאי 2019 כ-80 אחוזים ממקומות הכליאה בישראל היו קטנים מתקן 4.5 מטרים רבועים לאסיר (יכימוביץ-כהן, 2020). על רקע זה נערך בסתיו 2021 סקר תנאי המחיה הראשון בהיקפו בשירות בתי הסוהר, בקרב 2,363 שפוטים ו-1,427 עצורים, ובו נמצא שהלגיטימיות ממתנת את הקשר בין תנאי המחיה לבין שביעות הרצון מפעילויות החינוך, הטיפול והשיקום (ועקנין, 2024). המחקר הנוכחי לוקח מאותו מערך נתונים חוט אחד ובוחן את הקשר הישיר בין רווחתו הנפשית של האסיר לבין האופן שבו הוא תופס את לגיטימיות הסגל, בקרב שפוטים בלבד, משום שלשפוט יש אופק ידוע ושהות ממושכת יותר מול אותו סגל.‏</a:t>
+              <a:t>‏בית הסוהר הוא מוסד שבו סמכות הסגל כמעט מוחלטת, ובכל זאת הסדר היומיומי באגף תלוי בשיתוף פעולה של האסירים. ספרקס ובוטומס (1995) טענו שסדר בבתי סוהר אינו מתקיים בכוח בלבד אלא נשען על תחושת האסירים שהמשטר הוגן ושמי שמפעיל אותו ראוי לציות, ותחושה זו היא הלגיטימיות: המידה שבה האסיר תופס את הסגל כמכבד, כנגיש וכהוגן בטיפול בבקשותיו. ההקשר הישראלי מוסיף לשאלה משקל, שכן במאי 2019 כ⁠-⁠80 אחוזים ממקומות הכליאה בישראל היו קטנים מתקן 4.5 מטרים רבועים לאסיר (יכימוביץ⁠-⁠כהן, 2020). על רקע זה נערך בסתיו 2021 סקר תנאי המחיה הראשון בהיקפו בשירות בתי הסוהר, בקרב 2,363 שפוטים ו⁠-⁠1,427 עצורים, ובו נמצא שהלגיטימיות ממתנת את הקשר בין תנאי המחיה לבין שביעות הרצון מפעילויות החינוך, הטיפול והשיקום (ועקנין, 2024). המחקר הנוכחי לוקח מאותו מערך נתונים חוט אחד ובוחן את הקשר הישיר בין רווחתו הנפשית של האסיר לבין האופן שבו הוא תופס את לגיטימיות הסגל, בקרב שפוטים בלבד, משום שלשפוט יש אופק ידוע ושהות ממושכת יותר מול אותו סגל.‏</a:t>
             </a:r>
             <a:endParaRPr lang="he-IL" sz="1400" dirty="0"/>
           </a:p>
@@ -2280,11 +2280,11 @@
             </a:avLst>
           </a:prstGeom>
           <a:solidFill>
-            <a:srgbClr val="E4EDF7"/>
+            <a:srgbClr val="FFFFFF"/>
           </a:solidFill>
           <a:ln w="12700">
             <a:solidFill>
-              <a:srgbClr val="E4EDF7"/>
+              <a:srgbClr val="B9CCE0"/>
             </a:solidFill>
             <a:prstDash val="solid"/>
           </a:ln>
@@ -2311,9 +2311,9 @@
           <a:bodyPr wrap="square" lIns="0" tIns="0" rIns="0" bIns="0" rtlCol="1" anchor="t"/>
           <a:lstStyle/>
           <a:p>
-            <a:pPr rtl="1" algn="just" indent="0" marL="0">
+            <a:pPr rtl="1" algn="r" indent="0" marL="0">
               <a:lnSpc>
-                <a:spcPct val="115000"/>
+                <a:spcPct val="120000"/>
               </a:lnSpc>
               <a:buNone/>
             </a:pPr>
@@ -2326,7 +2326,7 @@
                 <a:ea typeface="Arial" pitchFamily="34" charset="-122"/>
                 <a:cs typeface="Arial" pitchFamily="34" charset="-120"/>
               </a:rPr>
-              <a:t>‏הספרות על הסתגלות למאסר עברה מתיאור כללי של כאבי המאסר לבחינה של ההבדלים בין בתי סוהר ובין אסירים. אוטי וליבלינג (2024) זיהו, על בסיס 518 סקרי איכות חיים באנגליה ובוויילס, שמתחת לסף של 3.05 ביחסי סגל ואסירים עולים בחדות שיעורי האלימות והפגיעה העצמית, וון גינקן ואחרים (2019) מצאו בקרב 4,538 אסירים בהולנד שתפיסות אישיות של אוטונומיה וביטחון קשורות לרווחה הנפשית. במערך אורך באוסטרליה הראו סרג'נט ואחרים (2026) שצדק פרוצדורלי מעלה את הרווחה הנפשית ושהיחסים עם הסגל הם המנגנון המתווך. בתחום הלגיטימיות ניתחו ברנטון-סמית ומקארתי (2016) סקר של יותר מ-3,000 אסירים ומצאו שההוגנות הפרוצדורלית היא המנבא החזק ביותר של לגיטימיות, ופרנקה ואחרים (2010) הראו בניסוי אקראי שדלות סביבתית וחוויות שליליות הן שמכרסמות בלגיטימיות במהלך המאסר. בישראל מצא ועקנין (2024) לגיטימיות גבוהה יחסית, גבוהה יותר בקרב שפוטים מאשר בקרב עצורים, והציע לראות בה כלי ניהולי באגף. הקשר הישיר בין רווחה נפשית ללגיטימיות בקרב שפוטים טרם נבחן, וזהו הפער שהמחקר הנוכחי מבקש למלא.‏</a:t>
+              <a:t>‏הספרות על הסתגלות למאסר עברה מתיאור כללי של כאבי המאסר לבחינה של ההבדלים בין בתי סוהר ובין אסירים. אוטי וליבלינג (2024) זיהו, על בסיס 518 סקרי איכות חיים באנגליה ובוויילס, שמתחת לסף של 3.05 ביחסי סגל ואסירים עולים בחדות שיעורי האלימות והפגיעה העצמית, וון גינקן ואחרים (2019) מצאו בקרב 4,538 אסירים בהולנד שתפיסות אישיות של אוטונומיה וביטחון קשורות לרווחה הנפשית. במערך אורך באוסטרליה הראו סרג'נט ואחרים (2026) שצדק פרוצדורלי מעלה את הרווחה הנפשית ושהיחסים עם הסגל הם המנגנון המתווך. בתחום הלגיטימיות ניתחו ברנטון⁠-⁠סמית ומקארתי (2016) סקר של יותר מ⁠-⁠3,000 אסירים ומצאו שההוגנות הפרוצדורלית היא המנבא החזק ביותר של לגיטימיות, ופרנקה ואחרים (2010) הראו בניסוי אקראי שדלות סביבתית וחוויות שליליות הן שמכרסמות בלגיטימיות במהלך המאסר. בישראל מצא ועקנין (2024) לגיטימיות גבוהה יחסית, גבוהה יותר בקרב שפוטים מאשר בקרב עצורים, והציע לראות בה כלי ניהולי באגף. הקשר הישיר בין רווחה נפשית ללגיטימיות בקרב שפוטים טרם נבחן, וזהו הפער שהמחקר הנוכחי מבקש למלא.‏</a:t>
             </a:r>
             <a:endParaRPr lang="he-IL" sz="1250" dirty="0"/>
           </a:p>
@@ -2564,11 +2564,11 @@
             </a:avLst>
           </a:prstGeom>
           <a:solidFill>
-            <a:srgbClr val="E4EDF7"/>
+            <a:srgbClr val="FFFFFF"/>
           </a:solidFill>
           <a:ln w="12700">
             <a:solidFill>
-              <a:srgbClr val="E4EDF7"/>
+              <a:srgbClr val="B9CCE0"/>
             </a:solidFill>
             <a:prstDash val="solid"/>
           </a:ln>
@@ -2595,9 +2595,9 @@
           <a:bodyPr wrap="square" lIns="0" tIns="0" rIns="0" bIns="0" rtlCol="1" anchor="t"/>
           <a:lstStyle/>
           <a:p>
-            <a:pPr rtl="1" algn="just" indent="0" marL="0">
+            <a:pPr rtl="1" algn="r" indent="0" marL="0">
               <a:lnSpc>
-                <a:spcPct val="115000"/>
+                <a:spcPct val="120000"/>
               </a:lnSpc>
               <a:buNone/>
             </a:pPr>
@@ -2610,7 +2610,7 @@
                 <a:ea typeface="Arial" pitchFamily="34" charset="-122"/>
                 <a:cs typeface="Arial" pitchFamily="34" charset="-120"/>
               </a:rPr>
-              <a:t>‏המשתנה התלוי הוא תפיסת הלגיטימיות של הסגל, הנמדדת בשלושה פריטים מתוך שאלון סקר תנאי המחיה: האפשרות לדבר עם הסוהרים כשמודאגים או עצובים, היחס המכבד של הסוהרים ושביעות הרצון מהטיפול בבקשות (α = 0.67). המשתנה הבלתי תלוי הוא הרווחה הנפשית, הנמדדת בחמישה פריטים של בריאות גופנית ונפשית, שיפור בבריאות מאז המאסר, שמחה ושביעות רצון מהחיים בחודש האחרון (α = 0.81), ושני הסולמות נעים בטווח של 1 עד 5. השערת המחקר היא שיימצא קשר חיובי מובהק בין רווחה נפשית לבין לגיטימיות, כך שככל שהרווחה גבוהה יותר, הלגיטימיות המיוחסת לסגל גבוהה יותר, ולהפך. המחקר הוא מחקר כמותי מתאמי במערך חתך, המבוסס על נתונים סינתטיים שנבנו על פי סקר שירות בתי הסוהר משנת 2021 וצומצמו ל-2,379 שפוטים, והניתוח נערך ב-SPSS וכלל סטטיסטיקה תיאורית, בדיקת מהימנות ומתאמי פירסון וספירמן.‏</a:t>
+              <a:t>‏המשתנה התלוי הוא תפיסת הלגיטימיות של הסגל, הנמדדת בשלושה פריטים מתוך שאלון סקר תנאי המחיה: האפשרות לדבר עם הסוהרים כשמודאגים או עצובים, היחס המכבד של הסוהרים ושביעות הרצון מהטיפול בבקשות (α = 0.67). המשתנה הבלתי תלוי הוא הרווחה הנפשית, הנמדדת בחמישה פריטים של בריאות גופנית ונפשית, שיפור בבריאות מאז המאסר, שמחה ושביעות רצון מהחיים בחודש האחרון (α = 0.81), ושני הסולמות נעים בטווח של 1 עד 5. השערת המחקר היא שיימצא קשר חיובי מובהק בין רווחה נפשית לבין לגיטימיות, כך שככל שהרווחה גבוהה יותר, הלגיטימיות המיוחסת לסגל גבוהה יותר, ולהפך. המחקר הוא מחקר כמותי מתאמי במערך חתך, המבוסס על נתונים סינתטיים שנבנו על פי סקר שירות בתי הסוהר משנת 2021 וצומצמו ל⁠-⁠2,379 שפוטים, והניתוח נערך בתוכנת SPSS וכלל סטטיסטיקה תיאורית, בדיקת מהימנות ומתאמי פירסון וספירמן.‏</a:t>
             </a:r>
             <a:endParaRPr lang="he-IL" sz="1300" dirty="0"/>
           </a:p>
@@ -2782,11 +2782,11 @@
             </a:avLst>
           </a:prstGeom>
           <a:solidFill>
-            <a:srgbClr val="FBEBD8"/>
+            <a:srgbClr val="FFFFFF"/>
           </a:solidFill>
-          <a:ln w="12700">
+          <a:ln w="15875">
             <a:solidFill>
-              <a:srgbClr val="FBEBD8"/>
+              <a:srgbClr val="F0B978"/>
             </a:solidFill>
             <a:prstDash val="solid"/>
           </a:ln>
@@ -2813,9 +2813,9 @@
           <a:bodyPr wrap="square" lIns="0" tIns="0" rIns="0" bIns="0" rtlCol="1" anchor="t"/>
           <a:lstStyle/>
           <a:p>
-            <a:pPr rtl="1" algn="just" indent="0" marL="0">
+            <a:pPr rtl="1" algn="r" indent="0" marL="0">
               <a:lnSpc>
-                <a:spcPct val="115000"/>
+                <a:spcPct val="120000"/>
               </a:lnSpc>
               <a:buNone/>
             </a:pPr>
@@ -2828,7 +2828,7 @@
                 <a:ea typeface="Arial" pitchFamily="34" charset="-122"/>
                 <a:cs typeface="Arial" pitchFamily="34" charset="-120"/>
               </a:rPr>
-              <a:t>‏אוכלוסיית המחקר כוללת 2,379 אסירים פליליים שפוטים, שהם כשני שלישים מכלל המשיבים לסקר. רובם המכריע גברים, 2,302 איש שהם 96.8 אחוזים, ולעומתם 77 נשים בלבד שהן 3.2 אחוזים, והגיל הממוצע עומד על 37.9 שנים בטווח שבין 18 ל-82. מבחינת לאום המדגם מחולק כמעט שווה בשווה, 1,136 יהודים שהם 47.8 אחוזים ו-1,243 שאינם יהודים שהם 52.2 אחוזים. כמחצית מהשפוטים מרצים את מאסרם הראשון, 1,162 איש שהם 48.8 אחוזים, 528 נמצאים במאסרם השני ו-689 במאסר שלישי ומעלה, ומכאן שלמעלה ממחצית האוכלוסייה כבר ריצתה מאסר קודם. רוב השפוטים ותיקים באגף שבו הם שוהים: 1,624 מהם, שהם 68.3 אחוזים, נמצאים בו מעל שלושה חודשים, ורק 755 שהם 31.7 אחוזים הגיעו אליו בשלושת החודשים האחרונים. לבסוף, 486 שפוטים שהם 20.4 אחוזים משתתפים במסלול שיקום. התפלגות זו דומה לזו שדווחה בסקר המקורי, ומכאן שהמדגם משקף את אוכלוסיית האגפים הפליליים בשירות בתי הסוהר (ועקנין, 2024).‏</a:t>
+              <a:t>‏אוכלוסיית המחקר כוללת 2,379 אסירים פליליים שפוטים, שהם כשני שלישים מכלל המשיבים לסקר. רובם המכריע גברים, 2,302 איש שהם 96.8 אחוזים, ולעומתם 77 נשים בלבד שהן 3.2 אחוזים, והגיל הממוצע עומד על 37.9 שנים בטווח שבין 18 ל⁠-⁠82. מבחינת לאום המדגם מחולק כמעט שווה בשווה, 1,136 יהודים שהם 47.8 אחוזים ו⁠-⁠1,243 שאינם יהודים שהם 52.2 אחוזים. כמחצית מהשפוטים מרצים את מאסרם הראשון, 1,162 איש שהם 48.8 אחוזים, 528 נמצאים במאסרם השני ו⁠-⁠689 במאסר שלישי ומעלה, ומכאן שלמעלה ממחצית האוכלוסייה כבר ריצתה מאסר קודם. רוב השפוטים ותיקים באגף שבו הם שוהים: 1,624 מהם, שהם 68.3 אחוזים, נמצאים בו מעל שלושה חודשים, ורק 755 שהם 31.7 אחוזים הגיעו אליו בשלושת החודשים האחרונים. לבסוף, 486 שפוטים שהם 20.4 אחוזים משתתפים במסלול שיקום. התפלגות זו דומה לזו שדווחה בסקר המקורי, ומכאן שהמדגם משקף את אוכלוסיית האגפים הפליליים בשירות בתי הסוהר (ועקנין, 2024).‏</a:t>
             </a:r>
             <a:endParaRPr lang="he-IL" sz="1350" dirty="0"/>
           </a:p>
@@ -3086,9 +3086,9 @@
           <a:bodyPr wrap="square" lIns="0" tIns="0" rIns="0" bIns="0" rtlCol="1" anchor="t"/>
           <a:lstStyle/>
           <a:p>
-            <a:pPr rtl="1" algn="just" indent="0" marL="0">
+            <a:pPr rtl="1" algn="r" indent="0" marL="0">
               <a:lnSpc>
-                <a:spcPct val="110000"/>
+                <a:spcPct val="115000"/>
               </a:lnSpc>
               <a:buNone/>
             </a:pPr>
@@ -3124,11 +3124,11 @@
             </a:avLst>
           </a:prstGeom>
           <a:solidFill>
-            <a:srgbClr val="E4EDF7"/>
+            <a:srgbClr val="FFFFFF"/>
           </a:solidFill>
           <a:ln w="12700">
             <a:solidFill>
-              <a:srgbClr val="E4EDF7"/>
+              <a:srgbClr val="B9CCE0"/>
             </a:solidFill>
             <a:prstDash val="solid"/>
           </a:ln>
@@ -3142,8 +3142,8 @@
         </p:nvSpPr>
         <p:spPr>
           <a:xfrm>
-            <a:off x="640080" y="3584448"/>
-            <a:ext cx="7863840" cy="960120"/>
+            <a:off x="640080" y="3566160"/>
+            <a:ext cx="7863840" cy="987552"/>
           </a:xfrm>
           <a:prstGeom prst="rect">
             <a:avLst/>
@@ -3155,14 +3155,14 @@
           <a:bodyPr wrap="square" lIns="0" tIns="0" rIns="0" bIns="0" rtlCol="1" anchor="t"/>
           <a:lstStyle/>
           <a:p>
-            <a:pPr rtl="1" algn="just" indent="0" marL="0">
+            <a:pPr rtl="1" algn="r" indent="0" marL="0">
               <a:lnSpc>
-                <a:spcPct val="115000"/>
+                <a:spcPct val="120000"/>
               </a:lnSpc>
               <a:buNone/>
             </a:pPr>
             <a:r>
-              <a:rPr lang="he-IL" altLang="en-US" sz="1100" dirty="0">
+              <a:rPr lang="he-IL" altLang="en-US" sz="1050" dirty="0">
                 <a:solidFill>
                   <a:srgbClr val="1F2933"/>
                 </a:solidFill>
@@ -3170,9 +3170,9 @@
                 <a:ea typeface="Arial" pitchFamily="34" charset="-122"/>
                 <a:cs typeface="Arial" pitchFamily="34" charset="-120"/>
               </a:rPr>
-              <a:t>‏ממוצע הלגיטימיות עמד על 4.24 עם סטיית תקן של 0.83, וממוצע הרווחה הנפשית על 3.78 עם סטיית תקן של 0.87, בסולם שנע בין 1 ל-5. נמצא קשר חיובי מובהק ברמה בינונית בין שני המשתנים, והוא קיים בכל שלושת פריטי הלגיטימיות כשהחזק שבהם הוא האפשרות לדבר עם הסוהרים. השפוטים ברמת הלגיטימיות הנמוכה דיווחו על רווחה ממוצעת של 3.34 לעומת 4.05 ברמה הגבוהה, פער של כ-0.7 נקודות שהוא כ-80 אחוזים מסטיית תקן, ומכאן שהרווחה חולקת עם הלגיטימיות כעשרה אחוזים מהשונות. השערת המחקר אוששה, והממצא עולה בקנה אחד עם המחקרים מהולנד, מאנגליה ומאוסטרליה.‏</a:t>
-            </a:r>
-            <a:endParaRPr lang="he-IL" sz="1100" dirty="0"/>
+              <a:t>‏ממוצע הלגיטימיות עמד על 4.24 עם סטיית תקן של 0.83, וממוצע הרווחה הנפשית על 3.78 עם סטיית תקן של 0.87, בסולם שנע בין 1 ל⁠-⁠5. נמצא קשר חיובי מובהק ברמה בינונית בין שני המשתנים, והוא קיים בכל שלושת פריטי הלגיטימיות כשהחזק שבהם הוא האפשרות לדבר עם הסוהרים. השפוטים ברמת הלגיטימיות הנמוכה דיווחו על רווחה ממוצעת של 3.34 לעומת 4.05 ברמה הגבוהה, פער של כ⁠-⁠0.7 נקודות שהוא כ⁠-⁠80 אחוזים מסטיית תקן, ומכאן שהרווחה חולקת עם הלגיטימיות כעשרה אחוזים מהשונות. השערת המחקר אוששה, והממצא עולה בקנה אחד עם המחקרים מהולנד, מאנגליה ומאוסטרליה.‏</a:t>
+            </a:r>
+            <a:endParaRPr lang="he-IL" sz="1050" dirty="0"/>
           </a:p>
         </p:txBody>
       </p:sp>

</xml_diff>